<commit_message>
Redraw suite pipeline diagram as six distinct skill nodes
Reworks the "How They Work Together" slide from grouped pairs to a single
left-to-right pipeline of six distinct nodes — Detect (tech-detector) ->
Plan (setup-plan) -> Build (data-collection-builder) -> Publish
(property-creator) -> Audit (audit-builder) -> Reconcile (data-reconciliation)
— with BUILD and ASSURE phase labels above the row. Node/arrow positions are
computed for non-overlap.

Co-Authored-By: Claude Fable 5 <noreply@anthropic.com>
Claude-Session: https://claude.ai/code/session_01L22pJWjoypJEHfB9cqhWZF
</commit_message>
<xml_diff>
--- a/websdk-property/docs/adobe-data-collection-skills-suite.pptx
+++ b/websdk-property/docs/adobe-data-collection-skills-suite.pptx
@@ -6454,48 +6454,14 @@
       </p:sp>
       <p:sp>
         <p:nvSpPr>
-          <p:cNvPr id="100" name="Box"/>
-          <p:cNvSpPr/>
-          <p:nvPr/>
-        </p:nvSpPr>
-        <p:spPr>
-          <a:xfrm>
-            <a:off x="4696000" y="1450000"/>
-            <a:ext cx="2800000" cy="650000"/>
-          </a:xfrm>
-          <a:prstGeom prst="roundRect">
-            <a:avLst>
-              <a:gd name="adj" fmla="val 9412"/>
-            </a:avLst>
-          </a:prstGeom>
-          <a:solidFill>
-            <a:srgbClr val="F2F2F2"/>
-          </a:solidFill>
-          <a:ln w="19050">
-            <a:solidFill>
-              <a:srgbClr val="666666"/>
-            </a:solidFill>
-            <a:prstDash val="solid"/>
-          </a:ln>
-        </p:spPr>
-        <p:txBody>
-          <a:bodyPr/>
-          <a:lstStyle/>
-          <a:p>
-            <a:endParaRPr lang="en-US"/>
-          </a:p>
-        </p:txBody>
-      </p:sp>
-      <p:sp>
-        <p:nvSpPr>
           <p:cNvPr id="101" name="BoxText"/>
           <p:cNvSpPr/>
           <p:nvPr/>
         </p:nvSpPr>
         <p:spPr>
           <a:xfrm>
-            <a:off x="4769152" y="1450000"/>
-            <a:ext cx="2653696" cy="650000"/>
+            <a:off x="548640" y="1572768"/>
+            <a:ext cx="11064240" cy="365760"/>
           </a:xfrm>
           <a:prstGeom prst="rect">
             <a:avLst/>
@@ -6519,171 +6485,8 @@
                 <a:ea typeface="Avenir Next LT Pro" pitchFamily="34" charset="-122"/>
                 <a:cs typeface="Avenir Next LT Pro" pitchFamily="34" charset="-120"/>
               </a:rPr>
-              <a:t>THE CLIENT'S LIVE SITE</a:t>
-            </a:r>
-          </a:p>
-          <a:p>
-            <a:pPr marL="0" indent="0" algn="ctr">
-              <a:buNone/>
-            </a:pPr>
-            <a:r>
-              <a:rPr lang="en-US" sz="1050" dirty="0">
-                <a:solidFill>
-                  <a:srgbClr val="000000"/>
-                </a:solidFill>
-                <a:latin typeface="Avenir Next LT Pro" pitchFamily="34" charset="0"/>
-                <a:ea typeface="Avenir Next LT Pro" pitchFamily="34" charset="-122"/>
-                <a:cs typeface="Avenir Next LT Pro" pitchFamily="34" charset="-120"/>
-              </a:rPr>
-              <a:t>one source, inspected directly</a:t>
-            </a:r>
-          </a:p>
-        </p:txBody>
-      </p:sp>
-      <p:sp>
-        <p:nvSpPr>
-          <p:cNvPr id="110" name="Line"/>
-          <p:cNvSpPr/>
-          <p:nvPr/>
-        </p:nvSpPr>
-        <p:spPr>
-          <a:xfrm>
-            <a:off x="6096000" y="2100000"/>
-            <a:ext cx="0" cy="250000"/>
-          </a:xfrm>
-          <a:prstGeom prst="line">
-            <a:avLst/>
-          </a:prstGeom>
-          <a:noFill/>
-          <a:ln w="19050">
-            <a:solidFill>
-              <a:srgbClr val="666666"/>
-            </a:solidFill>
-            <a:prstDash val="solid"/>
-          </a:ln>
-        </p:spPr>
-        <p:txBody>
-          <a:bodyPr/>
-          <a:lstStyle/>
-          <a:p>
-            <a:endParaRPr lang="en-US"/>
-          </a:p>
-        </p:txBody>
-      </p:sp>
-      <p:sp>
-        <p:nvSpPr>
-          <p:cNvPr id="112" name="Dot"/>
-          <p:cNvSpPr/>
-          <p:nvPr/>
-        </p:nvSpPr>
-        <p:spPr>
-          <a:xfrm>
-            <a:off x="6032000" y="2286000"/>
-            <a:ext cx="128016" cy="128016"/>
-          </a:xfrm>
-          <a:prstGeom prst="ellipse">
-            <a:avLst/>
-          </a:prstGeom>
-          <a:solidFill>
-            <a:srgbClr val="666666"/>
-          </a:solidFill>
-          <a:ln/>
-        </p:spPr>
-        <p:txBody>
-          <a:bodyPr/>
-          <a:lstStyle/>
-          <a:p>
-            <a:endParaRPr lang="en-US"/>
-          </a:p>
-        </p:txBody>
-      </p:sp>
-      <p:sp>
-        <p:nvSpPr>
-          <p:cNvPr id="114" name="Line"/>
-          <p:cNvSpPr/>
-          <p:nvPr/>
-        </p:nvSpPr>
-        <p:spPr>
-          <a:xfrm>
-            <a:off x="2400000" y="2350000"/>
-            <a:ext cx="7300000" cy="0"/>
-          </a:xfrm>
-          <a:prstGeom prst="line">
-            <a:avLst/>
-          </a:prstGeom>
-          <a:noFill/>
-          <a:ln w="19050">
-            <a:solidFill>
-              <a:srgbClr val="666666"/>
-            </a:solidFill>
-            <a:prstDash val="solid"/>
-          </a:ln>
-        </p:spPr>
-        <p:txBody>
-          <a:bodyPr/>
-          <a:lstStyle/>
-          <a:p>
-            <a:endParaRPr lang="en-US"/>
-          </a:p>
-        </p:txBody>
-      </p:sp>
-      <p:sp>
-        <p:nvSpPr>
-          <p:cNvPr id="116" name="Line"/>
-          <p:cNvSpPr/>
-          <p:nvPr/>
-        </p:nvSpPr>
-        <p:spPr>
-          <a:xfrm>
-            <a:off x="2400000" y="2350000"/>
-            <a:ext cx="0" cy="320000"/>
-          </a:xfrm>
-          <a:prstGeom prst="line">
-            <a:avLst/>
-          </a:prstGeom>
-          <a:noFill/>
-          <a:ln w="19050">
-            <a:solidFill>
-              <a:srgbClr val="666666"/>
-            </a:solidFill>
-            <a:prstDash val="solid"/>
-          </a:ln>
-        </p:spPr>
-        <p:txBody>
-          <a:bodyPr/>
-          <a:lstStyle/>
-          <a:p>
-            <a:endParaRPr lang="en-US"/>
-          </a:p>
-        </p:txBody>
-      </p:sp>
-      <p:sp>
-        <p:nvSpPr>
-          <p:cNvPr id="118" name="Line"/>
-          <p:cNvSpPr/>
-          <p:nvPr/>
-        </p:nvSpPr>
-        <p:spPr>
-          <a:xfrm>
-            <a:off x="9700000" y="2350000"/>
-            <a:ext cx="0" cy="320000"/>
-          </a:xfrm>
-          <a:prstGeom prst="line">
-            <a:avLst/>
-          </a:prstGeom>
-          <a:noFill/>
-          <a:ln w="19050">
-            <a:solidFill>
-              <a:srgbClr val="666666"/>
-            </a:solidFill>
-            <a:prstDash val="solid"/>
-          </a:ln>
-        </p:spPr>
-        <p:txBody>
-          <a:bodyPr/>
-          <a:lstStyle/>
-          <a:p>
-            <a:endParaRPr lang="en-US"/>
+              <a:t>Starts from the client's live site — inspected directly. Then each stage feeds the next, and every output is a client-ready artifact.</a:t>
+            </a:r>
           </a:p>
         </p:txBody>
       </p:sp>
@@ -6695,8 +6498,8 @@
         </p:nvSpPr>
         <p:spPr>
           <a:xfrm>
-            <a:off x="548640" y="2670000"/>
-            <a:ext cx="3700000" cy="320040"/>
+            <a:off x="548640" y="2331720"/>
+            <a:ext cx="7278624" cy="320040"/>
           </a:xfrm>
           <a:prstGeom prst="roundRect">
             <a:avLst>
@@ -6724,8 +6527,8 @@
         </p:nvSpPr>
         <p:spPr>
           <a:xfrm>
-            <a:off x="548640" y="2670000"/>
-            <a:ext cx="3700000" cy="320040"/>
+            <a:off x="548640" y="2331720"/>
+            <a:ext cx="7278624" cy="320040"/>
           </a:xfrm>
           <a:prstGeom prst="rect">
             <a:avLst/>
@@ -6749,7 +6552,7 @@
                 <a:ea typeface="Avenir Next LT Pro" pitchFamily="34" charset="-122"/>
                 <a:cs typeface="Avenir Next LT Pro" pitchFamily="34" charset="-120"/>
               </a:rPr>
-              <a:t>BUILD — STAND UP THE IMPLEMENTATION</a:t>
+              <a:t>BUILD  —  DETECT · PLAN · BUILD · PUBLISH</a:t>
             </a:r>
           </a:p>
         </p:txBody>
@@ -6762,8 +6565,8 @@
         </p:nvSpPr>
         <p:spPr>
           <a:xfrm>
-            <a:off x="548640" y="3050000"/>
-            <a:ext cx="2200000" cy="750000"/>
+            <a:off x="548640" y="2834640"/>
+            <a:ext cx="1600200" cy="960120"/>
           </a:xfrm>
           <a:prstGeom prst="roundRect">
             <a:avLst>
@@ -6796,8 +6599,8 @@
         </p:nvSpPr>
         <p:spPr>
           <a:xfrm>
-            <a:off x="621792" y="3050000"/>
-            <a:ext cx="2053696" cy="750000"/>
+            <a:off x="621792" y="2889504"/>
+            <a:ext cx="1453896" cy="850392"/>
           </a:xfrm>
           <a:prstGeom prst="rect">
             <a:avLst/>
@@ -6821,7 +6624,7 @@
                 <a:ea typeface="Avenir Next LT Pro" pitchFamily="34" charset="-122"/>
                 <a:cs typeface="Avenir Next LT Pro" pitchFamily="34" charset="-120"/>
               </a:rPr>
-              <a:t>Detect + Plan</a:t>
+              <a:t>Detect</a:t>
             </a:r>
           </a:p>
           <a:p>
@@ -6837,7 +6640,7 @@
                 <a:ea typeface="Avenir Next LT Pro" pitchFamily="34" charset="-122"/>
                 <a:cs typeface="Avenir Next LT Pro" pitchFamily="34" charset="-120"/>
               </a:rPr>
-              <a:t>tech-detector · setup-plan</a:t>
+              <a:t>tech-detector</a:t>
             </a:r>
           </a:p>
         </p:txBody>
@@ -6850,8 +6653,8 @@
         </p:nvSpPr>
         <p:spPr>
           <a:xfrm>
-            <a:off x="2823000" y="3050000"/>
-            <a:ext cx="274320" cy="750000"/>
+            <a:off x="2148840" y="2852928"/>
+            <a:ext cx="292608" cy="960120"/>
           </a:xfrm>
           <a:prstGeom prst="rect">
             <a:avLst/>
@@ -6879,14 +6682,456 @@
       </p:sp>
       <p:sp>
         <p:nvSpPr>
-          <p:cNvPr id="150" name="Box"/>
-          <p:cNvSpPr/>
-          <p:nvPr/>
-        </p:nvSpPr>
-        <p:spPr>
-          <a:xfrm>
-            <a:off x="3097320" y="3050000"/>
-            <a:ext cx="2450000" cy="750000"/>
+          <p:cNvPr id="170" name="Label"/>
+          <p:cNvSpPr/>
+          <p:nvPr/>
+        </p:nvSpPr>
+        <p:spPr>
+          <a:xfrm>
+            <a:off x="8119872" y="2331720"/>
+            <a:ext cx="3493008" cy="320040"/>
+          </a:xfrm>
+          <a:prstGeom prst="roundRect">
+            <a:avLst>
+              <a:gd name="adj" fmla="val 30000"/>
+            </a:avLst>
+          </a:prstGeom>
+          <a:solidFill>
+            <a:srgbClr val="0C62FB"/>
+          </a:solidFill>
+          <a:ln/>
+        </p:spPr>
+        <p:txBody>
+          <a:bodyPr/>
+          <a:lstStyle/>
+          <a:p>
+            <a:endParaRPr lang="en-US"/>
+          </a:p>
+        </p:txBody>
+      </p:sp>
+      <p:sp>
+        <p:nvSpPr>
+          <p:cNvPr id="171" name="LabelText"/>
+          <p:cNvSpPr/>
+          <p:nvPr/>
+        </p:nvSpPr>
+        <p:spPr>
+          <a:xfrm>
+            <a:off x="8119872" y="2331720"/>
+            <a:ext cx="3493008" cy="320040"/>
+          </a:xfrm>
+          <a:prstGeom prst="rect">
+            <a:avLst/>
+          </a:prstGeom>
+          <a:noFill/>
+          <a:ln/>
+        </p:spPr>
+        <p:txBody>
+          <a:bodyPr wrap="square" lIns="0" tIns="0" rIns="0" bIns="0" rtlCol="0" anchor="ctr"/>
+          <a:lstStyle/>
+          <a:p>
+            <a:pPr marL="0" indent="0" algn="ctr">
+              <a:buNone/>
+            </a:pPr>
+            <a:r>
+              <a:rPr lang="en-US" sz="1150" b="1" dirty="0">
+                <a:solidFill>
+                  <a:srgbClr val="FFFFFF"/>
+                </a:solidFill>
+                <a:latin typeface="Avenir Next LT Pro" pitchFamily="34" charset="0"/>
+                <a:ea typeface="Avenir Next LT Pro" pitchFamily="34" charset="-122"/>
+                <a:cs typeface="Avenir Next LT Pro" pitchFamily="34" charset="-120"/>
+              </a:rPr>
+              <a:t>ASSURE  —  AUDIT · RECONCILE</a:t>
+            </a:r>
+          </a:p>
+        </p:txBody>
+      </p:sp>
+      <p:sp>
+        <p:nvSpPr>
+          <p:cNvPr id="222" name="Banner"/>
+          <p:cNvSpPr/>
+          <p:nvPr/>
+        </p:nvSpPr>
+        <p:spPr>
+          <a:xfrm>
+            <a:off x="4322320" y="4150000"/>
+            <a:ext cx="6408120" cy="550000"/>
+          </a:xfrm>
+          <a:prstGeom prst="roundRect">
+            <a:avLst>
+              <a:gd name="adj" fmla="val 12000"/>
+            </a:avLst>
+          </a:prstGeom>
+          <a:solidFill>
+            <a:srgbClr val="FF4D5F"/>
+          </a:solidFill>
+          <a:ln/>
+        </p:spPr>
+        <p:txBody>
+          <a:bodyPr/>
+          <a:lstStyle/>
+          <a:p>
+            <a:endParaRPr lang="en-US"/>
+          </a:p>
+        </p:txBody>
+      </p:sp>
+      <p:sp>
+        <p:nvSpPr>
+          <p:cNvPr id="224" name="BannerText"/>
+          <p:cNvSpPr/>
+          <p:nvPr/>
+        </p:nvSpPr>
+        <p:spPr>
+          <a:xfrm>
+            <a:off x="4822320" y="4150000"/>
+            <a:ext cx="5858120" cy="550000"/>
+          </a:xfrm>
+          <a:prstGeom prst="rect">
+            <a:avLst/>
+          </a:prstGeom>
+          <a:noFill/>
+          <a:ln/>
+        </p:spPr>
+        <p:txBody>
+          <a:bodyPr wrap="square" lIns="0" tIns="0" rIns="0" bIns="0" rtlCol="0" anchor="ctr"/>
+          <a:lstStyle/>
+          <a:p>
+            <a:pPr marL="0" indent="0" algn="ctr">
+              <a:lnSpc>
+                <a:spcPct val="110000"/>
+              </a:lnSpc>
+              <a:buNone/>
+            </a:pPr>
+            <a:r>
+              <a:rPr lang="en-US" sz="1200" b="1" dirty="0">
+                <a:solidFill>
+                  <a:srgbClr val="FFFFFF"/>
+                </a:solidFill>
+                <a:latin typeface="Avenir Next LT Pro" pitchFamily="34" charset="0"/>
+                <a:ea typeface="Avenir Next LT Pro" pitchFamily="34" charset="-122"/>
+                <a:cs typeface="Avenir Next LT Pro" pitchFamily="34" charset="-120"/>
+              </a:rPr>
+              <a:t>ONE GOVERNED PIPELINE — EVERY OUTPUT FEEDS THE NEXT</a:t>
+            </a:r>
+          </a:p>
+          <a:p>
+            <a:pPr marL="0" indent="0" algn="ctr">
+              <a:buNone/>
+            </a:pPr>
+            <a:r>
+              <a:rPr lang="en-US" sz="1000" dirty="0">
+                <a:solidFill>
+                  <a:srgbClr val="FFFFFF"/>
+                </a:solidFill>
+                <a:latin typeface="Avenir Next LT Pro" pitchFamily="34" charset="0"/>
+                <a:ea typeface="Avenir Next LT Pro" pitchFamily="34" charset="-122"/>
+                <a:cs typeface="Avenir Next LT Pro" pitchFamily="34" charset="-120"/>
+              </a:rPr>
+              <a:t>Detection informs the plan; the plan drives the build; the build is audited; the audit is reconciled into decisions.</a:t>
+            </a:r>
+          </a:p>
+        </p:txBody>
+      </p:sp>
+      <p:sp>
+        <p:nvSpPr>
+          <p:cNvPr id="230" name="Callout"/>
+          <p:cNvSpPr/>
+          <p:nvPr/>
+        </p:nvSpPr>
+        <p:spPr>
+          <a:xfrm>
+            <a:off x="548640" y="4950000"/>
+            <a:ext cx="11064240" cy="1000000"/>
+          </a:xfrm>
+          <a:prstGeom prst="roundRect">
+            <a:avLst>
+              <a:gd name="adj" fmla="val 7273"/>
+            </a:avLst>
+          </a:prstGeom>
+          <a:solidFill>
+            <a:srgbClr val="F2F2F2"/>
+          </a:solidFill>
+          <a:ln/>
+        </p:spPr>
+        <p:txBody>
+          <a:bodyPr/>
+          <a:lstStyle/>
+          <a:p>
+            <a:endParaRPr lang="en-US"/>
+          </a:p>
+        </p:txBody>
+      </p:sp>
+      <p:sp>
+        <p:nvSpPr>
+          <p:cNvPr id="232" name="CalloutText"/>
+          <p:cNvSpPr/>
+          <p:nvPr/>
+        </p:nvSpPr>
+        <p:spPr>
+          <a:xfrm>
+            <a:off x="777240" y="4950000"/>
+            <a:ext cx="10607040" cy="1000000"/>
+          </a:xfrm>
+          <a:prstGeom prst="rect">
+            <a:avLst/>
+          </a:prstGeom>
+          <a:noFill/>
+          <a:ln/>
+        </p:spPr>
+        <p:txBody>
+          <a:bodyPr wrap="square" lIns="0" tIns="0" rIns="0" bIns="0" rtlCol="0" anchor="ctr"/>
+          <a:lstStyle/>
+          <a:p>
+            <a:pPr marL="0" indent="0">
+              <a:lnSpc>
+                <a:spcPct val="115000"/>
+              </a:lnSpc>
+              <a:buNone/>
+            </a:pPr>
+            <a:r>
+              <a:rPr lang="en-US" sz="1150" b="1" dirty="0">
+                <a:solidFill>
+                  <a:srgbClr val="002FAF"/>
+                </a:solidFill>
+                <a:latin typeface="Avenir Next LT Pro" pitchFamily="34" charset="0"/>
+                <a:ea typeface="Avenir Next LT Pro" pitchFamily="34" charset="-122"/>
+                <a:cs typeface="Avenir Next LT Pro" pitchFamily="34" charset="-120"/>
+              </a:rPr>
+              <a:t>What the client gets: </a:t>
+            </a:r>
+            <a:r>
+              <a:rPr lang="en-US" sz="1150" dirty="0">
+                <a:solidFill>
+                  <a:srgbClr val="000000"/>
+                </a:solidFill>
+                <a:latin typeface="Avenir Next LT Pro" pitchFamily="34" charset="0"/>
+                <a:ea typeface="Avenir Next LT Pro" pitchFamily="34" charset="-122"/>
+                <a:cs typeface="Avenir Next LT Pro" pitchFamily="34" charset="-120"/>
+              </a:rPr>
+              <a:t>a documented, governed Adobe implementation — plus the evidence (audit deck + workbook) and the decisions (reconciliation workbook + email) to trust it and act.</a:t>
+            </a:r>
+            <a:endParaRPr lang="en-US" sz="1150" dirty="0"/>
+          </a:p>
+        </p:txBody>
+      </p:sp>
+      <p:sp>
+        <p:nvSpPr>
+          <p:cNvPr id="43" name="Shape 39"/>
+          <p:cNvSpPr/>
+          <p:nvPr/>
+        </p:nvSpPr>
+        <p:spPr>
+          <a:xfrm>
+            <a:off x="0" y="0"/>
+            <a:ext cx="2432304" cy="137160"/>
+          </a:xfrm>
+          <a:prstGeom prst="rect">
+            <a:avLst/>
+          </a:prstGeom>
+          <a:solidFill>
+            <a:srgbClr val="002FAF"/>
+          </a:solidFill>
+          <a:ln/>
+        </p:spPr>
+        <p:txBody>
+          <a:bodyPr/>
+          <a:lstStyle/>
+          <a:p>
+            <a:endParaRPr lang="en-US"/>
+          </a:p>
+        </p:txBody>
+      </p:sp>
+      <p:sp>
+        <p:nvSpPr>
+          <p:cNvPr id="44" name="Shape 40"/>
+          <p:cNvSpPr/>
+          <p:nvPr/>
+        </p:nvSpPr>
+        <p:spPr>
+          <a:xfrm>
+            <a:off x="2432304" y="0"/>
+            <a:ext cx="2432304" cy="137160"/>
+          </a:xfrm>
+          <a:prstGeom prst="rect">
+            <a:avLst/>
+          </a:prstGeom>
+          <a:solidFill>
+            <a:srgbClr val="0C62FB"/>
+          </a:solidFill>
+          <a:ln/>
+        </p:spPr>
+        <p:txBody>
+          <a:bodyPr/>
+          <a:lstStyle/>
+          <a:p>
+            <a:endParaRPr lang="en-US"/>
+          </a:p>
+        </p:txBody>
+      </p:sp>
+      <p:sp>
+        <p:nvSpPr>
+          <p:cNvPr id="45" name="Shape 41"/>
+          <p:cNvSpPr/>
+          <p:nvPr/>
+        </p:nvSpPr>
+        <p:spPr>
+          <a:xfrm>
+            <a:off x="4864608" y="0"/>
+            <a:ext cx="2432304" cy="137160"/>
+          </a:xfrm>
+          <a:prstGeom prst="rect">
+            <a:avLst/>
+          </a:prstGeom>
+          <a:solidFill>
+            <a:srgbClr val="1BE1F2"/>
+          </a:solidFill>
+          <a:ln/>
+        </p:spPr>
+        <p:txBody>
+          <a:bodyPr/>
+          <a:lstStyle/>
+          <a:p>
+            <a:endParaRPr lang="en-US"/>
+          </a:p>
+        </p:txBody>
+      </p:sp>
+      <p:sp>
+        <p:nvSpPr>
+          <p:cNvPr id="46" name="Shape 42"/>
+          <p:cNvSpPr/>
+          <p:nvPr/>
+        </p:nvSpPr>
+        <p:spPr>
+          <a:xfrm>
+            <a:off x="7296912" y="0"/>
+            <a:ext cx="2432304" cy="137160"/>
+          </a:xfrm>
+          <a:prstGeom prst="rect">
+            <a:avLst/>
+          </a:prstGeom>
+          <a:solidFill>
+            <a:srgbClr val="FF4D5F"/>
+          </a:solidFill>
+          <a:ln/>
+        </p:spPr>
+        <p:txBody>
+          <a:bodyPr/>
+          <a:lstStyle/>
+          <a:p>
+            <a:endParaRPr lang="en-US"/>
+          </a:p>
+        </p:txBody>
+      </p:sp>
+      <p:sp>
+        <p:nvSpPr>
+          <p:cNvPr id="47" name="Shape 43"/>
+          <p:cNvSpPr/>
+          <p:nvPr/>
+        </p:nvSpPr>
+        <p:spPr>
+          <a:xfrm>
+            <a:off x="9729216" y="0"/>
+            <a:ext cx="2432304" cy="137160"/>
+          </a:xfrm>
+          <a:prstGeom prst="rect">
+            <a:avLst/>
+          </a:prstGeom>
+          <a:solidFill>
+            <a:srgbClr val="C7B9FF"/>
+          </a:solidFill>
+          <a:ln/>
+        </p:spPr>
+        <p:txBody>
+          <a:bodyPr/>
+          <a:lstStyle/>
+          <a:p>
+            <a:endParaRPr lang="en-US"/>
+          </a:p>
+        </p:txBody>
+      </p:sp>
+      <p:sp>
+        <p:nvSpPr>
+          <p:cNvPr id="48" name="Text 44"/>
+          <p:cNvSpPr/>
+          <p:nvPr/>
+        </p:nvSpPr>
+        <p:spPr>
+          <a:xfrm>
+            <a:off x="548640" y="6446520"/>
+            <a:ext cx="7315200" cy="274320"/>
+          </a:xfrm>
+          <a:prstGeom prst="rect">
+            <a:avLst/>
+          </a:prstGeom>
+          <a:noFill/>
+          <a:ln/>
+        </p:spPr>
+        <p:txBody>
+          <a:bodyPr wrap="square" lIns="0" tIns="0" rIns="0" bIns="0" rtlCol="0" anchor="ctr"/>
+          <a:lstStyle/>
+          <a:p>
+            <a:pPr marL="0" indent="0" algn="l">
+              <a:buNone/>
+            </a:pPr>
+            <a:r>
+              <a:rPr lang="en-US" sz="750" dirty="0">
+                <a:solidFill>
+                  <a:srgbClr val="666666"/>
+                </a:solidFill>
+              </a:rPr>
+              <a:t>© Slalom. All Rights Reserved. Proprietary and Confidential.</a:t>
+            </a:r>
+            <a:endParaRPr lang="en-US" sz="750" dirty="0"/>
+          </a:p>
+        </p:txBody>
+      </p:sp>
+      <p:sp>
+        <p:nvSpPr>
+          <p:cNvPr id="49" name="Text 45"/>
+          <p:cNvSpPr/>
+          <p:nvPr/>
+        </p:nvSpPr>
+        <p:spPr>
+          <a:xfrm>
+            <a:off x="11521440" y="6446520"/>
+            <a:ext cx="365760" cy="274320"/>
+          </a:xfrm>
+          <a:prstGeom prst="rect">
+            <a:avLst/>
+          </a:prstGeom>
+          <a:noFill/>
+          <a:ln/>
+        </p:spPr>
+        <p:txBody>
+          <a:bodyPr wrap="square" lIns="0" tIns="0" rIns="0" bIns="0" rtlCol="0" anchor="ctr"/>
+          <a:lstStyle/>
+          <a:p>
+            <a:pPr marL="0" indent="0" algn="r">
+              <a:buNone/>
+            </a:pPr>
+            <a:r>
+              <a:rPr lang="en-US" sz="1000" dirty="0">
+                <a:solidFill>
+                  <a:srgbClr val="666666"/>
+                </a:solidFill>
+              </a:rPr>
+              <a:t>6</a:t>
+            </a:r>
+            <a:endParaRPr lang="en-US" sz="1000" dirty="0"/>
+          </a:p>
+        </p:txBody>
+      </p:sp>
+      <p:sp>
+        <p:nvSpPr>
+          <p:cNvPr id="233" name="Box_233"/>
+          <p:cNvSpPr/>
+          <p:nvPr/>
+        </p:nvSpPr>
+        <p:spPr>
+          <a:xfrm>
+            <a:off x="2441448" y="2834640"/>
+            <a:ext cx="1600200" cy="960120"/>
           </a:xfrm>
           <a:prstGeom prst="roundRect">
             <a:avLst>
@@ -6913,14 +7158,14 @@
       </p:sp>
       <p:sp>
         <p:nvSpPr>
-          <p:cNvPr id="151" name="BoxText"/>
-          <p:cNvSpPr/>
-          <p:nvPr/>
-        </p:nvSpPr>
-        <p:spPr>
-          <a:xfrm>
-            <a:off x="3170472" y="3050000"/>
-            <a:ext cx="2303696" cy="750000"/>
+          <p:cNvPr id="234" name="BoxText_234"/>
+          <p:cNvSpPr/>
+          <p:nvPr/>
+        </p:nvSpPr>
+        <p:spPr>
+          <a:xfrm>
+            <a:off x="2514600" y="2889504"/>
+            <a:ext cx="1453896" cy="850392"/>
           </a:xfrm>
           <a:prstGeom prst="rect">
             <a:avLst/>
@@ -6944,7 +7189,7 @@
                 <a:ea typeface="Avenir Next LT Pro" pitchFamily="34" charset="-122"/>
                 <a:cs typeface="Avenir Next LT Pro" pitchFamily="34" charset="-120"/>
               </a:rPr>
-              <a:t>Build + Publish</a:t>
+              <a:t>Plan</a:t>
             </a:r>
           </a:p>
           <a:p>
@@ -6960,126 +7205,21 @@
                 <a:ea typeface="Avenir Next LT Pro" pitchFamily="34" charset="-122"/>
                 <a:cs typeface="Avenir Next LT Pro" pitchFamily="34" charset="-120"/>
               </a:rPr>
-              <a:t>data-collection-builder · property-creator</a:t>
-            </a:r>
-          </a:p>
-        </p:txBody>
-      </p:sp>
-      <p:sp>
-        <p:nvSpPr>
-          <p:cNvPr id="160" name="Caption"/>
-          <p:cNvSpPr/>
-          <p:nvPr/>
-        </p:nvSpPr>
-        <p:spPr>
-          <a:xfrm>
-            <a:off x="548640" y="3860000"/>
-            <a:ext cx="3000000" cy="274320"/>
-          </a:xfrm>
-          <a:prstGeom prst="rect">
-            <a:avLst/>
-          </a:prstGeom>
-          <a:noFill/>
-          <a:ln/>
-        </p:spPr>
-        <p:txBody>
-          <a:bodyPr wrap="square" lIns="0" tIns="0" rIns="0" bIns="0" rtlCol="0" anchor="ctr"/>
-          <a:lstStyle/>
-          <a:p>
-            <a:pPr marL="0" indent="0">
-              <a:buNone/>
-            </a:pPr>
-            <a:r>
-              <a:rPr lang="en-US" sz="1100" i="1" dirty="0">
-                <a:solidFill>
-                  <a:srgbClr val="666666"/>
-                </a:solidFill>
-                <a:latin typeface="Avenir Next LT Pro" pitchFamily="34" charset="0"/>
-                <a:ea typeface="Avenir Next LT Pro" pitchFamily="34" charset="-122"/>
-                <a:cs typeface="Avenir Next LT Pro" pitchFamily="34" charset="-120"/>
-              </a:rPr>
-              <a:t>Delivers: SDR · XDM · data elements · rules · a live, published Launch property</a:t>
-            </a:r>
-          </a:p>
-        </p:txBody>
-      </p:sp>
-      <p:sp>
-        <p:nvSpPr>
-          <p:cNvPr id="170" name="Label"/>
-          <p:cNvSpPr/>
-          <p:nvPr/>
-        </p:nvSpPr>
-        <p:spPr>
-          <a:xfrm>
-            <a:off x="6800000" y="2670000"/>
-            <a:ext cx="3300000" cy="320040"/>
-          </a:xfrm>
-          <a:prstGeom prst="roundRect">
-            <a:avLst>
-              <a:gd name="adj" fmla="val 30000"/>
-            </a:avLst>
-          </a:prstGeom>
-          <a:solidFill>
-            <a:srgbClr val="0C62FB"/>
-          </a:solidFill>
-          <a:ln/>
-        </p:spPr>
-        <p:txBody>
-          <a:bodyPr/>
-          <a:lstStyle/>
-          <a:p>
-            <a:endParaRPr lang="en-US"/>
-          </a:p>
-        </p:txBody>
-      </p:sp>
-      <p:sp>
-        <p:nvSpPr>
-          <p:cNvPr id="171" name="LabelText"/>
-          <p:cNvSpPr/>
-          <p:nvPr/>
-        </p:nvSpPr>
-        <p:spPr>
-          <a:xfrm>
-            <a:off x="6800000" y="2670000"/>
-            <a:ext cx="3300000" cy="320040"/>
-          </a:xfrm>
-          <a:prstGeom prst="rect">
-            <a:avLst/>
-          </a:prstGeom>
-          <a:noFill/>
-          <a:ln/>
-        </p:spPr>
-        <p:txBody>
-          <a:bodyPr wrap="square" lIns="0" tIns="0" rIns="0" bIns="0" rtlCol="0" anchor="ctr"/>
-          <a:lstStyle/>
-          <a:p>
-            <a:pPr marL="0" indent="0" algn="ctr">
-              <a:buNone/>
-            </a:pPr>
-            <a:r>
-              <a:rPr lang="en-US" sz="1150" b="1" dirty="0">
-                <a:solidFill>
-                  <a:srgbClr val="FFFFFF"/>
-                </a:solidFill>
-                <a:latin typeface="Avenir Next LT Pro" pitchFamily="34" charset="0"/>
-                <a:ea typeface="Avenir Next LT Pro" pitchFamily="34" charset="-122"/>
-                <a:cs typeface="Avenir Next LT Pro" pitchFamily="34" charset="-120"/>
-              </a:rPr>
-              <a:t>ASSURE — PROVE IT &amp; DECIDE</a:t>
-            </a:r>
-          </a:p>
-        </p:txBody>
-      </p:sp>
-      <p:sp>
-        <p:nvSpPr>
-          <p:cNvPr id="180" name="Box"/>
-          <p:cNvSpPr/>
-          <p:nvPr/>
-        </p:nvSpPr>
-        <p:spPr>
-          <a:xfrm>
-            <a:off x="6800000" y="3050000"/>
-            <a:ext cx="2200000" cy="750000"/>
+              <a:t>setup-plan</a:t>
+            </a:r>
+          </a:p>
+        </p:txBody>
+      </p:sp>
+      <p:sp>
+        <p:nvSpPr>
+          <p:cNvPr id="235" name="Box_235"/>
+          <p:cNvSpPr/>
+          <p:nvPr/>
+        </p:nvSpPr>
+        <p:spPr>
+          <a:xfrm>
+            <a:off x="4334256" y="2834640"/>
+            <a:ext cx="1600200" cy="960120"/>
           </a:xfrm>
           <a:prstGeom prst="roundRect">
             <a:avLst>
@@ -7091,7 +7231,7 @@
           </a:solidFill>
           <a:ln w="19050">
             <a:solidFill>
-              <a:srgbClr val="0C62FB"/>
+              <a:srgbClr val="6B5CA5"/>
             </a:solidFill>
             <a:prstDash val="solid"/>
           </a:ln>
@@ -7106,14 +7246,14 @@
       </p:sp>
       <p:sp>
         <p:nvSpPr>
-          <p:cNvPr id="181" name="BoxText"/>
-          <p:cNvSpPr/>
-          <p:nvPr/>
-        </p:nvSpPr>
-        <p:spPr>
-          <a:xfrm>
-            <a:off x="6873152" y="3050000"/>
-            <a:ext cx="2053696" cy="750000"/>
+          <p:cNvPr id="236" name="BoxText_236"/>
+          <p:cNvSpPr/>
+          <p:nvPr/>
+        </p:nvSpPr>
+        <p:spPr>
+          <a:xfrm>
+            <a:off x="4407408" y="2889504"/>
+            <a:ext cx="1453896" cy="850392"/>
           </a:xfrm>
           <a:prstGeom prst="rect">
             <a:avLst/>
@@ -7137,7 +7277,7 @@
                 <a:ea typeface="Avenir Next LT Pro" pitchFamily="34" charset="-122"/>
                 <a:cs typeface="Avenir Next LT Pro" pitchFamily="34" charset="-120"/>
               </a:rPr>
-              <a:t>Audit</a:t>
+              <a:t>Build</a:t>
             </a:r>
           </a:p>
           <a:p>
@@ -7153,56 +7293,21 @@
                 <a:ea typeface="Avenir Next LT Pro" pitchFamily="34" charset="-122"/>
                 <a:cs typeface="Avenir Next LT Pro" pitchFamily="34" charset="-120"/>
               </a:rPr>
-              <a:t>audit-builder</a:t>
-            </a:r>
-          </a:p>
-        </p:txBody>
-      </p:sp>
-      <p:sp>
-        <p:nvSpPr>
-          <p:cNvPr id="190" name="Arrow"/>
-          <p:cNvSpPr/>
-          <p:nvPr/>
-        </p:nvSpPr>
-        <p:spPr>
-          <a:xfrm>
-            <a:off x="9074000" y="3050000"/>
-            <a:ext cx="274320" cy="750000"/>
-          </a:xfrm>
-          <a:prstGeom prst="rect">
-            <a:avLst/>
-          </a:prstGeom>
-          <a:noFill/>
-          <a:ln/>
-        </p:spPr>
-        <p:txBody>
-          <a:bodyPr wrap="square" lIns="0" tIns="0" rIns="0" bIns="0" rtlCol="0" anchor="ctr"/>
-          <a:lstStyle/>
-          <a:p>
-            <a:pPr marL="0" indent="0" algn="ctr">
-              <a:buNone/>
-            </a:pPr>
-            <a:r>
-              <a:rPr lang="en-US" sz="1600" b="1" dirty="0">
-                <a:solidFill>
-                  <a:srgbClr val="0C62FB"/>
-                </a:solidFill>
-              </a:rPr>
-              <a:t>→</a:t>
-            </a:r>
-          </a:p>
-        </p:txBody>
-      </p:sp>
-      <p:sp>
-        <p:nvSpPr>
-          <p:cNvPr id="200" name="Box"/>
-          <p:cNvSpPr/>
-          <p:nvPr/>
-        </p:nvSpPr>
-        <p:spPr>
-          <a:xfrm>
-            <a:off x="9348320" y="3050000"/>
-            <a:ext cx="2764240" cy="750000"/>
+              <a:t>data-builder</a:t>
+            </a:r>
+          </a:p>
+        </p:txBody>
+      </p:sp>
+      <p:sp>
+        <p:nvSpPr>
+          <p:cNvPr id="237" name="Box_237"/>
+          <p:cNvSpPr/>
+          <p:nvPr/>
+        </p:nvSpPr>
+        <p:spPr>
+          <a:xfrm>
+            <a:off x="6227064" y="2834640"/>
+            <a:ext cx="1600200" cy="960120"/>
           </a:xfrm>
           <a:prstGeom prst="roundRect">
             <a:avLst>
@@ -7214,7 +7319,7 @@
           </a:solidFill>
           <a:ln w="19050">
             <a:solidFill>
-              <a:srgbClr val="0C62FB"/>
+              <a:srgbClr val="6B5CA5"/>
             </a:solidFill>
             <a:prstDash val="solid"/>
           </a:ln>
@@ -7229,14 +7334,14 @@
       </p:sp>
       <p:sp>
         <p:nvSpPr>
-          <p:cNvPr id="201" name="BoxText"/>
-          <p:cNvSpPr/>
-          <p:nvPr/>
-        </p:nvSpPr>
-        <p:spPr>
-          <a:xfrm>
-            <a:off x="9421472" y="3050000"/>
-            <a:ext cx="2617936" cy="750000"/>
+          <p:cNvPr id="238" name="BoxText_238"/>
+          <p:cNvSpPr/>
+          <p:nvPr/>
+        </p:nvSpPr>
+        <p:spPr>
+          <a:xfrm>
+            <a:off x="6300216" y="2889504"/>
+            <a:ext cx="1453896" cy="850392"/>
           </a:xfrm>
           <a:prstGeom prst="rect">
             <a:avLst/>
@@ -7252,7 +7357,7 @@
               <a:buNone/>
             </a:pPr>
             <a:r>
-              <a:rPr lang="en-US" sz="1200" b="1" dirty="0">
+              <a:rPr lang="en-US" sz="1300" b="1" dirty="0">
                 <a:solidFill>
                   <a:srgbClr val="000000"/>
                 </a:solidFill>
@@ -7260,7 +7365,7 @@
                 <a:ea typeface="Avenir Next LT Pro" pitchFamily="34" charset="-122"/>
                 <a:cs typeface="Avenir Next LT Pro" pitchFamily="34" charset="-120"/>
               </a:rPr>
-              <a:t>Reconcile</a:t>
+              <a:t>Publish</a:t>
             </a:r>
           </a:p>
           <a:p>
@@ -7268,7 +7373,7 @@
               <a:buNone/>
             </a:pPr>
             <a:r>
-              <a:rPr lang="en-US" sz="1050" dirty="0">
+              <a:rPr lang="en-US" sz="1150" dirty="0">
                 <a:solidFill>
                   <a:srgbClr val="000000"/>
                 </a:solidFill>
@@ -7276,115 +7381,36 @@
                 <a:ea typeface="Avenir Next LT Pro" pitchFamily="34" charset="-122"/>
                 <a:cs typeface="Avenir Next LT Pro" pitchFamily="34" charset="-120"/>
               </a:rPr>
-              <a:t>data-reconciliation</a:t>
-            </a:r>
-          </a:p>
-        </p:txBody>
-      </p:sp>
-      <p:sp>
-        <p:nvSpPr>
-          <p:cNvPr id="210" name="Line"/>
-          <p:cNvSpPr/>
-          <p:nvPr/>
-        </p:nvSpPr>
-        <p:spPr>
-          <a:xfrm>
-            <a:off x="4322320" y="3800000"/>
-            <a:ext cx="0" cy="350000"/>
-          </a:xfrm>
-          <a:prstGeom prst="line">
-            <a:avLst/>
-          </a:prstGeom>
-          <a:noFill/>
-          <a:ln w="12700">
-            <a:solidFill>
-              <a:srgbClr val="FF4D5F"/>
-            </a:solidFill>
-            <a:prstDash val="dash"/>
-          </a:ln>
-        </p:spPr>
-        <p:txBody>
-          <a:bodyPr/>
-          <a:lstStyle/>
-          <a:p>
-            <a:endParaRPr lang="en-US"/>
-          </a:p>
-        </p:txBody>
-      </p:sp>
-      <p:sp>
-        <p:nvSpPr>
-          <p:cNvPr id="212" name="Line"/>
-          <p:cNvSpPr/>
-          <p:nvPr/>
-        </p:nvSpPr>
-        <p:spPr>
-          <a:xfrm>
-            <a:off x="10730440" y="3800000"/>
-            <a:ext cx="0" cy="350000"/>
-          </a:xfrm>
-          <a:prstGeom prst="line">
-            <a:avLst/>
-          </a:prstGeom>
-          <a:noFill/>
-          <a:ln w="12700">
-            <a:solidFill>
-              <a:srgbClr val="FF4D5F"/>
-            </a:solidFill>
-            <a:prstDash val="dash"/>
-          </a:ln>
-        </p:spPr>
-        <p:txBody>
-          <a:bodyPr/>
-          <a:lstStyle/>
-          <a:p>
-            <a:endParaRPr lang="en-US"/>
-          </a:p>
-        </p:txBody>
-      </p:sp>
-      <p:pic>
-        <p:nvPicPr>
-          <p:cNvPr id="220" name="XIcon" descr="preencoded.png"/>
-          <p:cNvPicPr>
-            <a:picLocks noChangeAspect="1"/>
-          </p:cNvPicPr>
-          <p:nvPr/>
-        </p:nvPicPr>
-        <p:blipFill>
-          <a:blip r:embed="rId3"/>
-          <a:stretch>
-            <a:fillRect/>
-          </a:stretch>
-        </p:blipFill>
-        <p:spPr>
-          <a:xfrm>
-            <a:off x="4472320" y="4260000"/>
-            <a:ext cx="280000" cy="280000"/>
-          </a:xfrm>
-          <a:prstGeom prst="rect">
-            <a:avLst/>
-          </a:prstGeom>
-        </p:spPr>
-      </p:pic>
-      <p:sp>
-        <p:nvSpPr>
-          <p:cNvPr id="222" name="Banner"/>
-          <p:cNvSpPr/>
-          <p:nvPr/>
-        </p:nvSpPr>
-        <p:spPr>
-          <a:xfrm>
-            <a:off x="4322320" y="4150000"/>
-            <a:ext cx="6408120" cy="550000"/>
+              <a:t>property-creator</a:t>
+            </a:r>
+          </a:p>
+        </p:txBody>
+      </p:sp>
+      <p:sp>
+        <p:nvSpPr>
+          <p:cNvPr id="239" name="Box_239"/>
+          <p:cNvSpPr/>
+          <p:nvPr/>
+        </p:nvSpPr>
+        <p:spPr>
+          <a:xfrm>
+            <a:off x="8119872" y="2834640"/>
+            <a:ext cx="1600200" cy="960120"/>
           </a:xfrm>
           <a:prstGeom prst="roundRect">
             <a:avLst>
-              <a:gd name="adj" fmla="val 12000"/>
+              <a:gd name="adj" fmla="val 9412"/>
             </a:avLst>
           </a:prstGeom>
           <a:solidFill>
-            <a:srgbClr val="FF4D5F"/>
-          </a:solidFill>
-          <a:ln/>
+            <a:srgbClr val="F2F2F2"/>
+          </a:solidFill>
+          <a:ln w="19050">
+            <a:solidFill>
+              <a:srgbClr val="6B5CA5"/>
+            </a:solidFill>
+            <a:prstDash val="solid"/>
+          </a:ln>
         </p:spPr>
         <p:txBody>
           <a:bodyPr/>
@@ -7396,14 +7422,14 @@
       </p:sp>
       <p:sp>
         <p:nvSpPr>
-          <p:cNvPr id="224" name="BannerText"/>
-          <p:cNvSpPr/>
-          <p:nvPr/>
-        </p:nvSpPr>
-        <p:spPr>
-          <a:xfrm>
-            <a:off x="4822320" y="4150000"/>
-            <a:ext cx="5858120" cy="550000"/>
+          <p:cNvPr id="240" name="BoxText_240"/>
+          <p:cNvSpPr/>
+          <p:nvPr/>
+        </p:nvSpPr>
+        <p:spPr>
+          <a:xfrm>
+            <a:off x="8193024" y="2889504"/>
+            <a:ext cx="1453896" cy="850392"/>
           </a:xfrm>
           <a:prstGeom prst="rect">
             <a:avLst/>
@@ -7416,21 +7442,18 @@
           <a:lstStyle/>
           <a:p>
             <a:pPr marL="0" indent="0" algn="ctr">
-              <a:lnSpc>
-                <a:spcPct val="110000"/>
-              </a:lnSpc>
-              <a:buNone/>
-            </a:pPr>
-            <a:r>
-              <a:rPr lang="en-US" sz="1200" b="1" dirty="0">
-                <a:solidFill>
-                  <a:srgbClr val="FFFFFF"/>
+              <a:buNone/>
+            </a:pPr>
+            <a:r>
+              <a:rPr lang="en-US" sz="1300" b="1" dirty="0">
+                <a:solidFill>
+                  <a:srgbClr val="000000"/>
                 </a:solidFill>
                 <a:latin typeface="Avenir Next LT Pro" pitchFamily="34" charset="0"/>
                 <a:ea typeface="Avenir Next LT Pro" pitchFamily="34" charset="-122"/>
                 <a:cs typeface="Avenir Next LT Pro" pitchFamily="34" charset="-120"/>
               </a:rPr>
-              <a:t>ONE GOVERNED PIPELINE — EVERY OUTPUT FEEDS THE NEXT</a:t>
+              <a:t>Audit</a:t>
             </a:r>
           </a:p>
           <a:p>
@@ -7438,39 +7461,44 @@
               <a:buNone/>
             </a:pPr>
             <a:r>
-              <a:rPr lang="en-US" sz="1000" dirty="0">
-                <a:solidFill>
-                  <a:srgbClr val="FFFFFF"/>
+              <a:rPr lang="en-US" sz="1150" dirty="0">
+                <a:solidFill>
+                  <a:srgbClr val="000000"/>
                 </a:solidFill>
                 <a:latin typeface="Avenir Next LT Pro" pitchFamily="34" charset="0"/>
                 <a:ea typeface="Avenir Next LT Pro" pitchFamily="34" charset="-122"/>
                 <a:cs typeface="Avenir Next LT Pro" pitchFamily="34" charset="-120"/>
               </a:rPr>
-              <a:t>Detection informs the plan; the plan drives the build; the build is audited; the audit is reconciled into decisions.</a:t>
-            </a:r>
-          </a:p>
-        </p:txBody>
-      </p:sp>
-      <p:sp>
-        <p:nvSpPr>
-          <p:cNvPr id="230" name="Callout"/>
-          <p:cNvSpPr/>
-          <p:nvPr/>
-        </p:nvSpPr>
-        <p:spPr>
-          <a:xfrm>
-            <a:off x="548640" y="4950000"/>
-            <a:ext cx="11064240" cy="1000000"/>
+              <a:t>audit-builder</a:t>
+            </a:r>
+          </a:p>
+        </p:txBody>
+      </p:sp>
+      <p:sp>
+        <p:nvSpPr>
+          <p:cNvPr id="241" name="Box_241"/>
+          <p:cNvSpPr/>
+          <p:nvPr/>
+        </p:nvSpPr>
+        <p:spPr>
+          <a:xfrm>
+            <a:off x="10012680" y="2834640"/>
+            <a:ext cx="1600200" cy="960120"/>
           </a:xfrm>
           <a:prstGeom prst="roundRect">
             <a:avLst>
-              <a:gd name="adj" fmla="val 7273"/>
+              <a:gd name="adj" fmla="val 9412"/>
             </a:avLst>
           </a:prstGeom>
           <a:solidFill>
             <a:srgbClr val="F2F2F2"/>
           </a:solidFill>
-          <a:ln/>
+          <a:ln w="19050">
+            <a:solidFill>
+              <a:srgbClr val="6B5CA5"/>
+            </a:solidFill>
+            <a:prstDash val="solid"/>
+          </a:ln>
         </p:spPr>
         <p:txBody>
           <a:bodyPr/>
@@ -7482,42 +7510,44 @@
       </p:sp>
       <p:sp>
         <p:nvSpPr>
-          <p:cNvPr id="232" name="CalloutText"/>
-          <p:cNvSpPr/>
-          <p:nvPr/>
-        </p:nvSpPr>
-        <p:spPr>
-          <a:xfrm>
-            <a:off x="777240" y="4950000"/>
-            <a:ext cx="10607040" cy="1000000"/>
-          </a:xfrm>
-          <a:prstGeom prst="rect">
-            <a:avLst/>
-          </a:prstGeom>
-          <a:noFill/>
-          <a:ln/>
-        </p:spPr>
-        <p:txBody>
-          <a:bodyPr wrap="square" lIns="0" tIns="0" rIns="0" bIns="0" rtlCol="0" anchor="ctr"/>
-          <a:lstStyle/>
-          <a:p>
-            <a:pPr marL="0" indent="0">
-              <a:lnSpc>
-                <a:spcPct val="115000"/>
-              </a:lnSpc>
-              <a:buNone/>
-            </a:pPr>
-            <a:r>
-              <a:rPr lang="en-US" sz="1150" b="1" dirty="0">
-                <a:solidFill>
-                  <a:srgbClr val="002FAF"/>
+          <p:cNvPr id="242" name="BoxText_242"/>
+          <p:cNvSpPr/>
+          <p:nvPr/>
+        </p:nvSpPr>
+        <p:spPr>
+          <a:xfrm>
+            <a:off x="10085832" y="2889504"/>
+            <a:ext cx="1453896" cy="850392"/>
+          </a:xfrm>
+          <a:prstGeom prst="rect">
+            <a:avLst/>
+          </a:prstGeom>
+          <a:noFill/>
+          <a:ln/>
+        </p:spPr>
+        <p:txBody>
+          <a:bodyPr wrap="square" lIns="0" tIns="0" rIns="0" bIns="0" rtlCol="0" anchor="ctr"/>
+          <a:lstStyle/>
+          <a:p>
+            <a:pPr marL="0" indent="0" algn="ctr">
+              <a:buNone/>
+            </a:pPr>
+            <a:r>
+              <a:rPr lang="en-US" sz="1300" b="1" dirty="0">
+                <a:solidFill>
+                  <a:srgbClr val="000000"/>
                 </a:solidFill>
                 <a:latin typeface="Avenir Next LT Pro" pitchFamily="34" charset="0"/>
                 <a:ea typeface="Avenir Next LT Pro" pitchFamily="34" charset="-122"/>
                 <a:cs typeface="Avenir Next LT Pro" pitchFamily="34" charset="-120"/>
               </a:rPr>
-              <a:t>What the client gets: </a:t>
-            </a:r>
+              <a:t>Reconcile</a:t>
+            </a:r>
+          </a:p>
+          <a:p>
+            <a:pPr marL="0" indent="0" algn="ctr">
+              <a:buNone/>
+            </a:pPr>
             <a:r>
               <a:rPr lang="en-US" sz="1150" dirty="0">
                 <a:solidFill>
@@ -7527,216 +7557,148 @@
                 <a:ea typeface="Avenir Next LT Pro" pitchFamily="34" charset="-122"/>
                 <a:cs typeface="Avenir Next LT Pro" pitchFamily="34" charset="-120"/>
               </a:rPr>
-              <a:t>a documented, governed Adobe implementation — plus the evidence (audit deck + workbook) and the decisions (reconciliation workbook + email) to trust it and act.</a:t>
-            </a:r>
-            <a:endParaRPr lang="en-US" sz="1150" dirty="0"/>
-          </a:p>
-        </p:txBody>
-      </p:sp>
-      <p:sp>
-        <p:nvSpPr>
-          <p:cNvPr id="43" name="Shape 39"/>
-          <p:cNvSpPr/>
-          <p:nvPr/>
-        </p:nvSpPr>
-        <p:spPr>
-          <a:xfrm>
-            <a:off x="0" y="0"/>
-            <a:ext cx="2432304" cy="137160"/>
-          </a:xfrm>
-          <a:prstGeom prst="rect">
-            <a:avLst/>
-          </a:prstGeom>
-          <a:solidFill>
-            <a:srgbClr val="002FAF"/>
-          </a:solidFill>
-          <a:ln/>
-        </p:spPr>
-        <p:txBody>
-          <a:bodyPr/>
-          <a:lstStyle/>
-          <a:p>
-            <a:endParaRPr lang="en-US"/>
-          </a:p>
-        </p:txBody>
-      </p:sp>
-      <p:sp>
-        <p:nvSpPr>
-          <p:cNvPr id="44" name="Shape 40"/>
-          <p:cNvSpPr/>
-          <p:nvPr/>
-        </p:nvSpPr>
-        <p:spPr>
-          <a:xfrm>
-            <a:off x="2432304" y="0"/>
-            <a:ext cx="2432304" cy="137160"/>
-          </a:xfrm>
-          <a:prstGeom prst="rect">
-            <a:avLst/>
-          </a:prstGeom>
-          <a:solidFill>
-            <a:srgbClr val="0C62FB"/>
-          </a:solidFill>
-          <a:ln/>
-        </p:spPr>
-        <p:txBody>
-          <a:bodyPr/>
-          <a:lstStyle/>
-          <a:p>
-            <a:endParaRPr lang="en-US"/>
-          </a:p>
-        </p:txBody>
-      </p:sp>
-      <p:sp>
-        <p:nvSpPr>
-          <p:cNvPr id="45" name="Shape 41"/>
-          <p:cNvSpPr/>
-          <p:nvPr/>
-        </p:nvSpPr>
-        <p:spPr>
-          <a:xfrm>
-            <a:off x="4864608" y="0"/>
-            <a:ext cx="2432304" cy="137160"/>
-          </a:xfrm>
-          <a:prstGeom prst="rect">
-            <a:avLst/>
-          </a:prstGeom>
-          <a:solidFill>
-            <a:srgbClr val="1BE1F2"/>
-          </a:solidFill>
-          <a:ln/>
-        </p:spPr>
-        <p:txBody>
-          <a:bodyPr/>
-          <a:lstStyle/>
-          <a:p>
-            <a:endParaRPr lang="en-US"/>
-          </a:p>
-        </p:txBody>
-      </p:sp>
-      <p:sp>
-        <p:nvSpPr>
-          <p:cNvPr id="46" name="Shape 42"/>
-          <p:cNvSpPr/>
-          <p:nvPr/>
-        </p:nvSpPr>
-        <p:spPr>
-          <a:xfrm>
-            <a:off x="7296912" y="0"/>
-            <a:ext cx="2432304" cy="137160"/>
-          </a:xfrm>
-          <a:prstGeom prst="rect">
-            <a:avLst/>
-          </a:prstGeom>
-          <a:solidFill>
-            <a:srgbClr val="FF4D5F"/>
-          </a:solidFill>
-          <a:ln/>
-        </p:spPr>
-        <p:txBody>
-          <a:bodyPr/>
-          <a:lstStyle/>
-          <a:p>
-            <a:endParaRPr lang="en-US"/>
-          </a:p>
-        </p:txBody>
-      </p:sp>
-      <p:sp>
-        <p:nvSpPr>
-          <p:cNvPr id="47" name="Shape 43"/>
-          <p:cNvSpPr/>
-          <p:nvPr/>
-        </p:nvSpPr>
-        <p:spPr>
-          <a:xfrm>
-            <a:off x="9729216" y="0"/>
-            <a:ext cx="2432304" cy="137160"/>
-          </a:xfrm>
-          <a:prstGeom prst="rect">
-            <a:avLst/>
-          </a:prstGeom>
-          <a:solidFill>
-            <a:srgbClr val="C7B9FF"/>
-          </a:solidFill>
-          <a:ln/>
-        </p:spPr>
-        <p:txBody>
-          <a:bodyPr/>
-          <a:lstStyle/>
-          <a:p>
-            <a:endParaRPr lang="en-US"/>
-          </a:p>
-        </p:txBody>
-      </p:sp>
-      <p:sp>
-        <p:nvSpPr>
-          <p:cNvPr id="48" name="Text 44"/>
-          <p:cNvSpPr/>
-          <p:nvPr/>
-        </p:nvSpPr>
-        <p:spPr>
-          <a:xfrm>
-            <a:off x="548640" y="6446520"/>
-            <a:ext cx="7315200" cy="274320"/>
-          </a:xfrm>
-          <a:prstGeom prst="rect">
-            <a:avLst/>
-          </a:prstGeom>
-          <a:noFill/>
-          <a:ln/>
-        </p:spPr>
-        <p:txBody>
-          <a:bodyPr wrap="square" lIns="0" tIns="0" rIns="0" bIns="0" rtlCol="0" anchor="ctr"/>
-          <a:lstStyle/>
-          <a:p>
-            <a:pPr marL="0" indent="0" algn="l">
-              <a:buNone/>
-            </a:pPr>
-            <a:r>
-              <a:rPr lang="en-US" sz="750" dirty="0">
-                <a:solidFill>
-                  <a:srgbClr val="666666"/>
-                </a:solidFill>
-              </a:rPr>
-              <a:t>© Slalom. All Rights Reserved. Proprietary and Confidential.</a:t>
-            </a:r>
-            <a:endParaRPr lang="en-US" sz="750" dirty="0"/>
-          </a:p>
-        </p:txBody>
-      </p:sp>
-      <p:sp>
-        <p:nvSpPr>
-          <p:cNvPr id="49" name="Text 45"/>
-          <p:cNvSpPr/>
-          <p:nvPr/>
-        </p:nvSpPr>
-        <p:spPr>
-          <a:xfrm>
-            <a:off x="11521440" y="6446520"/>
-            <a:ext cx="365760" cy="274320"/>
-          </a:xfrm>
-          <a:prstGeom prst="rect">
-            <a:avLst/>
-          </a:prstGeom>
-          <a:noFill/>
-          <a:ln/>
-        </p:spPr>
-        <p:txBody>
-          <a:bodyPr wrap="square" lIns="0" tIns="0" rIns="0" bIns="0" rtlCol="0" anchor="ctr"/>
-          <a:lstStyle/>
-          <a:p>
-            <a:pPr marL="0" indent="0" algn="r">
-              <a:buNone/>
-            </a:pPr>
-            <a:r>
-              <a:rPr lang="en-US" sz="1000" dirty="0">
-                <a:solidFill>
-                  <a:srgbClr val="666666"/>
-                </a:solidFill>
-              </a:rPr>
-              <a:t>6</a:t>
-            </a:r>
-            <a:endParaRPr lang="en-US" sz="1000" dirty="0"/>
+              <a:t>reconciliation</a:t>
+            </a:r>
+          </a:p>
+        </p:txBody>
+      </p:sp>
+      <p:sp>
+        <p:nvSpPr>
+          <p:cNvPr id="243" name="Arrow_243"/>
+          <p:cNvSpPr/>
+          <p:nvPr/>
+        </p:nvSpPr>
+        <p:spPr>
+          <a:xfrm>
+            <a:off x="4041648" y="2852928"/>
+            <a:ext cx="292608" cy="960120"/>
+          </a:xfrm>
+          <a:prstGeom prst="rect">
+            <a:avLst/>
+          </a:prstGeom>
+          <a:noFill/>
+          <a:ln/>
+        </p:spPr>
+        <p:txBody>
+          <a:bodyPr wrap="square" lIns="0" tIns="0" rIns="0" bIns="0" rtlCol="0" anchor="ctr"/>
+          <a:lstStyle/>
+          <a:p>
+            <a:pPr marL="0" indent="0" algn="ctr">
+              <a:buNone/>
+            </a:pPr>
+            <a:r>
+              <a:rPr lang="en-US" sz="1600" b="1" dirty="0">
+                <a:solidFill>
+                  <a:srgbClr val="6B5CA5"/>
+                </a:solidFill>
+              </a:rPr>
+              <a:t>→</a:t>
+            </a:r>
+          </a:p>
+        </p:txBody>
+      </p:sp>
+      <p:sp>
+        <p:nvSpPr>
+          <p:cNvPr id="244" name="Arrow_244"/>
+          <p:cNvSpPr/>
+          <p:nvPr/>
+        </p:nvSpPr>
+        <p:spPr>
+          <a:xfrm>
+            <a:off x="5934456" y="2852928"/>
+            <a:ext cx="292608" cy="960120"/>
+          </a:xfrm>
+          <a:prstGeom prst="rect">
+            <a:avLst/>
+          </a:prstGeom>
+          <a:noFill/>
+          <a:ln/>
+        </p:spPr>
+        <p:txBody>
+          <a:bodyPr wrap="square" lIns="0" tIns="0" rIns="0" bIns="0" rtlCol="0" anchor="ctr"/>
+          <a:lstStyle/>
+          <a:p>
+            <a:pPr marL="0" indent="0" algn="ctr">
+              <a:buNone/>
+            </a:pPr>
+            <a:r>
+              <a:rPr lang="en-US" sz="1600" b="1" dirty="0">
+                <a:solidFill>
+                  <a:srgbClr val="6B5CA5"/>
+                </a:solidFill>
+              </a:rPr>
+              <a:t>→</a:t>
+            </a:r>
+          </a:p>
+        </p:txBody>
+      </p:sp>
+      <p:sp>
+        <p:nvSpPr>
+          <p:cNvPr id="245" name="Arrow_245"/>
+          <p:cNvSpPr/>
+          <p:nvPr/>
+        </p:nvSpPr>
+        <p:spPr>
+          <a:xfrm>
+            <a:off x="7827264" y="2852928"/>
+            <a:ext cx="292608" cy="960120"/>
+          </a:xfrm>
+          <a:prstGeom prst="rect">
+            <a:avLst/>
+          </a:prstGeom>
+          <a:noFill/>
+          <a:ln/>
+        </p:spPr>
+        <p:txBody>
+          <a:bodyPr wrap="square" lIns="0" tIns="0" rIns="0" bIns="0" rtlCol="0" anchor="ctr"/>
+          <a:lstStyle/>
+          <a:p>
+            <a:pPr marL="0" indent="0" algn="ctr">
+              <a:buNone/>
+            </a:pPr>
+            <a:r>
+              <a:rPr lang="en-US" sz="1600" b="1" dirty="0">
+                <a:solidFill>
+                  <a:srgbClr val="6B5CA5"/>
+                </a:solidFill>
+              </a:rPr>
+              <a:t>→</a:t>
+            </a:r>
+          </a:p>
+        </p:txBody>
+      </p:sp>
+      <p:sp>
+        <p:nvSpPr>
+          <p:cNvPr id="246" name="Arrow_246"/>
+          <p:cNvSpPr/>
+          <p:nvPr/>
+        </p:nvSpPr>
+        <p:spPr>
+          <a:xfrm>
+            <a:off x="9720072" y="2852928"/>
+            <a:ext cx="292608" cy="960120"/>
+          </a:xfrm>
+          <a:prstGeom prst="rect">
+            <a:avLst/>
+          </a:prstGeom>
+          <a:noFill/>
+          <a:ln/>
+        </p:spPr>
+        <p:txBody>
+          <a:bodyPr wrap="square" lIns="0" tIns="0" rIns="0" bIns="0" rtlCol="0" anchor="ctr"/>
+          <a:lstStyle/>
+          <a:p>
+            <a:pPr marL="0" indent="0" algn="ctr">
+              <a:buNone/>
+            </a:pPr>
+            <a:r>
+              <a:rPr lang="en-US" sz="1600" b="1" dirty="0">
+                <a:solidFill>
+                  <a:srgbClr val="6B5CA5"/>
+                </a:solidFill>
+              </a:rPr>
+              <a:t>→</a:t>
+            </a:r>
           </a:p>
         </p:txBody>
       </p:sp>

</xml_diff>

<commit_message>
Add premium icon-and-pill visuals to suite deck
Applies an icon-in-circle + colored outcome-pill treatment (in the light Slalom
palette) to the suite deck:

- Value slide: each row now has a brand-colored icon circle (speed / governance /
  evidence) on the left and a colored outcome pill on the right
  ("Faster delivery" / "Consistent & governed" / "Defensible & repeatable").
- Deliverables slide: the plain markers become brand-colored icon circles
  (SDR/XDM, property, audit, workbook, email).

Icons are crisp Feather glyphs rendered to PNG. Shape positions are computed for
non-overlap.

Co-Authored-By: Claude Fable 5 <noreply@anthropic.com>
Claude-Session: https://claude.ai/code/session_01L22pJWjoypJEHfB9cqhWZF
</commit_message>
<xml_diff>
--- a/websdk-property/docs/adobe-data-collection-skills-suite.pptx
+++ b/websdk-property/docs/adobe-data-collection-skills-suite.pptx
@@ -4159,8 +4159,8 @@
         </p:nvSpPr>
         <p:spPr>
           <a:xfrm>
-            <a:off x="777240" y="1382880"/>
-            <a:ext cx="10607040" cy="256032"/>
+            <a:off x="1783080" y="1382880"/>
+            <a:ext cx="6537960" cy="256032"/>
           </a:xfrm>
           <a:prstGeom prst="rect">
             <a:avLst/>
@@ -4198,8 +4198,8 @@
         </p:nvSpPr>
         <p:spPr>
           <a:xfrm>
-            <a:off x="777240" y="1702920"/>
-            <a:ext cx="10607040" cy="1009920"/>
+            <a:off x="1783080" y="1702920"/>
+            <a:ext cx="6537960" cy="1009920"/>
           </a:xfrm>
           <a:prstGeom prst="rect">
             <a:avLst/>
@@ -4272,8 +4272,8 @@
         </p:nvSpPr>
         <p:spPr>
           <a:xfrm>
-            <a:off x="777240" y="3232880"/>
-            <a:ext cx="10607040" cy="256032"/>
+            <a:off x="1783080" y="3232880"/>
+            <a:ext cx="6537960" cy="256032"/>
           </a:xfrm>
           <a:prstGeom prst="rect">
             <a:avLst/>
@@ -4311,8 +4311,8 @@
         </p:nvSpPr>
         <p:spPr>
           <a:xfrm>
-            <a:off x="777240" y="3552920"/>
-            <a:ext cx="10607040" cy="1009920"/>
+            <a:off x="1783080" y="3552920"/>
+            <a:ext cx="6537960" cy="1009920"/>
           </a:xfrm>
           <a:prstGeom prst="rect">
             <a:avLst/>
@@ -4385,8 +4385,8 @@
         </p:nvSpPr>
         <p:spPr>
           <a:xfrm>
-            <a:off x="777240" y="4982880"/>
-            <a:ext cx="10607040" cy="256032"/>
+            <a:off x="1783080" y="4982880"/>
+            <a:ext cx="6537960" cy="256032"/>
           </a:xfrm>
           <a:prstGeom prst="rect">
             <a:avLst/>
@@ -4424,8 +4424,8 @@
         </p:nvSpPr>
         <p:spPr>
           <a:xfrm>
-            <a:off x="777240" y="5302920"/>
-            <a:ext cx="10607040" cy="909920"/>
+            <a:off x="1783080" y="5302920"/>
+            <a:ext cx="6537960" cy="909920"/>
           </a:xfrm>
           <a:prstGeom prst="rect">
             <a:avLst/>
@@ -4662,6 +4662,375 @@
                 </a:solidFill>
               </a:rPr>
               <a:t>4</a:t>
+            </a:r>
+          </a:p>
+        </p:txBody>
+      </p:sp>
+      <p:sp>
+        <p:nvSpPr>
+          <p:cNvPr id="207" name="Oval 206"/>
+          <p:cNvSpPr/>
+          <p:nvPr/>
+        </p:nvSpPr>
+        <p:spPr>
+          <a:xfrm>
+            <a:off x="777240" y="1682496"/>
+            <a:ext cx="777240" cy="777240"/>
+          </a:xfrm>
+          <a:prstGeom prst="ellipse">
+            <a:avLst/>
+          </a:prstGeom>
+          <a:solidFill>
+            <a:srgbClr val="002FAF"/>
+          </a:solidFill>
+          <a:ln>
+            <a:noFill/>
+          </a:ln>
+          <a:effectLst/>
+        </p:spPr>
+        <p:style>
+          <a:lnRef idx="1">
+            <a:schemeClr val="accent1"/>
+          </a:lnRef>
+          <a:fillRef idx="3">
+            <a:schemeClr val="accent1"/>
+          </a:fillRef>
+          <a:effectRef idx="2">
+            <a:schemeClr val="accent1"/>
+          </a:effectRef>
+          <a:fontRef idx="minor">
+            <a:schemeClr val="lt1"/>
+          </a:fontRef>
+        </p:style>
+        <p:txBody>
+          <a:bodyPr rtlCol="0" anchor="ctr"/>
+          <a:lstStyle/>
+          <a:p>
+            <a:pPr algn="ctr"/>
+          </a:p>
+        </p:txBody>
+      </p:sp>
+      <p:pic>
+        <p:nvPicPr>
+          <p:cNvPr id="208" name="Picture 207" descr="icon_zap.png"/>
+          <p:cNvPicPr>
+            <a:picLocks noChangeAspect="1"/>
+          </p:cNvPicPr>
+          <p:nvPr/>
+        </p:nvPicPr>
+        <p:blipFill>
+          <a:blip r:embed="rId3"/>
+          <a:stretch>
+            <a:fillRect/>
+          </a:stretch>
+        </p:blipFill>
+        <p:spPr>
+          <a:xfrm>
+            <a:off x="952119" y="1857375"/>
+            <a:ext cx="427482" cy="427482"/>
+          </a:xfrm>
+          <a:prstGeom prst="rect">
+            <a:avLst/>
+          </a:prstGeom>
+        </p:spPr>
+      </p:pic>
+      <p:sp>
+        <p:nvSpPr>
+          <p:cNvPr id="209" name="Rounded Rectangle 208"/>
+          <p:cNvSpPr/>
+          <p:nvPr/>
+        </p:nvSpPr>
+        <p:spPr>
+          <a:xfrm>
+            <a:off x="8686800" y="1659636"/>
+            <a:ext cx="2788920" cy="822960"/>
+          </a:xfrm>
+          <a:prstGeom prst="roundRect">
+            <a:avLst>
+              <a:gd name="adj" fmla="val 22000"/>
+            </a:avLst>
+          </a:prstGeom>
+          <a:solidFill>
+            <a:srgbClr val="002FAF"/>
+          </a:solidFill>
+          <a:ln>
+            <a:noFill/>
+          </a:ln>
+          <a:effectLst/>
+        </p:spPr>
+        <p:style>
+          <a:lnRef idx="1">
+            <a:schemeClr val="accent1"/>
+          </a:lnRef>
+          <a:fillRef idx="3">
+            <a:schemeClr val="accent1"/>
+          </a:fillRef>
+          <a:effectRef idx="2">
+            <a:schemeClr val="accent1"/>
+          </a:effectRef>
+          <a:fontRef idx="minor">
+            <a:schemeClr val="lt1"/>
+          </a:fontRef>
+        </p:style>
+        <p:txBody>
+          <a:bodyPr rtlCol="0" anchor="ctr" wrap="square" lIns="54864" rIns="54864" tIns="18288" bIns="18288"/>
+          <a:lstStyle/>
+          <a:p>
+            <a:pPr algn="ctr"/>
+            <a:r>
+              <a:rPr b="1" sz="1200">
+                <a:solidFill>
+                  <a:srgbClr val="FFFFFF"/>
+                </a:solidFill>
+                <a:latin typeface="Calibri"/>
+              </a:rPr>
+              <a:t>Faster delivery</a:t>
+            </a:r>
+          </a:p>
+        </p:txBody>
+      </p:sp>
+      <p:sp>
+        <p:nvSpPr>
+          <p:cNvPr id="210" name="Oval 209"/>
+          <p:cNvSpPr/>
+          <p:nvPr/>
+        </p:nvSpPr>
+        <p:spPr>
+          <a:xfrm>
+            <a:off x="777240" y="3488436"/>
+            <a:ext cx="777240" cy="777240"/>
+          </a:xfrm>
+          <a:prstGeom prst="ellipse">
+            <a:avLst/>
+          </a:prstGeom>
+          <a:solidFill>
+            <a:srgbClr val="0C62FB"/>
+          </a:solidFill>
+          <a:ln>
+            <a:noFill/>
+          </a:ln>
+          <a:effectLst/>
+        </p:spPr>
+        <p:style>
+          <a:lnRef idx="1">
+            <a:schemeClr val="accent1"/>
+          </a:lnRef>
+          <a:fillRef idx="3">
+            <a:schemeClr val="accent1"/>
+          </a:fillRef>
+          <a:effectRef idx="2">
+            <a:schemeClr val="accent1"/>
+          </a:effectRef>
+          <a:fontRef idx="minor">
+            <a:schemeClr val="lt1"/>
+          </a:fontRef>
+        </p:style>
+        <p:txBody>
+          <a:bodyPr rtlCol="0" anchor="ctr"/>
+          <a:lstStyle/>
+          <a:p>
+            <a:pPr algn="ctr"/>
+          </a:p>
+        </p:txBody>
+      </p:sp>
+      <p:pic>
+        <p:nvPicPr>
+          <p:cNvPr id="211" name="Picture 210" descr="icon_shield.png"/>
+          <p:cNvPicPr>
+            <a:picLocks noChangeAspect="1"/>
+          </p:cNvPicPr>
+          <p:nvPr/>
+        </p:nvPicPr>
+        <p:blipFill>
+          <a:blip r:embed="rId4"/>
+          <a:stretch>
+            <a:fillRect/>
+          </a:stretch>
+        </p:blipFill>
+        <p:spPr>
+          <a:xfrm>
+            <a:off x="952119" y="3663314"/>
+            <a:ext cx="427482" cy="427482"/>
+          </a:xfrm>
+          <a:prstGeom prst="rect">
+            <a:avLst/>
+          </a:prstGeom>
+        </p:spPr>
+      </p:pic>
+      <p:sp>
+        <p:nvSpPr>
+          <p:cNvPr id="212" name="Rounded Rectangle 211"/>
+          <p:cNvSpPr/>
+          <p:nvPr/>
+        </p:nvSpPr>
+        <p:spPr>
+          <a:xfrm>
+            <a:off x="8686800" y="3465576"/>
+            <a:ext cx="2788920" cy="822960"/>
+          </a:xfrm>
+          <a:prstGeom prst="roundRect">
+            <a:avLst>
+              <a:gd name="adj" fmla="val 22000"/>
+            </a:avLst>
+          </a:prstGeom>
+          <a:solidFill>
+            <a:srgbClr val="0C62FB"/>
+          </a:solidFill>
+          <a:ln>
+            <a:noFill/>
+          </a:ln>
+          <a:effectLst/>
+        </p:spPr>
+        <p:style>
+          <a:lnRef idx="1">
+            <a:schemeClr val="accent1"/>
+          </a:lnRef>
+          <a:fillRef idx="3">
+            <a:schemeClr val="accent1"/>
+          </a:fillRef>
+          <a:effectRef idx="2">
+            <a:schemeClr val="accent1"/>
+          </a:effectRef>
+          <a:fontRef idx="minor">
+            <a:schemeClr val="lt1"/>
+          </a:fontRef>
+        </p:style>
+        <p:txBody>
+          <a:bodyPr rtlCol="0" anchor="ctr" wrap="square" lIns="54864" rIns="54864" tIns="18288" bIns="18288"/>
+          <a:lstStyle/>
+          <a:p>
+            <a:pPr algn="ctr"/>
+            <a:r>
+              <a:rPr b="1" sz="1200">
+                <a:solidFill>
+                  <a:srgbClr val="FFFFFF"/>
+                </a:solidFill>
+                <a:latin typeface="Calibri"/>
+              </a:rPr>
+              <a:t>Consistent &amp; governed</a:t>
+            </a:r>
+          </a:p>
+        </p:txBody>
+      </p:sp>
+      <p:sp>
+        <p:nvSpPr>
+          <p:cNvPr id="213" name="Oval 212"/>
+          <p:cNvSpPr/>
+          <p:nvPr/>
+        </p:nvSpPr>
+        <p:spPr>
+          <a:xfrm>
+            <a:off x="777240" y="5189220"/>
+            <a:ext cx="777240" cy="777240"/>
+          </a:xfrm>
+          <a:prstGeom prst="ellipse">
+            <a:avLst/>
+          </a:prstGeom>
+          <a:solidFill>
+            <a:srgbClr val="0E8FA0"/>
+          </a:solidFill>
+          <a:ln>
+            <a:noFill/>
+          </a:ln>
+          <a:effectLst/>
+        </p:spPr>
+        <p:style>
+          <a:lnRef idx="1">
+            <a:schemeClr val="accent1"/>
+          </a:lnRef>
+          <a:fillRef idx="3">
+            <a:schemeClr val="accent1"/>
+          </a:fillRef>
+          <a:effectRef idx="2">
+            <a:schemeClr val="accent1"/>
+          </a:effectRef>
+          <a:fontRef idx="minor">
+            <a:schemeClr val="lt1"/>
+          </a:fontRef>
+        </p:style>
+        <p:txBody>
+          <a:bodyPr rtlCol="0" anchor="ctr"/>
+          <a:lstStyle/>
+          <a:p>
+            <a:pPr algn="ctr"/>
+          </a:p>
+        </p:txBody>
+      </p:sp>
+      <p:pic>
+        <p:nvPicPr>
+          <p:cNvPr id="214" name="Picture 213" descr="icon_award.png"/>
+          <p:cNvPicPr>
+            <a:picLocks noChangeAspect="1"/>
+          </p:cNvPicPr>
+          <p:nvPr/>
+        </p:nvPicPr>
+        <p:blipFill>
+          <a:blip r:embed="rId5"/>
+          <a:stretch>
+            <a:fillRect/>
+          </a:stretch>
+        </p:blipFill>
+        <p:spPr>
+          <a:xfrm>
+            <a:off x="952119" y="5364099"/>
+            <a:ext cx="427482" cy="427482"/>
+          </a:xfrm>
+          <a:prstGeom prst="rect">
+            <a:avLst/>
+          </a:prstGeom>
+        </p:spPr>
+      </p:pic>
+      <p:sp>
+        <p:nvSpPr>
+          <p:cNvPr id="215" name="Rounded Rectangle 214"/>
+          <p:cNvSpPr/>
+          <p:nvPr/>
+        </p:nvSpPr>
+        <p:spPr>
+          <a:xfrm>
+            <a:off x="8686800" y="5166360"/>
+            <a:ext cx="2788920" cy="822960"/>
+          </a:xfrm>
+          <a:prstGeom prst="roundRect">
+            <a:avLst>
+              <a:gd name="adj" fmla="val 22000"/>
+            </a:avLst>
+          </a:prstGeom>
+          <a:solidFill>
+            <a:srgbClr val="0E8FA0"/>
+          </a:solidFill>
+          <a:ln>
+            <a:noFill/>
+          </a:ln>
+          <a:effectLst/>
+        </p:spPr>
+        <p:style>
+          <a:lnRef idx="1">
+            <a:schemeClr val="accent1"/>
+          </a:lnRef>
+          <a:fillRef idx="3">
+            <a:schemeClr val="accent1"/>
+          </a:fillRef>
+          <a:effectRef idx="2">
+            <a:schemeClr val="accent1"/>
+          </a:effectRef>
+          <a:fontRef idx="minor">
+            <a:schemeClr val="lt1"/>
+          </a:fontRef>
+        </p:style>
+        <p:txBody>
+          <a:bodyPr rtlCol="0" anchor="ctr" wrap="square" lIns="54864" rIns="54864" tIns="18288" bIns="18288"/>
+          <a:lstStyle/>
+          <a:p>
+            <a:pPr algn="ctr"/>
+            <a:r>
+              <a:rPr b="1" sz="1200">
+                <a:solidFill>
+                  <a:srgbClr val="FFFFFF"/>
+                </a:solidFill>
+                <a:latin typeface="Calibri"/>
+              </a:rPr>
+              <a:t>Defensible &amp; repeatable</a:t>
             </a:r>
           </a:p>
         </p:txBody>
@@ -8750,6 +9119,346 @@
           </a:p>
         </p:txBody>
       </p:sp>
+      <p:sp>
+        <p:nvSpPr>
+          <p:cNvPr id="152" name="Oval 151"/>
+          <p:cNvSpPr/>
+          <p:nvPr/>
+        </p:nvSpPr>
+        <p:spPr>
+          <a:xfrm>
+            <a:off x="548640" y="3809827"/>
+            <a:ext cx="310896" cy="310896"/>
+          </a:xfrm>
+          <a:prstGeom prst="ellipse">
+            <a:avLst/>
+          </a:prstGeom>
+          <a:solidFill>
+            <a:srgbClr val="0C62FB"/>
+          </a:solidFill>
+          <a:ln>
+            <a:noFill/>
+          </a:ln>
+          <a:effectLst/>
+        </p:spPr>
+        <p:style>
+          <a:lnRef idx="1">
+            <a:schemeClr val="accent1"/>
+          </a:lnRef>
+          <a:fillRef idx="3">
+            <a:schemeClr val="accent1"/>
+          </a:fillRef>
+          <a:effectRef idx="2">
+            <a:schemeClr val="accent1"/>
+          </a:effectRef>
+          <a:fontRef idx="minor">
+            <a:schemeClr val="lt1"/>
+          </a:fontRef>
+        </p:style>
+        <p:txBody>
+          <a:bodyPr rtlCol="0" anchor="ctr"/>
+          <a:lstStyle/>
+          <a:p>
+            <a:pPr algn="ctr"/>
+          </a:p>
+        </p:txBody>
+      </p:sp>
+      <p:pic>
+        <p:nvPicPr>
+          <p:cNvPr id="153" name="Picture 152" descr="icon_file.png"/>
+          <p:cNvPicPr>
+            <a:picLocks noChangeAspect="1"/>
+          </p:cNvPicPr>
+          <p:nvPr/>
+        </p:nvPicPr>
+        <p:blipFill>
+          <a:blip r:embed="rId3"/>
+          <a:stretch>
+            <a:fillRect/>
+          </a:stretch>
+        </p:blipFill>
+        <p:spPr>
+          <a:xfrm>
+            <a:off x="617037" y="3878224"/>
+            <a:ext cx="174101" cy="174101"/>
+          </a:xfrm>
+          <a:prstGeom prst="rect">
+            <a:avLst/>
+          </a:prstGeom>
+        </p:spPr>
+      </p:pic>
+      <p:sp>
+        <p:nvSpPr>
+          <p:cNvPr id="154" name="Oval 153"/>
+          <p:cNvSpPr/>
+          <p:nvPr/>
+        </p:nvSpPr>
+        <p:spPr>
+          <a:xfrm>
+            <a:off x="548640" y="4325344"/>
+            <a:ext cx="310896" cy="310896"/>
+          </a:xfrm>
+          <a:prstGeom prst="ellipse">
+            <a:avLst/>
+          </a:prstGeom>
+          <a:solidFill>
+            <a:srgbClr val="0C62FB"/>
+          </a:solidFill>
+          <a:ln>
+            <a:noFill/>
+          </a:ln>
+          <a:effectLst/>
+        </p:spPr>
+        <p:style>
+          <a:lnRef idx="1">
+            <a:schemeClr val="accent1"/>
+          </a:lnRef>
+          <a:fillRef idx="3">
+            <a:schemeClr val="accent1"/>
+          </a:fillRef>
+          <a:effectRef idx="2">
+            <a:schemeClr val="accent1"/>
+          </a:effectRef>
+          <a:fontRef idx="minor">
+            <a:schemeClr val="lt1"/>
+          </a:fontRef>
+        </p:style>
+        <p:txBody>
+          <a:bodyPr rtlCol="0" anchor="ctr"/>
+          <a:lstStyle/>
+          <a:p>
+            <a:pPr algn="ctr"/>
+          </a:p>
+        </p:txBody>
+      </p:sp>
+      <p:pic>
+        <p:nvPicPr>
+          <p:cNvPr id="155" name="Picture 154" descr="icon_server.png"/>
+          <p:cNvPicPr>
+            <a:picLocks noChangeAspect="1"/>
+          </p:cNvPicPr>
+          <p:nvPr/>
+        </p:nvPicPr>
+        <p:blipFill>
+          <a:blip r:embed="rId4"/>
+          <a:stretch>
+            <a:fillRect/>
+          </a:stretch>
+        </p:blipFill>
+        <p:spPr>
+          <a:xfrm>
+            <a:off x="617037" y="4393741"/>
+            <a:ext cx="174101" cy="174101"/>
+          </a:xfrm>
+          <a:prstGeom prst="rect">
+            <a:avLst/>
+          </a:prstGeom>
+        </p:spPr>
+      </p:pic>
+      <p:sp>
+        <p:nvSpPr>
+          <p:cNvPr id="156" name="Oval 155"/>
+          <p:cNvSpPr/>
+          <p:nvPr/>
+        </p:nvSpPr>
+        <p:spPr>
+          <a:xfrm>
+            <a:off x="6263640" y="3782015"/>
+            <a:ext cx="310896" cy="310896"/>
+          </a:xfrm>
+          <a:prstGeom prst="ellipse">
+            <a:avLst/>
+          </a:prstGeom>
+          <a:solidFill>
+            <a:srgbClr val="0E8FA0"/>
+          </a:solidFill>
+          <a:ln>
+            <a:noFill/>
+          </a:ln>
+          <a:effectLst/>
+        </p:spPr>
+        <p:style>
+          <a:lnRef idx="1">
+            <a:schemeClr val="accent1"/>
+          </a:lnRef>
+          <a:fillRef idx="3">
+            <a:schemeClr val="accent1"/>
+          </a:fillRef>
+          <a:effectRef idx="2">
+            <a:schemeClr val="accent1"/>
+          </a:effectRef>
+          <a:fontRef idx="minor">
+            <a:schemeClr val="lt1"/>
+          </a:fontRef>
+        </p:style>
+        <p:txBody>
+          <a:bodyPr rtlCol="0" anchor="ctr"/>
+          <a:lstStyle/>
+          <a:p>
+            <a:pPr algn="ctr"/>
+          </a:p>
+        </p:txBody>
+      </p:sp>
+      <p:pic>
+        <p:nvPicPr>
+          <p:cNvPr id="157" name="Picture 156" descr="icon_search.png"/>
+          <p:cNvPicPr>
+            <a:picLocks noChangeAspect="1"/>
+          </p:cNvPicPr>
+          <p:nvPr/>
+        </p:nvPicPr>
+        <p:blipFill>
+          <a:blip r:embed="rId5"/>
+          <a:stretch>
+            <a:fillRect/>
+          </a:stretch>
+        </p:blipFill>
+        <p:spPr>
+          <a:xfrm>
+            <a:off x="6332037" y="3850413"/>
+            <a:ext cx="174101" cy="174101"/>
+          </a:xfrm>
+          <a:prstGeom prst="rect">
+            <a:avLst/>
+          </a:prstGeom>
+        </p:spPr>
+      </p:pic>
+      <p:sp>
+        <p:nvSpPr>
+          <p:cNvPr id="158" name="Oval 157"/>
+          <p:cNvSpPr/>
+          <p:nvPr/>
+        </p:nvSpPr>
+        <p:spPr>
+          <a:xfrm>
+            <a:off x="6263640" y="4282016"/>
+            <a:ext cx="310896" cy="310896"/>
+          </a:xfrm>
+          <a:prstGeom prst="ellipse">
+            <a:avLst/>
+          </a:prstGeom>
+          <a:solidFill>
+            <a:srgbClr val="0E8FA0"/>
+          </a:solidFill>
+          <a:ln>
+            <a:noFill/>
+          </a:ln>
+          <a:effectLst/>
+        </p:spPr>
+        <p:style>
+          <a:lnRef idx="1">
+            <a:schemeClr val="accent1"/>
+          </a:lnRef>
+          <a:fillRef idx="3">
+            <a:schemeClr val="accent1"/>
+          </a:fillRef>
+          <a:effectRef idx="2">
+            <a:schemeClr val="accent1"/>
+          </a:effectRef>
+          <a:fontRef idx="minor">
+            <a:schemeClr val="lt1"/>
+          </a:fontRef>
+        </p:style>
+        <p:txBody>
+          <a:bodyPr rtlCol="0" anchor="ctr"/>
+          <a:lstStyle/>
+          <a:p>
+            <a:pPr algn="ctr"/>
+          </a:p>
+        </p:txBody>
+      </p:sp>
+      <p:pic>
+        <p:nvPicPr>
+          <p:cNvPr id="159" name="Picture 158" descr="icon_grid.png"/>
+          <p:cNvPicPr>
+            <a:picLocks noChangeAspect="1"/>
+          </p:cNvPicPr>
+          <p:nvPr/>
+        </p:nvPicPr>
+        <p:blipFill>
+          <a:blip r:embed="rId6"/>
+          <a:stretch>
+            <a:fillRect/>
+          </a:stretch>
+        </p:blipFill>
+        <p:spPr>
+          <a:xfrm>
+            <a:off x="6332037" y="4350413"/>
+            <a:ext cx="174101" cy="174101"/>
+          </a:xfrm>
+          <a:prstGeom prst="rect">
+            <a:avLst/>
+          </a:prstGeom>
+        </p:spPr>
+      </p:pic>
+      <p:sp>
+        <p:nvSpPr>
+          <p:cNvPr id="160" name="Oval 159"/>
+          <p:cNvSpPr/>
+          <p:nvPr/>
+        </p:nvSpPr>
+        <p:spPr>
+          <a:xfrm>
+            <a:off x="6263640" y="4882016"/>
+            <a:ext cx="310896" cy="310896"/>
+          </a:xfrm>
+          <a:prstGeom prst="ellipse">
+            <a:avLst/>
+          </a:prstGeom>
+          <a:solidFill>
+            <a:srgbClr val="0E8FA0"/>
+          </a:solidFill>
+          <a:ln>
+            <a:noFill/>
+          </a:ln>
+          <a:effectLst/>
+        </p:spPr>
+        <p:style>
+          <a:lnRef idx="1">
+            <a:schemeClr val="accent1"/>
+          </a:lnRef>
+          <a:fillRef idx="3">
+            <a:schemeClr val="accent1"/>
+          </a:fillRef>
+          <a:effectRef idx="2">
+            <a:schemeClr val="accent1"/>
+          </a:effectRef>
+          <a:fontRef idx="minor">
+            <a:schemeClr val="lt1"/>
+          </a:fontRef>
+        </p:style>
+        <p:txBody>
+          <a:bodyPr rtlCol="0" anchor="ctr"/>
+          <a:lstStyle/>
+          <a:p>
+            <a:pPr algn="ctr"/>
+          </a:p>
+        </p:txBody>
+      </p:sp>
+      <p:pic>
+        <p:nvPicPr>
+          <p:cNvPr id="161" name="Picture 160" descr="icon_mail.png"/>
+          <p:cNvPicPr>
+            <a:picLocks noChangeAspect="1"/>
+          </p:cNvPicPr>
+          <p:nvPr/>
+        </p:nvPicPr>
+        <p:blipFill>
+          <a:blip r:embed="rId7"/>
+          <a:stretch>
+            <a:fillRect/>
+          </a:stretch>
+        </p:blipFill>
+        <p:spPr>
+          <a:xfrm>
+            <a:off x="6332037" y="4950413"/>
+            <a:ext cx="174101" cy="174101"/>
+          </a:xfrm>
+          <a:prstGeom prst="rect">
+            <a:avLst/>
+          </a:prstGeom>
+        </p:spPr>
+      </p:pic>
     </p:spTree>
   </p:cSld>
   <p:clrMapOvr>

</xml_diff>

<commit_message>
Replace suite pipeline diagram with a rendered premium graphic
Slide 6's diagram is now a high-resolution rendered graphic (Slalom palette,
BUILD/ASSURE phase containers, icon cards per skill, connector arrows, banner and
callout) embedded as an image, replacing the shape-based version. Rendered from
HTML via headless Chromium and visually verified before embedding.

Co-Authored-By: Claude Fable 5 <noreply@anthropic.com>
Claude-Session: https://claude.ai/code/session_01L22pJWjoypJEHfB9cqhWZF
</commit_message>
<xml_diff>
--- a/websdk-property/docs/adobe-data-collection-skills-suite.pptx
+++ b/websdk-property/docs/adobe-data-collection-skills-suite.pptx
@@ -6823,469 +6823,6 @@
       </p:sp>
       <p:sp>
         <p:nvSpPr>
-          <p:cNvPr id="101" name="BoxText"/>
-          <p:cNvSpPr/>
-          <p:nvPr/>
-        </p:nvSpPr>
-        <p:spPr>
-          <a:xfrm>
-            <a:off x="548640" y="1572768"/>
-            <a:ext cx="11064240" cy="365760"/>
-          </a:xfrm>
-          <a:prstGeom prst="rect">
-            <a:avLst/>
-          </a:prstGeom>
-          <a:noFill/>
-          <a:ln/>
-        </p:spPr>
-        <p:txBody>
-          <a:bodyPr wrap="square" lIns="0" tIns="0" rIns="0" bIns="0" rtlCol="0" anchor="ctr"/>
-          <a:lstStyle/>
-          <a:p>
-            <a:pPr marL="0" indent="0" algn="ctr">
-              <a:buNone/>
-            </a:pPr>
-            <a:r>
-              <a:rPr lang="en-US" sz="1300" b="1" dirty="0">
-                <a:solidFill>
-                  <a:srgbClr val="000000"/>
-                </a:solidFill>
-                <a:latin typeface="Avenir Next LT Pro" pitchFamily="34" charset="0"/>
-                <a:ea typeface="Avenir Next LT Pro" pitchFamily="34" charset="-122"/>
-                <a:cs typeface="Avenir Next LT Pro" pitchFamily="34" charset="-120"/>
-              </a:rPr>
-              <a:t>Starts from the client's live site — inspected directly. Then each stage feeds the next, and every output is a client-ready artifact.</a:t>
-            </a:r>
-          </a:p>
-        </p:txBody>
-      </p:sp>
-      <p:sp>
-        <p:nvSpPr>
-          <p:cNvPr id="120" name="Label"/>
-          <p:cNvSpPr/>
-          <p:nvPr/>
-        </p:nvSpPr>
-        <p:spPr>
-          <a:xfrm>
-            <a:off x="548640" y="2331720"/>
-            <a:ext cx="7278624" cy="320040"/>
-          </a:xfrm>
-          <a:prstGeom prst="roundRect">
-            <a:avLst>
-              <a:gd name="adj" fmla="val 30000"/>
-            </a:avLst>
-          </a:prstGeom>
-          <a:solidFill>
-            <a:srgbClr val="6B5CA5"/>
-          </a:solidFill>
-          <a:ln/>
-        </p:spPr>
-        <p:txBody>
-          <a:bodyPr/>
-          <a:lstStyle/>
-          <a:p>
-            <a:endParaRPr lang="en-US"/>
-          </a:p>
-        </p:txBody>
-      </p:sp>
-      <p:sp>
-        <p:nvSpPr>
-          <p:cNvPr id="121" name="LabelText"/>
-          <p:cNvSpPr/>
-          <p:nvPr/>
-        </p:nvSpPr>
-        <p:spPr>
-          <a:xfrm>
-            <a:off x="548640" y="2331720"/>
-            <a:ext cx="7278624" cy="320040"/>
-          </a:xfrm>
-          <a:prstGeom prst="rect">
-            <a:avLst/>
-          </a:prstGeom>
-          <a:noFill/>
-          <a:ln/>
-        </p:spPr>
-        <p:txBody>
-          <a:bodyPr wrap="square" lIns="0" tIns="0" rIns="0" bIns="0" rtlCol="0" anchor="ctr"/>
-          <a:lstStyle/>
-          <a:p>
-            <a:pPr marL="0" indent="0" algn="ctr">
-              <a:buNone/>
-            </a:pPr>
-            <a:r>
-              <a:rPr lang="en-US" sz="1150" b="1" dirty="0">
-                <a:solidFill>
-                  <a:srgbClr val="FFFFFF"/>
-                </a:solidFill>
-                <a:latin typeface="Avenir Next LT Pro" pitchFamily="34" charset="0"/>
-                <a:ea typeface="Avenir Next LT Pro" pitchFamily="34" charset="-122"/>
-                <a:cs typeface="Avenir Next LT Pro" pitchFamily="34" charset="-120"/>
-              </a:rPr>
-              <a:t>BUILD  —  DETECT · PLAN · BUILD · PUBLISH</a:t>
-            </a:r>
-          </a:p>
-        </p:txBody>
-      </p:sp>
-      <p:sp>
-        <p:nvSpPr>
-          <p:cNvPr id="130" name="Box"/>
-          <p:cNvSpPr/>
-          <p:nvPr/>
-        </p:nvSpPr>
-        <p:spPr>
-          <a:xfrm>
-            <a:off x="548640" y="2834640"/>
-            <a:ext cx="1600200" cy="960120"/>
-          </a:xfrm>
-          <a:prstGeom prst="roundRect">
-            <a:avLst>
-              <a:gd name="adj" fmla="val 9412"/>
-            </a:avLst>
-          </a:prstGeom>
-          <a:solidFill>
-            <a:srgbClr val="F2F2F2"/>
-          </a:solidFill>
-          <a:ln w="19050">
-            <a:solidFill>
-              <a:srgbClr val="6B5CA5"/>
-            </a:solidFill>
-            <a:prstDash val="solid"/>
-          </a:ln>
-        </p:spPr>
-        <p:txBody>
-          <a:bodyPr/>
-          <a:lstStyle/>
-          <a:p>
-            <a:endParaRPr lang="en-US"/>
-          </a:p>
-        </p:txBody>
-      </p:sp>
-      <p:sp>
-        <p:nvSpPr>
-          <p:cNvPr id="131" name="BoxText"/>
-          <p:cNvSpPr/>
-          <p:nvPr/>
-        </p:nvSpPr>
-        <p:spPr>
-          <a:xfrm>
-            <a:off x="621792" y="2889504"/>
-            <a:ext cx="1453896" cy="850392"/>
-          </a:xfrm>
-          <a:prstGeom prst="rect">
-            <a:avLst/>
-          </a:prstGeom>
-          <a:noFill/>
-          <a:ln/>
-        </p:spPr>
-        <p:txBody>
-          <a:bodyPr wrap="square" lIns="0" tIns="0" rIns="0" bIns="0" rtlCol="0" anchor="ctr"/>
-          <a:lstStyle/>
-          <a:p>
-            <a:pPr marL="0" indent="0" algn="ctr">
-              <a:buNone/>
-            </a:pPr>
-            <a:r>
-              <a:rPr lang="en-US" sz="1300" b="1" dirty="0">
-                <a:solidFill>
-                  <a:srgbClr val="000000"/>
-                </a:solidFill>
-                <a:latin typeface="Avenir Next LT Pro" pitchFamily="34" charset="0"/>
-                <a:ea typeface="Avenir Next LT Pro" pitchFamily="34" charset="-122"/>
-                <a:cs typeface="Avenir Next LT Pro" pitchFamily="34" charset="-120"/>
-              </a:rPr>
-              <a:t>Detect</a:t>
-            </a:r>
-          </a:p>
-          <a:p>
-            <a:pPr marL="0" indent="0" algn="ctr">
-              <a:buNone/>
-            </a:pPr>
-            <a:r>
-              <a:rPr lang="en-US" sz="1150" dirty="0">
-                <a:solidFill>
-                  <a:srgbClr val="000000"/>
-                </a:solidFill>
-                <a:latin typeface="Avenir Next LT Pro" pitchFamily="34" charset="0"/>
-                <a:ea typeface="Avenir Next LT Pro" pitchFamily="34" charset="-122"/>
-                <a:cs typeface="Avenir Next LT Pro" pitchFamily="34" charset="-120"/>
-              </a:rPr>
-              <a:t>tech-detector</a:t>
-            </a:r>
-          </a:p>
-        </p:txBody>
-      </p:sp>
-      <p:sp>
-        <p:nvSpPr>
-          <p:cNvPr id="140" name="Arrow"/>
-          <p:cNvSpPr/>
-          <p:nvPr/>
-        </p:nvSpPr>
-        <p:spPr>
-          <a:xfrm>
-            <a:off x="2148840" y="2852928"/>
-            <a:ext cx="292608" cy="960120"/>
-          </a:xfrm>
-          <a:prstGeom prst="rect">
-            <a:avLst/>
-          </a:prstGeom>
-          <a:noFill/>
-          <a:ln/>
-        </p:spPr>
-        <p:txBody>
-          <a:bodyPr wrap="square" lIns="0" tIns="0" rIns="0" bIns="0" rtlCol="0" anchor="ctr"/>
-          <a:lstStyle/>
-          <a:p>
-            <a:pPr marL="0" indent="0" algn="ctr">
-              <a:buNone/>
-            </a:pPr>
-            <a:r>
-              <a:rPr lang="en-US" sz="1600" b="1" dirty="0">
-                <a:solidFill>
-                  <a:srgbClr val="6B5CA5"/>
-                </a:solidFill>
-              </a:rPr>
-              <a:t>→</a:t>
-            </a:r>
-          </a:p>
-        </p:txBody>
-      </p:sp>
-      <p:sp>
-        <p:nvSpPr>
-          <p:cNvPr id="170" name="Label"/>
-          <p:cNvSpPr/>
-          <p:nvPr/>
-        </p:nvSpPr>
-        <p:spPr>
-          <a:xfrm>
-            <a:off x="8119872" y="2331720"/>
-            <a:ext cx="3493008" cy="320040"/>
-          </a:xfrm>
-          <a:prstGeom prst="roundRect">
-            <a:avLst>
-              <a:gd name="adj" fmla="val 30000"/>
-            </a:avLst>
-          </a:prstGeom>
-          <a:solidFill>
-            <a:srgbClr val="0C62FB"/>
-          </a:solidFill>
-          <a:ln/>
-        </p:spPr>
-        <p:txBody>
-          <a:bodyPr/>
-          <a:lstStyle/>
-          <a:p>
-            <a:endParaRPr lang="en-US"/>
-          </a:p>
-        </p:txBody>
-      </p:sp>
-      <p:sp>
-        <p:nvSpPr>
-          <p:cNvPr id="171" name="LabelText"/>
-          <p:cNvSpPr/>
-          <p:nvPr/>
-        </p:nvSpPr>
-        <p:spPr>
-          <a:xfrm>
-            <a:off x="8119872" y="2331720"/>
-            <a:ext cx="3493008" cy="320040"/>
-          </a:xfrm>
-          <a:prstGeom prst="rect">
-            <a:avLst/>
-          </a:prstGeom>
-          <a:noFill/>
-          <a:ln/>
-        </p:spPr>
-        <p:txBody>
-          <a:bodyPr wrap="square" lIns="0" tIns="0" rIns="0" bIns="0" rtlCol="0" anchor="ctr"/>
-          <a:lstStyle/>
-          <a:p>
-            <a:pPr marL="0" indent="0" algn="ctr">
-              <a:buNone/>
-            </a:pPr>
-            <a:r>
-              <a:rPr lang="en-US" sz="1150" b="1" dirty="0">
-                <a:solidFill>
-                  <a:srgbClr val="FFFFFF"/>
-                </a:solidFill>
-                <a:latin typeface="Avenir Next LT Pro" pitchFamily="34" charset="0"/>
-                <a:ea typeface="Avenir Next LT Pro" pitchFamily="34" charset="-122"/>
-                <a:cs typeface="Avenir Next LT Pro" pitchFamily="34" charset="-120"/>
-              </a:rPr>
-              <a:t>ASSURE  —  AUDIT · RECONCILE</a:t>
-            </a:r>
-          </a:p>
-        </p:txBody>
-      </p:sp>
-      <p:sp>
-        <p:nvSpPr>
-          <p:cNvPr id="222" name="Banner"/>
-          <p:cNvSpPr/>
-          <p:nvPr/>
-        </p:nvSpPr>
-        <p:spPr>
-          <a:xfrm>
-            <a:off x="4322320" y="4150000"/>
-            <a:ext cx="6408120" cy="550000"/>
-          </a:xfrm>
-          <a:prstGeom prst="roundRect">
-            <a:avLst>
-              <a:gd name="adj" fmla="val 12000"/>
-            </a:avLst>
-          </a:prstGeom>
-          <a:solidFill>
-            <a:srgbClr val="FF4D5F"/>
-          </a:solidFill>
-          <a:ln/>
-        </p:spPr>
-        <p:txBody>
-          <a:bodyPr/>
-          <a:lstStyle/>
-          <a:p>
-            <a:endParaRPr lang="en-US"/>
-          </a:p>
-        </p:txBody>
-      </p:sp>
-      <p:sp>
-        <p:nvSpPr>
-          <p:cNvPr id="224" name="BannerText"/>
-          <p:cNvSpPr/>
-          <p:nvPr/>
-        </p:nvSpPr>
-        <p:spPr>
-          <a:xfrm>
-            <a:off x="4822320" y="4150000"/>
-            <a:ext cx="5858120" cy="550000"/>
-          </a:xfrm>
-          <a:prstGeom prst="rect">
-            <a:avLst/>
-          </a:prstGeom>
-          <a:noFill/>
-          <a:ln/>
-        </p:spPr>
-        <p:txBody>
-          <a:bodyPr wrap="square" lIns="0" tIns="0" rIns="0" bIns="0" rtlCol="0" anchor="ctr"/>
-          <a:lstStyle/>
-          <a:p>
-            <a:pPr marL="0" indent="0" algn="ctr">
-              <a:lnSpc>
-                <a:spcPct val="110000"/>
-              </a:lnSpc>
-              <a:buNone/>
-            </a:pPr>
-            <a:r>
-              <a:rPr lang="en-US" sz="1200" b="1" dirty="0">
-                <a:solidFill>
-                  <a:srgbClr val="FFFFFF"/>
-                </a:solidFill>
-                <a:latin typeface="Avenir Next LT Pro" pitchFamily="34" charset="0"/>
-                <a:ea typeface="Avenir Next LT Pro" pitchFamily="34" charset="-122"/>
-                <a:cs typeface="Avenir Next LT Pro" pitchFamily="34" charset="-120"/>
-              </a:rPr>
-              <a:t>ONE GOVERNED PIPELINE — EVERY OUTPUT FEEDS THE NEXT</a:t>
-            </a:r>
-          </a:p>
-          <a:p>
-            <a:pPr marL="0" indent="0" algn="ctr">
-              <a:buNone/>
-            </a:pPr>
-            <a:r>
-              <a:rPr lang="en-US" sz="1000" dirty="0">
-                <a:solidFill>
-                  <a:srgbClr val="FFFFFF"/>
-                </a:solidFill>
-                <a:latin typeface="Avenir Next LT Pro" pitchFamily="34" charset="0"/>
-                <a:ea typeface="Avenir Next LT Pro" pitchFamily="34" charset="-122"/>
-                <a:cs typeface="Avenir Next LT Pro" pitchFamily="34" charset="-120"/>
-              </a:rPr>
-              <a:t>Detection informs the plan; the plan drives the build; the build is audited; the audit is reconciled into decisions.</a:t>
-            </a:r>
-          </a:p>
-        </p:txBody>
-      </p:sp>
-      <p:sp>
-        <p:nvSpPr>
-          <p:cNvPr id="230" name="Callout"/>
-          <p:cNvSpPr/>
-          <p:nvPr/>
-        </p:nvSpPr>
-        <p:spPr>
-          <a:xfrm>
-            <a:off x="548640" y="4950000"/>
-            <a:ext cx="11064240" cy="1000000"/>
-          </a:xfrm>
-          <a:prstGeom prst="roundRect">
-            <a:avLst>
-              <a:gd name="adj" fmla="val 7273"/>
-            </a:avLst>
-          </a:prstGeom>
-          <a:solidFill>
-            <a:srgbClr val="F2F2F2"/>
-          </a:solidFill>
-          <a:ln/>
-        </p:spPr>
-        <p:txBody>
-          <a:bodyPr/>
-          <a:lstStyle/>
-          <a:p>
-            <a:endParaRPr lang="en-US"/>
-          </a:p>
-        </p:txBody>
-      </p:sp>
-      <p:sp>
-        <p:nvSpPr>
-          <p:cNvPr id="232" name="CalloutText"/>
-          <p:cNvSpPr/>
-          <p:nvPr/>
-        </p:nvSpPr>
-        <p:spPr>
-          <a:xfrm>
-            <a:off x="777240" y="4950000"/>
-            <a:ext cx="10607040" cy="1000000"/>
-          </a:xfrm>
-          <a:prstGeom prst="rect">
-            <a:avLst/>
-          </a:prstGeom>
-          <a:noFill/>
-          <a:ln/>
-        </p:spPr>
-        <p:txBody>
-          <a:bodyPr wrap="square" lIns="0" tIns="0" rIns="0" bIns="0" rtlCol="0" anchor="ctr"/>
-          <a:lstStyle/>
-          <a:p>
-            <a:pPr marL="0" indent="0">
-              <a:lnSpc>
-                <a:spcPct val="115000"/>
-              </a:lnSpc>
-              <a:buNone/>
-            </a:pPr>
-            <a:r>
-              <a:rPr lang="en-US" sz="1150" b="1" dirty="0">
-                <a:solidFill>
-                  <a:srgbClr val="002FAF"/>
-                </a:solidFill>
-                <a:latin typeface="Avenir Next LT Pro" pitchFamily="34" charset="0"/>
-                <a:ea typeface="Avenir Next LT Pro" pitchFamily="34" charset="-122"/>
-                <a:cs typeface="Avenir Next LT Pro" pitchFamily="34" charset="-120"/>
-              </a:rPr>
-              <a:t>What the client gets: </a:t>
-            </a:r>
-            <a:r>
-              <a:rPr lang="en-US" sz="1150" dirty="0">
-                <a:solidFill>
-                  <a:srgbClr val="000000"/>
-                </a:solidFill>
-                <a:latin typeface="Avenir Next LT Pro" pitchFamily="34" charset="0"/>
-                <a:ea typeface="Avenir Next LT Pro" pitchFamily="34" charset="-122"/>
-                <a:cs typeface="Avenir Next LT Pro" pitchFamily="34" charset="-120"/>
-              </a:rPr>
-              <a:t>a documented, governed Adobe implementation — plus the evidence (audit deck + workbook) and the decisions (reconciliation workbook + email) to trust it and act.</a:t>
-            </a:r>
-            <a:endParaRPr lang="en-US" sz="1150" dirty="0"/>
-          </a:p>
-        </p:txBody>
-      </p:sp>
-      <p:sp>
-        <p:nvSpPr>
           <p:cNvPr id="43" name="Shape 39"/>
           <p:cNvSpPr/>
           <p:nvPr/>
@@ -7491,586 +7028,30 @@
           </a:p>
         </p:txBody>
       </p:sp>
-      <p:sp>
-        <p:nvSpPr>
-          <p:cNvPr id="233" name="Box_233"/>
-          <p:cNvSpPr/>
-          <p:nvPr/>
-        </p:nvSpPr>
-        <p:spPr>
-          <a:xfrm>
-            <a:off x="2441448" y="2834640"/>
-            <a:ext cx="1600200" cy="960120"/>
-          </a:xfrm>
-          <a:prstGeom prst="roundRect">
-            <a:avLst>
-              <a:gd name="adj" fmla="val 9412"/>
-            </a:avLst>
-          </a:prstGeom>
-          <a:solidFill>
-            <a:srgbClr val="F2F2F2"/>
-          </a:solidFill>
-          <a:ln w="19050">
-            <a:solidFill>
-              <a:srgbClr val="6B5CA5"/>
-            </a:solidFill>
-            <a:prstDash val="solid"/>
-          </a:ln>
-        </p:spPr>
-        <p:txBody>
-          <a:bodyPr/>
-          <a:lstStyle/>
-          <a:p>
-            <a:endParaRPr lang="en-US"/>
-          </a:p>
-        </p:txBody>
-      </p:sp>
-      <p:sp>
-        <p:nvSpPr>
-          <p:cNvPr id="234" name="BoxText_234"/>
-          <p:cNvSpPr/>
-          <p:nvPr/>
-        </p:nvSpPr>
-        <p:spPr>
-          <a:xfrm>
-            <a:off x="2514600" y="2889504"/>
-            <a:ext cx="1453896" cy="850392"/>
-          </a:xfrm>
-          <a:prstGeom prst="rect">
-            <a:avLst/>
-          </a:prstGeom>
-          <a:noFill/>
-          <a:ln/>
-        </p:spPr>
-        <p:txBody>
-          <a:bodyPr wrap="square" lIns="0" tIns="0" rIns="0" bIns="0" rtlCol="0" anchor="ctr"/>
-          <a:lstStyle/>
-          <a:p>
-            <a:pPr marL="0" indent="0" algn="ctr">
-              <a:buNone/>
-            </a:pPr>
-            <a:r>
-              <a:rPr lang="en-US" sz="1300" b="1" dirty="0">
-                <a:solidFill>
-                  <a:srgbClr val="000000"/>
-                </a:solidFill>
-                <a:latin typeface="Avenir Next LT Pro" pitchFamily="34" charset="0"/>
-                <a:ea typeface="Avenir Next LT Pro" pitchFamily="34" charset="-122"/>
-                <a:cs typeface="Avenir Next LT Pro" pitchFamily="34" charset="-120"/>
-              </a:rPr>
-              <a:t>Plan</a:t>
-            </a:r>
-          </a:p>
-          <a:p>
-            <a:pPr marL="0" indent="0" algn="ctr">
-              <a:buNone/>
-            </a:pPr>
-            <a:r>
-              <a:rPr lang="en-US" sz="1150" dirty="0">
-                <a:solidFill>
-                  <a:srgbClr val="000000"/>
-                </a:solidFill>
-                <a:latin typeface="Avenir Next LT Pro" pitchFamily="34" charset="0"/>
-                <a:ea typeface="Avenir Next LT Pro" pitchFamily="34" charset="-122"/>
-                <a:cs typeface="Avenir Next LT Pro" pitchFamily="34" charset="-120"/>
-              </a:rPr>
-              <a:t>setup-plan</a:t>
-            </a:r>
-          </a:p>
-        </p:txBody>
-      </p:sp>
-      <p:sp>
-        <p:nvSpPr>
-          <p:cNvPr id="235" name="Box_235"/>
-          <p:cNvSpPr/>
-          <p:nvPr/>
-        </p:nvSpPr>
-        <p:spPr>
-          <a:xfrm>
-            <a:off x="4334256" y="2834640"/>
-            <a:ext cx="1600200" cy="960120"/>
-          </a:xfrm>
-          <a:prstGeom prst="roundRect">
-            <a:avLst>
-              <a:gd name="adj" fmla="val 9412"/>
-            </a:avLst>
-          </a:prstGeom>
-          <a:solidFill>
-            <a:srgbClr val="F2F2F2"/>
-          </a:solidFill>
-          <a:ln w="19050">
-            <a:solidFill>
-              <a:srgbClr val="6B5CA5"/>
-            </a:solidFill>
-            <a:prstDash val="solid"/>
-          </a:ln>
-        </p:spPr>
-        <p:txBody>
-          <a:bodyPr/>
-          <a:lstStyle/>
-          <a:p>
-            <a:endParaRPr lang="en-US"/>
-          </a:p>
-        </p:txBody>
-      </p:sp>
-      <p:sp>
-        <p:nvSpPr>
-          <p:cNvPr id="236" name="BoxText_236"/>
-          <p:cNvSpPr/>
-          <p:nvPr/>
-        </p:nvSpPr>
-        <p:spPr>
-          <a:xfrm>
-            <a:off x="4407408" y="2889504"/>
-            <a:ext cx="1453896" cy="850392"/>
-          </a:xfrm>
-          <a:prstGeom prst="rect">
-            <a:avLst/>
-          </a:prstGeom>
-          <a:noFill/>
-          <a:ln/>
-        </p:spPr>
-        <p:txBody>
-          <a:bodyPr wrap="square" lIns="0" tIns="0" rIns="0" bIns="0" rtlCol="0" anchor="ctr"/>
-          <a:lstStyle/>
-          <a:p>
-            <a:pPr marL="0" indent="0" algn="ctr">
-              <a:buNone/>
-            </a:pPr>
-            <a:r>
-              <a:rPr lang="en-US" sz="1300" b="1" dirty="0">
-                <a:solidFill>
-                  <a:srgbClr val="000000"/>
-                </a:solidFill>
-                <a:latin typeface="Avenir Next LT Pro" pitchFamily="34" charset="0"/>
-                <a:ea typeface="Avenir Next LT Pro" pitchFamily="34" charset="-122"/>
-                <a:cs typeface="Avenir Next LT Pro" pitchFamily="34" charset="-120"/>
-              </a:rPr>
-              <a:t>Build</a:t>
-            </a:r>
-          </a:p>
-          <a:p>
-            <a:pPr marL="0" indent="0" algn="ctr">
-              <a:buNone/>
-            </a:pPr>
-            <a:r>
-              <a:rPr lang="en-US" sz="1150" dirty="0">
-                <a:solidFill>
-                  <a:srgbClr val="000000"/>
-                </a:solidFill>
-                <a:latin typeface="Avenir Next LT Pro" pitchFamily="34" charset="0"/>
-                <a:ea typeface="Avenir Next LT Pro" pitchFamily="34" charset="-122"/>
-                <a:cs typeface="Avenir Next LT Pro" pitchFamily="34" charset="-120"/>
-              </a:rPr>
-              <a:t>data-builder</a:t>
-            </a:r>
-          </a:p>
-        </p:txBody>
-      </p:sp>
-      <p:sp>
-        <p:nvSpPr>
-          <p:cNvPr id="237" name="Box_237"/>
-          <p:cNvSpPr/>
-          <p:nvPr/>
-        </p:nvSpPr>
-        <p:spPr>
-          <a:xfrm>
-            <a:off x="6227064" y="2834640"/>
-            <a:ext cx="1600200" cy="960120"/>
-          </a:xfrm>
-          <a:prstGeom prst="roundRect">
-            <a:avLst>
-              <a:gd name="adj" fmla="val 9412"/>
-            </a:avLst>
-          </a:prstGeom>
-          <a:solidFill>
-            <a:srgbClr val="F2F2F2"/>
-          </a:solidFill>
-          <a:ln w="19050">
-            <a:solidFill>
-              <a:srgbClr val="6B5CA5"/>
-            </a:solidFill>
-            <a:prstDash val="solid"/>
-          </a:ln>
-        </p:spPr>
-        <p:txBody>
-          <a:bodyPr/>
-          <a:lstStyle/>
-          <a:p>
-            <a:endParaRPr lang="en-US"/>
-          </a:p>
-        </p:txBody>
-      </p:sp>
-      <p:sp>
-        <p:nvSpPr>
-          <p:cNvPr id="238" name="BoxText_238"/>
-          <p:cNvSpPr/>
-          <p:nvPr/>
-        </p:nvSpPr>
-        <p:spPr>
-          <a:xfrm>
-            <a:off x="6300216" y="2889504"/>
-            <a:ext cx="1453896" cy="850392"/>
-          </a:xfrm>
-          <a:prstGeom prst="rect">
-            <a:avLst/>
-          </a:prstGeom>
-          <a:noFill/>
-          <a:ln/>
-        </p:spPr>
-        <p:txBody>
-          <a:bodyPr wrap="square" lIns="0" tIns="0" rIns="0" bIns="0" rtlCol="0" anchor="ctr"/>
-          <a:lstStyle/>
-          <a:p>
-            <a:pPr marL="0" indent="0" algn="ctr">
-              <a:buNone/>
-            </a:pPr>
-            <a:r>
-              <a:rPr lang="en-US" sz="1300" b="1" dirty="0">
-                <a:solidFill>
-                  <a:srgbClr val="000000"/>
-                </a:solidFill>
-                <a:latin typeface="Avenir Next LT Pro" pitchFamily="34" charset="0"/>
-                <a:ea typeface="Avenir Next LT Pro" pitchFamily="34" charset="-122"/>
-                <a:cs typeface="Avenir Next LT Pro" pitchFamily="34" charset="-120"/>
-              </a:rPr>
-              <a:t>Publish</a:t>
-            </a:r>
-          </a:p>
-          <a:p>
-            <a:pPr marL="0" indent="0" algn="ctr">
-              <a:buNone/>
-            </a:pPr>
-            <a:r>
-              <a:rPr lang="en-US" sz="1150" dirty="0">
-                <a:solidFill>
-                  <a:srgbClr val="000000"/>
-                </a:solidFill>
-                <a:latin typeface="Avenir Next LT Pro" pitchFamily="34" charset="0"/>
-                <a:ea typeface="Avenir Next LT Pro" pitchFamily="34" charset="-122"/>
-                <a:cs typeface="Avenir Next LT Pro" pitchFamily="34" charset="-120"/>
-              </a:rPr>
-              <a:t>property-creator</a:t>
-            </a:r>
-          </a:p>
-        </p:txBody>
-      </p:sp>
-      <p:sp>
-        <p:nvSpPr>
-          <p:cNvPr id="239" name="Box_239"/>
-          <p:cNvSpPr/>
-          <p:nvPr/>
-        </p:nvSpPr>
-        <p:spPr>
-          <a:xfrm>
-            <a:off x="8119872" y="2834640"/>
-            <a:ext cx="1600200" cy="960120"/>
-          </a:xfrm>
-          <a:prstGeom prst="roundRect">
-            <a:avLst>
-              <a:gd name="adj" fmla="val 9412"/>
-            </a:avLst>
-          </a:prstGeom>
-          <a:solidFill>
-            <a:srgbClr val="F2F2F2"/>
-          </a:solidFill>
-          <a:ln w="19050">
-            <a:solidFill>
-              <a:srgbClr val="6B5CA5"/>
-            </a:solidFill>
-            <a:prstDash val="solid"/>
-          </a:ln>
-        </p:spPr>
-        <p:txBody>
-          <a:bodyPr/>
-          <a:lstStyle/>
-          <a:p>
-            <a:endParaRPr lang="en-US"/>
-          </a:p>
-        </p:txBody>
-      </p:sp>
-      <p:sp>
-        <p:nvSpPr>
-          <p:cNvPr id="240" name="BoxText_240"/>
-          <p:cNvSpPr/>
-          <p:nvPr/>
-        </p:nvSpPr>
-        <p:spPr>
-          <a:xfrm>
-            <a:off x="8193024" y="2889504"/>
-            <a:ext cx="1453896" cy="850392"/>
-          </a:xfrm>
-          <a:prstGeom prst="rect">
-            <a:avLst/>
-          </a:prstGeom>
-          <a:noFill/>
-          <a:ln/>
-        </p:spPr>
-        <p:txBody>
-          <a:bodyPr wrap="square" lIns="0" tIns="0" rIns="0" bIns="0" rtlCol="0" anchor="ctr"/>
-          <a:lstStyle/>
-          <a:p>
-            <a:pPr marL="0" indent="0" algn="ctr">
-              <a:buNone/>
-            </a:pPr>
-            <a:r>
-              <a:rPr lang="en-US" sz="1300" b="1" dirty="0">
-                <a:solidFill>
-                  <a:srgbClr val="000000"/>
-                </a:solidFill>
-                <a:latin typeface="Avenir Next LT Pro" pitchFamily="34" charset="0"/>
-                <a:ea typeface="Avenir Next LT Pro" pitchFamily="34" charset="-122"/>
-                <a:cs typeface="Avenir Next LT Pro" pitchFamily="34" charset="-120"/>
-              </a:rPr>
-              <a:t>Audit</a:t>
-            </a:r>
-          </a:p>
-          <a:p>
-            <a:pPr marL="0" indent="0" algn="ctr">
-              <a:buNone/>
-            </a:pPr>
-            <a:r>
-              <a:rPr lang="en-US" sz="1150" dirty="0">
-                <a:solidFill>
-                  <a:srgbClr val="000000"/>
-                </a:solidFill>
-                <a:latin typeface="Avenir Next LT Pro" pitchFamily="34" charset="0"/>
-                <a:ea typeface="Avenir Next LT Pro" pitchFamily="34" charset="-122"/>
-                <a:cs typeface="Avenir Next LT Pro" pitchFamily="34" charset="-120"/>
-              </a:rPr>
-              <a:t>audit-builder</a:t>
-            </a:r>
-          </a:p>
-        </p:txBody>
-      </p:sp>
-      <p:sp>
-        <p:nvSpPr>
-          <p:cNvPr id="241" name="Box_241"/>
-          <p:cNvSpPr/>
-          <p:nvPr/>
-        </p:nvSpPr>
-        <p:spPr>
-          <a:xfrm>
-            <a:off x="10012680" y="2834640"/>
-            <a:ext cx="1600200" cy="960120"/>
-          </a:xfrm>
-          <a:prstGeom prst="roundRect">
-            <a:avLst>
-              <a:gd name="adj" fmla="val 9412"/>
-            </a:avLst>
-          </a:prstGeom>
-          <a:solidFill>
-            <a:srgbClr val="F2F2F2"/>
-          </a:solidFill>
-          <a:ln w="19050">
-            <a:solidFill>
-              <a:srgbClr val="6B5CA5"/>
-            </a:solidFill>
-            <a:prstDash val="solid"/>
-          </a:ln>
-        </p:spPr>
-        <p:txBody>
-          <a:bodyPr/>
-          <a:lstStyle/>
-          <a:p>
-            <a:endParaRPr lang="en-US"/>
-          </a:p>
-        </p:txBody>
-      </p:sp>
-      <p:sp>
-        <p:nvSpPr>
-          <p:cNvPr id="242" name="BoxText_242"/>
-          <p:cNvSpPr/>
-          <p:nvPr/>
-        </p:nvSpPr>
-        <p:spPr>
-          <a:xfrm>
-            <a:off x="10085832" y="2889504"/>
-            <a:ext cx="1453896" cy="850392"/>
-          </a:xfrm>
-          <a:prstGeom prst="rect">
-            <a:avLst/>
-          </a:prstGeom>
-          <a:noFill/>
-          <a:ln/>
-        </p:spPr>
-        <p:txBody>
-          <a:bodyPr wrap="square" lIns="0" tIns="0" rIns="0" bIns="0" rtlCol="0" anchor="ctr"/>
-          <a:lstStyle/>
-          <a:p>
-            <a:pPr marL="0" indent="0" algn="ctr">
-              <a:buNone/>
-            </a:pPr>
-            <a:r>
-              <a:rPr lang="en-US" sz="1300" b="1" dirty="0">
-                <a:solidFill>
-                  <a:srgbClr val="000000"/>
-                </a:solidFill>
-                <a:latin typeface="Avenir Next LT Pro" pitchFamily="34" charset="0"/>
-                <a:ea typeface="Avenir Next LT Pro" pitchFamily="34" charset="-122"/>
-                <a:cs typeface="Avenir Next LT Pro" pitchFamily="34" charset="-120"/>
-              </a:rPr>
-              <a:t>Reconcile</a:t>
-            </a:r>
-          </a:p>
-          <a:p>
-            <a:pPr marL="0" indent="0" algn="ctr">
-              <a:buNone/>
-            </a:pPr>
-            <a:r>
-              <a:rPr lang="en-US" sz="1150" dirty="0">
-                <a:solidFill>
-                  <a:srgbClr val="000000"/>
-                </a:solidFill>
-                <a:latin typeface="Avenir Next LT Pro" pitchFamily="34" charset="0"/>
-                <a:ea typeface="Avenir Next LT Pro" pitchFamily="34" charset="-122"/>
-                <a:cs typeface="Avenir Next LT Pro" pitchFamily="34" charset="-120"/>
-              </a:rPr>
-              <a:t>reconciliation</a:t>
-            </a:r>
-          </a:p>
-        </p:txBody>
-      </p:sp>
-      <p:sp>
-        <p:nvSpPr>
-          <p:cNvPr id="243" name="Arrow_243"/>
-          <p:cNvSpPr/>
-          <p:nvPr/>
-        </p:nvSpPr>
-        <p:spPr>
-          <a:xfrm>
-            <a:off x="4041648" y="2852928"/>
-            <a:ext cx="292608" cy="960120"/>
-          </a:xfrm>
-          <a:prstGeom prst="rect">
-            <a:avLst/>
-          </a:prstGeom>
-          <a:noFill/>
-          <a:ln/>
-        </p:spPr>
-        <p:txBody>
-          <a:bodyPr wrap="square" lIns="0" tIns="0" rIns="0" bIns="0" rtlCol="0" anchor="ctr"/>
-          <a:lstStyle/>
-          <a:p>
-            <a:pPr marL="0" indent="0" algn="ctr">
-              <a:buNone/>
-            </a:pPr>
-            <a:r>
-              <a:rPr lang="en-US" sz="1600" b="1" dirty="0">
-                <a:solidFill>
-                  <a:srgbClr val="6B5CA5"/>
-                </a:solidFill>
-              </a:rPr>
-              <a:t>→</a:t>
-            </a:r>
-          </a:p>
-        </p:txBody>
-      </p:sp>
-      <p:sp>
-        <p:nvSpPr>
-          <p:cNvPr id="244" name="Arrow_244"/>
-          <p:cNvSpPr/>
-          <p:nvPr/>
-        </p:nvSpPr>
-        <p:spPr>
-          <a:xfrm>
-            <a:off x="5934456" y="2852928"/>
-            <a:ext cx="292608" cy="960120"/>
-          </a:xfrm>
-          <a:prstGeom prst="rect">
-            <a:avLst/>
-          </a:prstGeom>
-          <a:noFill/>
-          <a:ln/>
-        </p:spPr>
-        <p:txBody>
-          <a:bodyPr wrap="square" lIns="0" tIns="0" rIns="0" bIns="0" rtlCol="0" anchor="ctr"/>
-          <a:lstStyle/>
-          <a:p>
-            <a:pPr marL="0" indent="0" algn="ctr">
-              <a:buNone/>
-            </a:pPr>
-            <a:r>
-              <a:rPr lang="en-US" sz="1600" b="1" dirty="0">
-                <a:solidFill>
-                  <a:srgbClr val="6B5CA5"/>
-                </a:solidFill>
-              </a:rPr>
-              <a:t>→</a:t>
-            </a:r>
-          </a:p>
-        </p:txBody>
-      </p:sp>
-      <p:sp>
-        <p:nvSpPr>
-          <p:cNvPr id="245" name="Arrow_245"/>
-          <p:cNvSpPr/>
-          <p:nvPr/>
-        </p:nvSpPr>
-        <p:spPr>
-          <a:xfrm>
-            <a:off x="7827264" y="2852928"/>
-            <a:ext cx="292608" cy="960120"/>
-          </a:xfrm>
-          <a:prstGeom prst="rect">
-            <a:avLst/>
-          </a:prstGeom>
-          <a:noFill/>
-          <a:ln/>
-        </p:spPr>
-        <p:txBody>
-          <a:bodyPr wrap="square" lIns="0" tIns="0" rIns="0" bIns="0" rtlCol="0" anchor="ctr"/>
-          <a:lstStyle/>
-          <a:p>
-            <a:pPr marL="0" indent="0" algn="ctr">
-              <a:buNone/>
-            </a:pPr>
-            <a:r>
-              <a:rPr lang="en-US" sz="1600" b="1" dirty="0">
-                <a:solidFill>
-                  <a:srgbClr val="6B5CA5"/>
-                </a:solidFill>
-              </a:rPr>
-              <a:t>→</a:t>
-            </a:r>
-          </a:p>
-        </p:txBody>
-      </p:sp>
-      <p:sp>
-        <p:nvSpPr>
-          <p:cNvPr id="246" name="Arrow_246"/>
-          <p:cNvSpPr/>
-          <p:nvPr/>
-        </p:nvSpPr>
-        <p:spPr>
-          <a:xfrm>
-            <a:off x="9720072" y="2852928"/>
-            <a:ext cx="292608" cy="960120"/>
-          </a:xfrm>
-          <a:prstGeom prst="rect">
-            <a:avLst/>
-          </a:prstGeom>
-          <a:noFill/>
-          <a:ln/>
-        </p:spPr>
-        <p:txBody>
-          <a:bodyPr wrap="square" lIns="0" tIns="0" rIns="0" bIns="0" rtlCol="0" anchor="ctr"/>
-          <a:lstStyle/>
-          <a:p>
-            <a:pPr marL="0" indent="0" algn="ctr">
-              <a:buNone/>
-            </a:pPr>
-            <a:r>
-              <a:rPr lang="en-US" sz="1600" b="1" dirty="0">
-                <a:solidFill>
-                  <a:srgbClr val="6B5CA5"/>
-                </a:solidFill>
-              </a:rPr>
-              <a:t>→</a:t>
-            </a:r>
-          </a:p>
-        </p:txBody>
-      </p:sp>
+      <p:pic>
+        <p:nvPicPr>
+          <p:cNvPr id="50" name="Picture 49" descr="diagram.png"/>
+          <p:cNvPicPr>
+            <a:picLocks noChangeAspect="1"/>
+          </p:cNvPicPr>
+          <p:nvPr/>
+        </p:nvPicPr>
+        <p:blipFill>
+          <a:blip r:embed="rId4"/>
+          <a:stretch>
+            <a:fillRect/>
+          </a:stretch>
+        </p:blipFill>
+        <p:spPr>
+          <a:xfrm>
+            <a:off x="338328" y="1600200"/>
+            <a:ext cx="11521440" cy="4169663"/>
+          </a:xfrm>
+          <a:prstGeom prst="rect">
+            <a:avLst/>
+          </a:prstGeom>
+        </p:spPr>
+      </p:pic>
     </p:spTree>
   </p:cSld>
   <p:clrMapOvr>

</xml_diff>

<commit_message>
Add "How to Invoke the Skills" slide (example prompts per skill)
New slide 8 (before Thank You): a 2x3 grid of native prompt cards, one
per skill, each showing the skill's icon, name, slug, and a realistic
example prompt in a monospace "type this" bubble — so the audience can
see exactly what to type to trigger each skill. Header/stripes/footer
copied from an existing slide for exact style consistency; verified no
light-on-light text, XML well-formed, 9 slides in correct order.

Co-Authored-By: Claude Opus 4.8 <noreply@anthropic.com>
Claude-Session: https://claude.ai/code/session_01L22pJWjoypJEHfB9cqhWZF
</commit_message>
<xml_diff>
--- a/websdk-property/docs/adobe-data-collection-skills-suite.pptx
+++ b/websdk-property/docs/adobe-data-collection-skills-suite.pptx
@@ -15,6 +15,7 @@
     <p:sldId id="260" r:id="rId8"/>
     <p:sldId id="287" r:id="rId27"/>
     <p:sldId id="294" r:id="rId33"/>
+    <p:sldId id="302" r:id="rId16"/>
     <p:sldId id="296" r:id="rId35"/>
   </p:sldIdLst>
   <p:sldSz cx="12192000" cy="6858000"/>
@@ -12086,6 +12087,2042 @@
 </p:sld>
 </file>
 
+<file path=ppt/slides/slide9.xml><?xml version="1.0" encoding="utf-8"?>
+<p:sld xmlns:a="http://schemas.openxmlformats.org/drawingml/2006/main" xmlns:p="http://schemas.openxmlformats.org/presentationml/2006/main" xmlns:r="http://schemas.openxmlformats.org/officeDocument/2006/relationships">
+  <p:cSld>
+    <p:spTree>
+      <p:nvGrpSpPr>
+        <p:cNvPr id="1" name=""/>
+        <p:cNvGrpSpPr/>
+        <p:nvPr/>
+      </p:nvGrpSpPr>
+      <p:grpSpPr/>
+      <p:sp>
+        <p:nvSpPr>
+          <p:cNvPr id="4" name="Text 1"/>
+          <p:cNvSpPr/>
+          <p:nvPr/>
+        </p:nvSpPr>
+        <p:spPr>
+          <a:xfrm>
+            <a:off x="548640" y="411480"/>
+            <a:ext cx="9144000" cy="292608"/>
+          </a:xfrm>
+          <a:prstGeom prst="rect">
+            <a:avLst/>
+          </a:prstGeom>
+          <a:noFill/>
+          <a:ln/>
+        </p:spPr>
+        <p:txBody>
+          <a:bodyPr wrap="square" lIns="0" tIns="0" rIns="0" bIns="0" rtlCol="0" anchor="ctr"/>
+          <a:lstStyle/>
+          <a:p>
+            <a:pPr marL="0" indent="0">
+              <a:buNone/>
+            </a:pPr>
+            <a:r>
+              <a:rPr lang="en-US" sz="1200" b="1" kern="0" spc="200" dirty="0">
+                <a:solidFill>
+                  <a:srgbClr val="0C62FB"/>
+                </a:solidFill>
+                <a:latin typeface="Avenir Next LT Pro" pitchFamily="34" charset="0"/>
+                <a:ea typeface="Avenir Next LT Pro" pitchFamily="34" charset="-122"/>
+                <a:cs typeface="Avenir Next LT Pro" pitchFamily="34" charset="-120"/>
+              </a:rPr>
+              <a:t>GET STARTED IN ONE LINE</a:t>
+            </a:r>
+            <a:endParaRPr lang="en-US" sz="1200" dirty="0"/>
+          </a:p>
+        </p:txBody>
+      </p:sp>
+      <p:sp>
+        <p:nvSpPr>
+          <p:cNvPr id="5" name="Text 2"/>
+          <p:cNvSpPr/>
+          <p:nvPr/>
+        </p:nvSpPr>
+        <p:spPr>
+          <a:xfrm>
+            <a:off x="548640" y="667512"/>
+            <a:ext cx="11064240" cy="566928"/>
+          </a:xfrm>
+          <a:prstGeom prst="rect">
+            <a:avLst/>
+          </a:prstGeom>
+          <a:noFill/>
+          <a:ln/>
+        </p:spPr>
+        <p:txBody>
+          <a:bodyPr wrap="square" lIns="0" tIns="0" rIns="0" bIns="0" rtlCol="0" anchor="ctr"/>
+          <a:lstStyle/>
+          <a:p>
+            <a:pPr marL="0" indent="0">
+              <a:buNone/>
+            </a:pPr>
+            <a:r>
+              <a:rPr lang="en-US" sz="2800" b="1" dirty="0">
+                <a:solidFill>
+                  <a:srgbClr val="000000"/>
+                </a:solidFill>
+                <a:latin typeface="Avenir Next LT Pro" pitchFamily="34" charset="0"/>
+                <a:ea typeface="Avenir Next LT Pro" pitchFamily="34" charset="-122"/>
+                <a:cs typeface="Avenir Next LT Pro" pitchFamily="34" charset="-120"/>
+              </a:rPr>
+              <a:t>How to Invoke the Skills</a:t>
+            </a:r>
+            <a:endParaRPr lang="en-US" sz="2800" dirty="0"/>
+          </a:p>
+        </p:txBody>
+      </p:sp>
+      <p:sp>
+        <p:nvSpPr>
+          <p:cNvPr id="24" name="Shape 21"/>
+          <p:cNvSpPr/>
+          <p:nvPr/>
+        </p:nvSpPr>
+        <p:spPr>
+          <a:xfrm>
+            <a:off x="0" y="0"/>
+            <a:ext cx="2432304" cy="137160"/>
+          </a:xfrm>
+          <a:prstGeom prst="rect">
+            <a:avLst/>
+          </a:prstGeom>
+          <a:solidFill>
+            <a:srgbClr val="002FAF"/>
+          </a:solidFill>
+          <a:ln/>
+        </p:spPr>
+        <p:txBody>
+          <a:bodyPr/>
+          <a:lstStyle/>
+          <a:p>
+            <a:endParaRPr lang="en-US"/>
+          </a:p>
+        </p:txBody>
+      </p:sp>
+      <p:sp>
+        <p:nvSpPr>
+          <p:cNvPr id="25" name="Shape 22"/>
+          <p:cNvSpPr/>
+          <p:nvPr/>
+        </p:nvSpPr>
+        <p:spPr>
+          <a:xfrm>
+            <a:off x="2432304" y="0"/>
+            <a:ext cx="2432304" cy="137160"/>
+          </a:xfrm>
+          <a:prstGeom prst="rect">
+            <a:avLst/>
+          </a:prstGeom>
+          <a:solidFill>
+            <a:srgbClr val="0C62FB"/>
+          </a:solidFill>
+          <a:ln/>
+        </p:spPr>
+        <p:txBody>
+          <a:bodyPr/>
+          <a:lstStyle/>
+          <a:p>
+            <a:endParaRPr lang="en-US"/>
+          </a:p>
+        </p:txBody>
+      </p:sp>
+      <p:sp>
+        <p:nvSpPr>
+          <p:cNvPr id="26" name="Shape 23"/>
+          <p:cNvSpPr/>
+          <p:nvPr/>
+        </p:nvSpPr>
+        <p:spPr>
+          <a:xfrm>
+            <a:off x="4864608" y="0"/>
+            <a:ext cx="2432304" cy="137160"/>
+          </a:xfrm>
+          <a:prstGeom prst="rect">
+            <a:avLst/>
+          </a:prstGeom>
+          <a:solidFill>
+            <a:srgbClr val="1BE1F2"/>
+          </a:solidFill>
+          <a:ln/>
+        </p:spPr>
+        <p:txBody>
+          <a:bodyPr/>
+          <a:lstStyle/>
+          <a:p>
+            <a:endParaRPr lang="en-US"/>
+          </a:p>
+        </p:txBody>
+      </p:sp>
+      <p:sp>
+        <p:nvSpPr>
+          <p:cNvPr id="27" name="Shape 24"/>
+          <p:cNvSpPr/>
+          <p:nvPr/>
+        </p:nvSpPr>
+        <p:spPr>
+          <a:xfrm>
+            <a:off x="7296912" y="0"/>
+            <a:ext cx="2432304" cy="137160"/>
+          </a:xfrm>
+          <a:prstGeom prst="rect">
+            <a:avLst/>
+          </a:prstGeom>
+          <a:solidFill>
+            <a:srgbClr val="FF4D5F"/>
+          </a:solidFill>
+          <a:ln/>
+        </p:spPr>
+        <p:txBody>
+          <a:bodyPr/>
+          <a:lstStyle/>
+          <a:p>
+            <a:endParaRPr lang="en-US"/>
+          </a:p>
+        </p:txBody>
+      </p:sp>
+      <p:sp>
+        <p:nvSpPr>
+          <p:cNvPr id="28" name="Shape 25"/>
+          <p:cNvSpPr/>
+          <p:nvPr/>
+        </p:nvSpPr>
+        <p:spPr>
+          <a:xfrm>
+            <a:off x="9729216" y="0"/>
+            <a:ext cx="2432304" cy="137160"/>
+          </a:xfrm>
+          <a:prstGeom prst="rect">
+            <a:avLst/>
+          </a:prstGeom>
+          <a:solidFill>
+            <a:srgbClr val="C7B9FF"/>
+          </a:solidFill>
+          <a:ln/>
+        </p:spPr>
+        <p:txBody>
+          <a:bodyPr/>
+          <a:lstStyle/>
+          <a:p>
+            <a:endParaRPr lang="en-US"/>
+          </a:p>
+        </p:txBody>
+      </p:sp>
+      <p:sp>
+        <p:nvSpPr>
+          <p:cNvPr id="29" name="Text 26"/>
+          <p:cNvSpPr/>
+          <p:nvPr/>
+        </p:nvSpPr>
+        <p:spPr>
+          <a:xfrm>
+            <a:off x="548640" y="6446520"/>
+            <a:ext cx="7315200" cy="274320"/>
+          </a:xfrm>
+          <a:prstGeom prst="rect">
+            <a:avLst/>
+          </a:prstGeom>
+          <a:noFill/>
+          <a:ln/>
+        </p:spPr>
+        <p:txBody>
+          <a:bodyPr wrap="square" lIns="0" tIns="0" rIns="0" bIns="0" rtlCol="0" anchor="ctr"/>
+          <a:lstStyle/>
+          <a:p>
+            <a:pPr marL="0" indent="0" algn="l">
+              <a:buNone/>
+            </a:pPr>
+            <a:r>
+              <a:rPr lang="en-US" sz="750" dirty="0">
+                <a:solidFill>
+                  <a:srgbClr val="666666"/>
+                </a:solidFill>
+              </a:rPr>
+              <a:t>© Slalom. All Rights Reserved. Proprietary and Confidential.</a:t>
+            </a:r>
+            <a:endParaRPr lang="en-US" sz="750" dirty="0"/>
+          </a:p>
+        </p:txBody>
+      </p:sp>
+      <p:sp>
+        <p:nvSpPr>
+          <p:cNvPr id="30" name="Text 27"/>
+          <p:cNvSpPr/>
+          <p:nvPr/>
+        </p:nvSpPr>
+        <p:spPr>
+          <a:xfrm>
+            <a:off x="11521440" y="6446520"/>
+            <a:ext cx="365760" cy="274320"/>
+          </a:xfrm>
+          <a:prstGeom prst="rect">
+            <a:avLst/>
+          </a:prstGeom>
+          <a:noFill/>
+          <a:ln/>
+        </p:spPr>
+        <p:txBody>
+          <a:bodyPr wrap="square" lIns="0" tIns="0" rIns="0" bIns="0" rtlCol="0" anchor="ctr"/>
+          <a:lstStyle/>
+          <a:p>
+            <a:pPr marL="0" indent="0" algn="r">
+              <a:buNone/>
+            </a:pPr>
+            <a:r>
+              <a:rPr lang="en-US" sz="1000" dirty="0">
+                <a:solidFill>
+                  <a:srgbClr val="666666"/>
+                </a:solidFill>
+              </a:rPr>
+              <a:t>8</a:t>
+            </a:r>
+            <a:endParaRPr lang="en-US" sz="1000" dirty="0"/>
+          </a:p>
+        </p:txBody>
+      </p:sp>
+      <p:sp>
+        <p:nvSpPr>
+          <p:cNvPr id="31" name="TextBox 30"/>
+          <p:cNvSpPr txBox="1"/>
+          <p:nvPr/>
+        </p:nvSpPr>
+        <p:spPr>
+          <a:xfrm>
+            <a:off x="548640" y="1188720"/>
+            <a:ext cx="11064240" cy="365760"/>
+          </a:xfrm>
+          <a:prstGeom prst="rect">
+            <a:avLst/>
+          </a:prstGeom>
+          <a:noFill/>
+        </p:spPr>
+        <p:txBody>
+          <a:bodyPr wrap="square" lIns="27432" rIns="27432" tIns="0" bIns="0" anchor="ctr">
+            <a:spAutoFit/>
+          </a:bodyPr>
+          <a:lstStyle/>
+          <a:p>
+            <a:pPr algn="l"/>
+            <a:r>
+              <a:rPr sz="1400" b="0">
+                <a:solidFill>
+                  <a:srgbClr val="5A6478"/>
+                </a:solidFill>
+                <a:latin typeface="Avenir Next LT Pro"/>
+              </a:rPr>
+              <a:t>Each skill triggers from natural language — </a:t>
+            </a:r>
+            <a:r>
+              <a:rPr sz="1400" b="1">
+                <a:solidFill>
+                  <a:srgbClr val="17203A"/>
+                </a:solidFill>
+                <a:latin typeface="Avenir Next LT Pro"/>
+              </a:rPr>
+              <a:t>type a prompt like these</a:t>
+            </a:r>
+            <a:r>
+              <a:rPr sz="1400" b="0">
+                <a:solidFill>
+                  <a:srgbClr val="5A6478"/>
+                </a:solidFill>
+                <a:latin typeface="Avenir Next LT Pro"/>
+              </a:rPr>
+              <a:t> in Claude Code and the matching skill takes over. No commands to memorise.</a:t>
+            </a:r>
+          </a:p>
+        </p:txBody>
+      </p:sp>
+      <p:sp>
+        <p:nvSpPr>
+          <p:cNvPr id="32" name="Rounded Rectangle 31"/>
+          <p:cNvSpPr/>
+          <p:nvPr/>
+        </p:nvSpPr>
+        <p:spPr>
+          <a:xfrm>
+            <a:off x="548640" y="1572768"/>
+            <a:ext cx="5440680" cy="1453896"/>
+          </a:xfrm>
+          <a:prstGeom prst="roundRect">
+            <a:avLst>
+              <a:gd name="adj" fmla="val 5500"/>
+            </a:avLst>
+          </a:prstGeom>
+          <a:solidFill>
+            <a:srgbClr val="FFFFFF"/>
+          </a:solidFill>
+          <a:ln w="12700">
+            <a:solidFill>
+              <a:srgbClr val="E7ECF5"/>
+            </a:solidFill>
+          </a:ln>
+          <a:effectLst/>
+        </p:spPr>
+        <p:style>
+          <a:lnRef idx="1">
+            <a:schemeClr val="accent1"/>
+          </a:lnRef>
+          <a:fillRef idx="3">
+            <a:schemeClr val="accent1"/>
+          </a:fillRef>
+          <a:effectRef idx="2">
+            <a:schemeClr val="accent1"/>
+          </a:effectRef>
+          <a:fontRef idx="minor">
+            <a:schemeClr val="lt1"/>
+          </a:fontRef>
+        </p:style>
+        <p:txBody>
+          <a:bodyPr rtlCol="0" anchor="ctr"/>
+          <a:lstStyle/>
+          <a:p>
+            <a:pPr algn="ctr"/>
+          </a:p>
+        </p:txBody>
+      </p:sp>
+      <p:sp>
+        <p:nvSpPr>
+          <p:cNvPr id="33" name="Rounded Rectangle 32"/>
+          <p:cNvSpPr/>
+          <p:nvPr/>
+        </p:nvSpPr>
+        <p:spPr>
+          <a:xfrm>
+            <a:off x="768096" y="1755648"/>
+            <a:ext cx="384048" cy="384048"/>
+          </a:xfrm>
+          <a:prstGeom prst="roundRect">
+            <a:avLst>
+              <a:gd name="adj" fmla="val 26000"/>
+            </a:avLst>
+          </a:prstGeom>
+          <a:solidFill>
+            <a:srgbClr val="2E9E5B"/>
+          </a:solidFill>
+          <a:ln>
+            <a:noFill/>
+          </a:ln>
+          <a:effectLst/>
+        </p:spPr>
+        <p:style>
+          <a:lnRef idx="1">
+            <a:schemeClr val="accent1"/>
+          </a:lnRef>
+          <a:fillRef idx="3">
+            <a:schemeClr val="accent1"/>
+          </a:fillRef>
+          <a:effectRef idx="2">
+            <a:schemeClr val="accent1"/>
+          </a:effectRef>
+          <a:fontRef idx="minor">
+            <a:schemeClr val="lt1"/>
+          </a:fontRef>
+        </p:style>
+        <p:txBody>
+          <a:bodyPr rtlCol="0" anchor="ctr"/>
+          <a:lstStyle/>
+          <a:p>
+            <a:pPr algn="ctr"/>
+          </a:p>
+        </p:txBody>
+      </p:sp>
+      <p:pic>
+        <p:nvPicPr>
+          <p:cNvPr id="34" name="Picture 33" descr="image.png"/>
+          <p:cNvPicPr>
+            <a:picLocks noChangeAspect="1"/>
+          </p:cNvPicPr>
+          <p:nvPr/>
+        </p:nvPicPr>
+        <p:blipFill>
+          <a:blip r:embed="rId2"/>
+          <a:stretch>
+            <a:fillRect/>
+          </a:stretch>
+        </p:blipFill>
+        <p:spPr>
+          <a:xfrm>
+            <a:off x="868680" y="1856231"/>
+            <a:ext cx="182880" cy="182880"/>
+          </a:xfrm>
+          <a:prstGeom prst="rect">
+            <a:avLst/>
+          </a:prstGeom>
+        </p:spPr>
+      </p:pic>
+      <p:sp>
+        <p:nvSpPr>
+          <p:cNvPr id="35" name="TextBox 34"/>
+          <p:cNvSpPr txBox="1"/>
+          <p:nvPr/>
+        </p:nvSpPr>
+        <p:spPr>
+          <a:xfrm>
+            <a:off x="1280160" y="1755648"/>
+            <a:ext cx="4526280" cy="384048"/>
+          </a:xfrm>
+          <a:prstGeom prst="rect">
+            <a:avLst/>
+          </a:prstGeom>
+          <a:noFill/>
+        </p:spPr>
+        <p:txBody>
+          <a:bodyPr wrap="square" lIns="27432" rIns="27432" tIns="0" bIns="0" anchor="ctr">
+            <a:spAutoFit/>
+          </a:bodyPr>
+          <a:lstStyle/>
+          <a:p>
+            <a:pPr algn="l"/>
+            <a:r>
+              <a:rPr sz="1800" b="1">
+                <a:solidFill>
+                  <a:srgbClr val="2E9E5B"/>
+                </a:solidFill>
+                <a:latin typeface="Avenir Next LT Pro"/>
+              </a:rPr>
+              <a:t>Detect  </a:t>
+            </a:r>
+            <a:r>
+              <a:rPr sz="1200" b="0">
+                <a:solidFill>
+                  <a:srgbClr val="6B7280"/>
+                </a:solidFill>
+                <a:latin typeface="Consolas"/>
+              </a:rPr>
+              <a:t>tech-detector</a:t>
+            </a:r>
+          </a:p>
+        </p:txBody>
+      </p:sp>
+      <p:sp>
+        <p:nvSpPr>
+          <p:cNvPr id="36" name="Rounded Rectangle 35"/>
+          <p:cNvSpPr/>
+          <p:nvPr/>
+        </p:nvSpPr>
+        <p:spPr>
+          <a:xfrm>
+            <a:off x="768096" y="2286000"/>
+            <a:ext cx="5001768" cy="603504"/>
+          </a:xfrm>
+          <a:prstGeom prst="roundRect">
+            <a:avLst>
+              <a:gd name="adj" fmla="val 12000"/>
+            </a:avLst>
+          </a:prstGeom>
+          <a:solidFill>
+            <a:srgbClr val="F4F7FB"/>
+          </a:solidFill>
+          <a:ln w="12700">
+            <a:solidFill>
+              <a:srgbClr val="E4EAF3"/>
+            </a:solidFill>
+          </a:ln>
+          <a:effectLst/>
+        </p:spPr>
+        <p:style>
+          <a:lnRef idx="1">
+            <a:schemeClr val="accent1"/>
+          </a:lnRef>
+          <a:fillRef idx="3">
+            <a:schemeClr val="accent1"/>
+          </a:fillRef>
+          <a:effectRef idx="2">
+            <a:schemeClr val="accent1"/>
+          </a:effectRef>
+          <a:fontRef idx="minor">
+            <a:schemeClr val="lt1"/>
+          </a:fontRef>
+        </p:style>
+        <p:txBody>
+          <a:bodyPr rtlCol="0" anchor="ctr"/>
+          <a:lstStyle/>
+          <a:p>
+            <a:pPr algn="ctr"/>
+          </a:p>
+        </p:txBody>
+      </p:sp>
+      <p:sp>
+        <p:nvSpPr>
+          <p:cNvPr id="37" name="TextBox 36"/>
+          <p:cNvSpPr txBox="1"/>
+          <p:nvPr/>
+        </p:nvSpPr>
+        <p:spPr>
+          <a:xfrm>
+            <a:off x="896112" y="2286000"/>
+            <a:ext cx="274320" cy="603504"/>
+          </a:xfrm>
+          <a:prstGeom prst="rect">
+            <a:avLst/>
+          </a:prstGeom>
+          <a:noFill/>
+        </p:spPr>
+        <p:txBody>
+          <a:bodyPr wrap="square" lIns="27432" rIns="27432" tIns="0" bIns="0" anchor="ctr">
+            <a:spAutoFit/>
+          </a:bodyPr>
+          <a:lstStyle/>
+          <a:p>
+            <a:pPr algn="l"/>
+            <a:r>
+              <a:rPr sz="1300" b="1">
+                <a:solidFill>
+                  <a:srgbClr val="2E9E5B"/>
+                </a:solidFill>
+                <a:latin typeface="Consolas"/>
+              </a:rPr>
+              <a:t>❯</a:t>
+            </a:r>
+          </a:p>
+        </p:txBody>
+      </p:sp>
+      <p:sp>
+        <p:nvSpPr>
+          <p:cNvPr id="38" name="TextBox 37"/>
+          <p:cNvSpPr txBox="1"/>
+          <p:nvPr/>
+        </p:nvSpPr>
+        <p:spPr>
+          <a:xfrm>
+            <a:off x="1152144" y="2304288"/>
+            <a:ext cx="4572000" cy="566928"/>
+          </a:xfrm>
+          <a:prstGeom prst="rect">
+            <a:avLst/>
+          </a:prstGeom>
+          <a:noFill/>
+        </p:spPr>
+        <p:txBody>
+          <a:bodyPr wrap="square" lIns="27432" rIns="27432" tIns="0" bIns="0" anchor="ctr">
+            <a:spAutoFit/>
+          </a:bodyPr>
+          <a:lstStyle/>
+          <a:p>
+            <a:pPr algn="l"/>
+            <a:r>
+              <a:rPr sz="1200" b="0">
+                <a:solidFill>
+                  <a:srgbClr val="2B3550"/>
+                </a:solidFill>
+                <a:latin typeface="Consolas"/>
+              </a:rPr>
+              <a:t>What Adobe tools does aboutamazon.com run — Web SDK or AppMeasurement?</a:t>
+            </a:r>
+          </a:p>
+        </p:txBody>
+      </p:sp>
+      <p:sp>
+        <p:nvSpPr>
+          <p:cNvPr id="39" name="Rounded Rectangle 38"/>
+          <p:cNvSpPr/>
+          <p:nvPr/>
+        </p:nvSpPr>
+        <p:spPr>
+          <a:xfrm>
+            <a:off x="6199632" y="1572768"/>
+            <a:ext cx="5440680" cy="1453896"/>
+          </a:xfrm>
+          <a:prstGeom prst="roundRect">
+            <a:avLst>
+              <a:gd name="adj" fmla="val 5500"/>
+            </a:avLst>
+          </a:prstGeom>
+          <a:solidFill>
+            <a:srgbClr val="FFFFFF"/>
+          </a:solidFill>
+          <a:ln w="12700">
+            <a:solidFill>
+              <a:srgbClr val="E7ECF5"/>
+            </a:solidFill>
+          </a:ln>
+          <a:effectLst/>
+        </p:spPr>
+        <p:style>
+          <a:lnRef idx="1">
+            <a:schemeClr val="accent1"/>
+          </a:lnRef>
+          <a:fillRef idx="3">
+            <a:schemeClr val="accent1"/>
+          </a:fillRef>
+          <a:effectRef idx="2">
+            <a:schemeClr val="accent1"/>
+          </a:effectRef>
+          <a:fontRef idx="minor">
+            <a:schemeClr val="lt1"/>
+          </a:fontRef>
+        </p:style>
+        <p:txBody>
+          <a:bodyPr rtlCol="0" anchor="ctr"/>
+          <a:lstStyle/>
+          <a:p>
+            <a:pPr algn="ctr"/>
+          </a:p>
+        </p:txBody>
+      </p:sp>
+      <p:sp>
+        <p:nvSpPr>
+          <p:cNvPr id="40" name="Rounded Rectangle 39"/>
+          <p:cNvSpPr/>
+          <p:nvPr/>
+        </p:nvSpPr>
+        <p:spPr>
+          <a:xfrm>
+            <a:off x="6419088" y="1755648"/>
+            <a:ext cx="384048" cy="384048"/>
+          </a:xfrm>
+          <a:prstGeom prst="roundRect">
+            <a:avLst>
+              <a:gd name="adj" fmla="val 26000"/>
+            </a:avLst>
+          </a:prstGeom>
+          <a:solidFill>
+            <a:srgbClr val="12A5A0"/>
+          </a:solidFill>
+          <a:ln>
+            <a:noFill/>
+          </a:ln>
+          <a:effectLst/>
+        </p:spPr>
+        <p:style>
+          <a:lnRef idx="1">
+            <a:schemeClr val="accent1"/>
+          </a:lnRef>
+          <a:fillRef idx="3">
+            <a:schemeClr val="accent1"/>
+          </a:fillRef>
+          <a:effectRef idx="2">
+            <a:schemeClr val="accent1"/>
+          </a:effectRef>
+          <a:fontRef idx="minor">
+            <a:schemeClr val="lt1"/>
+          </a:fontRef>
+        </p:style>
+        <p:txBody>
+          <a:bodyPr rtlCol="0" anchor="ctr"/>
+          <a:lstStyle/>
+          <a:p>
+            <a:pPr algn="ctr"/>
+          </a:p>
+        </p:txBody>
+      </p:sp>
+      <p:pic>
+        <p:nvPicPr>
+          <p:cNvPr id="41" name="Picture 40" descr="image.png"/>
+          <p:cNvPicPr>
+            <a:picLocks noChangeAspect="1"/>
+          </p:cNvPicPr>
+          <p:nvPr/>
+        </p:nvPicPr>
+        <p:blipFill>
+          <a:blip r:embed="rId3"/>
+          <a:stretch>
+            <a:fillRect/>
+          </a:stretch>
+        </p:blipFill>
+        <p:spPr>
+          <a:xfrm>
+            <a:off x="6519672" y="1856231"/>
+            <a:ext cx="182880" cy="182880"/>
+          </a:xfrm>
+          <a:prstGeom prst="rect">
+            <a:avLst/>
+          </a:prstGeom>
+        </p:spPr>
+      </p:pic>
+      <p:sp>
+        <p:nvSpPr>
+          <p:cNvPr id="42" name="TextBox 41"/>
+          <p:cNvSpPr txBox="1"/>
+          <p:nvPr/>
+        </p:nvSpPr>
+        <p:spPr>
+          <a:xfrm>
+            <a:off x="6931152" y="1755648"/>
+            <a:ext cx="4526280" cy="384048"/>
+          </a:xfrm>
+          <a:prstGeom prst="rect">
+            <a:avLst/>
+          </a:prstGeom>
+          <a:noFill/>
+        </p:spPr>
+        <p:txBody>
+          <a:bodyPr wrap="square" lIns="27432" rIns="27432" tIns="0" bIns="0" anchor="ctr">
+            <a:spAutoFit/>
+          </a:bodyPr>
+          <a:lstStyle/>
+          <a:p>
+            <a:pPr algn="l"/>
+            <a:r>
+              <a:rPr sz="1800" b="1">
+                <a:solidFill>
+                  <a:srgbClr val="12A5A0"/>
+                </a:solidFill>
+                <a:latin typeface="Avenir Next LT Pro"/>
+              </a:rPr>
+              <a:t>Plan  </a:t>
+            </a:r>
+            <a:r>
+              <a:rPr sz="1200" b="0">
+                <a:solidFill>
+                  <a:srgbClr val="6B7280"/>
+                </a:solidFill>
+                <a:latin typeface="Consolas"/>
+              </a:rPr>
+              <a:t>setup-plan</a:t>
+            </a:r>
+          </a:p>
+        </p:txBody>
+      </p:sp>
+      <p:sp>
+        <p:nvSpPr>
+          <p:cNvPr id="43" name="Rounded Rectangle 42"/>
+          <p:cNvSpPr/>
+          <p:nvPr/>
+        </p:nvSpPr>
+        <p:spPr>
+          <a:xfrm>
+            <a:off x="6419088" y="2286000"/>
+            <a:ext cx="5001768" cy="603504"/>
+          </a:xfrm>
+          <a:prstGeom prst="roundRect">
+            <a:avLst>
+              <a:gd name="adj" fmla="val 12000"/>
+            </a:avLst>
+          </a:prstGeom>
+          <a:solidFill>
+            <a:srgbClr val="F4F7FB"/>
+          </a:solidFill>
+          <a:ln w="12700">
+            <a:solidFill>
+              <a:srgbClr val="E4EAF3"/>
+            </a:solidFill>
+          </a:ln>
+          <a:effectLst/>
+        </p:spPr>
+        <p:style>
+          <a:lnRef idx="1">
+            <a:schemeClr val="accent1"/>
+          </a:lnRef>
+          <a:fillRef idx="3">
+            <a:schemeClr val="accent1"/>
+          </a:fillRef>
+          <a:effectRef idx="2">
+            <a:schemeClr val="accent1"/>
+          </a:effectRef>
+          <a:fontRef idx="minor">
+            <a:schemeClr val="lt1"/>
+          </a:fontRef>
+        </p:style>
+        <p:txBody>
+          <a:bodyPr rtlCol="0" anchor="ctr"/>
+          <a:lstStyle/>
+          <a:p>
+            <a:pPr algn="ctr"/>
+          </a:p>
+        </p:txBody>
+      </p:sp>
+      <p:sp>
+        <p:nvSpPr>
+          <p:cNvPr id="44" name="TextBox 43"/>
+          <p:cNvSpPr txBox="1"/>
+          <p:nvPr/>
+        </p:nvSpPr>
+        <p:spPr>
+          <a:xfrm>
+            <a:off x="6547104" y="2286000"/>
+            <a:ext cx="274320" cy="603504"/>
+          </a:xfrm>
+          <a:prstGeom prst="rect">
+            <a:avLst/>
+          </a:prstGeom>
+          <a:noFill/>
+        </p:spPr>
+        <p:txBody>
+          <a:bodyPr wrap="square" lIns="27432" rIns="27432" tIns="0" bIns="0" anchor="ctr">
+            <a:spAutoFit/>
+          </a:bodyPr>
+          <a:lstStyle/>
+          <a:p>
+            <a:pPr algn="l"/>
+            <a:r>
+              <a:rPr sz="1300" b="1">
+                <a:solidFill>
+                  <a:srgbClr val="12A5A0"/>
+                </a:solidFill>
+                <a:latin typeface="Consolas"/>
+              </a:rPr>
+              <a:t>❯</a:t>
+            </a:r>
+          </a:p>
+        </p:txBody>
+      </p:sp>
+      <p:sp>
+        <p:nvSpPr>
+          <p:cNvPr id="45" name="TextBox 44"/>
+          <p:cNvSpPr txBox="1"/>
+          <p:nvPr/>
+        </p:nvSpPr>
+        <p:spPr>
+          <a:xfrm>
+            <a:off x="6803136" y="2304288"/>
+            <a:ext cx="4572000" cy="566928"/>
+          </a:xfrm>
+          <a:prstGeom prst="rect">
+            <a:avLst/>
+          </a:prstGeom>
+          <a:noFill/>
+        </p:spPr>
+        <p:txBody>
+          <a:bodyPr wrap="square" lIns="27432" rIns="27432" tIns="0" bIns="0" anchor="ctr">
+            <a:spAutoFit/>
+          </a:bodyPr>
+          <a:lstStyle/>
+          <a:p>
+            <a:pPr algn="l"/>
+            <a:r>
+              <a:rPr sz="1200" b="0">
+                <a:solidFill>
+                  <a:srgbClr val="2B3550"/>
+                </a:solidFill>
+                <a:latin typeface="Consolas"/>
+              </a:rPr>
+              <a:t>Plan our DTM-to-Launch migration with consent gating and approval gates.</a:t>
+            </a:r>
+          </a:p>
+        </p:txBody>
+      </p:sp>
+      <p:sp>
+        <p:nvSpPr>
+          <p:cNvPr id="46" name="Rounded Rectangle 45"/>
+          <p:cNvSpPr/>
+          <p:nvPr/>
+        </p:nvSpPr>
+        <p:spPr>
+          <a:xfrm>
+            <a:off x="548640" y="3191256"/>
+            <a:ext cx="5440680" cy="1453896"/>
+          </a:xfrm>
+          <a:prstGeom prst="roundRect">
+            <a:avLst>
+              <a:gd name="adj" fmla="val 5500"/>
+            </a:avLst>
+          </a:prstGeom>
+          <a:solidFill>
+            <a:srgbClr val="FFFFFF"/>
+          </a:solidFill>
+          <a:ln w="12700">
+            <a:solidFill>
+              <a:srgbClr val="E7ECF5"/>
+            </a:solidFill>
+          </a:ln>
+          <a:effectLst/>
+        </p:spPr>
+        <p:style>
+          <a:lnRef idx="1">
+            <a:schemeClr val="accent1"/>
+          </a:lnRef>
+          <a:fillRef idx="3">
+            <a:schemeClr val="accent1"/>
+          </a:fillRef>
+          <a:effectRef idx="2">
+            <a:schemeClr val="accent1"/>
+          </a:effectRef>
+          <a:fontRef idx="minor">
+            <a:schemeClr val="lt1"/>
+          </a:fontRef>
+        </p:style>
+        <p:txBody>
+          <a:bodyPr rtlCol="0" anchor="ctr"/>
+          <a:lstStyle/>
+          <a:p>
+            <a:pPr algn="ctr"/>
+          </a:p>
+        </p:txBody>
+      </p:sp>
+      <p:sp>
+        <p:nvSpPr>
+          <p:cNvPr id="47" name="Rounded Rectangle 46"/>
+          <p:cNvSpPr/>
+          <p:nvPr/>
+        </p:nvSpPr>
+        <p:spPr>
+          <a:xfrm>
+            <a:off x="768096" y="3374136"/>
+            <a:ext cx="384048" cy="384048"/>
+          </a:xfrm>
+          <a:prstGeom prst="roundRect">
+            <a:avLst>
+              <a:gd name="adj" fmla="val 26000"/>
+            </a:avLst>
+          </a:prstGeom>
+          <a:solidFill>
+            <a:srgbClr val="1391C4"/>
+          </a:solidFill>
+          <a:ln>
+            <a:noFill/>
+          </a:ln>
+          <a:effectLst/>
+        </p:spPr>
+        <p:style>
+          <a:lnRef idx="1">
+            <a:schemeClr val="accent1"/>
+          </a:lnRef>
+          <a:fillRef idx="3">
+            <a:schemeClr val="accent1"/>
+          </a:fillRef>
+          <a:effectRef idx="2">
+            <a:schemeClr val="accent1"/>
+          </a:effectRef>
+          <a:fontRef idx="minor">
+            <a:schemeClr val="lt1"/>
+          </a:fontRef>
+        </p:style>
+        <p:txBody>
+          <a:bodyPr rtlCol="0" anchor="ctr"/>
+          <a:lstStyle/>
+          <a:p>
+            <a:pPr algn="ctr"/>
+          </a:p>
+        </p:txBody>
+      </p:sp>
+      <p:pic>
+        <p:nvPicPr>
+          <p:cNvPr id="48" name="Picture 47" descr="image.png"/>
+          <p:cNvPicPr>
+            <a:picLocks noChangeAspect="1"/>
+          </p:cNvPicPr>
+          <p:nvPr/>
+        </p:nvPicPr>
+        <p:blipFill>
+          <a:blip r:embed="rId4"/>
+          <a:stretch>
+            <a:fillRect/>
+          </a:stretch>
+        </p:blipFill>
+        <p:spPr>
+          <a:xfrm>
+            <a:off x="868680" y="3474720"/>
+            <a:ext cx="182880" cy="182880"/>
+          </a:xfrm>
+          <a:prstGeom prst="rect">
+            <a:avLst/>
+          </a:prstGeom>
+        </p:spPr>
+      </p:pic>
+      <p:sp>
+        <p:nvSpPr>
+          <p:cNvPr id="49" name="TextBox 48"/>
+          <p:cNvSpPr txBox="1"/>
+          <p:nvPr/>
+        </p:nvSpPr>
+        <p:spPr>
+          <a:xfrm>
+            <a:off x="1280160" y="3374136"/>
+            <a:ext cx="4526280" cy="384048"/>
+          </a:xfrm>
+          <a:prstGeom prst="rect">
+            <a:avLst/>
+          </a:prstGeom>
+          <a:noFill/>
+        </p:spPr>
+        <p:txBody>
+          <a:bodyPr wrap="square" lIns="27432" rIns="27432" tIns="0" bIns="0" anchor="ctr">
+            <a:spAutoFit/>
+          </a:bodyPr>
+          <a:lstStyle/>
+          <a:p>
+            <a:pPr algn="l"/>
+            <a:r>
+              <a:rPr sz="1800" b="1">
+                <a:solidFill>
+                  <a:srgbClr val="1391C4"/>
+                </a:solidFill>
+                <a:latin typeface="Avenir Next LT Pro"/>
+              </a:rPr>
+              <a:t>Build  </a:t>
+            </a:r>
+            <a:r>
+              <a:rPr sz="1200" b="0">
+                <a:solidFill>
+                  <a:srgbClr val="6B7280"/>
+                </a:solidFill>
+                <a:latin typeface="Consolas"/>
+              </a:rPr>
+              <a:t>data-collection-builder</a:t>
+            </a:r>
+          </a:p>
+        </p:txBody>
+      </p:sp>
+      <p:sp>
+        <p:nvSpPr>
+          <p:cNvPr id="50" name="Rounded Rectangle 49"/>
+          <p:cNvSpPr/>
+          <p:nvPr/>
+        </p:nvSpPr>
+        <p:spPr>
+          <a:xfrm>
+            <a:off x="768096" y="3904488"/>
+            <a:ext cx="5001768" cy="603504"/>
+          </a:xfrm>
+          <a:prstGeom prst="roundRect">
+            <a:avLst>
+              <a:gd name="adj" fmla="val 12000"/>
+            </a:avLst>
+          </a:prstGeom>
+          <a:solidFill>
+            <a:srgbClr val="F4F7FB"/>
+          </a:solidFill>
+          <a:ln w="12700">
+            <a:solidFill>
+              <a:srgbClr val="E4EAF3"/>
+            </a:solidFill>
+          </a:ln>
+          <a:effectLst/>
+        </p:spPr>
+        <p:style>
+          <a:lnRef idx="1">
+            <a:schemeClr val="accent1"/>
+          </a:lnRef>
+          <a:fillRef idx="3">
+            <a:schemeClr val="accent1"/>
+          </a:fillRef>
+          <a:effectRef idx="2">
+            <a:schemeClr val="accent1"/>
+          </a:effectRef>
+          <a:fontRef idx="minor">
+            <a:schemeClr val="lt1"/>
+          </a:fontRef>
+        </p:style>
+        <p:txBody>
+          <a:bodyPr rtlCol="0" anchor="ctr"/>
+          <a:lstStyle/>
+          <a:p>
+            <a:pPr algn="ctr"/>
+          </a:p>
+        </p:txBody>
+      </p:sp>
+      <p:sp>
+        <p:nvSpPr>
+          <p:cNvPr id="51" name="TextBox 50"/>
+          <p:cNvSpPr txBox="1"/>
+          <p:nvPr/>
+        </p:nvSpPr>
+        <p:spPr>
+          <a:xfrm>
+            <a:off x="896112" y="3904488"/>
+            <a:ext cx="274320" cy="603504"/>
+          </a:xfrm>
+          <a:prstGeom prst="rect">
+            <a:avLst/>
+          </a:prstGeom>
+          <a:noFill/>
+        </p:spPr>
+        <p:txBody>
+          <a:bodyPr wrap="square" lIns="27432" rIns="27432" tIns="0" bIns="0" anchor="ctr">
+            <a:spAutoFit/>
+          </a:bodyPr>
+          <a:lstStyle/>
+          <a:p>
+            <a:pPr algn="l"/>
+            <a:r>
+              <a:rPr sz="1300" b="1">
+                <a:solidFill>
+                  <a:srgbClr val="1391C4"/>
+                </a:solidFill>
+                <a:latin typeface="Consolas"/>
+              </a:rPr>
+              <a:t>❯</a:t>
+            </a:r>
+          </a:p>
+        </p:txBody>
+      </p:sp>
+      <p:sp>
+        <p:nvSpPr>
+          <p:cNvPr id="52" name="TextBox 51"/>
+          <p:cNvSpPr txBox="1"/>
+          <p:nvPr/>
+        </p:nvSpPr>
+        <p:spPr>
+          <a:xfrm>
+            <a:off x="1152144" y="3922776"/>
+            <a:ext cx="4572000" cy="566928"/>
+          </a:xfrm>
+          <a:prstGeom prst="rect">
+            <a:avLst/>
+          </a:prstGeom>
+          <a:noFill/>
+        </p:spPr>
+        <p:txBody>
+          <a:bodyPr wrap="square" lIns="27432" rIns="27432" tIns="0" bIns="0" anchor="ctr">
+            <a:spAutoFit/>
+          </a:bodyPr>
+          <a:lstStyle/>
+          <a:p>
+            <a:pPr algn="l"/>
+            <a:r>
+              <a:rPr sz="1200" b="0">
+                <a:solidFill>
+                  <a:srgbClr val="2B3550"/>
+                </a:solidFill>
+                <a:latin typeface="Consolas"/>
+              </a:rPr>
+              <a:t>Build the SDR and Web SDK XDM schema, with universal data elements &amp; rules.</a:t>
+            </a:r>
+          </a:p>
+        </p:txBody>
+      </p:sp>
+      <p:sp>
+        <p:nvSpPr>
+          <p:cNvPr id="53" name="Rounded Rectangle 52"/>
+          <p:cNvSpPr/>
+          <p:nvPr/>
+        </p:nvSpPr>
+        <p:spPr>
+          <a:xfrm>
+            <a:off x="6199632" y="3191256"/>
+            <a:ext cx="5440680" cy="1453896"/>
+          </a:xfrm>
+          <a:prstGeom prst="roundRect">
+            <a:avLst>
+              <a:gd name="adj" fmla="val 5500"/>
+            </a:avLst>
+          </a:prstGeom>
+          <a:solidFill>
+            <a:srgbClr val="FFFFFF"/>
+          </a:solidFill>
+          <a:ln w="12700">
+            <a:solidFill>
+              <a:srgbClr val="E7ECF5"/>
+            </a:solidFill>
+          </a:ln>
+          <a:effectLst/>
+        </p:spPr>
+        <p:style>
+          <a:lnRef idx="1">
+            <a:schemeClr val="accent1"/>
+          </a:lnRef>
+          <a:fillRef idx="3">
+            <a:schemeClr val="accent1"/>
+          </a:fillRef>
+          <a:effectRef idx="2">
+            <a:schemeClr val="accent1"/>
+          </a:effectRef>
+          <a:fontRef idx="minor">
+            <a:schemeClr val="lt1"/>
+          </a:fontRef>
+        </p:style>
+        <p:txBody>
+          <a:bodyPr rtlCol="0" anchor="ctr"/>
+          <a:lstStyle/>
+          <a:p>
+            <a:pPr algn="ctr"/>
+          </a:p>
+        </p:txBody>
+      </p:sp>
+      <p:sp>
+        <p:nvSpPr>
+          <p:cNvPr id="54" name="Rounded Rectangle 53"/>
+          <p:cNvSpPr/>
+          <p:nvPr/>
+        </p:nvSpPr>
+        <p:spPr>
+          <a:xfrm>
+            <a:off x="6419088" y="3374136"/>
+            <a:ext cx="384048" cy="384048"/>
+          </a:xfrm>
+          <a:prstGeom prst="roundRect">
+            <a:avLst>
+              <a:gd name="adj" fmla="val 26000"/>
+            </a:avLst>
+          </a:prstGeom>
+          <a:solidFill>
+            <a:srgbClr val="0C62FB"/>
+          </a:solidFill>
+          <a:ln>
+            <a:noFill/>
+          </a:ln>
+          <a:effectLst/>
+        </p:spPr>
+        <p:style>
+          <a:lnRef idx="1">
+            <a:schemeClr val="accent1"/>
+          </a:lnRef>
+          <a:fillRef idx="3">
+            <a:schemeClr val="accent1"/>
+          </a:fillRef>
+          <a:effectRef idx="2">
+            <a:schemeClr val="accent1"/>
+          </a:effectRef>
+          <a:fontRef idx="minor">
+            <a:schemeClr val="lt1"/>
+          </a:fontRef>
+        </p:style>
+        <p:txBody>
+          <a:bodyPr rtlCol="0" anchor="ctr"/>
+          <a:lstStyle/>
+          <a:p>
+            <a:pPr algn="ctr"/>
+          </a:p>
+        </p:txBody>
+      </p:sp>
+      <p:pic>
+        <p:nvPicPr>
+          <p:cNvPr id="55" name="Picture 54" descr="image.png"/>
+          <p:cNvPicPr>
+            <a:picLocks noChangeAspect="1"/>
+          </p:cNvPicPr>
+          <p:nvPr/>
+        </p:nvPicPr>
+        <p:blipFill>
+          <a:blip r:embed="rId5"/>
+          <a:stretch>
+            <a:fillRect/>
+          </a:stretch>
+        </p:blipFill>
+        <p:spPr>
+          <a:xfrm>
+            <a:off x="6519672" y="3474720"/>
+            <a:ext cx="182880" cy="182880"/>
+          </a:xfrm>
+          <a:prstGeom prst="rect">
+            <a:avLst/>
+          </a:prstGeom>
+        </p:spPr>
+      </p:pic>
+      <p:sp>
+        <p:nvSpPr>
+          <p:cNvPr id="56" name="TextBox 55"/>
+          <p:cNvSpPr txBox="1"/>
+          <p:nvPr/>
+        </p:nvSpPr>
+        <p:spPr>
+          <a:xfrm>
+            <a:off x="6931152" y="3374136"/>
+            <a:ext cx="4526280" cy="384048"/>
+          </a:xfrm>
+          <a:prstGeom prst="rect">
+            <a:avLst/>
+          </a:prstGeom>
+          <a:noFill/>
+        </p:spPr>
+        <p:txBody>
+          <a:bodyPr wrap="square" lIns="27432" rIns="27432" tIns="0" bIns="0" anchor="ctr">
+            <a:spAutoFit/>
+          </a:bodyPr>
+          <a:lstStyle/>
+          <a:p>
+            <a:pPr algn="l"/>
+            <a:r>
+              <a:rPr sz="1800" b="1">
+                <a:solidFill>
+                  <a:srgbClr val="0C62FB"/>
+                </a:solidFill>
+                <a:latin typeface="Avenir Next LT Pro"/>
+              </a:rPr>
+              <a:t>Publish  </a:t>
+            </a:r>
+            <a:r>
+              <a:rPr sz="1200" b="0">
+                <a:solidFill>
+                  <a:srgbClr val="6B7280"/>
+                </a:solidFill>
+                <a:latin typeface="Consolas"/>
+              </a:rPr>
+              <a:t>property-creator</a:t>
+            </a:r>
+          </a:p>
+        </p:txBody>
+      </p:sp>
+      <p:sp>
+        <p:nvSpPr>
+          <p:cNvPr id="57" name="Rounded Rectangle 56"/>
+          <p:cNvSpPr/>
+          <p:nvPr/>
+        </p:nvSpPr>
+        <p:spPr>
+          <a:xfrm>
+            <a:off x="6419088" y="3904488"/>
+            <a:ext cx="5001768" cy="603504"/>
+          </a:xfrm>
+          <a:prstGeom prst="roundRect">
+            <a:avLst>
+              <a:gd name="adj" fmla="val 12000"/>
+            </a:avLst>
+          </a:prstGeom>
+          <a:solidFill>
+            <a:srgbClr val="F4F7FB"/>
+          </a:solidFill>
+          <a:ln w="12700">
+            <a:solidFill>
+              <a:srgbClr val="E4EAF3"/>
+            </a:solidFill>
+          </a:ln>
+          <a:effectLst/>
+        </p:spPr>
+        <p:style>
+          <a:lnRef idx="1">
+            <a:schemeClr val="accent1"/>
+          </a:lnRef>
+          <a:fillRef idx="3">
+            <a:schemeClr val="accent1"/>
+          </a:fillRef>
+          <a:effectRef idx="2">
+            <a:schemeClr val="accent1"/>
+          </a:effectRef>
+          <a:fontRef idx="minor">
+            <a:schemeClr val="lt1"/>
+          </a:fontRef>
+        </p:style>
+        <p:txBody>
+          <a:bodyPr rtlCol="0" anchor="ctr"/>
+          <a:lstStyle/>
+          <a:p>
+            <a:pPr algn="ctr"/>
+          </a:p>
+        </p:txBody>
+      </p:sp>
+      <p:sp>
+        <p:nvSpPr>
+          <p:cNvPr id="58" name="TextBox 57"/>
+          <p:cNvSpPr txBox="1"/>
+          <p:nvPr/>
+        </p:nvSpPr>
+        <p:spPr>
+          <a:xfrm>
+            <a:off x="6547104" y="3904488"/>
+            <a:ext cx="274320" cy="603504"/>
+          </a:xfrm>
+          <a:prstGeom prst="rect">
+            <a:avLst/>
+          </a:prstGeom>
+          <a:noFill/>
+        </p:spPr>
+        <p:txBody>
+          <a:bodyPr wrap="square" lIns="27432" rIns="27432" tIns="0" bIns="0" anchor="ctr">
+            <a:spAutoFit/>
+          </a:bodyPr>
+          <a:lstStyle/>
+          <a:p>
+            <a:pPr algn="l"/>
+            <a:r>
+              <a:rPr sz="1300" b="1">
+                <a:solidFill>
+                  <a:srgbClr val="0C62FB"/>
+                </a:solidFill>
+                <a:latin typeface="Consolas"/>
+              </a:rPr>
+              <a:t>❯</a:t>
+            </a:r>
+          </a:p>
+        </p:txBody>
+      </p:sp>
+      <p:sp>
+        <p:nvSpPr>
+          <p:cNvPr id="59" name="TextBox 58"/>
+          <p:cNvSpPr txBox="1"/>
+          <p:nvPr/>
+        </p:nvSpPr>
+        <p:spPr>
+          <a:xfrm>
+            <a:off x="6803136" y="3922776"/>
+            <a:ext cx="4572000" cy="566928"/>
+          </a:xfrm>
+          <a:prstGeom prst="rect">
+            <a:avLst/>
+          </a:prstGeom>
+          <a:noFill/>
+        </p:spPr>
+        <p:txBody>
+          <a:bodyPr wrap="square" lIns="27432" rIns="27432" tIns="0" bIns="0" anchor="ctr">
+            <a:spAutoFit/>
+          </a:bodyPr>
+          <a:lstStyle/>
+          <a:p>
+            <a:pPr algn="l"/>
+            <a:r>
+              <a:rPr sz="1200" b="0">
+                <a:solidFill>
+                  <a:srgbClr val="2B3550"/>
+                </a:solidFill>
+                <a:latin typeface="Consolas"/>
+              </a:rPr>
+              <a:t>Create the Launch property via the Reactor API and publish dev → prod.</a:t>
+            </a:r>
+          </a:p>
+        </p:txBody>
+      </p:sp>
+      <p:sp>
+        <p:nvSpPr>
+          <p:cNvPr id="60" name="Rounded Rectangle 59"/>
+          <p:cNvSpPr/>
+          <p:nvPr/>
+        </p:nvSpPr>
+        <p:spPr>
+          <a:xfrm>
+            <a:off x="548640" y="4809744"/>
+            <a:ext cx="5440680" cy="1453896"/>
+          </a:xfrm>
+          <a:prstGeom prst="roundRect">
+            <a:avLst>
+              <a:gd name="adj" fmla="val 5500"/>
+            </a:avLst>
+          </a:prstGeom>
+          <a:solidFill>
+            <a:srgbClr val="FFFFFF"/>
+          </a:solidFill>
+          <a:ln w="12700">
+            <a:solidFill>
+              <a:srgbClr val="E7ECF5"/>
+            </a:solidFill>
+          </a:ln>
+          <a:effectLst/>
+        </p:spPr>
+        <p:style>
+          <a:lnRef idx="1">
+            <a:schemeClr val="accent1"/>
+          </a:lnRef>
+          <a:fillRef idx="3">
+            <a:schemeClr val="accent1"/>
+          </a:fillRef>
+          <a:effectRef idx="2">
+            <a:schemeClr val="accent1"/>
+          </a:effectRef>
+          <a:fontRef idx="minor">
+            <a:schemeClr val="lt1"/>
+          </a:fontRef>
+        </p:style>
+        <p:txBody>
+          <a:bodyPr rtlCol="0" anchor="ctr"/>
+          <a:lstStyle/>
+          <a:p>
+            <a:pPr algn="ctr"/>
+          </a:p>
+        </p:txBody>
+      </p:sp>
+      <p:sp>
+        <p:nvSpPr>
+          <p:cNvPr id="61" name="Rounded Rectangle 60"/>
+          <p:cNvSpPr/>
+          <p:nvPr/>
+        </p:nvSpPr>
+        <p:spPr>
+          <a:xfrm>
+            <a:off x="768096" y="4992624"/>
+            <a:ext cx="384048" cy="384048"/>
+          </a:xfrm>
+          <a:prstGeom prst="roundRect">
+            <a:avLst>
+              <a:gd name="adj" fmla="val 26000"/>
+            </a:avLst>
+          </a:prstGeom>
+          <a:solidFill>
+            <a:srgbClr val="2547C8"/>
+          </a:solidFill>
+          <a:ln>
+            <a:noFill/>
+          </a:ln>
+          <a:effectLst/>
+        </p:spPr>
+        <p:style>
+          <a:lnRef idx="1">
+            <a:schemeClr val="accent1"/>
+          </a:lnRef>
+          <a:fillRef idx="3">
+            <a:schemeClr val="accent1"/>
+          </a:fillRef>
+          <a:effectRef idx="2">
+            <a:schemeClr val="accent1"/>
+          </a:effectRef>
+          <a:fontRef idx="minor">
+            <a:schemeClr val="lt1"/>
+          </a:fontRef>
+        </p:style>
+        <p:txBody>
+          <a:bodyPr rtlCol="0" anchor="ctr"/>
+          <a:lstStyle/>
+          <a:p>
+            <a:pPr algn="ctr"/>
+          </a:p>
+        </p:txBody>
+      </p:sp>
+      <p:pic>
+        <p:nvPicPr>
+          <p:cNvPr id="62" name="Picture 61" descr="image.png"/>
+          <p:cNvPicPr>
+            <a:picLocks noChangeAspect="1"/>
+          </p:cNvPicPr>
+          <p:nvPr/>
+        </p:nvPicPr>
+        <p:blipFill>
+          <a:blip r:embed="rId6"/>
+          <a:stretch>
+            <a:fillRect/>
+          </a:stretch>
+        </p:blipFill>
+        <p:spPr>
+          <a:xfrm>
+            <a:off x="868680" y="5093208"/>
+            <a:ext cx="182880" cy="182880"/>
+          </a:xfrm>
+          <a:prstGeom prst="rect">
+            <a:avLst/>
+          </a:prstGeom>
+        </p:spPr>
+      </p:pic>
+      <p:sp>
+        <p:nvSpPr>
+          <p:cNvPr id="63" name="TextBox 62"/>
+          <p:cNvSpPr txBox="1"/>
+          <p:nvPr/>
+        </p:nvSpPr>
+        <p:spPr>
+          <a:xfrm>
+            <a:off x="1280160" y="4992624"/>
+            <a:ext cx="4526280" cy="384048"/>
+          </a:xfrm>
+          <a:prstGeom prst="rect">
+            <a:avLst/>
+          </a:prstGeom>
+          <a:noFill/>
+        </p:spPr>
+        <p:txBody>
+          <a:bodyPr wrap="square" lIns="27432" rIns="27432" tIns="0" bIns="0" anchor="ctr">
+            <a:spAutoFit/>
+          </a:bodyPr>
+          <a:lstStyle/>
+          <a:p>
+            <a:pPr algn="l"/>
+            <a:r>
+              <a:rPr sz="1800" b="1">
+                <a:solidFill>
+                  <a:srgbClr val="2547C8"/>
+                </a:solidFill>
+                <a:latin typeface="Avenir Next LT Pro"/>
+              </a:rPr>
+              <a:t>Audit  </a:t>
+            </a:r>
+            <a:r>
+              <a:rPr sz="1200" b="0">
+                <a:solidFill>
+                  <a:srgbClr val="6B7280"/>
+                </a:solidFill>
+                <a:latin typeface="Consolas"/>
+              </a:rPr>
+              <a:t>audit-builder</a:t>
+            </a:r>
+          </a:p>
+        </p:txBody>
+      </p:sp>
+      <p:sp>
+        <p:nvSpPr>
+          <p:cNvPr id="64" name="Rounded Rectangle 63"/>
+          <p:cNvSpPr/>
+          <p:nvPr/>
+        </p:nvSpPr>
+        <p:spPr>
+          <a:xfrm>
+            <a:off x="768096" y="5522976"/>
+            <a:ext cx="5001768" cy="603504"/>
+          </a:xfrm>
+          <a:prstGeom prst="roundRect">
+            <a:avLst>
+              <a:gd name="adj" fmla="val 12000"/>
+            </a:avLst>
+          </a:prstGeom>
+          <a:solidFill>
+            <a:srgbClr val="F4F7FB"/>
+          </a:solidFill>
+          <a:ln w="12700">
+            <a:solidFill>
+              <a:srgbClr val="E4EAF3"/>
+            </a:solidFill>
+          </a:ln>
+          <a:effectLst/>
+        </p:spPr>
+        <p:style>
+          <a:lnRef idx="1">
+            <a:schemeClr val="accent1"/>
+          </a:lnRef>
+          <a:fillRef idx="3">
+            <a:schemeClr val="accent1"/>
+          </a:fillRef>
+          <a:effectRef idx="2">
+            <a:schemeClr val="accent1"/>
+          </a:effectRef>
+          <a:fontRef idx="minor">
+            <a:schemeClr val="lt1"/>
+          </a:fontRef>
+        </p:style>
+        <p:txBody>
+          <a:bodyPr rtlCol="0" anchor="ctr"/>
+          <a:lstStyle/>
+          <a:p>
+            <a:pPr algn="ctr"/>
+          </a:p>
+        </p:txBody>
+      </p:sp>
+      <p:sp>
+        <p:nvSpPr>
+          <p:cNvPr id="65" name="TextBox 64"/>
+          <p:cNvSpPr txBox="1"/>
+          <p:nvPr/>
+        </p:nvSpPr>
+        <p:spPr>
+          <a:xfrm>
+            <a:off x="896112" y="5522976"/>
+            <a:ext cx="274320" cy="603504"/>
+          </a:xfrm>
+          <a:prstGeom prst="rect">
+            <a:avLst/>
+          </a:prstGeom>
+          <a:noFill/>
+        </p:spPr>
+        <p:txBody>
+          <a:bodyPr wrap="square" lIns="27432" rIns="27432" tIns="0" bIns="0" anchor="ctr">
+            <a:spAutoFit/>
+          </a:bodyPr>
+          <a:lstStyle/>
+          <a:p>
+            <a:pPr algn="l"/>
+            <a:r>
+              <a:rPr sz="1300" b="1">
+                <a:solidFill>
+                  <a:srgbClr val="2547C8"/>
+                </a:solidFill>
+                <a:latin typeface="Consolas"/>
+              </a:rPr>
+              <a:t>❯</a:t>
+            </a:r>
+          </a:p>
+        </p:txBody>
+      </p:sp>
+      <p:sp>
+        <p:nvSpPr>
+          <p:cNvPr id="66" name="TextBox 65"/>
+          <p:cNvSpPr txBox="1"/>
+          <p:nvPr/>
+        </p:nvSpPr>
+        <p:spPr>
+          <a:xfrm>
+            <a:off x="1152144" y="5541264"/>
+            <a:ext cx="4572000" cy="566928"/>
+          </a:xfrm>
+          <a:prstGeom prst="rect">
+            <a:avLst/>
+          </a:prstGeom>
+          <a:noFill/>
+        </p:spPr>
+        <p:txBody>
+          <a:bodyPr wrap="square" lIns="27432" rIns="27432" tIns="0" bIns="0" anchor="ctr">
+            <a:spAutoFit/>
+          </a:bodyPr>
+          <a:lstStyle/>
+          <a:p>
+            <a:pPr algn="l"/>
+            <a:r>
+              <a:rPr sz="1200" b="0">
+                <a:solidFill>
+                  <a:srgbClr val="2B3550"/>
+                </a:solidFill>
+                <a:latin typeface="Consolas"/>
+              </a:rPr>
+              <a:t>Audit this site's Adobe setup and turn the findings into a deck.</a:t>
+            </a:r>
+          </a:p>
+        </p:txBody>
+      </p:sp>
+      <p:sp>
+        <p:nvSpPr>
+          <p:cNvPr id="67" name="Rounded Rectangle 66"/>
+          <p:cNvSpPr/>
+          <p:nvPr/>
+        </p:nvSpPr>
+        <p:spPr>
+          <a:xfrm>
+            <a:off x="6199632" y="4809744"/>
+            <a:ext cx="5440680" cy="1453896"/>
+          </a:xfrm>
+          <a:prstGeom prst="roundRect">
+            <a:avLst>
+              <a:gd name="adj" fmla="val 5500"/>
+            </a:avLst>
+          </a:prstGeom>
+          <a:solidFill>
+            <a:srgbClr val="FFFFFF"/>
+          </a:solidFill>
+          <a:ln w="12700">
+            <a:solidFill>
+              <a:srgbClr val="E7ECF5"/>
+            </a:solidFill>
+          </a:ln>
+          <a:effectLst/>
+        </p:spPr>
+        <p:style>
+          <a:lnRef idx="1">
+            <a:schemeClr val="accent1"/>
+          </a:lnRef>
+          <a:fillRef idx="3">
+            <a:schemeClr val="accent1"/>
+          </a:fillRef>
+          <a:effectRef idx="2">
+            <a:schemeClr val="accent1"/>
+          </a:effectRef>
+          <a:fontRef idx="minor">
+            <a:schemeClr val="lt1"/>
+          </a:fontRef>
+        </p:style>
+        <p:txBody>
+          <a:bodyPr rtlCol="0" anchor="ctr"/>
+          <a:lstStyle/>
+          <a:p>
+            <a:pPr algn="ctr"/>
+          </a:p>
+        </p:txBody>
+      </p:sp>
+      <p:sp>
+        <p:nvSpPr>
+          <p:cNvPr id="68" name="Rounded Rectangle 67"/>
+          <p:cNvSpPr/>
+          <p:nvPr/>
+        </p:nvSpPr>
+        <p:spPr>
+          <a:xfrm>
+            <a:off x="6419088" y="4992624"/>
+            <a:ext cx="384048" cy="384048"/>
+          </a:xfrm>
+          <a:prstGeom prst="roundRect">
+            <a:avLst>
+              <a:gd name="adj" fmla="val 26000"/>
+            </a:avLst>
+          </a:prstGeom>
+          <a:solidFill>
+            <a:srgbClr val="002FAF"/>
+          </a:solidFill>
+          <a:ln>
+            <a:noFill/>
+          </a:ln>
+          <a:effectLst/>
+        </p:spPr>
+        <p:style>
+          <a:lnRef idx="1">
+            <a:schemeClr val="accent1"/>
+          </a:lnRef>
+          <a:fillRef idx="3">
+            <a:schemeClr val="accent1"/>
+          </a:fillRef>
+          <a:effectRef idx="2">
+            <a:schemeClr val="accent1"/>
+          </a:effectRef>
+          <a:fontRef idx="minor">
+            <a:schemeClr val="lt1"/>
+          </a:fontRef>
+        </p:style>
+        <p:txBody>
+          <a:bodyPr rtlCol="0" anchor="ctr"/>
+          <a:lstStyle/>
+          <a:p>
+            <a:pPr algn="ctr"/>
+          </a:p>
+        </p:txBody>
+      </p:sp>
+      <p:pic>
+        <p:nvPicPr>
+          <p:cNvPr id="69" name="Picture 68" descr="image.png"/>
+          <p:cNvPicPr>
+            <a:picLocks noChangeAspect="1"/>
+          </p:cNvPicPr>
+          <p:nvPr/>
+        </p:nvPicPr>
+        <p:blipFill>
+          <a:blip r:embed="rId7"/>
+          <a:stretch>
+            <a:fillRect/>
+          </a:stretch>
+        </p:blipFill>
+        <p:spPr>
+          <a:xfrm>
+            <a:off x="6519672" y="5093208"/>
+            <a:ext cx="182880" cy="182880"/>
+          </a:xfrm>
+          <a:prstGeom prst="rect">
+            <a:avLst/>
+          </a:prstGeom>
+        </p:spPr>
+      </p:pic>
+      <p:sp>
+        <p:nvSpPr>
+          <p:cNvPr id="70" name="TextBox 69"/>
+          <p:cNvSpPr txBox="1"/>
+          <p:nvPr/>
+        </p:nvSpPr>
+        <p:spPr>
+          <a:xfrm>
+            <a:off x="6931152" y="4992624"/>
+            <a:ext cx="4526280" cy="384048"/>
+          </a:xfrm>
+          <a:prstGeom prst="rect">
+            <a:avLst/>
+          </a:prstGeom>
+          <a:noFill/>
+        </p:spPr>
+        <p:txBody>
+          <a:bodyPr wrap="square" lIns="27432" rIns="27432" tIns="0" bIns="0" anchor="ctr">
+            <a:spAutoFit/>
+          </a:bodyPr>
+          <a:lstStyle/>
+          <a:p>
+            <a:pPr algn="l"/>
+            <a:r>
+              <a:rPr sz="1800" b="1">
+                <a:solidFill>
+                  <a:srgbClr val="002FAF"/>
+                </a:solidFill>
+                <a:latin typeface="Avenir Next LT Pro"/>
+              </a:rPr>
+              <a:t>Reconcile  </a:t>
+            </a:r>
+            <a:r>
+              <a:rPr sz="1200" b="0">
+                <a:solidFill>
+                  <a:srgbClr val="6B7280"/>
+                </a:solidFill>
+                <a:latin typeface="Consolas"/>
+              </a:rPr>
+              <a:t>data-reconciliation</a:t>
+            </a:r>
+          </a:p>
+        </p:txBody>
+      </p:sp>
+      <p:sp>
+        <p:nvSpPr>
+          <p:cNvPr id="71" name="Rounded Rectangle 70"/>
+          <p:cNvSpPr/>
+          <p:nvPr/>
+        </p:nvSpPr>
+        <p:spPr>
+          <a:xfrm>
+            <a:off x="6419088" y="5522976"/>
+            <a:ext cx="5001768" cy="603504"/>
+          </a:xfrm>
+          <a:prstGeom prst="roundRect">
+            <a:avLst>
+              <a:gd name="adj" fmla="val 12000"/>
+            </a:avLst>
+          </a:prstGeom>
+          <a:solidFill>
+            <a:srgbClr val="F4F7FB"/>
+          </a:solidFill>
+          <a:ln w="12700">
+            <a:solidFill>
+              <a:srgbClr val="E4EAF3"/>
+            </a:solidFill>
+          </a:ln>
+          <a:effectLst/>
+        </p:spPr>
+        <p:style>
+          <a:lnRef idx="1">
+            <a:schemeClr val="accent1"/>
+          </a:lnRef>
+          <a:fillRef idx="3">
+            <a:schemeClr val="accent1"/>
+          </a:fillRef>
+          <a:effectRef idx="2">
+            <a:schemeClr val="accent1"/>
+          </a:effectRef>
+          <a:fontRef idx="minor">
+            <a:schemeClr val="lt1"/>
+          </a:fontRef>
+        </p:style>
+        <p:txBody>
+          <a:bodyPr rtlCol="0" anchor="ctr"/>
+          <a:lstStyle/>
+          <a:p>
+            <a:pPr algn="ctr"/>
+          </a:p>
+        </p:txBody>
+      </p:sp>
+      <p:sp>
+        <p:nvSpPr>
+          <p:cNvPr id="72" name="TextBox 71"/>
+          <p:cNvSpPr txBox="1"/>
+          <p:nvPr/>
+        </p:nvSpPr>
+        <p:spPr>
+          <a:xfrm>
+            <a:off x="6547104" y="5522976"/>
+            <a:ext cx="274320" cy="603504"/>
+          </a:xfrm>
+          <a:prstGeom prst="rect">
+            <a:avLst/>
+          </a:prstGeom>
+          <a:noFill/>
+        </p:spPr>
+        <p:txBody>
+          <a:bodyPr wrap="square" lIns="27432" rIns="27432" tIns="0" bIns="0" anchor="ctr">
+            <a:spAutoFit/>
+          </a:bodyPr>
+          <a:lstStyle/>
+          <a:p>
+            <a:pPr algn="l"/>
+            <a:r>
+              <a:rPr sz="1300" b="1">
+                <a:solidFill>
+                  <a:srgbClr val="002FAF"/>
+                </a:solidFill>
+                <a:latin typeface="Consolas"/>
+              </a:rPr>
+              <a:t>❯</a:t>
+            </a:r>
+          </a:p>
+        </p:txBody>
+      </p:sp>
+      <p:sp>
+        <p:nvSpPr>
+          <p:cNvPr id="73" name="TextBox 72"/>
+          <p:cNvSpPr txBox="1"/>
+          <p:nvPr/>
+        </p:nvSpPr>
+        <p:spPr>
+          <a:xfrm>
+            <a:off x="6803136" y="5541264"/>
+            <a:ext cx="4572000" cy="566928"/>
+          </a:xfrm>
+          <a:prstGeom prst="rect">
+            <a:avLst/>
+          </a:prstGeom>
+          <a:noFill/>
+        </p:spPr>
+        <p:txBody>
+          <a:bodyPr wrap="square" lIns="27432" rIns="27432" tIns="0" bIns="0" anchor="ctr">
+            <a:spAutoFit/>
+          </a:bodyPr>
+          <a:lstStyle/>
+          <a:p>
+            <a:pPr algn="l"/>
+            <a:r>
+              <a:rPr sz="1200" b="0">
+                <a:solidFill>
+                  <a:srgbClr val="2B3550"/>
+                </a:solidFill>
+                <a:latin typeface="Consolas"/>
+              </a:rPr>
+              <a:t>Reconcile the report suite against the property — which eVars actually collect?</a:t>
+            </a:r>
+          </a:p>
+        </p:txBody>
+      </p:sp>
+    </p:spTree>
+  </p:cSld>
+  <p:clrMapOvr>
+    <a:masterClrMapping/>
+  </p:clrMapOvr>
+</p:sld>
+</file>
+
 <file path=ppt/theme/theme1.xml><?xml version="1.0" encoding="utf-8"?>
 <a:theme xmlns:a="http://schemas.openxmlformats.org/drawingml/2006/main" name="Office Theme">
   <a:themeElements>

</xml_diff>

<commit_message>
Slide 1: move Slalom logo to top-right; slide 7: drop icon backing boxes
- Title slide: reposition the Slalom wordmark from top-left to top-right
  (symmetric 0.7in margin), leaving the eyebrow label top-left.
- Deliverables slide: remove the five teal-bordered backing boxes sitting
  behind each icon chip (their border peeked out as a stray green box);
  the colored chips and glyphs remain.

Co-Authored-By: Claude Opus 4.8 <noreply@anthropic.com>
Claude-Session: https://claude.ai/code/session_01L22pJWjoypJEHfB9cqhWZF
</commit_message>
<xml_diff>
--- a/websdk-property/docs/adobe-data-collection-skills-suite.pptx
+++ b/websdk-property/docs/adobe-data-collection-skills-suite.pptx
@@ -1455,7 +1455,7 @@
         </p:blipFill>
         <p:spPr>
           <a:xfrm>
-            <a:off x="640080" y="502920"/>
+            <a:off x="10131552" y="502920"/>
             <a:ext cx="1417320" cy="365760"/>
           </a:xfrm>
           <a:prstGeom prst="rect">
@@ -11271,7 +11271,9 @@
             <a:avLst/>
           </a:prstGeom>
           <a:noFill/>
-          <a:ln/>
+          <a:ln>
+            <a:solidFill/>
+          </a:ln>
         </p:spPr>
         <p:txBody>
           <a:bodyPr wrap="square" lIns="0" tIns="0" rIns="0" bIns="0" rtlCol="0" anchor="ctr"/>
@@ -11310,7 +11312,9 @@
             <a:avLst/>
           </a:prstGeom>
           <a:noFill/>
-          <a:ln/>
+          <a:ln>
+            <a:solidFill/>
+          </a:ln>
         </p:spPr>
         <p:txBody>
           <a:bodyPr wrap="square" lIns="0" tIns="0" rIns="0" bIns="0" rtlCol="0" anchor="ctr"/>
@@ -11353,7 +11357,9 @@
           <a:solidFill>
             <a:srgbClr val="F2F2F2"/>
           </a:solidFill>
-          <a:ln/>
+          <a:ln>
+            <a:solidFill/>
+          </a:ln>
         </p:spPr>
         <p:txBody>
           <a:bodyPr/>
@@ -11378,7 +11384,9 @@
             <a:avLst/>
           </a:prstGeom>
           <a:noFill/>
-          <a:ln/>
+          <a:ln>
+            <a:solidFill/>
+          </a:ln>
         </p:spPr>
         <p:txBody>
           <a:bodyPr wrap="square" lIns="0" tIns="0" rIns="0" bIns="0" rtlCol="0" anchor="ctr"/>
@@ -11417,7 +11425,9 @@
             <a:avLst/>
           </a:prstGeom>
           <a:noFill/>
-          <a:ln/>
+          <a:ln>
+            <a:solidFill/>
+          </a:ln>
         </p:spPr>
         <p:txBody>
           <a:bodyPr wrap="square" lIns="0" tIns="0" rIns="0" bIns="0" rtlCol="0" anchor="ctr"/>
@@ -11460,7 +11470,9 @@
           <a:solidFill>
             <a:srgbClr val="F2F2F2"/>
           </a:solidFill>
-          <a:ln/>
+          <a:ln>
+            <a:solidFill/>
+          </a:ln>
         </p:spPr>
         <p:txBody>
           <a:bodyPr/>
@@ -11485,7 +11497,9 @@
             <a:avLst/>
           </a:prstGeom>
           <a:noFill/>
-          <a:ln/>
+          <a:ln>
+            <a:solidFill/>
+          </a:ln>
         </p:spPr>
         <p:txBody>
           <a:bodyPr wrap="square" lIns="0" tIns="0" rIns="0" bIns="0" rtlCol="0" anchor="ctr"/>
@@ -11524,7 +11538,9 @@
             <a:avLst/>
           </a:prstGeom>
           <a:noFill/>
-          <a:ln/>
+          <a:ln>
+            <a:solidFill/>
+          </a:ln>
         </p:spPr>
         <p:txBody>
           <a:bodyPr wrap="square" lIns="0" tIns="0" rIns="0" bIns="0" rtlCol="0" anchor="ctr"/>
@@ -11567,7 +11583,9 @@
           <a:solidFill>
             <a:srgbClr val="0C62FB"/>
           </a:solidFill>
-          <a:ln/>
+          <a:ln>
+            <a:solidFill/>
+          </a:ln>
         </p:spPr>
         <p:txBody>
           <a:bodyPr/>
@@ -11592,7 +11610,9 @@
             <a:avLst/>
           </a:prstGeom>
           <a:noFill/>
-          <a:ln/>
+          <a:ln>
+            <a:solidFill/>
+          </a:ln>
         </p:spPr>
         <p:txBody>
           <a:bodyPr wrap="square" lIns="0" tIns="0" rIns="0" bIns="0" rtlCol="0" anchor="ctr"/>
@@ -11635,7 +11655,9 @@
           <a:solidFill>
             <a:srgbClr val="0E8FA0"/>
           </a:solidFill>
-          <a:ln/>
+          <a:ln>
+            <a:solidFill/>
+          </a:ln>
         </p:spPr>
         <p:txBody>
           <a:bodyPr/>
@@ -11660,7 +11682,9 @@
             <a:avLst/>
           </a:prstGeom>
           <a:noFill/>
-          <a:ln/>
+          <a:ln>
+            <a:solidFill/>
+          </a:ln>
         </p:spPr>
         <p:txBody>
           <a:bodyPr wrap="square" lIns="0" tIns="0" rIns="0" bIns="0" rtlCol="0" anchor="ctr"/>
@@ -11686,40 +11710,6 @@
       </p:sp>
       <p:sp>
         <p:nvSpPr>
-          <p:cNvPr id="16" name="Shape 13"/>
-          <p:cNvSpPr/>
-          <p:nvPr/>
-        </p:nvSpPr>
-        <p:spPr>
-          <a:xfrm>
-            <a:off x="548640" y="3809827"/>
-            <a:ext cx="292608" cy="292608"/>
-          </a:xfrm>
-          <a:prstGeom prst="roundRect">
-            <a:avLst>
-              <a:gd name="adj" fmla="val 18750"/>
-            </a:avLst>
-          </a:prstGeom>
-          <a:solidFill>
-            <a:srgbClr val="F2F2F2"/>
-          </a:solidFill>
-          <a:ln w="22225">
-            <a:solidFill>
-              <a:srgbClr val="0E8FA0"/>
-            </a:solidFill>
-            <a:prstDash val="solid"/>
-          </a:ln>
-        </p:spPr>
-        <p:txBody>
-          <a:bodyPr/>
-          <a:lstStyle/>
-          <a:p>
-            <a:endParaRPr lang="en-US"/>
-          </a:p>
-        </p:txBody>
-      </p:sp>
-      <p:sp>
-        <p:nvSpPr>
           <p:cNvPr id="17" name="Text 14"/>
           <p:cNvSpPr/>
           <p:nvPr/>
@@ -11733,7 +11723,9 @@
             <a:avLst/>
           </a:prstGeom>
           <a:noFill/>
-          <a:ln/>
+          <a:ln>
+            <a:solidFill/>
+          </a:ln>
         </p:spPr>
         <p:txBody>
           <a:bodyPr wrap="square" lIns="0" tIns="0" rIns="0" bIns="0" rtlCol="0" anchor="ctr"/>
@@ -11762,40 +11754,6 @@
       </p:sp>
       <p:sp>
         <p:nvSpPr>
-          <p:cNvPr id="18" name="Shape 15"/>
-          <p:cNvSpPr/>
-          <p:nvPr/>
-        </p:nvSpPr>
-        <p:spPr>
-          <a:xfrm>
-            <a:off x="548640" y="4325344"/>
-            <a:ext cx="292608" cy="292608"/>
-          </a:xfrm>
-          <a:prstGeom prst="roundRect">
-            <a:avLst>
-              <a:gd name="adj" fmla="val 18750"/>
-            </a:avLst>
-          </a:prstGeom>
-          <a:solidFill>
-            <a:srgbClr val="F2F2F2"/>
-          </a:solidFill>
-          <a:ln w="22225">
-            <a:solidFill>
-              <a:srgbClr val="0E8FA0"/>
-            </a:solidFill>
-            <a:prstDash val="solid"/>
-          </a:ln>
-        </p:spPr>
-        <p:txBody>
-          <a:bodyPr/>
-          <a:lstStyle/>
-          <a:p>
-            <a:endParaRPr lang="en-US"/>
-          </a:p>
-        </p:txBody>
-      </p:sp>
-      <p:sp>
-        <p:nvSpPr>
           <p:cNvPr id="19" name="Text 16"/>
           <p:cNvSpPr/>
           <p:nvPr/>
@@ -11809,7 +11767,9 @@
             <a:avLst/>
           </a:prstGeom>
           <a:noFill/>
-          <a:ln/>
+          <a:ln>
+            <a:solidFill/>
+          </a:ln>
         </p:spPr>
         <p:txBody>
           <a:bodyPr wrap="square" lIns="0" tIns="0" rIns="0" bIns="0" rtlCol="0" anchor="ctr"/>
@@ -11838,40 +11798,6 @@
       </p:sp>
       <p:sp>
         <p:nvSpPr>
-          <p:cNvPr id="20" name="Shape 17"/>
-          <p:cNvSpPr/>
-          <p:nvPr/>
-        </p:nvSpPr>
-        <p:spPr>
-          <a:xfrm>
-            <a:off x="6263640" y="3782016"/>
-            <a:ext cx="292608" cy="292608"/>
-          </a:xfrm>
-          <a:prstGeom prst="roundRect">
-            <a:avLst>
-              <a:gd name="adj" fmla="val 18750"/>
-            </a:avLst>
-          </a:prstGeom>
-          <a:solidFill>
-            <a:srgbClr val="F2F2F2"/>
-          </a:solidFill>
-          <a:ln w="22225">
-            <a:solidFill>
-              <a:srgbClr val="0E8FA0"/>
-            </a:solidFill>
-            <a:prstDash val="solid"/>
-          </a:ln>
-        </p:spPr>
-        <p:txBody>
-          <a:bodyPr/>
-          <a:lstStyle/>
-          <a:p>
-            <a:endParaRPr lang="en-US"/>
-          </a:p>
-        </p:txBody>
-      </p:sp>
-      <p:sp>
-        <p:nvSpPr>
           <p:cNvPr id="21" name="Text 18"/>
           <p:cNvSpPr/>
           <p:nvPr/>
@@ -11885,7 +11811,9 @@
             <a:avLst/>
           </a:prstGeom>
           <a:noFill/>
-          <a:ln/>
+          <a:ln>
+            <a:solidFill/>
+          </a:ln>
         </p:spPr>
         <p:txBody>
           <a:bodyPr wrap="square" lIns="0" tIns="0" rIns="0" bIns="0" rtlCol="0" anchor="ctr"/>
@@ -11914,40 +11842,6 @@
       </p:sp>
       <p:sp>
         <p:nvSpPr>
-          <p:cNvPr id="150" name="Shape BodyHiding"/>
-          <p:cNvSpPr/>
-          <p:nvPr/>
-        </p:nvSpPr>
-        <p:spPr>
-          <a:xfrm>
-            <a:off x="6263640" y="4282016"/>
-            <a:ext cx="292608" cy="292608"/>
-          </a:xfrm>
-          <a:prstGeom prst="roundRect">
-            <a:avLst>
-              <a:gd name="adj" fmla="val 18750"/>
-            </a:avLst>
-          </a:prstGeom>
-          <a:solidFill>
-            <a:srgbClr val="F2F2F2"/>
-          </a:solidFill>
-          <a:ln w="22225">
-            <a:solidFill>
-              <a:srgbClr val="0E8FA0"/>
-            </a:solidFill>
-            <a:prstDash val="solid"/>
-          </a:ln>
-        </p:spPr>
-        <p:txBody>
-          <a:bodyPr/>
-          <a:lstStyle/>
-          <a:p>
-            <a:endParaRPr lang="en-US"/>
-          </a:p>
-        </p:txBody>
-      </p:sp>
-      <p:sp>
-        <p:nvSpPr>
           <p:cNvPr id="151" name="Text BodyHiding"/>
           <p:cNvSpPr/>
           <p:nvPr/>
@@ -11961,7 +11855,9 @@
             <a:avLst/>
           </a:prstGeom>
           <a:noFill/>
-          <a:ln/>
+          <a:ln>
+            <a:solidFill/>
+          </a:ln>
         </p:spPr>
         <p:txBody>
           <a:bodyPr wrap="square" lIns="0" tIns="0" rIns="0" bIns="0" rtlCol="0" anchor="ctr"/>
@@ -11990,40 +11886,6 @@
       </p:sp>
       <p:sp>
         <p:nvSpPr>
-          <p:cNvPr id="22" name="Shape 19"/>
-          <p:cNvSpPr/>
-          <p:nvPr/>
-        </p:nvSpPr>
-        <p:spPr>
-          <a:xfrm>
-            <a:off x="6263640" y="4882016"/>
-            <a:ext cx="292608" cy="292608"/>
-          </a:xfrm>
-          <a:prstGeom prst="roundRect">
-            <a:avLst>
-              <a:gd name="adj" fmla="val 18750"/>
-            </a:avLst>
-          </a:prstGeom>
-          <a:solidFill>
-            <a:srgbClr val="F2F2F2"/>
-          </a:solidFill>
-          <a:ln w="22225">
-            <a:solidFill>
-              <a:srgbClr val="0E8FA0"/>
-            </a:solidFill>
-            <a:prstDash val="solid"/>
-          </a:ln>
-        </p:spPr>
-        <p:txBody>
-          <a:bodyPr/>
-          <a:lstStyle/>
-          <a:p>
-            <a:endParaRPr lang="en-US"/>
-          </a:p>
-        </p:txBody>
-      </p:sp>
-      <p:sp>
-        <p:nvSpPr>
           <p:cNvPr id="23" name="Text 20"/>
           <p:cNvSpPr/>
           <p:nvPr/>
@@ -12037,7 +11899,9 @@
             <a:avLst/>
           </a:prstGeom>
           <a:noFill/>
-          <a:ln/>
+          <a:ln>
+            <a:solidFill/>
+          </a:ln>
         </p:spPr>
         <p:txBody>
           <a:bodyPr wrap="square" lIns="0" tIns="0" rIns="0" bIns="0" rtlCol="0" anchor="ctr"/>
@@ -12081,7 +11945,9 @@
           <a:solidFill>
             <a:srgbClr val="002FAF"/>
           </a:solidFill>
-          <a:ln/>
+          <a:ln>
+            <a:solidFill/>
+          </a:ln>
         </p:spPr>
         <p:txBody>
           <a:bodyPr/>
@@ -12108,7 +11974,9 @@
           <a:solidFill>
             <a:srgbClr val="0C62FB"/>
           </a:solidFill>
-          <a:ln/>
+          <a:ln>
+            <a:solidFill/>
+          </a:ln>
         </p:spPr>
         <p:txBody>
           <a:bodyPr/>
@@ -12135,7 +12003,9 @@
           <a:solidFill>
             <a:srgbClr val="1BE1F2"/>
           </a:solidFill>
-          <a:ln/>
+          <a:ln>
+            <a:solidFill/>
+          </a:ln>
         </p:spPr>
         <p:txBody>
           <a:bodyPr/>
@@ -12162,7 +12032,9 @@
           <a:solidFill>
             <a:srgbClr val="FF4D5F"/>
           </a:solidFill>
-          <a:ln/>
+          <a:ln>
+            <a:solidFill/>
+          </a:ln>
         </p:spPr>
         <p:txBody>
           <a:bodyPr/>
@@ -12189,7 +12061,9 @@
           <a:solidFill>
             <a:srgbClr val="C7B9FF"/>
           </a:solidFill>
-          <a:ln/>
+          <a:ln>
+            <a:solidFill/>
+          </a:ln>
         </p:spPr>
         <p:txBody>
           <a:bodyPr/>
@@ -12214,7 +12088,9 @@
             <a:avLst/>
           </a:prstGeom>
           <a:noFill/>
-          <a:ln/>
+          <a:ln>
+            <a:solidFill/>
+          </a:ln>
         </p:spPr>
         <p:txBody>
           <a:bodyPr wrap="square" lIns="0" tIns="0" rIns="0" bIns="0" rtlCol="0" anchor="ctr"/>
@@ -12250,7 +12126,9 @@
             <a:avLst/>
           </a:prstGeom>
           <a:noFill/>
-          <a:ln/>
+          <a:ln>
+            <a:solidFill/>
+          </a:ln>
         </p:spPr>
         <p:txBody>
           <a:bodyPr wrap="square" lIns="0" tIns="0" rIns="0" bIns="0" rtlCol="0" anchor="ctr"/>
@@ -12289,7 +12167,7 @@
             <a:srgbClr val="0C62FB"/>
           </a:solidFill>
           <a:ln>
-            <a:noFill/>
+            <a:solidFill/>
           </a:ln>
           <a:effectLst/>
         </p:spPr>
@@ -12337,6 +12215,9 @@
           <a:prstGeom prst="rect">
             <a:avLst/>
           </a:prstGeom>
+          <a:ln>
+            <a:solidFill/>
+          </a:ln>
         </p:spPr>
       </p:pic>
       <p:sp>
@@ -12357,7 +12238,7 @@
             <a:srgbClr val="0C62FB"/>
           </a:solidFill>
           <a:ln>
-            <a:noFill/>
+            <a:solidFill/>
           </a:ln>
           <a:effectLst/>
         </p:spPr>
@@ -12405,6 +12286,9 @@
           <a:prstGeom prst="rect">
             <a:avLst/>
           </a:prstGeom>
+          <a:ln>
+            <a:solidFill/>
+          </a:ln>
         </p:spPr>
       </p:pic>
       <p:sp>
@@ -12425,7 +12309,7 @@
             <a:srgbClr val="0E8FA0"/>
           </a:solidFill>
           <a:ln>
-            <a:noFill/>
+            <a:solidFill/>
           </a:ln>
           <a:effectLst/>
         </p:spPr>
@@ -12473,6 +12357,9 @@
           <a:prstGeom prst="rect">
             <a:avLst/>
           </a:prstGeom>
+          <a:ln>
+            <a:solidFill/>
+          </a:ln>
         </p:spPr>
       </p:pic>
       <p:sp>
@@ -12493,7 +12380,7 @@
             <a:srgbClr val="0E8FA0"/>
           </a:solidFill>
           <a:ln>
-            <a:noFill/>
+            <a:solidFill/>
           </a:ln>
           <a:effectLst/>
         </p:spPr>
@@ -12541,6 +12428,9 @@
           <a:prstGeom prst="rect">
             <a:avLst/>
           </a:prstGeom>
+          <a:ln>
+            <a:solidFill/>
+          </a:ln>
         </p:spPr>
       </p:pic>
       <p:sp>
@@ -12561,7 +12451,7 @@
             <a:srgbClr val="0E8FA0"/>
           </a:solidFill>
           <a:ln>
-            <a:noFill/>
+            <a:solidFill/>
           </a:ln>
           <a:effectLst/>
         </p:spPr>
@@ -12609,6 +12499,9 @@
           <a:prstGeom prst="rect">
             <a:avLst/>
           </a:prstGeom>
+          <a:ln>
+            <a:solidFill/>
+          </a:ln>
         </p:spPr>
       </p:pic>
     </p:spTree>

</xml_diff>

<commit_message>
Restyle slide 4 (The Value Add) as a concentric layers-of-value diagram
Rebuild the three stacked value rows as a multilayered concentric
diagram (Client Value core -> Speed -> Governance -> Evidence) beside
three color-matched value cards, each with icon, title, an outcome pill,
and description. Native/editable, designed via HTML render and verified
(ring labels sit over their colored rings; nothing off-canvas; valid XML).

Co-Authored-By: Claude Opus 4.8 <noreply@anthropic.com>
Claude-Session: https://claude.ai/code/session_01L22pJWjoypJEHfB9cqhWZF
</commit_message>
<xml_diff>
--- a/websdk-property/docs/adobe-data-collection-skills-suite.pptx
+++ b/websdk-property/docs/adobe-data-collection-skills-suite.pptx
@@ -5007,22 +5007,20 @@
       </p:sp>
       <p:sp>
         <p:nvSpPr>
-          <p:cNvPr id="100" name="Card"/>
-          <p:cNvSpPr/>
-          <p:nvPr/>
-        </p:nvSpPr>
-        <p:spPr>
-          <a:xfrm>
-            <a:off x="548640" y="1200000"/>
-            <a:ext cx="11064240" cy="1750000"/>
-          </a:xfrm>
-          <a:prstGeom prst="roundRect">
-            <a:avLst>
-              <a:gd name="adj" fmla="val 4364"/>
-            </a:avLst>
-          </a:prstGeom>
-          <a:solidFill>
-            <a:srgbClr val="F2F2F2"/>
+          <p:cNvPr id="200" name="Shape Bar1"/>
+          <p:cNvSpPr/>
+          <p:nvPr/>
+        </p:nvSpPr>
+        <p:spPr>
+          <a:xfrm>
+            <a:off x="0" y="0"/>
+            <a:ext cx="2432304" cy="137160"/>
+          </a:xfrm>
+          <a:prstGeom prst="rect">
+            <a:avLst/>
+          </a:prstGeom>
+          <a:solidFill>
+            <a:srgbClr val="002FAF"/>
           </a:solidFill>
           <a:ln/>
         </p:spPr>
@@ -5036,14 +5034,122 @@
       </p:sp>
       <p:sp>
         <p:nvSpPr>
-          <p:cNvPr id="101" name="Caption"/>
-          <p:cNvSpPr/>
-          <p:nvPr/>
-        </p:nvSpPr>
-        <p:spPr>
-          <a:xfrm>
-            <a:off x="1783080" y="1382880"/>
-            <a:ext cx="6537960" cy="256032"/>
+          <p:cNvPr id="201" name="Shape Bar2"/>
+          <p:cNvSpPr/>
+          <p:nvPr/>
+        </p:nvSpPr>
+        <p:spPr>
+          <a:xfrm>
+            <a:off x="2432304" y="0"/>
+            <a:ext cx="2432304" cy="137160"/>
+          </a:xfrm>
+          <a:prstGeom prst="rect">
+            <a:avLst/>
+          </a:prstGeom>
+          <a:solidFill>
+            <a:srgbClr val="0C62FB"/>
+          </a:solidFill>
+          <a:ln/>
+        </p:spPr>
+        <p:txBody>
+          <a:bodyPr/>
+          <a:lstStyle/>
+          <a:p>
+            <a:endParaRPr lang="en-US"/>
+          </a:p>
+        </p:txBody>
+      </p:sp>
+      <p:sp>
+        <p:nvSpPr>
+          <p:cNvPr id="202" name="Shape Bar3"/>
+          <p:cNvSpPr/>
+          <p:nvPr/>
+        </p:nvSpPr>
+        <p:spPr>
+          <a:xfrm>
+            <a:off x="4864608" y="0"/>
+            <a:ext cx="2432304" cy="137160"/>
+          </a:xfrm>
+          <a:prstGeom prst="rect">
+            <a:avLst/>
+          </a:prstGeom>
+          <a:solidFill>
+            <a:srgbClr val="1BE1F2"/>
+          </a:solidFill>
+          <a:ln/>
+        </p:spPr>
+        <p:txBody>
+          <a:bodyPr/>
+          <a:lstStyle/>
+          <a:p>
+            <a:endParaRPr lang="en-US"/>
+          </a:p>
+        </p:txBody>
+      </p:sp>
+      <p:sp>
+        <p:nvSpPr>
+          <p:cNvPr id="203" name="Shape Bar4"/>
+          <p:cNvSpPr/>
+          <p:nvPr/>
+        </p:nvSpPr>
+        <p:spPr>
+          <a:xfrm>
+            <a:off x="7296912" y="0"/>
+            <a:ext cx="2432304" cy="137160"/>
+          </a:xfrm>
+          <a:prstGeom prst="rect">
+            <a:avLst/>
+          </a:prstGeom>
+          <a:solidFill>
+            <a:srgbClr val="FF4D5F"/>
+          </a:solidFill>
+          <a:ln/>
+        </p:spPr>
+        <p:txBody>
+          <a:bodyPr/>
+          <a:lstStyle/>
+          <a:p>
+            <a:endParaRPr lang="en-US"/>
+          </a:p>
+        </p:txBody>
+      </p:sp>
+      <p:sp>
+        <p:nvSpPr>
+          <p:cNvPr id="204" name="Shape Bar5"/>
+          <p:cNvSpPr/>
+          <p:nvPr/>
+        </p:nvSpPr>
+        <p:spPr>
+          <a:xfrm>
+            <a:off x="9729216" y="0"/>
+            <a:ext cx="2432304" cy="137160"/>
+          </a:xfrm>
+          <a:prstGeom prst="rect">
+            <a:avLst/>
+          </a:prstGeom>
+          <a:solidFill>
+            <a:srgbClr val="C7B9FF"/>
+          </a:solidFill>
+          <a:ln/>
+        </p:spPr>
+        <p:txBody>
+          <a:bodyPr/>
+          <a:lstStyle/>
+          <a:p>
+            <a:endParaRPr lang="en-US"/>
+          </a:p>
+        </p:txBody>
+      </p:sp>
+      <p:sp>
+        <p:nvSpPr>
+          <p:cNvPr id="205" name="Text Copyright"/>
+          <p:cNvSpPr/>
+          <p:nvPr/>
+        </p:nvSpPr>
+        <p:spPr>
+          <a:xfrm>
+            <a:off x="548640" y="6446520"/>
+            <a:ext cx="7315200" cy="274320"/>
           </a:xfrm>
           <a:prstGeom prst="rect">
             <a:avLst/>
@@ -5059,451 +5165,6 @@
               <a:buNone/>
             </a:pPr>
             <a:r>
-              <a:rPr lang="en-US" sz="1200" b="1" spc="100" dirty="0">
-                <a:solidFill>
-                  <a:srgbClr val="0C62FB"/>
-                </a:solidFill>
-                <a:latin typeface="Avenir Next LT Pro" pitchFamily="34" charset="0"/>
-                <a:ea typeface="Avenir Next LT Pro" pitchFamily="34" charset="-122"/>
-                <a:cs typeface="Avenir Next LT Pro" pitchFamily="34" charset="-120"/>
-              </a:rPr>
-              <a:t>REUSABLE IP &amp; SPEED</a:t>
-            </a:r>
-            <a:endParaRPr lang="en-US" sz="1200" dirty="0"/>
-          </a:p>
-        </p:txBody>
-      </p:sp>
-      <p:sp>
-        <p:nvSpPr>
-          <p:cNvPr id="102" name="Body"/>
-          <p:cNvSpPr/>
-          <p:nvPr/>
-        </p:nvSpPr>
-        <p:spPr>
-          <a:xfrm>
-            <a:off x="1783080" y="1702920"/>
-            <a:ext cx="6537960" cy="1009920"/>
-          </a:xfrm>
-          <a:prstGeom prst="rect">
-            <a:avLst/>
-          </a:prstGeom>
-          <a:noFill/>
-          <a:ln/>
-        </p:spPr>
-        <p:txBody>
-          <a:bodyPr wrap="square" lIns="0" tIns="0" rIns="0" bIns="0" rtlCol="0" anchor="t"/>
-          <a:lstStyle/>
-          <a:p>
-            <a:pPr marL="228600" indent="0">
-              <a:lnSpc>
-                <a:spcPct val="112000"/>
-              </a:lnSpc>
-              <a:spcBef>
-                <a:spcPts val="550"/>
-              </a:spcBef>
-              <a:buFont typeface="Arial"/>
-              <a:buChar char="•"/>
-            </a:pPr>
-            <a:r>
-              <a:rPr lang="en-US" sz="1100" dirty="0">
-                <a:solidFill>
-                  <a:srgbClr val="000000"/>
-                </a:solidFill>
-                <a:latin typeface="Avenir Next LT Pro" pitchFamily="34" charset="0"/>
-                <a:ea typeface="Avenir Next LT Pro" pitchFamily="34" charset="-122"/>
-                <a:cs typeface="Avenir Next LT Pro" pitchFamily="34" charset="-120"/>
-              </a:rPr>
-              <a:t>A one-off engagement becomes a repeatable asset. What took weeks of manual setup runs in hours; the next client reuses the same accelerators instead of starting over.</a:t>
-            </a:r>
-          </a:p>
-        </p:txBody>
-      </p:sp>
-      <p:sp>
-        <p:nvSpPr>
-          <p:cNvPr id="110" name="Card"/>
-          <p:cNvSpPr/>
-          <p:nvPr/>
-        </p:nvSpPr>
-        <p:spPr>
-          <a:xfrm>
-            <a:off x="548640" y="3050000"/>
-            <a:ext cx="11064240" cy="1650000"/>
-          </a:xfrm>
-          <a:prstGeom prst="roundRect">
-            <a:avLst>
-              <a:gd name="adj" fmla="val 4364"/>
-            </a:avLst>
-          </a:prstGeom>
-          <a:solidFill>
-            <a:srgbClr val="F2F2F2"/>
-          </a:solidFill>
-          <a:ln/>
-        </p:spPr>
-        <p:txBody>
-          <a:bodyPr/>
-          <a:lstStyle/>
-          <a:p>
-            <a:endParaRPr lang="en-US"/>
-          </a:p>
-        </p:txBody>
-      </p:sp>
-      <p:sp>
-        <p:nvSpPr>
-          <p:cNvPr id="111" name="Caption"/>
-          <p:cNvSpPr/>
-          <p:nvPr/>
-        </p:nvSpPr>
-        <p:spPr>
-          <a:xfrm>
-            <a:off x="1783080" y="3232880"/>
-            <a:ext cx="6537960" cy="256032"/>
-          </a:xfrm>
-          <a:prstGeom prst="rect">
-            <a:avLst/>
-          </a:prstGeom>
-          <a:noFill/>
-          <a:ln/>
-        </p:spPr>
-        <p:txBody>
-          <a:bodyPr wrap="square" lIns="0" tIns="0" rIns="0" bIns="0" rtlCol="0" anchor="ctr"/>
-          <a:lstStyle/>
-          <a:p>
-            <a:pPr marL="0" indent="0">
-              <a:buNone/>
-            </a:pPr>
-            <a:r>
-              <a:rPr lang="en-US" sz="1200" b="1" spc="100" dirty="0">
-                <a:solidFill>
-                  <a:srgbClr val="FF4D5F"/>
-                </a:solidFill>
-                <a:latin typeface="Avenir Next LT Pro" pitchFamily="34" charset="0"/>
-                <a:ea typeface="Avenir Next LT Pro" pitchFamily="34" charset="-122"/>
-                <a:cs typeface="Avenir Next LT Pro" pitchFamily="34" charset="-120"/>
-              </a:rPr>
-              <a:t>CONSISTENCY &amp; GOVERNANCE</a:t>
-            </a:r>
-            <a:endParaRPr lang="en-US" sz="1200" dirty="0"/>
-          </a:p>
-        </p:txBody>
-      </p:sp>
-      <p:sp>
-        <p:nvSpPr>
-          <p:cNvPr id="112" name="Body"/>
-          <p:cNvSpPr/>
-          <p:nvPr/>
-        </p:nvSpPr>
-        <p:spPr>
-          <a:xfrm>
-            <a:off x="1783080" y="3552920"/>
-            <a:ext cx="6537960" cy="1009920"/>
-          </a:xfrm>
-          <a:prstGeom prst="rect">
-            <a:avLst/>
-          </a:prstGeom>
-          <a:noFill/>
-          <a:ln/>
-        </p:spPr>
-        <p:txBody>
-          <a:bodyPr wrap="square" lIns="0" tIns="0" rIns="0" bIns="0" rtlCol="0" anchor="t"/>
-          <a:lstStyle/>
-          <a:p>
-            <a:pPr marL="228600" indent="0">
-              <a:lnSpc>
-                <a:spcPct val="112000"/>
-              </a:lnSpc>
-              <a:spcBef>
-                <a:spcPts val="550"/>
-              </a:spcBef>
-              <a:buFont typeface="Arial"/>
-              <a:buChar char="•"/>
-            </a:pPr>
-            <a:r>
-              <a:rPr lang="en-US" sz="1100" dirty="0">
-                <a:solidFill>
-                  <a:srgbClr val="000000"/>
-                </a:solidFill>
-                <a:latin typeface="Avenir Next LT Pro" pitchFamily="34" charset="0"/>
-                <a:ea typeface="Avenir Next LT Pro" pitchFamily="34" charset="-122"/>
-                <a:cs typeface="Avenir Next LT Pro" pitchFamily="34" charset="-120"/>
-              </a:rPr>
-              <a:t>The same standards, naming, and quality bar on every engagement — with approval gates, rollback, and human sign-off built into the build and publish stages, not bolted on after.</a:t>
-            </a:r>
-          </a:p>
-        </p:txBody>
-      </p:sp>
-      <p:sp>
-        <p:nvSpPr>
-          <p:cNvPr id="120" name="Card"/>
-          <p:cNvSpPr/>
-          <p:nvPr/>
-        </p:nvSpPr>
-        <p:spPr>
-          <a:xfrm>
-            <a:off x="548640" y="4800000"/>
-            <a:ext cx="11064240" cy="1550000"/>
-          </a:xfrm>
-          <a:prstGeom prst="roundRect">
-            <a:avLst>
-              <a:gd name="adj" fmla="val 4364"/>
-            </a:avLst>
-          </a:prstGeom>
-          <a:solidFill>
-            <a:srgbClr val="F2F2F2"/>
-          </a:solidFill>
-          <a:ln/>
-        </p:spPr>
-        <p:txBody>
-          <a:bodyPr/>
-          <a:lstStyle/>
-          <a:p>
-            <a:endParaRPr lang="en-US"/>
-          </a:p>
-        </p:txBody>
-      </p:sp>
-      <p:sp>
-        <p:nvSpPr>
-          <p:cNvPr id="121" name="Caption"/>
-          <p:cNvSpPr/>
-          <p:nvPr/>
-        </p:nvSpPr>
-        <p:spPr>
-          <a:xfrm>
-            <a:off x="1783080" y="4982880"/>
-            <a:ext cx="6537960" cy="256032"/>
-          </a:xfrm>
-          <a:prstGeom prst="rect">
-            <a:avLst/>
-          </a:prstGeom>
-          <a:noFill/>
-          <a:ln/>
-        </p:spPr>
-        <p:txBody>
-          <a:bodyPr wrap="square" lIns="0" tIns="0" rIns="0" bIns="0" rtlCol="0" anchor="ctr"/>
-          <a:lstStyle/>
-          <a:p>
-            <a:pPr marL="0" indent="0">
-              <a:buNone/>
-            </a:pPr>
-            <a:r>
-              <a:rPr lang="en-US" sz="1200" b="1" spc="100" dirty="0">
-                <a:solidFill>
-                  <a:srgbClr val="0E8FA0"/>
-                </a:solidFill>
-                <a:latin typeface="Avenir Next LT Pro" pitchFamily="34" charset="0"/>
-                <a:ea typeface="Avenir Next LT Pro" pitchFamily="34" charset="-122"/>
-                <a:cs typeface="Avenir Next LT Pro" pitchFamily="34" charset="-120"/>
-              </a:rPr>
-              <a:t>A QUALITY FLOOR &amp; EVIDENCE</a:t>
-            </a:r>
-            <a:endParaRPr lang="en-US" sz="1200" dirty="0"/>
-          </a:p>
-        </p:txBody>
-      </p:sp>
-      <p:sp>
-        <p:nvSpPr>
-          <p:cNvPr id="122" name="Body"/>
-          <p:cNvSpPr/>
-          <p:nvPr/>
-        </p:nvSpPr>
-        <p:spPr>
-          <a:xfrm>
-            <a:off x="1783080" y="5302920"/>
-            <a:ext cx="6537960" cy="909920"/>
-          </a:xfrm>
-          <a:prstGeom prst="rect">
-            <a:avLst/>
-          </a:prstGeom>
-          <a:noFill/>
-          <a:ln/>
-        </p:spPr>
-        <p:txBody>
-          <a:bodyPr wrap="square" lIns="0" tIns="0" rIns="0" bIns="0" rtlCol="0" anchor="t"/>
-          <a:lstStyle/>
-          <a:p>
-            <a:pPr marL="228600" indent="0">
-              <a:lnSpc>
-                <a:spcPct val="112000"/>
-              </a:lnSpc>
-              <a:spcBef>
-                <a:spcPts val="550"/>
-              </a:spcBef>
-              <a:buFont typeface="Arial"/>
-              <a:buChar char="•"/>
-            </a:pPr>
-            <a:r>
-              <a:rPr lang="en-US" sz="1100" dirty="0">
-                <a:solidFill>
-                  <a:srgbClr val="000000"/>
-                </a:solidFill>
-                <a:latin typeface="Avenir Next LT Pro" pitchFamily="34" charset="0"/>
-                <a:ea typeface="Avenir Next LT Pro" pitchFamily="34" charset="-122"/>
-                <a:cs typeface="Avenir Next LT Pro" pitchFamily="34" charset="-120"/>
-              </a:rPr>
-              <a:t>Junior consultants ship senior-quality output. Every finding and recommendation is sourced from live configuration — capturable, repeatable, and defensible to a skeptical client.</a:t>
-            </a:r>
-          </a:p>
-        </p:txBody>
-      </p:sp>
-      <p:sp>
-        <p:nvSpPr>
-          <p:cNvPr id="200" name="Shape Bar1"/>
-          <p:cNvSpPr/>
-          <p:nvPr/>
-        </p:nvSpPr>
-        <p:spPr>
-          <a:xfrm>
-            <a:off x="0" y="0"/>
-            <a:ext cx="2432304" cy="137160"/>
-          </a:xfrm>
-          <a:prstGeom prst="rect">
-            <a:avLst/>
-          </a:prstGeom>
-          <a:solidFill>
-            <a:srgbClr val="002FAF"/>
-          </a:solidFill>
-          <a:ln/>
-        </p:spPr>
-        <p:txBody>
-          <a:bodyPr/>
-          <a:lstStyle/>
-          <a:p>
-            <a:endParaRPr lang="en-US"/>
-          </a:p>
-        </p:txBody>
-      </p:sp>
-      <p:sp>
-        <p:nvSpPr>
-          <p:cNvPr id="201" name="Shape Bar2"/>
-          <p:cNvSpPr/>
-          <p:nvPr/>
-        </p:nvSpPr>
-        <p:spPr>
-          <a:xfrm>
-            <a:off x="2432304" y="0"/>
-            <a:ext cx="2432304" cy="137160"/>
-          </a:xfrm>
-          <a:prstGeom prst="rect">
-            <a:avLst/>
-          </a:prstGeom>
-          <a:solidFill>
-            <a:srgbClr val="0C62FB"/>
-          </a:solidFill>
-          <a:ln/>
-        </p:spPr>
-        <p:txBody>
-          <a:bodyPr/>
-          <a:lstStyle/>
-          <a:p>
-            <a:endParaRPr lang="en-US"/>
-          </a:p>
-        </p:txBody>
-      </p:sp>
-      <p:sp>
-        <p:nvSpPr>
-          <p:cNvPr id="202" name="Shape Bar3"/>
-          <p:cNvSpPr/>
-          <p:nvPr/>
-        </p:nvSpPr>
-        <p:spPr>
-          <a:xfrm>
-            <a:off x="4864608" y="0"/>
-            <a:ext cx="2432304" cy="137160"/>
-          </a:xfrm>
-          <a:prstGeom prst="rect">
-            <a:avLst/>
-          </a:prstGeom>
-          <a:solidFill>
-            <a:srgbClr val="1BE1F2"/>
-          </a:solidFill>
-          <a:ln/>
-        </p:spPr>
-        <p:txBody>
-          <a:bodyPr/>
-          <a:lstStyle/>
-          <a:p>
-            <a:endParaRPr lang="en-US"/>
-          </a:p>
-        </p:txBody>
-      </p:sp>
-      <p:sp>
-        <p:nvSpPr>
-          <p:cNvPr id="203" name="Shape Bar4"/>
-          <p:cNvSpPr/>
-          <p:nvPr/>
-        </p:nvSpPr>
-        <p:spPr>
-          <a:xfrm>
-            <a:off x="7296912" y="0"/>
-            <a:ext cx="2432304" cy="137160"/>
-          </a:xfrm>
-          <a:prstGeom prst="rect">
-            <a:avLst/>
-          </a:prstGeom>
-          <a:solidFill>
-            <a:srgbClr val="FF4D5F"/>
-          </a:solidFill>
-          <a:ln/>
-        </p:spPr>
-        <p:txBody>
-          <a:bodyPr/>
-          <a:lstStyle/>
-          <a:p>
-            <a:endParaRPr lang="en-US"/>
-          </a:p>
-        </p:txBody>
-      </p:sp>
-      <p:sp>
-        <p:nvSpPr>
-          <p:cNvPr id="204" name="Shape Bar5"/>
-          <p:cNvSpPr/>
-          <p:nvPr/>
-        </p:nvSpPr>
-        <p:spPr>
-          <a:xfrm>
-            <a:off x="9729216" y="0"/>
-            <a:ext cx="2432304" cy="137160"/>
-          </a:xfrm>
-          <a:prstGeom prst="rect">
-            <a:avLst/>
-          </a:prstGeom>
-          <a:solidFill>
-            <a:srgbClr val="C7B9FF"/>
-          </a:solidFill>
-          <a:ln/>
-        </p:spPr>
-        <p:txBody>
-          <a:bodyPr/>
-          <a:lstStyle/>
-          <a:p>
-            <a:endParaRPr lang="en-US"/>
-          </a:p>
-        </p:txBody>
-      </p:sp>
-      <p:sp>
-        <p:nvSpPr>
-          <p:cNvPr id="205" name="Text Copyright"/>
-          <p:cNvSpPr/>
-          <p:nvPr/>
-        </p:nvSpPr>
-        <p:spPr>
-          <a:xfrm>
-            <a:off x="548640" y="6446520"/>
-            <a:ext cx="7315200" cy="274320"/>
-          </a:xfrm>
-          <a:prstGeom prst="rect">
-            <a:avLst/>
-          </a:prstGeom>
-          <a:noFill/>
-          <a:ln/>
-        </p:spPr>
-        <p:txBody>
-          <a:bodyPr wrap="square" lIns="0" tIns="0" rIns="0" bIns="0" rtlCol="0" anchor="ctr"/>
-          <a:lstStyle/>
-          <a:p>
-            <a:pPr marL="0" indent="0">
-              <a:buNone/>
-            </a:pPr>
-            <a:r>
               <a:rPr lang="en-US" sz="1000" dirty="0">
                 <a:solidFill>
                   <a:srgbClr val="666666"/>
@@ -5557,14 +5218,14 @@
         </p:nvSpPr>
         <p:spPr>
           <a:xfrm>
-            <a:off x="777240" y="1682496"/>
-            <a:ext cx="777240" cy="777240"/>
+            <a:off x="731520" y="1700784"/>
+            <a:ext cx="4206240" cy="4206240"/>
           </a:xfrm>
           <a:prstGeom prst="ellipse">
             <a:avLst/>
           </a:prstGeom>
           <a:solidFill>
-            <a:srgbClr val="002FAF"/>
+            <a:srgbClr val="0E8FA0"/>
           </a:solidFill>
           <a:ln>
             <a:noFill/>
@@ -5593,9 +5254,458 @@
           </a:p>
         </p:txBody>
       </p:sp>
+      <p:sp>
+        <p:nvSpPr>
+          <p:cNvPr id="208" name="Oval 207"/>
+          <p:cNvSpPr/>
+          <p:nvPr/>
+        </p:nvSpPr>
+        <p:spPr>
+          <a:xfrm>
+            <a:off x="1261872" y="2231136"/>
+            <a:ext cx="3145536" cy="3145536"/>
+          </a:xfrm>
+          <a:prstGeom prst="ellipse">
+            <a:avLst/>
+          </a:prstGeom>
+          <a:solidFill>
+            <a:srgbClr val="0C62FB"/>
+          </a:solidFill>
+          <a:ln>
+            <a:noFill/>
+          </a:ln>
+          <a:effectLst/>
+        </p:spPr>
+        <p:style>
+          <a:lnRef idx="1">
+            <a:schemeClr val="accent1"/>
+          </a:lnRef>
+          <a:fillRef idx="3">
+            <a:schemeClr val="accent1"/>
+          </a:fillRef>
+          <a:effectRef idx="2">
+            <a:schemeClr val="accent1"/>
+          </a:effectRef>
+          <a:fontRef idx="minor">
+            <a:schemeClr val="lt1"/>
+          </a:fontRef>
+        </p:style>
+        <p:txBody>
+          <a:bodyPr rtlCol="0" anchor="ctr"/>
+          <a:lstStyle/>
+          <a:p>
+            <a:pPr algn="ctr"/>
+          </a:p>
+        </p:txBody>
+      </p:sp>
+      <p:sp>
+        <p:nvSpPr>
+          <p:cNvPr id="209" name="Oval 208"/>
+          <p:cNvSpPr/>
+          <p:nvPr/>
+        </p:nvSpPr>
+        <p:spPr>
+          <a:xfrm>
+            <a:off x="1792224" y="2761488"/>
+            <a:ext cx="2084831" cy="2084831"/>
+          </a:xfrm>
+          <a:prstGeom prst="ellipse">
+            <a:avLst/>
+          </a:prstGeom>
+          <a:solidFill>
+            <a:srgbClr val="002FAF"/>
+          </a:solidFill>
+          <a:ln>
+            <a:noFill/>
+          </a:ln>
+          <a:effectLst/>
+        </p:spPr>
+        <p:style>
+          <a:lnRef idx="1">
+            <a:schemeClr val="accent1"/>
+          </a:lnRef>
+          <a:fillRef idx="3">
+            <a:schemeClr val="accent1"/>
+          </a:fillRef>
+          <a:effectRef idx="2">
+            <a:schemeClr val="accent1"/>
+          </a:effectRef>
+          <a:fontRef idx="minor">
+            <a:schemeClr val="lt1"/>
+          </a:fontRef>
+        </p:style>
+        <p:txBody>
+          <a:bodyPr rtlCol="0" anchor="ctr"/>
+          <a:lstStyle/>
+          <a:p>
+            <a:pPr algn="ctr"/>
+          </a:p>
+        </p:txBody>
+      </p:sp>
+      <p:sp>
+        <p:nvSpPr>
+          <p:cNvPr id="210" name="TextBox 209"/>
+          <p:cNvSpPr txBox="1"/>
+          <p:nvPr/>
+        </p:nvSpPr>
+        <p:spPr>
+          <a:xfrm>
+            <a:off x="1463040" y="1810512"/>
+            <a:ext cx="2743200" cy="274320"/>
+          </a:xfrm>
+          <a:prstGeom prst="rect">
+            <a:avLst/>
+          </a:prstGeom>
+          <a:noFill/>
+        </p:spPr>
+        <p:txBody>
+          <a:bodyPr wrap="square" lIns="27432" rIns="27432" tIns="0" bIns="0" anchor="ctr">
+            <a:spAutoFit/>
+          </a:bodyPr>
+          <a:lstStyle/>
+          <a:p>
+            <a:pPr algn="ctr"/>
+            <a:r>
+              <a:rPr sz="1300" b="1">
+                <a:solidFill>
+                  <a:srgbClr val="FFFFFF"/>
+                </a:solidFill>
+                <a:latin typeface="Avenir Next LT Pro"/>
+              </a:rPr>
+              <a:t>EVIDENCE</a:t>
+            </a:r>
+          </a:p>
+        </p:txBody>
+      </p:sp>
+      <p:sp>
+        <p:nvSpPr>
+          <p:cNvPr id="211" name="TextBox 210"/>
+          <p:cNvSpPr txBox="1"/>
+          <p:nvPr/>
+        </p:nvSpPr>
+        <p:spPr>
+          <a:xfrm>
+            <a:off x="1463040" y="2340864"/>
+            <a:ext cx="2743200" cy="274320"/>
+          </a:xfrm>
+          <a:prstGeom prst="rect">
+            <a:avLst/>
+          </a:prstGeom>
+          <a:noFill/>
+        </p:spPr>
+        <p:txBody>
+          <a:bodyPr wrap="square" lIns="27432" rIns="27432" tIns="0" bIns="0" anchor="ctr">
+            <a:spAutoFit/>
+          </a:bodyPr>
+          <a:lstStyle/>
+          <a:p>
+            <a:pPr algn="ctr"/>
+            <a:r>
+              <a:rPr sz="1300" b="1">
+                <a:solidFill>
+                  <a:srgbClr val="FFFFFF"/>
+                </a:solidFill>
+                <a:latin typeface="Avenir Next LT Pro"/>
+              </a:rPr>
+              <a:t>GOVERNANCE</a:t>
+            </a:r>
+          </a:p>
+        </p:txBody>
+      </p:sp>
+      <p:sp>
+        <p:nvSpPr>
+          <p:cNvPr id="212" name="TextBox 211"/>
+          <p:cNvSpPr txBox="1"/>
+          <p:nvPr/>
+        </p:nvSpPr>
+        <p:spPr>
+          <a:xfrm>
+            <a:off x="1463040" y="2871216"/>
+            <a:ext cx="2743200" cy="274320"/>
+          </a:xfrm>
+          <a:prstGeom prst="rect">
+            <a:avLst/>
+          </a:prstGeom>
+          <a:noFill/>
+        </p:spPr>
+        <p:txBody>
+          <a:bodyPr wrap="square" lIns="27432" rIns="27432" tIns="0" bIns="0" anchor="ctr">
+            <a:spAutoFit/>
+          </a:bodyPr>
+          <a:lstStyle/>
+          <a:p>
+            <a:pPr algn="ctr"/>
+            <a:r>
+              <a:rPr sz="1300" b="1">
+                <a:solidFill>
+                  <a:srgbClr val="FFFFFF"/>
+                </a:solidFill>
+                <a:latin typeface="Avenir Next LT Pro"/>
+              </a:rPr>
+              <a:t>SPEED</a:t>
+            </a:r>
+          </a:p>
+        </p:txBody>
+      </p:sp>
+      <p:sp>
+        <p:nvSpPr>
+          <p:cNvPr id="213" name="Oval 212"/>
+          <p:cNvSpPr/>
+          <p:nvPr/>
+        </p:nvSpPr>
+        <p:spPr>
+          <a:xfrm>
+            <a:off x="2286000" y="3255264"/>
+            <a:ext cx="1097280" cy="1097280"/>
+          </a:xfrm>
+          <a:prstGeom prst="ellipse">
+            <a:avLst/>
+          </a:prstGeom>
+          <a:solidFill>
+            <a:srgbClr val="FFFFFF"/>
+          </a:solidFill>
+          <a:ln w="19050">
+            <a:solidFill>
+              <a:srgbClr val="D5DEF2"/>
+            </a:solidFill>
+          </a:ln>
+          <a:effectLst/>
+        </p:spPr>
+        <p:style>
+          <a:lnRef idx="1">
+            <a:schemeClr val="accent1"/>
+          </a:lnRef>
+          <a:fillRef idx="3">
+            <a:schemeClr val="accent1"/>
+          </a:fillRef>
+          <a:effectRef idx="2">
+            <a:schemeClr val="accent1"/>
+          </a:effectRef>
+          <a:fontRef idx="minor">
+            <a:schemeClr val="lt1"/>
+          </a:fontRef>
+        </p:style>
+        <p:txBody>
+          <a:bodyPr rtlCol="0" anchor="ctr"/>
+          <a:lstStyle/>
+          <a:p>
+            <a:pPr algn="ctr"/>
+          </a:p>
+        </p:txBody>
+      </p:sp>
+      <p:sp>
+        <p:nvSpPr>
+          <p:cNvPr id="214" name="TextBox 213"/>
+          <p:cNvSpPr txBox="1"/>
+          <p:nvPr/>
+        </p:nvSpPr>
+        <p:spPr>
+          <a:xfrm>
+            <a:off x="2304288" y="3584448"/>
+            <a:ext cx="1060704" cy="256032"/>
+          </a:xfrm>
+          <a:prstGeom prst="rect">
+            <a:avLst/>
+          </a:prstGeom>
+          <a:noFill/>
+        </p:spPr>
+        <p:txBody>
+          <a:bodyPr wrap="square" lIns="27432" rIns="27432" tIns="0" bIns="0" anchor="ctr">
+            <a:spAutoFit/>
+          </a:bodyPr>
+          <a:lstStyle/>
+          <a:p>
+            <a:pPr algn="ctr"/>
+            <a:r>
+              <a:rPr sz="1100" b="1">
+                <a:solidFill>
+                  <a:srgbClr val="002FAF"/>
+                </a:solidFill>
+                <a:latin typeface="Avenir Next LT Pro"/>
+              </a:rPr>
+              <a:t>CLIENT VALUE</a:t>
+            </a:r>
+          </a:p>
+        </p:txBody>
+      </p:sp>
+      <p:sp>
+        <p:nvSpPr>
+          <p:cNvPr id="215" name="TextBox 214"/>
+          <p:cNvSpPr txBox="1"/>
+          <p:nvPr/>
+        </p:nvSpPr>
+        <p:spPr>
+          <a:xfrm>
+            <a:off x="2304288" y="3822191"/>
+            <a:ext cx="1060704" cy="310896"/>
+          </a:xfrm>
+          <a:prstGeom prst="rect">
+            <a:avLst/>
+          </a:prstGeom>
+          <a:noFill/>
+        </p:spPr>
+        <p:txBody>
+          <a:bodyPr wrap="square" lIns="27432" rIns="27432" tIns="0" bIns="0" anchor="t">
+            <a:spAutoFit/>
+          </a:bodyPr>
+          <a:lstStyle/>
+          <a:p>
+            <a:pPr algn="ctr"/>
+            <a:r>
+              <a:rPr sz="850" b="0">
+                <a:solidFill>
+                  <a:srgbClr val="6B7280"/>
+                </a:solidFill>
+                <a:latin typeface="Avenir Next LT Pro"/>
+              </a:rPr>
+              <a:t>compounds every engagement</a:t>
+            </a:r>
+          </a:p>
+        </p:txBody>
+      </p:sp>
+      <p:sp>
+        <p:nvSpPr>
+          <p:cNvPr id="216" name="Rounded Rectangle 215"/>
+          <p:cNvSpPr/>
+          <p:nvPr/>
+        </p:nvSpPr>
+        <p:spPr>
+          <a:xfrm>
+            <a:off x="5577840" y="1691640"/>
+            <a:ext cx="6062472" cy="1280160"/>
+          </a:xfrm>
+          <a:prstGeom prst="roundRect">
+            <a:avLst>
+              <a:gd name="adj" fmla="val 6000"/>
+            </a:avLst>
+          </a:prstGeom>
+          <a:solidFill>
+            <a:srgbClr val="FFFFFF"/>
+          </a:solidFill>
+          <a:ln w="12700">
+            <a:solidFill>
+              <a:srgbClr val="E7ECF5"/>
+            </a:solidFill>
+          </a:ln>
+          <a:effectLst/>
+        </p:spPr>
+        <p:style>
+          <a:lnRef idx="1">
+            <a:schemeClr val="accent1"/>
+          </a:lnRef>
+          <a:fillRef idx="3">
+            <a:schemeClr val="accent1"/>
+          </a:fillRef>
+          <a:effectRef idx="2">
+            <a:schemeClr val="accent1"/>
+          </a:effectRef>
+          <a:fontRef idx="minor">
+            <a:schemeClr val="lt1"/>
+          </a:fontRef>
+        </p:style>
+        <p:txBody>
+          <a:bodyPr rtlCol="0" anchor="ctr"/>
+          <a:lstStyle/>
+          <a:p>
+            <a:pPr algn="ctr"/>
+          </a:p>
+        </p:txBody>
+      </p:sp>
+      <p:sp>
+        <p:nvSpPr>
+          <p:cNvPr id="217" name="Rounded Rectangle 216"/>
+          <p:cNvSpPr/>
+          <p:nvPr/>
+        </p:nvSpPr>
+        <p:spPr>
+          <a:xfrm>
+            <a:off x="5577840" y="1691640"/>
+            <a:ext cx="91440" cy="1280160"/>
+          </a:xfrm>
+          <a:prstGeom prst="roundRect">
+            <a:avLst>
+              <a:gd name="adj" fmla="val 50000"/>
+            </a:avLst>
+          </a:prstGeom>
+          <a:solidFill>
+            <a:srgbClr val="002FAF"/>
+          </a:solidFill>
+          <a:ln>
+            <a:noFill/>
+          </a:ln>
+          <a:effectLst/>
+        </p:spPr>
+        <p:style>
+          <a:lnRef idx="1">
+            <a:schemeClr val="accent1"/>
+          </a:lnRef>
+          <a:fillRef idx="3">
+            <a:schemeClr val="accent1"/>
+          </a:fillRef>
+          <a:effectRef idx="2">
+            <a:schemeClr val="accent1"/>
+          </a:effectRef>
+          <a:fontRef idx="minor">
+            <a:schemeClr val="lt1"/>
+          </a:fontRef>
+        </p:style>
+        <p:txBody>
+          <a:bodyPr rtlCol="0" anchor="ctr"/>
+          <a:lstStyle/>
+          <a:p>
+            <a:pPr algn="ctr"/>
+          </a:p>
+        </p:txBody>
+      </p:sp>
+      <p:sp>
+        <p:nvSpPr>
+          <p:cNvPr id="218" name="Rounded Rectangle 217"/>
+          <p:cNvSpPr/>
+          <p:nvPr/>
+        </p:nvSpPr>
+        <p:spPr>
+          <a:xfrm>
+            <a:off x="5797296" y="1874520"/>
+            <a:ext cx="347472" cy="347472"/>
+          </a:xfrm>
+          <a:prstGeom prst="roundRect">
+            <a:avLst>
+              <a:gd name="adj" fmla="val 26000"/>
+            </a:avLst>
+          </a:prstGeom>
+          <a:solidFill>
+            <a:srgbClr val="002FAF"/>
+          </a:solidFill>
+          <a:ln>
+            <a:noFill/>
+          </a:ln>
+          <a:effectLst/>
+        </p:spPr>
+        <p:style>
+          <a:lnRef idx="1">
+            <a:schemeClr val="accent1"/>
+          </a:lnRef>
+          <a:fillRef idx="3">
+            <a:schemeClr val="accent1"/>
+          </a:fillRef>
+          <a:effectRef idx="2">
+            <a:schemeClr val="accent1"/>
+          </a:effectRef>
+          <a:fontRef idx="minor">
+            <a:schemeClr val="lt1"/>
+          </a:fontRef>
+        </p:style>
+        <p:txBody>
+          <a:bodyPr rtlCol="0" anchor="ctr"/>
+          <a:lstStyle/>
+          <a:p>
+            <a:pPr algn="ctr"/>
+          </a:p>
+        </p:txBody>
+      </p:sp>
       <p:pic>
         <p:nvPicPr>
-          <p:cNvPr id="208" name="Picture 207" descr="icon_zap.png"/>
+          <p:cNvPr id="219" name="Picture 218" descr="image.png"/>
           <p:cNvPicPr>
             <a:picLocks noChangeAspect="1"/>
           </p:cNvPicPr>
@@ -5609,8 +5719,8 @@
         </p:blipFill>
         <p:spPr>
           <a:xfrm>
-            <a:off x="952119" y="1857375"/>
-            <a:ext cx="427482" cy="427482"/>
+            <a:off x="5879592" y="1956816"/>
+            <a:ext cx="182880" cy="182880"/>
           </a:xfrm>
           <a:prstGeom prst="rect">
             <a:avLst/>
@@ -5619,18 +5729,53 @@
       </p:pic>
       <p:sp>
         <p:nvSpPr>
-          <p:cNvPr id="209" name="Rounded Rectangle 208"/>
-          <p:cNvSpPr/>
-          <p:nvPr/>
-        </p:nvSpPr>
-        <p:spPr>
-          <a:xfrm>
-            <a:off x="8686800" y="1659636"/>
-            <a:ext cx="2788920" cy="822960"/>
+          <p:cNvPr id="220" name="TextBox 219"/>
+          <p:cNvSpPr txBox="1"/>
+          <p:nvPr/>
+        </p:nvSpPr>
+        <p:spPr>
+          <a:xfrm>
+            <a:off x="6272783" y="1892808"/>
+            <a:ext cx="3383280" cy="329184"/>
+          </a:xfrm>
+          <a:prstGeom prst="rect">
+            <a:avLst/>
+          </a:prstGeom>
+          <a:noFill/>
+        </p:spPr>
+        <p:txBody>
+          <a:bodyPr wrap="square" lIns="27432" rIns="27432" tIns="0" bIns="0" anchor="ctr">
+            <a:spAutoFit/>
+          </a:bodyPr>
+          <a:lstStyle/>
+          <a:p>
+            <a:pPr algn="l"/>
+            <a:r>
+              <a:rPr sz="1700" b="1">
+                <a:solidFill>
+                  <a:srgbClr val="002FAF"/>
+                </a:solidFill>
+                <a:latin typeface="Avenir Next LT Pro"/>
+              </a:rPr>
+              <a:t>Reusable IP &amp; Speed</a:t>
+            </a:r>
+          </a:p>
+        </p:txBody>
+      </p:sp>
+      <p:sp>
+        <p:nvSpPr>
+          <p:cNvPr id="221" name="Rounded Rectangle 220"/>
+          <p:cNvSpPr/>
+          <p:nvPr/>
+        </p:nvSpPr>
+        <p:spPr>
+          <a:xfrm>
+            <a:off x="9491472" y="1892808"/>
+            <a:ext cx="1965960" cy="310896"/>
           </a:xfrm>
           <a:prstGeom prst="roundRect">
             <a:avLst>
-              <a:gd name="adj" fmla="val 22000"/>
+              <a:gd name="adj" fmla="val 50000"/>
             </a:avLst>
           </a:prstGeom>
           <a:solidFill>
@@ -5656,16 +5801,16 @@
           </a:fontRef>
         </p:style>
         <p:txBody>
-          <a:bodyPr rtlCol="0" anchor="ctr" wrap="square" lIns="54864" rIns="54864" tIns="18288" bIns="18288"/>
+          <a:bodyPr rtlCol="0" anchor="ctr" wrap="square" lIns="27432" rIns="27432" tIns="0" bIns="0"/>
           <a:lstStyle/>
           <a:p>
             <a:pPr algn="ctr"/>
             <a:r>
-              <a:rPr b="1" sz="1200">
+              <a:rPr sz="1100" b="1">
                 <a:solidFill>
                   <a:srgbClr val="FFFFFF"/>
                 </a:solidFill>
-                <a:latin typeface="Calibri"/>
+                <a:latin typeface="Avenir Next LT Pro"/>
               </a:rPr>
               <a:t>Faster delivery</a:t>
             </a:r>
@@ -5674,23 +5819,62 @@
       </p:sp>
       <p:sp>
         <p:nvSpPr>
-          <p:cNvPr id="210" name="Oval 209"/>
-          <p:cNvSpPr/>
-          <p:nvPr/>
-        </p:nvSpPr>
-        <p:spPr>
-          <a:xfrm>
-            <a:off x="777240" y="3488436"/>
-            <a:ext cx="777240" cy="777240"/>
-          </a:xfrm>
-          <a:prstGeom prst="ellipse">
-            <a:avLst/>
-          </a:prstGeom>
-          <a:solidFill>
-            <a:srgbClr val="0C62FB"/>
-          </a:solidFill>
-          <a:ln>
-            <a:noFill/>
+          <p:cNvPr id="222" name="TextBox 221"/>
+          <p:cNvSpPr txBox="1"/>
+          <p:nvPr/>
+        </p:nvSpPr>
+        <p:spPr>
+          <a:xfrm>
+            <a:off x="5815583" y="2350008"/>
+            <a:ext cx="5605272" cy="548640"/>
+          </a:xfrm>
+          <a:prstGeom prst="rect">
+            <a:avLst/>
+          </a:prstGeom>
+          <a:noFill/>
+        </p:spPr>
+        <p:txBody>
+          <a:bodyPr wrap="square" lIns="27432" rIns="27432" tIns="0" bIns="0" anchor="t">
+            <a:spAutoFit/>
+          </a:bodyPr>
+          <a:lstStyle/>
+          <a:p>
+            <a:pPr algn="l"/>
+            <a:r>
+              <a:rPr sz="1150" b="0">
+                <a:solidFill>
+                  <a:srgbClr val="3E4759"/>
+                </a:solidFill>
+                <a:latin typeface="Avenir Next LT Pro"/>
+              </a:rPr>
+              <a:t>A one-off engagement becomes a repeatable asset — weeks of manual setup run in hours; the next client reuses the same accelerators.</a:t>
+            </a:r>
+          </a:p>
+        </p:txBody>
+      </p:sp>
+      <p:sp>
+        <p:nvSpPr>
+          <p:cNvPr id="223" name="Rounded Rectangle 222"/>
+          <p:cNvSpPr/>
+          <p:nvPr/>
+        </p:nvSpPr>
+        <p:spPr>
+          <a:xfrm>
+            <a:off x="5577840" y="3063240"/>
+            <a:ext cx="6062472" cy="1280160"/>
+          </a:xfrm>
+          <a:prstGeom prst="roundRect">
+            <a:avLst>
+              <a:gd name="adj" fmla="val 6000"/>
+            </a:avLst>
+          </a:prstGeom>
+          <a:solidFill>
+            <a:srgbClr val="FFFFFF"/>
+          </a:solidFill>
+          <a:ln w="12700">
+            <a:solidFill>
+              <a:srgbClr val="E7ECF5"/>
+            </a:solidFill>
           </a:ln>
           <a:effectLst/>
         </p:spPr>
@@ -5716,9 +5900,101 @@
           </a:p>
         </p:txBody>
       </p:sp>
+      <p:sp>
+        <p:nvSpPr>
+          <p:cNvPr id="224" name="Rounded Rectangle 223"/>
+          <p:cNvSpPr/>
+          <p:nvPr/>
+        </p:nvSpPr>
+        <p:spPr>
+          <a:xfrm>
+            <a:off x="5577840" y="3063240"/>
+            <a:ext cx="91440" cy="1280160"/>
+          </a:xfrm>
+          <a:prstGeom prst="roundRect">
+            <a:avLst>
+              <a:gd name="adj" fmla="val 50000"/>
+            </a:avLst>
+          </a:prstGeom>
+          <a:solidFill>
+            <a:srgbClr val="0C62FB"/>
+          </a:solidFill>
+          <a:ln>
+            <a:noFill/>
+          </a:ln>
+          <a:effectLst/>
+        </p:spPr>
+        <p:style>
+          <a:lnRef idx="1">
+            <a:schemeClr val="accent1"/>
+          </a:lnRef>
+          <a:fillRef idx="3">
+            <a:schemeClr val="accent1"/>
+          </a:fillRef>
+          <a:effectRef idx="2">
+            <a:schemeClr val="accent1"/>
+          </a:effectRef>
+          <a:fontRef idx="minor">
+            <a:schemeClr val="lt1"/>
+          </a:fontRef>
+        </p:style>
+        <p:txBody>
+          <a:bodyPr rtlCol="0" anchor="ctr"/>
+          <a:lstStyle/>
+          <a:p>
+            <a:pPr algn="ctr"/>
+          </a:p>
+        </p:txBody>
+      </p:sp>
+      <p:sp>
+        <p:nvSpPr>
+          <p:cNvPr id="225" name="Rounded Rectangle 224"/>
+          <p:cNvSpPr/>
+          <p:nvPr/>
+        </p:nvSpPr>
+        <p:spPr>
+          <a:xfrm>
+            <a:off x="5797296" y="3246120"/>
+            <a:ext cx="347472" cy="347472"/>
+          </a:xfrm>
+          <a:prstGeom prst="roundRect">
+            <a:avLst>
+              <a:gd name="adj" fmla="val 26000"/>
+            </a:avLst>
+          </a:prstGeom>
+          <a:solidFill>
+            <a:srgbClr val="0C62FB"/>
+          </a:solidFill>
+          <a:ln>
+            <a:noFill/>
+          </a:ln>
+          <a:effectLst/>
+        </p:spPr>
+        <p:style>
+          <a:lnRef idx="1">
+            <a:schemeClr val="accent1"/>
+          </a:lnRef>
+          <a:fillRef idx="3">
+            <a:schemeClr val="accent1"/>
+          </a:fillRef>
+          <a:effectRef idx="2">
+            <a:schemeClr val="accent1"/>
+          </a:effectRef>
+          <a:fontRef idx="minor">
+            <a:schemeClr val="lt1"/>
+          </a:fontRef>
+        </p:style>
+        <p:txBody>
+          <a:bodyPr rtlCol="0" anchor="ctr"/>
+          <a:lstStyle/>
+          <a:p>
+            <a:pPr algn="ctr"/>
+          </a:p>
+        </p:txBody>
+      </p:sp>
       <p:pic>
         <p:nvPicPr>
-          <p:cNvPr id="211" name="Picture 210" descr="icon_shield.png"/>
+          <p:cNvPr id="226" name="Picture 225" descr="image.png"/>
           <p:cNvPicPr>
             <a:picLocks noChangeAspect="1"/>
           </p:cNvPicPr>
@@ -5732,8 +6008,8 @@
         </p:blipFill>
         <p:spPr>
           <a:xfrm>
-            <a:off x="952119" y="3663314"/>
-            <a:ext cx="427482" cy="427482"/>
+            <a:off x="5879592" y="3328416"/>
+            <a:ext cx="182880" cy="182880"/>
           </a:xfrm>
           <a:prstGeom prst="rect">
             <a:avLst/>
@@ -5742,18 +6018,53 @@
       </p:pic>
       <p:sp>
         <p:nvSpPr>
-          <p:cNvPr id="212" name="Rounded Rectangle 211"/>
-          <p:cNvSpPr/>
-          <p:nvPr/>
-        </p:nvSpPr>
-        <p:spPr>
-          <a:xfrm>
-            <a:off x="8686800" y="3465576"/>
-            <a:ext cx="2788920" cy="822960"/>
+          <p:cNvPr id="227" name="TextBox 226"/>
+          <p:cNvSpPr txBox="1"/>
+          <p:nvPr/>
+        </p:nvSpPr>
+        <p:spPr>
+          <a:xfrm>
+            <a:off x="6272783" y="3264408"/>
+            <a:ext cx="3383280" cy="329184"/>
+          </a:xfrm>
+          <a:prstGeom prst="rect">
+            <a:avLst/>
+          </a:prstGeom>
+          <a:noFill/>
+        </p:spPr>
+        <p:txBody>
+          <a:bodyPr wrap="square" lIns="27432" rIns="27432" tIns="0" bIns="0" anchor="ctr">
+            <a:spAutoFit/>
+          </a:bodyPr>
+          <a:lstStyle/>
+          <a:p>
+            <a:pPr algn="l"/>
+            <a:r>
+              <a:rPr sz="1700" b="1">
+                <a:solidFill>
+                  <a:srgbClr val="0C62FB"/>
+                </a:solidFill>
+                <a:latin typeface="Avenir Next LT Pro"/>
+              </a:rPr>
+              <a:t>Consistency &amp; Governance</a:t>
+            </a:r>
+          </a:p>
+        </p:txBody>
+      </p:sp>
+      <p:sp>
+        <p:nvSpPr>
+          <p:cNvPr id="228" name="Rounded Rectangle 227"/>
+          <p:cNvSpPr/>
+          <p:nvPr/>
+        </p:nvSpPr>
+        <p:spPr>
+          <a:xfrm>
+            <a:off x="9491472" y="3264408"/>
+            <a:ext cx="1965960" cy="310896"/>
           </a:xfrm>
           <a:prstGeom prst="roundRect">
             <a:avLst>
-              <a:gd name="adj" fmla="val 22000"/>
+              <a:gd name="adj" fmla="val 50000"/>
             </a:avLst>
           </a:prstGeom>
           <a:solidFill>
@@ -5779,16 +6090,16 @@
           </a:fontRef>
         </p:style>
         <p:txBody>
-          <a:bodyPr rtlCol="0" anchor="ctr" wrap="square" lIns="54864" rIns="54864" tIns="18288" bIns="18288"/>
+          <a:bodyPr rtlCol="0" anchor="ctr" wrap="square" lIns="27432" rIns="27432" tIns="0" bIns="0"/>
           <a:lstStyle/>
           <a:p>
             <a:pPr algn="ctr"/>
             <a:r>
-              <a:rPr b="1" sz="1200">
+              <a:rPr sz="1100" b="1">
                 <a:solidFill>
                   <a:srgbClr val="FFFFFF"/>
                 </a:solidFill>
-                <a:latin typeface="Calibri"/>
+                <a:latin typeface="Avenir Next LT Pro"/>
               </a:rPr>
               <a:t>Consistent &amp; governed</a:t>
             </a:r>
@@ -5797,23 +6108,62 @@
       </p:sp>
       <p:sp>
         <p:nvSpPr>
-          <p:cNvPr id="213" name="Oval 212"/>
-          <p:cNvSpPr/>
-          <p:nvPr/>
-        </p:nvSpPr>
-        <p:spPr>
-          <a:xfrm>
-            <a:off x="777240" y="5189220"/>
-            <a:ext cx="777240" cy="777240"/>
-          </a:xfrm>
-          <a:prstGeom prst="ellipse">
-            <a:avLst/>
-          </a:prstGeom>
-          <a:solidFill>
-            <a:srgbClr val="0E8FA0"/>
-          </a:solidFill>
-          <a:ln>
-            <a:noFill/>
+          <p:cNvPr id="229" name="TextBox 228"/>
+          <p:cNvSpPr txBox="1"/>
+          <p:nvPr/>
+        </p:nvSpPr>
+        <p:spPr>
+          <a:xfrm>
+            <a:off x="5815583" y="3721608"/>
+            <a:ext cx="5605272" cy="548640"/>
+          </a:xfrm>
+          <a:prstGeom prst="rect">
+            <a:avLst/>
+          </a:prstGeom>
+          <a:noFill/>
+        </p:spPr>
+        <p:txBody>
+          <a:bodyPr wrap="square" lIns="27432" rIns="27432" tIns="0" bIns="0" anchor="t">
+            <a:spAutoFit/>
+          </a:bodyPr>
+          <a:lstStyle/>
+          <a:p>
+            <a:pPr algn="l"/>
+            <a:r>
+              <a:rPr sz="1150" b="0">
+                <a:solidFill>
+                  <a:srgbClr val="3E4759"/>
+                </a:solidFill>
+                <a:latin typeface="Avenir Next LT Pro"/>
+              </a:rPr>
+              <a:t>The same standards, naming and quality bar every time — approval gates, rollback and human sign-off built into build and publish.</a:t>
+            </a:r>
+          </a:p>
+        </p:txBody>
+      </p:sp>
+      <p:sp>
+        <p:nvSpPr>
+          <p:cNvPr id="230" name="Rounded Rectangle 229"/>
+          <p:cNvSpPr/>
+          <p:nvPr/>
+        </p:nvSpPr>
+        <p:spPr>
+          <a:xfrm>
+            <a:off x="5577840" y="4434840"/>
+            <a:ext cx="6062472" cy="1280160"/>
+          </a:xfrm>
+          <a:prstGeom prst="roundRect">
+            <a:avLst>
+              <a:gd name="adj" fmla="val 6000"/>
+            </a:avLst>
+          </a:prstGeom>
+          <a:solidFill>
+            <a:srgbClr val="FFFFFF"/>
+          </a:solidFill>
+          <a:ln w="12700">
+            <a:solidFill>
+              <a:srgbClr val="E7ECF5"/>
+            </a:solidFill>
           </a:ln>
           <a:effectLst/>
         </p:spPr>
@@ -5839,9 +6189,101 @@
           </a:p>
         </p:txBody>
       </p:sp>
+      <p:sp>
+        <p:nvSpPr>
+          <p:cNvPr id="231" name="Rounded Rectangle 230"/>
+          <p:cNvSpPr/>
+          <p:nvPr/>
+        </p:nvSpPr>
+        <p:spPr>
+          <a:xfrm>
+            <a:off x="5577840" y="4434840"/>
+            <a:ext cx="91440" cy="1280160"/>
+          </a:xfrm>
+          <a:prstGeom prst="roundRect">
+            <a:avLst>
+              <a:gd name="adj" fmla="val 50000"/>
+            </a:avLst>
+          </a:prstGeom>
+          <a:solidFill>
+            <a:srgbClr val="0E8FA0"/>
+          </a:solidFill>
+          <a:ln>
+            <a:noFill/>
+          </a:ln>
+          <a:effectLst/>
+        </p:spPr>
+        <p:style>
+          <a:lnRef idx="1">
+            <a:schemeClr val="accent1"/>
+          </a:lnRef>
+          <a:fillRef idx="3">
+            <a:schemeClr val="accent1"/>
+          </a:fillRef>
+          <a:effectRef idx="2">
+            <a:schemeClr val="accent1"/>
+          </a:effectRef>
+          <a:fontRef idx="minor">
+            <a:schemeClr val="lt1"/>
+          </a:fontRef>
+        </p:style>
+        <p:txBody>
+          <a:bodyPr rtlCol="0" anchor="ctr"/>
+          <a:lstStyle/>
+          <a:p>
+            <a:pPr algn="ctr"/>
+          </a:p>
+        </p:txBody>
+      </p:sp>
+      <p:sp>
+        <p:nvSpPr>
+          <p:cNvPr id="232" name="Rounded Rectangle 231"/>
+          <p:cNvSpPr/>
+          <p:nvPr/>
+        </p:nvSpPr>
+        <p:spPr>
+          <a:xfrm>
+            <a:off x="5797296" y="4617720"/>
+            <a:ext cx="347472" cy="347472"/>
+          </a:xfrm>
+          <a:prstGeom prst="roundRect">
+            <a:avLst>
+              <a:gd name="adj" fmla="val 26000"/>
+            </a:avLst>
+          </a:prstGeom>
+          <a:solidFill>
+            <a:srgbClr val="0E8FA0"/>
+          </a:solidFill>
+          <a:ln>
+            <a:noFill/>
+          </a:ln>
+          <a:effectLst/>
+        </p:spPr>
+        <p:style>
+          <a:lnRef idx="1">
+            <a:schemeClr val="accent1"/>
+          </a:lnRef>
+          <a:fillRef idx="3">
+            <a:schemeClr val="accent1"/>
+          </a:fillRef>
+          <a:effectRef idx="2">
+            <a:schemeClr val="accent1"/>
+          </a:effectRef>
+          <a:fontRef idx="minor">
+            <a:schemeClr val="lt1"/>
+          </a:fontRef>
+        </p:style>
+        <p:txBody>
+          <a:bodyPr rtlCol="0" anchor="ctr"/>
+          <a:lstStyle/>
+          <a:p>
+            <a:pPr algn="ctr"/>
+          </a:p>
+        </p:txBody>
+      </p:sp>
       <p:pic>
         <p:nvPicPr>
-          <p:cNvPr id="214" name="Picture 213" descr="icon_award.png"/>
+          <p:cNvPr id="233" name="Picture 232" descr="image.png"/>
           <p:cNvPicPr>
             <a:picLocks noChangeAspect="1"/>
           </p:cNvPicPr>
@@ -5855,8 +6297,8 @@
         </p:blipFill>
         <p:spPr>
           <a:xfrm>
-            <a:off x="952119" y="5364099"/>
-            <a:ext cx="427482" cy="427482"/>
+            <a:off x="5879592" y="4700016"/>
+            <a:ext cx="182880" cy="182880"/>
           </a:xfrm>
           <a:prstGeom prst="rect">
             <a:avLst/>
@@ -5865,18 +6307,53 @@
       </p:pic>
       <p:sp>
         <p:nvSpPr>
-          <p:cNvPr id="215" name="Rounded Rectangle 214"/>
-          <p:cNvSpPr/>
-          <p:nvPr/>
-        </p:nvSpPr>
-        <p:spPr>
-          <a:xfrm>
-            <a:off x="8686800" y="5166360"/>
-            <a:ext cx="2788920" cy="822960"/>
+          <p:cNvPr id="234" name="TextBox 233"/>
+          <p:cNvSpPr txBox="1"/>
+          <p:nvPr/>
+        </p:nvSpPr>
+        <p:spPr>
+          <a:xfrm>
+            <a:off x="6272783" y="4636007"/>
+            <a:ext cx="3383280" cy="329184"/>
+          </a:xfrm>
+          <a:prstGeom prst="rect">
+            <a:avLst/>
+          </a:prstGeom>
+          <a:noFill/>
+        </p:spPr>
+        <p:txBody>
+          <a:bodyPr wrap="square" lIns="27432" rIns="27432" tIns="0" bIns="0" anchor="ctr">
+            <a:spAutoFit/>
+          </a:bodyPr>
+          <a:lstStyle/>
+          <a:p>
+            <a:pPr algn="l"/>
+            <a:r>
+              <a:rPr sz="1700" b="1">
+                <a:solidFill>
+                  <a:srgbClr val="0E8FA0"/>
+                </a:solidFill>
+                <a:latin typeface="Avenir Next LT Pro"/>
+              </a:rPr>
+              <a:t>A Quality Floor &amp; Evidence</a:t>
+            </a:r>
+          </a:p>
+        </p:txBody>
+      </p:sp>
+      <p:sp>
+        <p:nvSpPr>
+          <p:cNvPr id="235" name="Rounded Rectangle 234"/>
+          <p:cNvSpPr/>
+          <p:nvPr/>
+        </p:nvSpPr>
+        <p:spPr>
+          <a:xfrm>
+            <a:off x="9491472" y="4636007"/>
+            <a:ext cx="1965960" cy="310896"/>
           </a:xfrm>
           <a:prstGeom prst="roundRect">
             <a:avLst>
-              <a:gd name="adj" fmla="val 22000"/>
+              <a:gd name="adj" fmla="val 50000"/>
             </a:avLst>
           </a:prstGeom>
           <a:solidFill>
@@ -5902,18 +6379,53 @@
           </a:fontRef>
         </p:style>
         <p:txBody>
-          <a:bodyPr rtlCol="0" anchor="ctr" wrap="square" lIns="54864" rIns="54864" tIns="18288" bIns="18288"/>
+          <a:bodyPr rtlCol="0" anchor="ctr" wrap="square" lIns="27432" rIns="27432" tIns="0" bIns="0"/>
           <a:lstStyle/>
           <a:p>
             <a:pPr algn="ctr"/>
             <a:r>
-              <a:rPr b="1" sz="1200">
+              <a:rPr sz="1100" b="1">
                 <a:solidFill>
                   <a:srgbClr val="FFFFFF"/>
                 </a:solidFill>
-                <a:latin typeface="Calibri"/>
+                <a:latin typeface="Avenir Next LT Pro"/>
               </a:rPr>
               <a:t>Defensible &amp; repeatable</a:t>
+            </a:r>
+          </a:p>
+        </p:txBody>
+      </p:sp>
+      <p:sp>
+        <p:nvSpPr>
+          <p:cNvPr id="236" name="TextBox 235"/>
+          <p:cNvSpPr txBox="1"/>
+          <p:nvPr/>
+        </p:nvSpPr>
+        <p:spPr>
+          <a:xfrm>
+            <a:off x="5815583" y="5093207"/>
+            <a:ext cx="5605272" cy="548640"/>
+          </a:xfrm>
+          <a:prstGeom prst="rect">
+            <a:avLst/>
+          </a:prstGeom>
+          <a:noFill/>
+        </p:spPr>
+        <p:txBody>
+          <a:bodyPr wrap="square" lIns="27432" rIns="27432" tIns="0" bIns="0" anchor="t">
+            <a:spAutoFit/>
+          </a:bodyPr>
+          <a:lstStyle/>
+          <a:p>
+            <a:pPr algn="l"/>
+            <a:r>
+              <a:rPr sz="1150" b="0">
+                <a:solidFill>
+                  <a:srgbClr val="3E4759"/>
+                </a:solidFill>
+                <a:latin typeface="Avenir Next LT Pro"/>
+              </a:rPr>
+              <a:t>Junior consultants ship senior-quality output — every finding sourced from live config, capturable and defensible to a skeptical client.</a:t>
             </a:r>
           </a:p>
         </p:txBody>

</xml_diff>

<commit_message>
Slide 2: add each skill's deliverable (the artifact it produces)
Extend the agenda so every skill now names what it hands over — a
"DELIVERS" line with file types called out (Findings deck PPTX + audit
workbook XLSX; reconciliation workbook XLSX + decisions email; SDR + XDM
schema; live Launch property; etc.) — framing the artifacts as value.
Swap the big overlapping numbers for small badges on the icon circles,
retitle to "...and What They Deliver", and reword Plan's "interview" to
"scoping Q&A" for a client audience.

Co-Authored-By: Claude Opus 4.8 <noreply@anthropic.com>
Claude-Session: https://claude.ai/code/session_01L22pJWjoypJEHfB9cqhWZF
</commit_message>
<xml_diff>
--- a/websdk-property/docs/adobe-data-collection-skills-suite.pptx
+++ b/websdk-property/docs/adobe-data-collection-skills-suite.pptx
@@ -1901,7 +1901,7 @@
                 <a:ea typeface="Avenir Next LT Pro" pitchFamily="34" charset="-122"/>
                 <a:cs typeface="Avenir Next LT Pro" pitchFamily="34" charset="-120"/>
               </a:rPr>
-              <a:t>What the Skills Are</a:t>
+              <a:t>What the Skills Are — and What They Deliver</a:t>
             </a:r>
             <a:endParaRPr lang="en-US" sz="2500" dirty="0"/>
           </a:p>
@@ -2087,7 +2087,7 @@
         <p:spPr>
           <a:xfrm>
             <a:off x="6062472" y="1371600"/>
-            <a:ext cx="54864" cy="274320"/>
+            <a:ext cx="54864" cy="237744"/>
           </a:xfrm>
           <a:prstGeom prst="rect">
             <a:avLst/>
@@ -2130,7 +2130,7 @@
         </p:nvSpPr>
         <p:spPr>
           <a:xfrm>
-            <a:off x="6062472" y="1645920"/>
+            <a:off x="6062472" y="1609344"/>
             <a:ext cx="54864" cy="859536"/>
           </a:xfrm>
           <a:prstGeom prst="rect">
@@ -2174,7 +2174,7 @@
         </p:nvSpPr>
         <p:spPr>
           <a:xfrm>
-            <a:off x="6062472" y="2505456"/>
+            <a:off x="6062472" y="2468880"/>
             <a:ext cx="54864" cy="859536"/>
           </a:xfrm>
           <a:prstGeom prst="rect">
@@ -2218,7 +2218,7 @@
         </p:nvSpPr>
         <p:spPr>
           <a:xfrm>
-            <a:off x="6062472" y="3364992"/>
+            <a:off x="6062472" y="3328416"/>
             <a:ext cx="54864" cy="859536"/>
           </a:xfrm>
           <a:prstGeom prst="rect">
@@ -2262,7 +2262,7 @@
         </p:nvSpPr>
         <p:spPr>
           <a:xfrm>
-            <a:off x="6062472" y="4224528"/>
+            <a:off x="6062472" y="4187952"/>
             <a:ext cx="54864" cy="859535"/>
           </a:xfrm>
           <a:prstGeom prst="rect">
@@ -2306,7 +2306,7 @@
         </p:nvSpPr>
         <p:spPr>
           <a:xfrm>
-            <a:off x="6062472" y="5084064"/>
+            <a:off x="6062472" y="5047488"/>
             <a:ext cx="54864" cy="859536"/>
           </a:xfrm>
           <a:prstGeom prst="rect">
@@ -2350,8 +2350,8 @@
         </p:nvSpPr>
         <p:spPr>
           <a:xfrm>
-            <a:off x="6062472" y="5943600"/>
-            <a:ext cx="54864" cy="274319"/>
+            <a:off x="6062472" y="5907024"/>
+            <a:ext cx="54864" cy="310895"/>
           </a:xfrm>
           <a:prstGeom prst="rect">
             <a:avLst/>
@@ -2394,8 +2394,8 @@
         </p:nvSpPr>
         <p:spPr>
           <a:xfrm>
-            <a:off x="2651760" y="1280160"/>
-            <a:ext cx="1828800" cy="292608"/>
+            <a:off x="914400" y="1197864"/>
+            <a:ext cx="4480560" cy="274320"/>
           </a:xfrm>
           <a:prstGeom prst="rect">
             <a:avLst/>
@@ -2410,13 +2410,22 @@
           <a:p>
             <a:pPr algn="r"/>
             <a:r>
-              <a:rPr sz="1700" b="1">
+              <a:rPr sz="1500" b="1">
                 <a:solidFill>
                   <a:srgbClr val="2E9E5B"/>
                 </a:solidFill>
                 <a:latin typeface="Avenir Next LT Pro"/>
               </a:rPr>
-              <a:t>DETECT</a:t>
+              <a:t>DETECT  </a:t>
+            </a:r>
+            <a:r>
+              <a:rPr sz="800" b="0">
+                <a:solidFill>
+                  <a:srgbClr val="6B7280"/>
+                </a:solidFill>
+                <a:latin typeface="Consolas"/>
+              </a:rPr>
+              <a:t>tech-detector</a:t>
             </a:r>
           </a:p>
         </p:txBody>
@@ -2429,78 +2438,8 @@
         </p:nvSpPr>
         <p:spPr>
           <a:xfrm>
-            <a:off x="2651760" y="1554480"/>
-            <a:ext cx="1828800" cy="219456"/>
-          </a:xfrm>
-          <a:prstGeom prst="rect">
-            <a:avLst/>
-          </a:prstGeom>
-          <a:noFill/>
-        </p:spPr>
-        <p:txBody>
-          <a:bodyPr wrap="square" lIns="18288" rIns="18288" tIns="0" bIns="0" anchor="t">
-            <a:spAutoFit/>
-          </a:bodyPr>
-          <a:lstStyle/>
-          <a:p>
-            <a:pPr algn="r"/>
-            <a:r>
-              <a:rPr sz="900" b="0">
-                <a:solidFill>
-                  <a:srgbClr val="6B7280"/>
-                </a:solidFill>
-                <a:latin typeface="Consolas"/>
-              </a:rPr>
-              <a:t>tech-detector</a:t>
-            </a:r>
-          </a:p>
-        </p:txBody>
-      </p:sp>
-      <p:sp>
-        <p:nvSpPr>
-          <p:cNvPr id="74" name="TextBox 73"/>
-          <p:cNvSpPr txBox="1"/>
-          <p:nvPr/>
-        </p:nvSpPr>
-        <p:spPr>
-          <a:xfrm>
-            <a:off x="868680" y="1783080"/>
-            <a:ext cx="3611880" cy="384048"/>
-          </a:xfrm>
-          <a:prstGeom prst="rect">
-            <a:avLst/>
-          </a:prstGeom>
-          <a:noFill/>
-        </p:spPr>
-        <p:txBody>
-          <a:bodyPr wrap="square" lIns="18288" rIns="18288" tIns="0" bIns="0" anchor="t">
-            <a:spAutoFit/>
-          </a:bodyPr>
-          <a:lstStyle/>
-          <a:p>
-            <a:pPr algn="r"/>
-            <a:r>
-              <a:rPr sz="1050" b="0">
-                <a:solidFill>
-                  <a:srgbClr val="3E4759"/>
-                </a:solidFill>
-                <a:latin typeface="Avenir Next LT Pro"/>
-              </a:rPr>
-              <a:t>Inspects the live site; reports the current martech stack.</a:t>
-            </a:r>
-          </a:p>
-        </p:txBody>
-      </p:sp>
-      <p:sp>
-        <p:nvSpPr>
-          <p:cNvPr id="75" name="TextBox 74"/>
-          <p:cNvSpPr txBox="1"/>
-          <p:nvPr/>
-        </p:nvSpPr>
-        <p:spPr>
-          <a:xfrm>
-            <a:off x="4590288" y="1298448"/>
-            <a:ext cx="777240" cy="694944"/>
+            <a:off x="914400" y="1472184"/>
+            <a:ext cx="4480560" cy="237744"/>
           </a:xfrm>
           <a:prstGeom prst="rect">
             <a:avLst/>
@@ -2515,26 +2454,70 @@
           <a:p>
             <a:pPr algn="r"/>
             <a:r>
-              <a:rPr sz="3000" b="1">
+              <a:rPr sz="1000" b="0">
+                <a:solidFill>
+                  <a:srgbClr val="3E4759"/>
+                </a:solidFill>
+                <a:latin typeface="Avenir Next LT Pro"/>
+              </a:rPr>
+              <a:t>Inspects the live site's martech.</a:t>
+            </a:r>
+          </a:p>
+        </p:txBody>
+      </p:sp>
+      <p:sp>
+        <p:nvSpPr>
+          <p:cNvPr id="74" name="TextBox 73"/>
+          <p:cNvSpPr txBox="1"/>
+          <p:nvPr/>
+        </p:nvSpPr>
+        <p:spPr>
+          <a:xfrm>
+            <a:off x="914400" y="1737360"/>
+            <a:ext cx="4480560" cy="256032"/>
+          </a:xfrm>
+          <a:prstGeom prst="rect">
+            <a:avLst/>
+          </a:prstGeom>
+          <a:noFill/>
+        </p:spPr>
+        <p:txBody>
+          <a:bodyPr wrap="square" lIns="18288" rIns="18288" tIns="0" bIns="0" anchor="ctr">
+            <a:spAutoFit/>
+          </a:bodyPr>
+          <a:lstStyle/>
+          <a:p>
+            <a:pPr algn="r"/>
+            <a:r>
+              <a:rPr sz="750" b="1">
+                <a:solidFill>
+                  <a:srgbClr val="9AA6BF"/>
+                </a:solidFill>
+                <a:latin typeface="Avenir Next LT Pro"/>
+              </a:rPr>
+              <a:t>DELIVERS  </a:t>
+            </a:r>
+            <a:r>
+              <a:rPr sz="950" b="1">
                 <a:solidFill>
                   <a:srgbClr val="2E9E5B"/>
                 </a:solidFill>
-                <a:latin typeface="Calibri"/>
-              </a:rPr>
-              <a:t>01</a:t>
-            </a:r>
-          </a:p>
-        </p:txBody>
-      </p:sp>
-      <p:sp>
-        <p:nvSpPr>
-          <p:cNvPr id="76" name="Oval 75"/>
-          <p:cNvSpPr/>
-          <p:nvPr/>
-        </p:nvSpPr>
-        <p:spPr>
-          <a:xfrm>
-            <a:off x="5760720" y="1316736"/>
+                <a:latin typeface="Avenir Next LT Pro"/>
+              </a:rPr>
+              <a:t>Current-state report</a:t>
+            </a:r>
+          </a:p>
+        </p:txBody>
+      </p:sp>
+      <p:sp>
+        <p:nvSpPr>
+          <p:cNvPr id="75" name="Oval 74"/>
+          <p:cNvSpPr/>
+          <p:nvPr/>
+        </p:nvSpPr>
+        <p:spPr>
+          <a:xfrm>
+            <a:off x="5760720" y="1280160"/>
             <a:ext cx="658368" cy="658368"/>
           </a:xfrm>
           <a:prstGeom prst="ellipse">
@@ -2574,7 +2557,7 @@
       </p:sp>
       <p:pic>
         <p:nvPicPr>
-          <p:cNvPr id="77" name="Picture 76" descr="image.png"/>
+          <p:cNvPr id="76" name="Picture 75" descr="image.png"/>
           <p:cNvPicPr>
             <a:picLocks noChangeAspect="1"/>
           </p:cNvPicPr>
@@ -2588,7 +2571,7 @@
         </p:blipFill>
         <p:spPr>
           <a:xfrm>
-            <a:off x="5934456" y="1490472"/>
+            <a:off x="5934456" y="1453896"/>
             <a:ext cx="310896" cy="310896"/>
           </a:xfrm>
           <a:prstGeom prst="rect">
@@ -2596,6 +2579,61 @@
           </a:prstGeom>
         </p:spPr>
       </p:pic>
+      <p:sp>
+        <p:nvSpPr>
+          <p:cNvPr id="77" name="Oval 76"/>
+          <p:cNvSpPr/>
+          <p:nvPr/>
+        </p:nvSpPr>
+        <p:spPr>
+          <a:xfrm>
+            <a:off x="6181344" y="1700784"/>
+            <a:ext cx="256032" cy="256032"/>
+          </a:xfrm>
+          <a:prstGeom prst="ellipse">
+            <a:avLst/>
+          </a:prstGeom>
+          <a:solidFill>
+            <a:srgbClr val="FFFFFF"/>
+          </a:solidFill>
+          <a:ln w="9525">
+            <a:solidFill>
+              <a:srgbClr val="D5DCEA"/>
+            </a:solidFill>
+          </a:ln>
+          <a:effectLst/>
+        </p:spPr>
+        <p:style>
+          <a:lnRef idx="1">
+            <a:schemeClr val="accent1"/>
+          </a:lnRef>
+          <a:fillRef idx="3">
+            <a:schemeClr val="accent1"/>
+          </a:fillRef>
+          <a:effectRef idx="2">
+            <a:schemeClr val="accent1"/>
+          </a:effectRef>
+          <a:fontRef idx="minor">
+            <a:schemeClr val="lt1"/>
+          </a:fontRef>
+        </p:style>
+        <p:txBody>
+          <a:bodyPr rtlCol="0" anchor="ctr" wrap="square" lIns="18288" rIns="18288" tIns="0" bIns="0"/>
+          <a:lstStyle/>
+          <a:p>
+            <a:pPr algn="ctr"/>
+            <a:r>
+              <a:rPr sz="1100" b="1">
+                <a:solidFill>
+                  <a:srgbClr val="17203A"/>
+                </a:solidFill>
+                <a:latin typeface="Calibri"/>
+              </a:rPr>
+              <a:t>1</a:t>
+            </a:r>
+          </a:p>
+        </p:txBody>
+      </p:sp>
       <p:sp>
         <p:nvSpPr>
           <p:cNvPr id="78" name="TextBox 77"/>
@@ -2604,8 +2642,8 @@
         </p:nvSpPr>
         <p:spPr>
           <a:xfrm>
-            <a:off x="7735824" y="2139696"/>
-            <a:ext cx="2194560" cy="292608"/>
+            <a:off x="6766560" y="2057400"/>
+            <a:ext cx="4846320" cy="274320"/>
           </a:xfrm>
           <a:prstGeom prst="rect">
             <a:avLst/>
@@ -2620,13 +2658,22 @@
           <a:p>
             <a:pPr algn="l"/>
             <a:r>
-              <a:rPr sz="1700" b="1">
+              <a:rPr sz="1500" b="1">
                 <a:solidFill>
                   <a:srgbClr val="12A5A0"/>
                 </a:solidFill>
                 <a:latin typeface="Avenir Next LT Pro"/>
               </a:rPr>
-              <a:t>PLAN</a:t>
+              <a:t>PLAN  </a:t>
+            </a:r>
+            <a:r>
+              <a:rPr sz="800" b="0">
+                <a:solidFill>
+                  <a:srgbClr val="6B7280"/>
+                </a:solidFill>
+                <a:latin typeface="Consolas"/>
+              </a:rPr>
+              <a:t>setup-plan</a:t>
             </a:r>
           </a:p>
         </p:txBody>
@@ -2639,78 +2686,8 @@
         </p:nvSpPr>
         <p:spPr>
           <a:xfrm>
-            <a:off x="7735824" y="2414016"/>
-            <a:ext cx="2743200" cy="219456"/>
-          </a:xfrm>
-          <a:prstGeom prst="rect">
-            <a:avLst/>
-          </a:prstGeom>
-          <a:noFill/>
-        </p:spPr>
-        <p:txBody>
-          <a:bodyPr wrap="square" lIns="18288" rIns="18288" tIns="0" bIns="0" anchor="t">
-            <a:spAutoFit/>
-          </a:bodyPr>
-          <a:lstStyle/>
-          <a:p>
-            <a:pPr algn="l"/>
-            <a:r>
-              <a:rPr sz="900" b="0">
-                <a:solidFill>
-                  <a:srgbClr val="6B7280"/>
-                </a:solidFill>
-                <a:latin typeface="Consolas"/>
-              </a:rPr>
-              <a:t>setup-plan</a:t>
-            </a:r>
-          </a:p>
-        </p:txBody>
-      </p:sp>
-      <p:sp>
-        <p:nvSpPr>
-          <p:cNvPr id="80" name="TextBox 79"/>
-          <p:cNvSpPr txBox="1"/>
-          <p:nvPr/>
-        </p:nvSpPr>
-        <p:spPr>
-          <a:xfrm>
-            <a:off x="7735824" y="2642616"/>
-            <a:ext cx="3657600" cy="384048"/>
-          </a:xfrm>
-          <a:prstGeom prst="rect">
-            <a:avLst/>
-          </a:prstGeom>
-          <a:noFill/>
-        </p:spPr>
-        <p:txBody>
-          <a:bodyPr wrap="square" lIns="18288" rIns="18288" tIns="0" bIns="0" anchor="t">
-            <a:spAutoFit/>
-          </a:bodyPr>
-          <a:lstStyle/>
-          <a:p>
-            <a:pPr algn="l"/>
-            <a:r>
-              <a:rPr sz="1050" b="0">
-                <a:solidFill>
-                  <a:srgbClr val="3E4759"/>
-                </a:solidFill>
-                <a:latin typeface="Avenir Next LT Pro"/>
-              </a:rPr>
-              <a:t>Turns a short interview into a governed implementation plan.</a:t>
-            </a:r>
-          </a:p>
-        </p:txBody>
-      </p:sp>
-      <p:sp>
-        <p:nvSpPr>
-          <p:cNvPr id="81" name="TextBox 80"/>
-          <p:cNvSpPr txBox="1"/>
-          <p:nvPr/>
-        </p:nvSpPr>
-        <p:spPr>
-          <a:xfrm>
-            <a:off x="6821424" y="2157984"/>
-            <a:ext cx="777240" cy="694944"/>
+            <a:off x="6766560" y="2331720"/>
+            <a:ext cx="4846320" cy="237744"/>
           </a:xfrm>
           <a:prstGeom prst="rect">
             <a:avLst/>
@@ -2725,26 +2702,70 @@
           <a:p>
             <a:pPr algn="l"/>
             <a:r>
-              <a:rPr sz="3000" b="1">
+              <a:rPr sz="1000" b="0">
+                <a:solidFill>
+                  <a:srgbClr val="3E4759"/>
+                </a:solidFill>
+                <a:latin typeface="Avenir Next LT Pro"/>
+              </a:rPr>
+              <a:t>Turns a scoping Q&amp;A into a build plan.</a:t>
+            </a:r>
+          </a:p>
+        </p:txBody>
+      </p:sp>
+      <p:sp>
+        <p:nvSpPr>
+          <p:cNvPr id="80" name="TextBox 79"/>
+          <p:cNvSpPr txBox="1"/>
+          <p:nvPr/>
+        </p:nvSpPr>
+        <p:spPr>
+          <a:xfrm>
+            <a:off x="6766560" y="2596896"/>
+            <a:ext cx="4846320" cy="256032"/>
+          </a:xfrm>
+          <a:prstGeom prst="rect">
+            <a:avLst/>
+          </a:prstGeom>
+          <a:noFill/>
+        </p:spPr>
+        <p:txBody>
+          <a:bodyPr wrap="square" lIns="18288" rIns="18288" tIns="0" bIns="0" anchor="ctr">
+            <a:spAutoFit/>
+          </a:bodyPr>
+          <a:lstStyle/>
+          <a:p>
+            <a:pPr algn="l"/>
+            <a:r>
+              <a:rPr sz="750" b="1">
+                <a:solidFill>
+                  <a:srgbClr val="9AA6BF"/>
+                </a:solidFill>
+                <a:latin typeface="Avenir Next LT Pro"/>
+              </a:rPr>
+              <a:t>DELIVERS  </a:t>
+            </a:r>
+            <a:r>
+              <a:rPr sz="950" b="1">
                 <a:solidFill>
                   <a:srgbClr val="12A5A0"/>
                 </a:solidFill>
-                <a:latin typeface="Calibri"/>
-              </a:rPr>
-              <a:t>02</a:t>
-            </a:r>
-          </a:p>
-        </p:txBody>
-      </p:sp>
-      <p:sp>
-        <p:nvSpPr>
-          <p:cNvPr id="82" name="Oval 81"/>
-          <p:cNvSpPr/>
-          <p:nvPr/>
-        </p:nvSpPr>
-        <p:spPr>
-          <a:xfrm>
-            <a:off x="5760720" y="2176272"/>
+                <a:latin typeface="Avenir Next LT Pro"/>
+              </a:rPr>
+              <a:t>Governed plan + property blueprint</a:t>
+            </a:r>
+          </a:p>
+        </p:txBody>
+      </p:sp>
+      <p:sp>
+        <p:nvSpPr>
+          <p:cNvPr id="81" name="Oval 80"/>
+          <p:cNvSpPr/>
+          <p:nvPr/>
+        </p:nvSpPr>
+        <p:spPr>
+          <a:xfrm>
+            <a:off x="5760720" y="2139696"/>
             <a:ext cx="658368" cy="658368"/>
           </a:xfrm>
           <a:prstGeom prst="ellipse">
@@ -2784,7 +2805,7 @@
       </p:sp>
       <p:pic>
         <p:nvPicPr>
-          <p:cNvPr id="83" name="Picture 82" descr="image.png"/>
+          <p:cNvPr id="82" name="Picture 81" descr="image.png"/>
           <p:cNvPicPr>
             <a:picLocks noChangeAspect="1"/>
           </p:cNvPicPr>
@@ -2798,7 +2819,7 @@
         </p:blipFill>
         <p:spPr>
           <a:xfrm>
-            <a:off x="5934456" y="2350008"/>
+            <a:off x="5934456" y="2313432"/>
             <a:ext cx="310896" cy="310896"/>
           </a:xfrm>
           <a:prstGeom prst="rect">
@@ -2806,6 +2827,61 @@
           </a:prstGeom>
         </p:spPr>
       </p:pic>
+      <p:sp>
+        <p:nvSpPr>
+          <p:cNvPr id="83" name="Oval 82"/>
+          <p:cNvSpPr/>
+          <p:nvPr/>
+        </p:nvSpPr>
+        <p:spPr>
+          <a:xfrm>
+            <a:off x="6181344" y="2560320"/>
+            <a:ext cx="256032" cy="256032"/>
+          </a:xfrm>
+          <a:prstGeom prst="ellipse">
+            <a:avLst/>
+          </a:prstGeom>
+          <a:solidFill>
+            <a:srgbClr val="FFFFFF"/>
+          </a:solidFill>
+          <a:ln w="9525">
+            <a:solidFill>
+              <a:srgbClr val="D5DCEA"/>
+            </a:solidFill>
+          </a:ln>
+          <a:effectLst/>
+        </p:spPr>
+        <p:style>
+          <a:lnRef idx="1">
+            <a:schemeClr val="accent1"/>
+          </a:lnRef>
+          <a:fillRef idx="3">
+            <a:schemeClr val="accent1"/>
+          </a:fillRef>
+          <a:effectRef idx="2">
+            <a:schemeClr val="accent1"/>
+          </a:effectRef>
+          <a:fontRef idx="minor">
+            <a:schemeClr val="lt1"/>
+          </a:fontRef>
+        </p:style>
+        <p:txBody>
+          <a:bodyPr rtlCol="0" anchor="ctr" wrap="square" lIns="18288" rIns="18288" tIns="0" bIns="0"/>
+          <a:lstStyle/>
+          <a:p>
+            <a:pPr algn="ctr"/>
+            <a:r>
+              <a:rPr sz="1100" b="1">
+                <a:solidFill>
+                  <a:srgbClr val="17203A"/>
+                </a:solidFill>
+                <a:latin typeface="Calibri"/>
+              </a:rPr>
+              <a:t>2</a:t>
+            </a:r>
+          </a:p>
+        </p:txBody>
+      </p:sp>
       <p:sp>
         <p:nvSpPr>
           <p:cNvPr id="84" name="TextBox 83"/>
@@ -2814,8 +2890,8 @@
         </p:nvSpPr>
         <p:spPr>
           <a:xfrm>
-            <a:off x="2651760" y="2999232"/>
-            <a:ext cx="1828800" cy="292608"/>
+            <a:off x="914400" y="2916936"/>
+            <a:ext cx="4480560" cy="274320"/>
           </a:xfrm>
           <a:prstGeom prst="rect">
             <a:avLst/>
@@ -2830,13 +2906,22 @@
           <a:p>
             <a:pPr algn="r"/>
             <a:r>
-              <a:rPr sz="1700" b="1">
+              <a:rPr sz="1500" b="1">
                 <a:solidFill>
                   <a:srgbClr val="1391C4"/>
                 </a:solidFill>
                 <a:latin typeface="Avenir Next LT Pro"/>
               </a:rPr>
-              <a:t>BUILD</a:t>
+              <a:t>BUILD  </a:t>
+            </a:r>
+            <a:r>
+              <a:rPr sz="800" b="0">
+                <a:solidFill>
+                  <a:srgbClr val="6B7280"/>
+                </a:solidFill>
+                <a:latin typeface="Consolas"/>
+              </a:rPr>
+              <a:t>data-collection-builder</a:t>
             </a:r>
           </a:p>
         </p:txBody>
@@ -2849,78 +2934,8 @@
         </p:nvSpPr>
         <p:spPr>
           <a:xfrm>
-            <a:off x="2651760" y="3273552"/>
-            <a:ext cx="1828800" cy="219456"/>
-          </a:xfrm>
-          <a:prstGeom prst="rect">
-            <a:avLst/>
-          </a:prstGeom>
-          <a:noFill/>
-        </p:spPr>
-        <p:txBody>
-          <a:bodyPr wrap="square" lIns="18288" rIns="18288" tIns="0" bIns="0" anchor="t">
-            <a:spAutoFit/>
-          </a:bodyPr>
-          <a:lstStyle/>
-          <a:p>
-            <a:pPr algn="r"/>
-            <a:r>
-              <a:rPr sz="900" b="0">
-                <a:solidFill>
-                  <a:srgbClr val="6B7280"/>
-                </a:solidFill>
-                <a:latin typeface="Consolas"/>
-              </a:rPr>
-              <a:t>data-collection-builder</a:t>
-            </a:r>
-          </a:p>
-        </p:txBody>
-      </p:sp>
-      <p:sp>
-        <p:nvSpPr>
-          <p:cNvPr id="86" name="TextBox 85"/>
-          <p:cNvSpPr txBox="1"/>
-          <p:nvPr/>
-        </p:nvSpPr>
-        <p:spPr>
-          <a:xfrm>
-            <a:off x="868680" y="3502152"/>
-            <a:ext cx="3611880" cy="384048"/>
-          </a:xfrm>
-          <a:prstGeom prst="rect">
-            <a:avLst/>
-          </a:prstGeom>
-          <a:noFill/>
-        </p:spPr>
-        <p:txBody>
-          <a:bodyPr wrap="square" lIns="18288" rIns="18288" tIns="0" bIns="0" anchor="t">
-            <a:spAutoFit/>
-          </a:bodyPr>
-          <a:lstStyle/>
-          <a:p>
-            <a:pPr algn="r"/>
-            <a:r>
-              <a:rPr sz="1050" b="0">
-                <a:solidFill>
-                  <a:srgbClr val="3E4759"/>
-                </a:solidFill>
-                <a:latin typeface="Avenir Next LT Pro"/>
-              </a:rPr>
-              <a:t>Builds the SDR + Web SDK XDM schema, data elements &amp; rules.</a:t>
-            </a:r>
-          </a:p>
-        </p:txBody>
-      </p:sp>
-      <p:sp>
-        <p:nvSpPr>
-          <p:cNvPr id="87" name="TextBox 86"/>
-          <p:cNvSpPr txBox="1"/>
-          <p:nvPr/>
-        </p:nvSpPr>
-        <p:spPr>
-          <a:xfrm>
-            <a:off x="4590288" y="3017520"/>
-            <a:ext cx="777240" cy="694944"/>
+            <a:off x="914400" y="3191256"/>
+            <a:ext cx="4480560" cy="237744"/>
           </a:xfrm>
           <a:prstGeom prst="rect">
             <a:avLst/>
@@ -2935,26 +2950,70 @@
           <a:p>
             <a:pPr algn="r"/>
             <a:r>
-              <a:rPr sz="3000" b="1">
+              <a:rPr sz="1000" b="0">
+                <a:solidFill>
+                  <a:srgbClr val="3E4759"/>
+                </a:solidFill>
+                <a:latin typeface="Avenir Next LT Pro"/>
+              </a:rPr>
+              <a:t>Generates the data-collection spec.</a:t>
+            </a:r>
+          </a:p>
+        </p:txBody>
+      </p:sp>
+      <p:sp>
+        <p:nvSpPr>
+          <p:cNvPr id="86" name="TextBox 85"/>
+          <p:cNvSpPr txBox="1"/>
+          <p:nvPr/>
+        </p:nvSpPr>
+        <p:spPr>
+          <a:xfrm>
+            <a:off x="914400" y="3456432"/>
+            <a:ext cx="4480560" cy="256032"/>
+          </a:xfrm>
+          <a:prstGeom prst="rect">
+            <a:avLst/>
+          </a:prstGeom>
+          <a:noFill/>
+        </p:spPr>
+        <p:txBody>
+          <a:bodyPr wrap="square" lIns="18288" rIns="18288" tIns="0" bIns="0" anchor="ctr">
+            <a:spAutoFit/>
+          </a:bodyPr>
+          <a:lstStyle/>
+          <a:p>
+            <a:pPr algn="r"/>
+            <a:r>
+              <a:rPr sz="750" b="1">
+                <a:solidFill>
+                  <a:srgbClr val="9AA6BF"/>
+                </a:solidFill>
+                <a:latin typeface="Avenir Next LT Pro"/>
+              </a:rPr>
+              <a:t>DELIVERS  </a:t>
+            </a:r>
+            <a:r>
+              <a:rPr sz="950" b="1">
                 <a:solidFill>
                   <a:srgbClr val="1391C4"/>
                 </a:solidFill>
-                <a:latin typeface="Calibri"/>
-              </a:rPr>
-              <a:t>03</a:t>
-            </a:r>
-          </a:p>
-        </p:txBody>
-      </p:sp>
-      <p:sp>
-        <p:nvSpPr>
-          <p:cNvPr id="88" name="Oval 87"/>
-          <p:cNvSpPr/>
-          <p:nvPr/>
-        </p:nvSpPr>
-        <p:spPr>
-          <a:xfrm>
-            <a:off x="5760720" y="3035808"/>
+                <a:latin typeface="Avenir Next LT Pro"/>
+              </a:rPr>
+              <a:t>SDR + XDM schema + data elements &amp; rules</a:t>
+            </a:r>
+          </a:p>
+        </p:txBody>
+      </p:sp>
+      <p:sp>
+        <p:nvSpPr>
+          <p:cNvPr id="87" name="Oval 86"/>
+          <p:cNvSpPr/>
+          <p:nvPr/>
+        </p:nvSpPr>
+        <p:spPr>
+          <a:xfrm>
+            <a:off x="5760720" y="2999232"/>
             <a:ext cx="658368" cy="658368"/>
           </a:xfrm>
           <a:prstGeom prst="ellipse">
@@ -2994,7 +3053,7 @@
       </p:sp>
       <p:pic>
         <p:nvPicPr>
-          <p:cNvPr id="89" name="Picture 88" descr="image.png"/>
+          <p:cNvPr id="88" name="Picture 87" descr="image.png"/>
           <p:cNvPicPr>
             <a:picLocks noChangeAspect="1"/>
           </p:cNvPicPr>
@@ -3008,7 +3067,7 @@
         </p:blipFill>
         <p:spPr>
           <a:xfrm>
-            <a:off x="5934456" y="3209544"/>
+            <a:off x="5934456" y="3172968"/>
             <a:ext cx="310896" cy="310896"/>
           </a:xfrm>
           <a:prstGeom prst="rect">
@@ -3016,6 +3075,61 @@
           </a:prstGeom>
         </p:spPr>
       </p:pic>
+      <p:sp>
+        <p:nvSpPr>
+          <p:cNvPr id="89" name="Oval 88"/>
+          <p:cNvSpPr/>
+          <p:nvPr/>
+        </p:nvSpPr>
+        <p:spPr>
+          <a:xfrm>
+            <a:off x="6181344" y="3419856"/>
+            <a:ext cx="256032" cy="256032"/>
+          </a:xfrm>
+          <a:prstGeom prst="ellipse">
+            <a:avLst/>
+          </a:prstGeom>
+          <a:solidFill>
+            <a:srgbClr val="FFFFFF"/>
+          </a:solidFill>
+          <a:ln w="9525">
+            <a:solidFill>
+              <a:srgbClr val="D5DCEA"/>
+            </a:solidFill>
+          </a:ln>
+          <a:effectLst/>
+        </p:spPr>
+        <p:style>
+          <a:lnRef idx="1">
+            <a:schemeClr val="accent1"/>
+          </a:lnRef>
+          <a:fillRef idx="3">
+            <a:schemeClr val="accent1"/>
+          </a:fillRef>
+          <a:effectRef idx="2">
+            <a:schemeClr val="accent1"/>
+          </a:effectRef>
+          <a:fontRef idx="minor">
+            <a:schemeClr val="lt1"/>
+          </a:fontRef>
+        </p:style>
+        <p:txBody>
+          <a:bodyPr rtlCol="0" anchor="ctr" wrap="square" lIns="18288" rIns="18288" tIns="0" bIns="0"/>
+          <a:lstStyle/>
+          <a:p>
+            <a:pPr algn="ctr"/>
+            <a:r>
+              <a:rPr sz="1100" b="1">
+                <a:solidFill>
+                  <a:srgbClr val="17203A"/>
+                </a:solidFill>
+                <a:latin typeface="Calibri"/>
+              </a:rPr>
+              <a:t>3</a:t>
+            </a:r>
+          </a:p>
+        </p:txBody>
+      </p:sp>
       <p:sp>
         <p:nvSpPr>
           <p:cNvPr id="90" name="TextBox 89"/>
@@ -3024,8 +3138,8 @@
         </p:nvSpPr>
         <p:spPr>
           <a:xfrm>
-            <a:off x="7735824" y="3858768"/>
-            <a:ext cx="2194560" cy="292608"/>
+            <a:off x="6766560" y="3776472"/>
+            <a:ext cx="4846320" cy="274320"/>
           </a:xfrm>
           <a:prstGeom prst="rect">
             <a:avLst/>
@@ -3040,13 +3154,22 @@
           <a:p>
             <a:pPr algn="l"/>
             <a:r>
-              <a:rPr sz="1700" b="1">
+              <a:rPr sz="1500" b="1">
                 <a:solidFill>
                   <a:srgbClr val="0C62FB"/>
                 </a:solidFill>
                 <a:latin typeface="Avenir Next LT Pro"/>
               </a:rPr>
-              <a:t>PUBLISH</a:t>
+              <a:t>PUBLISH  </a:t>
+            </a:r>
+            <a:r>
+              <a:rPr sz="800" b="0">
+                <a:solidFill>
+                  <a:srgbClr val="6B7280"/>
+                </a:solidFill>
+                <a:latin typeface="Consolas"/>
+              </a:rPr>
+              <a:t>property-creator</a:t>
             </a:r>
           </a:p>
         </p:txBody>
@@ -3059,78 +3182,8 @@
         </p:nvSpPr>
         <p:spPr>
           <a:xfrm>
-            <a:off x="7735824" y="4133088"/>
-            <a:ext cx="2743200" cy="219456"/>
-          </a:xfrm>
-          <a:prstGeom prst="rect">
-            <a:avLst/>
-          </a:prstGeom>
-          <a:noFill/>
-        </p:spPr>
-        <p:txBody>
-          <a:bodyPr wrap="square" lIns="18288" rIns="18288" tIns="0" bIns="0" anchor="t">
-            <a:spAutoFit/>
-          </a:bodyPr>
-          <a:lstStyle/>
-          <a:p>
-            <a:pPr algn="l"/>
-            <a:r>
-              <a:rPr sz="900" b="0">
-                <a:solidFill>
-                  <a:srgbClr val="6B7280"/>
-                </a:solidFill>
-                <a:latin typeface="Consolas"/>
-              </a:rPr>
-              <a:t>property-creator</a:t>
-            </a:r>
-          </a:p>
-        </p:txBody>
-      </p:sp>
-      <p:sp>
-        <p:nvSpPr>
-          <p:cNvPr id="92" name="TextBox 91"/>
-          <p:cNvSpPr txBox="1"/>
-          <p:nvPr/>
-        </p:nvSpPr>
-        <p:spPr>
-          <a:xfrm>
-            <a:off x="7735824" y="4361688"/>
-            <a:ext cx="3657600" cy="384048"/>
-          </a:xfrm>
-          <a:prstGeom prst="rect">
-            <a:avLst/>
-          </a:prstGeom>
-          <a:noFill/>
-        </p:spPr>
-        <p:txBody>
-          <a:bodyPr wrap="square" lIns="18288" rIns="18288" tIns="0" bIns="0" anchor="t">
-            <a:spAutoFit/>
-          </a:bodyPr>
-          <a:lstStyle/>
-          <a:p>
-            <a:pPr algn="l"/>
-            <a:r>
-              <a:rPr sz="1050" b="0">
-                <a:solidFill>
-                  <a:srgbClr val="3E4759"/>
-                </a:solidFill>
-                <a:latin typeface="Avenir Next LT Pro"/>
-              </a:rPr>
-              <a:t>Provisions the Launch property end-to-end via the Reactor API.</a:t>
-            </a:r>
-          </a:p>
-        </p:txBody>
-      </p:sp>
-      <p:sp>
-        <p:nvSpPr>
-          <p:cNvPr id="93" name="TextBox 92"/>
-          <p:cNvSpPr txBox="1"/>
-          <p:nvPr/>
-        </p:nvSpPr>
-        <p:spPr>
-          <a:xfrm>
-            <a:off x="6821424" y="3877056"/>
-            <a:ext cx="777240" cy="694944"/>
+            <a:off x="6766560" y="4050791"/>
+            <a:ext cx="4846320" cy="237744"/>
           </a:xfrm>
           <a:prstGeom prst="rect">
             <a:avLst/>
@@ -3145,26 +3198,70 @@
           <a:p>
             <a:pPr algn="l"/>
             <a:r>
-              <a:rPr sz="3000" b="1">
+              <a:rPr sz="1000" b="0">
+                <a:solidFill>
+                  <a:srgbClr val="3E4759"/>
+                </a:solidFill>
+                <a:latin typeface="Avenir Next LT Pro"/>
+              </a:rPr>
+              <a:t>Provisions the property via the API.</a:t>
+            </a:r>
+          </a:p>
+        </p:txBody>
+      </p:sp>
+      <p:sp>
+        <p:nvSpPr>
+          <p:cNvPr id="92" name="TextBox 91"/>
+          <p:cNvSpPr txBox="1"/>
+          <p:nvPr/>
+        </p:nvSpPr>
+        <p:spPr>
+          <a:xfrm>
+            <a:off x="6766560" y="4315968"/>
+            <a:ext cx="4846320" cy="256032"/>
+          </a:xfrm>
+          <a:prstGeom prst="rect">
+            <a:avLst/>
+          </a:prstGeom>
+          <a:noFill/>
+        </p:spPr>
+        <p:txBody>
+          <a:bodyPr wrap="square" lIns="18288" rIns="18288" tIns="0" bIns="0" anchor="ctr">
+            <a:spAutoFit/>
+          </a:bodyPr>
+          <a:lstStyle/>
+          <a:p>
+            <a:pPr algn="l"/>
+            <a:r>
+              <a:rPr sz="750" b="1">
+                <a:solidFill>
+                  <a:srgbClr val="9AA6BF"/>
+                </a:solidFill>
+                <a:latin typeface="Avenir Next LT Pro"/>
+              </a:rPr>
+              <a:t>DELIVERS  </a:t>
+            </a:r>
+            <a:r>
+              <a:rPr sz="950" b="1">
                 <a:solidFill>
                   <a:srgbClr val="0C62FB"/>
                 </a:solidFill>
-                <a:latin typeface="Calibri"/>
-              </a:rPr>
-              <a:t>04</a:t>
-            </a:r>
-          </a:p>
-        </p:txBody>
-      </p:sp>
-      <p:sp>
-        <p:nvSpPr>
-          <p:cNvPr id="94" name="Oval 93"/>
-          <p:cNvSpPr/>
-          <p:nvPr/>
-        </p:nvSpPr>
-        <p:spPr>
-          <a:xfrm>
-            <a:off x="5760720" y="3895344"/>
+                <a:latin typeface="Avenir Next LT Pro"/>
+              </a:rPr>
+              <a:t>A live Adobe Launch property</a:t>
+            </a:r>
+          </a:p>
+        </p:txBody>
+      </p:sp>
+      <p:sp>
+        <p:nvSpPr>
+          <p:cNvPr id="93" name="Oval 92"/>
+          <p:cNvSpPr/>
+          <p:nvPr/>
+        </p:nvSpPr>
+        <p:spPr>
+          <a:xfrm>
+            <a:off x="5760720" y="3858768"/>
             <a:ext cx="658368" cy="658368"/>
           </a:xfrm>
           <a:prstGeom prst="ellipse">
@@ -3204,7 +3301,7 @@
       </p:sp>
       <p:pic>
         <p:nvPicPr>
-          <p:cNvPr id="95" name="Picture 94" descr="image.png"/>
+          <p:cNvPr id="94" name="Picture 93" descr="image.png"/>
           <p:cNvPicPr>
             <a:picLocks noChangeAspect="1"/>
           </p:cNvPicPr>
@@ -3218,7 +3315,7 @@
         </p:blipFill>
         <p:spPr>
           <a:xfrm>
-            <a:off x="5934456" y="4069080"/>
+            <a:off x="5934456" y="4032504"/>
             <a:ext cx="310896" cy="310896"/>
           </a:xfrm>
           <a:prstGeom prst="rect">
@@ -3226,6 +3323,61 @@
           </a:prstGeom>
         </p:spPr>
       </p:pic>
+      <p:sp>
+        <p:nvSpPr>
+          <p:cNvPr id="95" name="Oval 94"/>
+          <p:cNvSpPr/>
+          <p:nvPr/>
+        </p:nvSpPr>
+        <p:spPr>
+          <a:xfrm>
+            <a:off x="6181344" y="4279392"/>
+            <a:ext cx="256032" cy="256032"/>
+          </a:xfrm>
+          <a:prstGeom prst="ellipse">
+            <a:avLst/>
+          </a:prstGeom>
+          <a:solidFill>
+            <a:srgbClr val="FFFFFF"/>
+          </a:solidFill>
+          <a:ln w="9525">
+            <a:solidFill>
+              <a:srgbClr val="D5DCEA"/>
+            </a:solidFill>
+          </a:ln>
+          <a:effectLst/>
+        </p:spPr>
+        <p:style>
+          <a:lnRef idx="1">
+            <a:schemeClr val="accent1"/>
+          </a:lnRef>
+          <a:fillRef idx="3">
+            <a:schemeClr val="accent1"/>
+          </a:fillRef>
+          <a:effectRef idx="2">
+            <a:schemeClr val="accent1"/>
+          </a:effectRef>
+          <a:fontRef idx="minor">
+            <a:schemeClr val="lt1"/>
+          </a:fontRef>
+        </p:style>
+        <p:txBody>
+          <a:bodyPr rtlCol="0" anchor="ctr" wrap="square" lIns="18288" rIns="18288" tIns="0" bIns="0"/>
+          <a:lstStyle/>
+          <a:p>
+            <a:pPr algn="ctr"/>
+            <a:r>
+              <a:rPr sz="1100" b="1">
+                <a:solidFill>
+                  <a:srgbClr val="17203A"/>
+                </a:solidFill>
+                <a:latin typeface="Calibri"/>
+              </a:rPr>
+              <a:t>4</a:t>
+            </a:r>
+          </a:p>
+        </p:txBody>
+      </p:sp>
       <p:sp>
         <p:nvSpPr>
           <p:cNvPr id="96" name="TextBox 95"/>
@@ -3234,8 +3386,8 @@
         </p:nvSpPr>
         <p:spPr>
           <a:xfrm>
-            <a:off x="2651760" y="4718303"/>
-            <a:ext cx="1828800" cy="292608"/>
+            <a:off x="914400" y="4636007"/>
+            <a:ext cx="4480560" cy="274320"/>
           </a:xfrm>
           <a:prstGeom prst="rect">
             <a:avLst/>
@@ -3250,13 +3402,22 @@
           <a:p>
             <a:pPr algn="r"/>
             <a:r>
-              <a:rPr sz="1700" b="1">
+              <a:rPr sz="1500" b="1">
                 <a:solidFill>
                   <a:srgbClr val="2547C8"/>
                 </a:solidFill>
                 <a:latin typeface="Avenir Next LT Pro"/>
               </a:rPr>
-              <a:t>AUDIT</a:t>
+              <a:t>AUDIT  </a:t>
+            </a:r>
+            <a:r>
+              <a:rPr sz="800" b="0">
+                <a:solidFill>
+                  <a:srgbClr val="6B7280"/>
+                </a:solidFill>
+                <a:latin typeface="Consolas"/>
+              </a:rPr>
+              <a:t>audit-builder</a:t>
             </a:r>
           </a:p>
         </p:txBody>
@@ -3269,78 +3430,8 @@
         </p:nvSpPr>
         <p:spPr>
           <a:xfrm>
-            <a:off x="2651760" y="4992624"/>
-            <a:ext cx="1828800" cy="219456"/>
-          </a:xfrm>
-          <a:prstGeom prst="rect">
-            <a:avLst/>
-          </a:prstGeom>
-          <a:noFill/>
-        </p:spPr>
-        <p:txBody>
-          <a:bodyPr wrap="square" lIns="18288" rIns="18288" tIns="0" bIns="0" anchor="t">
-            <a:spAutoFit/>
-          </a:bodyPr>
-          <a:lstStyle/>
-          <a:p>
-            <a:pPr algn="r"/>
-            <a:r>
-              <a:rPr sz="900" b="0">
-                <a:solidFill>
-                  <a:srgbClr val="6B7280"/>
-                </a:solidFill>
-                <a:latin typeface="Consolas"/>
-              </a:rPr>
-              <a:t>audit-builder</a:t>
-            </a:r>
-          </a:p>
-        </p:txBody>
-      </p:sp>
-      <p:sp>
-        <p:nvSpPr>
-          <p:cNvPr id="98" name="TextBox 97"/>
-          <p:cNvSpPr txBox="1"/>
-          <p:nvPr/>
-        </p:nvSpPr>
-        <p:spPr>
-          <a:xfrm>
-            <a:off x="868680" y="5221224"/>
-            <a:ext cx="3611880" cy="384048"/>
-          </a:xfrm>
-          <a:prstGeom prst="rect">
-            <a:avLst/>
-          </a:prstGeom>
-          <a:noFill/>
-        </p:spPr>
-        <p:txBody>
-          <a:bodyPr wrap="square" lIns="18288" rIns="18288" tIns="0" bIns="0" anchor="t">
-            <a:spAutoFit/>
-          </a:bodyPr>
-          <a:lstStyle/>
-          <a:p>
-            <a:pPr algn="r"/>
-            <a:r>
-              <a:rPr sz="1050" b="0">
-                <a:solidFill>
-                  <a:srgbClr val="3E4759"/>
-                </a:solidFill>
-                <a:latin typeface="Avenir Next LT Pro"/>
-              </a:rPr>
-              <a:t>Audits the live config for the issues that matter.</a:t>
-            </a:r>
-          </a:p>
-        </p:txBody>
-      </p:sp>
-      <p:sp>
-        <p:nvSpPr>
-          <p:cNvPr id="99" name="TextBox 98"/>
-          <p:cNvSpPr txBox="1"/>
-          <p:nvPr/>
-        </p:nvSpPr>
-        <p:spPr>
-          <a:xfrm>
-            <a:off x="4590288" y="4736592"/>
-            <a:ext cx="777240" cy="694944"/>
+            <a:off x="914400" y="4910327"/>
+            <a:ext cx="4480560" cy="237744"/>
           </a:xfrm>
           <a:prstGeom prst="rect">
             <a:avLst/>
@@ -3355,26 +3446,70 @@
           <a:p>
             <a:pPr algn="r"/>
             <a:r>
-              <a:rPr sz="3000" b="1">
+              <a:rPr sz="1000" b="0">
+                <a:solidFill>
+                  <a:srgbClr val="3E4759"/>
+                </a:solidFill>
+                <a:latin typeface="Avenir Next LT Pro"/>
+              </a:rPr>
+              <a:t>Audits the live configuration.</a:t>
+            </a:r>
+          </a:p>
+        </p:txBody>
+      </p:sp>
+      <p:sp>
+        <p:nvSpPr>
+          <p:cNvPr id="98" name="TextBox 97"/>
+          <p:cNvSpPr txBox="1"/>
+          <p:nvPr/>
+        </p:nvSpPr>
+        <p:spPr>
+          <a:xfrm>
+            <a:off x="914400" y="5175503"/>
+            <a:ext cx="4480560" cy="256032"/>
+          </a:xfrm>
+          <a:prstGeom prst="rect">
+            <a:avLst/>
+          </a:prstGeom>
+          <a:noFill/>
+        </p:spPr>
+        <p:txBody>
+          <a:bodyPr wrap="square" lIns="18288" rIns="18288" tIns="0" bIns="0" anchor="ctr">
+            <a:spAutoFit/>
+          </a:bodyPr>
+          <a:lstStyle/>
+          <a:p>
+            <a:pPr algn="r"/>
+            <a:r>
+              <a:rPr sz="750" b="1">
+                <a:solidFill>
+                  <a:srgbClr val="9AA6BF"/>
+                </a:solidFill>
+                <a:latin typeface="Avenir Next LT Pro"/>
+              </a:rPr>
+              <a:t>DELIVERS  </a:t>
+            </a:r>
+            <a:r>
+              <a:rPr sz="950" b="1">
                 <a:solidFill>
                   <a:srgbClr val="2547C8"/>
                 </a:solidFill>
-                <a:latin typeface="Calibri"/>
-              </a:rPr>
-              <a:t>05</a:t>
-            </a:r>
-          </a:p>
-        </p:txBody>
-      </p:sp>
-      <p:sp>
-        <p:nvSpPr>
-          <p:cNvPr id="100" name="Oval 99"/>
-          <p:cNvSpPr/>
-          <p:nvPr/>
-        </p:nvSpPr>
-        <p:spPr>
-          <a:xfrm>
-            <a:off x="5760720" y="4754879"/>
+                <a:latin typeface="Avenir Next LT Pro"/>
+              </a:rPr>
+              <a:t>Findings deck (PPTX) + audit workbook (XLSX)</a:t>
+            </a:r>
+          </a:p>
+        </p:txBody>
+      </p:sp>
+      <p:sp>
+        <p:nvSpPr>
+          <p:cNvPr id="99" name="Oval 98"/>
+          <p:cNvSpPr/>
+          <p:nvPr/>
+        </p:nvSpPr>
+        <p:spPr>
+          <a:xfrm>
+            <a:off x="5760720" y="4718303"/>
             <a:ext cx="658368" cy="658368"/>
           </a:xfrm>
           <a:prstGeom prst="ellipse">
@@ -3414,7 +3549,7 @@
       </p:sp>
       <p:pic>
         <p:nvPicPr>
-          <p:cNvPr id="101" name="Picture 100" descr="image.png"/>
+          <p:cNvPr id="100" name="Picture 99" descr="image.png"/>
           <p:cNvPicPr>
             <a:picLocks noChangeAspect="1"/>
           </p:cNvPicPr>
@@ -3428,7 +3563,7 @@
         </p:blipFill>
         <p:spPr>
           <a:xfrm>
-            <a:off x="5934456" y="4928616"/>
+            <a:off x="5934456" y="4892040"/>
             <a:ext cx="310896" cy="310896"/>
           </a:xfrm>
           <a:prstGeom prst="rect">
@@ -3436,6 +3571,61 @@
           </a:prstGeom>
         </p:spPr>
       </p:pic>
+      <p:sp>
+        <p:nvSpPr>
+          <p:cNvPr id="101" name="Oval 100"/>
+          <p:cNvSpPr/>
+          <p:nvPr/>
+        </p:nvSpPr>
+        <p:spPr>
+          <a:xfrm>
+            <a:off x="6181344" y="5138927"/>
+            <a:ext cx="256032" cy="256032"/>
+          </a:xfrm>
+          <a:prstGeom prst="ellipse">
+            <a:avLst/>
+          </a:prstGeom>
+          <a:solidFill>
+            <a:srgbClr val="FFFFFF"/>
+          </a:solidFill>
+          <a:ln w="9525">
+            <a:solidFill>
+              <a:srgbClr val="D5DCEA"/>
+            </a:solidFill>
+          </a:ln>
+          <a:effectLst/>
+        </p:spPr>
+        <p:style>
+          <a:lnRef idx="1">
+            <a:schemeClr val="accent1"/>
+          </a:lnRef>
+          <a:fillRef idx="3">
+            <a:schemeClr val="accent1"/>
+          </a:fillRef>
+          <a:effectRef idx="2">
+            <a:schemeClr val="accent1"/>
+          </a:effectRef>
+          <a:fontRef idx="minor">
+            <a:schemeClr val="lt1"/>
+          </a:fontRef>
+        </p:style>
+        <p:txBody>
+          <a:bodyPr rtlCol="0" anchor="ctr" wrap="square" lIns="18288" rIns="18288" tIns="0" bIns="0"/>
+          <a:lstStyle/>
+          <a:p>
+            <a:pPr algn="ctr"/>
+            <a:r>
+              <a:rPr sz="1100" b="1">
+                <a:solidFill>
+                  <a:srgbClr val="17203A"/>
+                </a:solidFill>
+                <a:latin typeface="Calibri"/>
+              </a:rPr>
+              <a:t>5</a:t>
+            </a:r>
+          </a:p>
+        </p:txBody>
+      </p:sp>
       <p:sp>
         <p:nvSpPr>
           <p:cNvPr id="102" name="TextBox 101"/>
@@ -3444,8 +3634,8 @@
         </p:nvSpPr>
         <p:spPr>
           <a:xfrm>
-            <a:off x="7735824" y="5577840"/>
-            <a:ext cx="2194560" cy="292608"/>
+            <a:off x="6766560" y="5495544"/>
+            <a:ext cx="4846320" cy="274320"/>
           </a:xfrm>
           <a:prstGeom prst="rect">
             <a:avLst/>
@@ -3460,13 +3650,22 @@
           <a:p>
             <a:pPr algn="l"/>
             <a:r>
-              <a:rPr sz="1700" b="1">
+              <a:rPr sz="1500" b="1">
                 <a:solidFill>
                   <a:srgbClr val="002FAF"/>
                 </a:solidFill>
                 <a:latin typeface="Avenir Next LT Pro"/>
               </a:rPr>
-              <a:t>RECONCILE</a:t>
+              <a:t>RECONCILE  </a:t>
+            </a:r>
+            <a:r>
+              <a:rPr sz="800" b="0">
+                <a:solidFill>
+                  <a:srgbClr val="6B7280"/>
+                </a:solidFill>
+                <a:latin typeface="Consolas"/>
+              </a:rPr>
+              <a:t>data-reconciliation</a:t>
             </a:r>
           </a:p>
         </p:txBody>
@@ -3479,78 +3678,8 @@
         </p:nvSpPr>
         <p:spPr>
           <a:xfrm>
-            <a:off x="7735824" y="5852160"/>
-            <a:ext cx="2743200" cy="219456"/>
-          </a:xfrm>
-          <a:prstGeom prst="rect">
-            <a:avLst/>
-          </a:prstGeom>
-          <a:noFill/>
-        </p:spPr>
-        <p:txBody>
-          <a:bodyPr wrap="square" lIns="18288" rIns="18288" tIns="0" bIns="0" anchor="t">
-            <a:spAutoFit/>
-          </a:bodyPr>
-          <a:lstStyle/>
-          <a:p>
-            <a:pPr algn="l"/>
-            <a:r>
-              <a:rPr sz="900" b="0">
-                <a:solidFill>
-                  <a:srgbClr val="6B7280"/>
-                </a:solidFill>
-                <a:latin typeface="Consolas"/>
-              </a:rPr>
-              <a:t>data-reconciliation</a:t>
-            </a:r>
-          </a:p>
-        </p:txBody>
-      </p:sp>
-      <p:sp>
-        <p:nvSpPr>
-          <p:cNvPr id="104" name="TextBox 103"/>
-          <p:cNvSpPr txBox="1"/>
-          <p:nvPr/>
-        </p:nvSpPr>
-        <p:spPr>
-          <a:xfrm>
-            <a:off x="7735824" y="6080760"/>
-            <a:ext cx="3657600" cy="384048"/>
-          </a:xfrm>
-          <a:prstGeom prst="rect">
-            <a:avLst/>
-          </a:prstGeom>
-          <a:noFill/>
-        </p:spPr>
-        <p:txBody>
-          <a:bodyPr wrap="square" lIns="18288" rIns="18288" tIns="0" bIns="0" anchor="t">
-            <a:spAutoFit/>
-          </a:bodyPr>
-          <a:lstStyle/>
-          <a:p>
-            <a:pPr algn="l"/>
-            <a:r>
-              <a:rPr sz="1050" b="0">
-                <a:solidFill>
-                  <a:srgbClr val="3E4759"/>
-                </a:solidFill>
-                <a:latin typeface="Avenir Next LT Pro"/>
-              </a:rPr>
-              <a:t>Reconciles report-suite variables vs. what the property collects.</a:t>
-            </a:r>
-          </a:p>
-        </p:txBody>
-      </p:sp>
-      <p:sp>
-        <p:nvSpPr>
-          <p:cNvPr id="105" name="TextBox 104"/>
-          <p:cNvSpPr txBox="1"/>
-          <p:nvPr/>
-        </p:nvSpPr>
-        <p:spPr>
-          <a:xfrm>
-            <a:off x="6821424" y="5596128"/>
-            <a:ext cx="777240" cy="694944"/>
+            <a:off x="6766560" y="5769864"/>
+            <a:ext cx="4846320" cy="237744"/>
           </a:xfrm>
           <a:prstGeom prst="rect">
             <a:avLst/>
@@ -3565,26 +3694,70 @@
           <a:p>
             <a:pPr algn="l"/>
             <a:r>
-              <a:rPr sz="3000" b="1">
+              <a:rPr sz="1000" b="0">
+                <a:solidFill>
+                  <a:srgbClr val="3E4759"/>
+                </a:solidFill>
+                <a:latin typeface="Avenir Next LT Pro"/>
+              </a:rPr>
+              <a:t>Report suite vs. the live property.</a:t>
+            </a:r>
+          </a:p>
+        </p:txBody>
+      </p:sp>
+      <p:sp>
+        <p:nvSpPr>
+          <p:cNvPr id="104" name="TextBox 103"/>
+          <p:cNvSpPr txBox="1"/>
+          <p:nvPr/>
+        </p:nvSpPr>
+        <p:spPr>
+          <a:xfrm>
+            <a:off x="6766560" y="6035040"/>
+            <a:ext cx="4846320" cy="256032"/>
+          </a:xfrm>
+          <a:prstGeom prst="rect">
+            <a:avLst/>
+          </a:prstGeom>
+          <a:noFill/>
+        </p:spPr>
+        <p:txBody>
+          <a:bodyPr wrap="square" lIns="18288" rIns="18288" tIns="0" bIns="0" anchor="ctr">
+            <a:spAutoFit/>
+          </a:bodyPr>
+          <a:lstStyle/>
+          <a:p>
+            <a:pPr algn="l"/>
+            <a:r>
+              <a:rPr sz="750" b="1">
+                <a:solidFill>
+                  <a:srgbClr val="9AA6BF"/>
+                </a:solidFill>
+                <a:latin typeface="Avenir Next LT Pro"/>
+              </a:rPr>
+              <a:t>DELIVERS  </a:t>
+            </a:r>
+            <a:r>
+              <a:rPr sz="950" b="1">
                 <a:solidFill>
                   <a:srgbClr val="002FAF"/>
                 </a:solidFill>
-                <a:latin typeface="Calibri"/>
-              </a:rPr>
-              <a:t>06</a:t>
-            </a:r>
-          </a:p>
-        </p:txBody>
-      </p:sp>
-      <p:sp>
-        <p:nvSpPr>
-          <p:cNvPr id="106" name="Oval 105"/>
-          <p:cNvSpPr/>
-          <p:nvPr/>
-        </p:nvSpPr>
-        <p:spPr>
-          <a:xfrm>
-            <a:off x="5760720" y="5614416"/>
+                <a:latin typeface="Avenir Next LT Pro"/>
+              </a:rPr>
+              <a:t>Reconciliation workbook (XLSX) + decisions email</a:t>
+            </a:r>
+          </a:p>
+        </p:txBody>
+      </p:sp>
+      <p:sp>
+        <p:nvSpPr>
+          <p:cNvPr id="105" name="Oval 104"/>
+          <p:cNvSpPr/>
+          <p:nvPr/>
+        </p:nvSpPr>
+        <p:spPr>
+          <a:xfrm>
+            <a:off x="5760720" y="5577840"/>
             <a:ext cx="658368" cy="658368"/>
           </a:xfrm>
           <a:prstGeom prst="ellipse">
@@ -3624,7 +3797,7 @@
       </p:sp>
       <p:pic>
         <p:nvPicPr>
-          <p:cNvPr id="107" name="Picture 106" descr="image.png"/>
+          <p:cNvPr id="106" name="Picture 105" descr="image.png"/>
           <p:cNvPicPr>
             <a:picLocks noChangeAspect="1"/>
           </p:cNvPicPr>
@@ -3638,7 +3811,7 @@
         </p:blipFill>
         <p:spPr>
           <a:xfrm>
-            <a:off x="5934456" y="5788152"/>
+            <a:off x="5934456" y="5751576"/>
             <a:ext cx="310896" cy="310896"/>
           </a:xfrm>
           <a:prstGeom prst="rect">
@@ -3646,6 +3819,61 @@
           </a:prstGeom>
         </p:spPr>
       </p:pic>
+      <p:sp>
+        <p:nvSpPr>
+          <p:cNvPr id="107" name="Oval 106"/>
+          <p:cNvSpPr/>
+          <p:nvPr/>
+        </p:nvSpPr>
+        <p:spPr>
+          <a:xfrm>
+            <a:off x="6181344" y="5998464"/>
+            <a:ext cx="256032" cy="256032"/>
+          </a:xfrm>
+          <a:prstGeom prst="ellipse">
+            <a:avLst/>
+          </a:prstGeom>
+          <a:solidFill>
+            <a:srgbClr val="FFFFFF"/>
+          </a:solidFill>
+          <a:ln w="9525">
+            <a:solidFill>
+              <a:srgbClr val="D5DCEA"/>
+            </a:solidFill>
+          </a:ln>
+          <a:effectLst/>
+        </p:spPr>
+        <p:style>
+          <a:lnRef idx="1">
+            <a:schemeClr val="accent1"/>
+          </a:lnRef>
+          <a:fillRef idx="3">
+            <a:schemeClr val="accent1"/>
+          </a:fillRef>
+          <a:effectRef idx="2">
+            <a:schemeClr val="accent1"/>
+          </a:effectRef>
+          <a:fontRef idx="minor">
+            <a:schemeClr val="lt1"/>
+          </a:fontRef>
+        </p:style>
+        <p:txBody>
+          <a:bodyPr rtlCol="0" anchor="ctr" wrap="square" lIns="18288" rIns="18288" tIns="0" bIns="0"/>
+          <a:lstStyle/>
+          <a:p>
+            <a:pPr algn="ctr"/>
+            <a:r>
+              <a:rPr sz="1100" b="1">
+                <a:solidFill>
+                  <a:srgbClr val="17203A"/>
+                </a:solidFill>
+                <a:latin typeface="Calibri"/>
+              </a:rPr>
+              <a:t>6</a:t>
+            </a:r>
+          </a:p>
+        </p:txBody>
+      </p:sp>
     </p:spTree>
   </p:cSld>
   <p:clrMapOvr>

</xml_diff>

<commit_message>
Plain-language two client-facing terms
- Slide 5: "idempotent" -> "safe to re-run".
- Slide 6: Plan's "a short interview" -> "a short scoping Q&A"
  (matching slide 2).

Co-Authored-By: Claude Opus 4.8 <noreply@anthropic.com>
Claude-Session: https://claude.ai/code/session_01L22pJWjoypJEHfB9cqhWZF
</commit_message>
<xml_diff>
--- a/websdk-property/docs/adobe-data-collection-skills-suite.pptx
+++ b/websdk-property/docs/adobe-data-collection-skills-suite.pptx
@@ -8701,7 +8701,7 @@
                 </a:solidFill>
                 <a:latin typeface="Calibri"/>
               </a:rPr>
-              <a:t>, idempotent</a:t>
+              <a:t>, safe to re-run</a:t>
             </a:r>
           </a:p>
         </p:txBody>
@@ -10472,7 +10472,7 @@
                 </a:solidFill>
                 <a:latin typeface="Calibri"/>
               </a:rPr>
-              <a:t>A short interview → a governed build plan.</a:t>
+              <a:t>A short scoping Q&amp;A → a governed build plan.</a:t>
             </a:r>
           </a:p>
         </p:txBody>

</xml_diff>

<commit_message>
Add "See it in action" slide; make invocation prompts domain-forward
- New slide 9 "One Prompt, and the Skill Takes Over": a recreated,
  on-brand terminal showing "Audit the site slalom.com" -> the audit
  router picking the Adobe Tags path -> the skill launching, with a
  three-step annotation and the deliverable (findings deck, PPTX).
- Slide 8: rewrite the six example prompts to be domain-forward
  (e.g., "Audit the site slalom.com"), matching how the skills actually
  trigger. Kept Adobe-only — SEO/accessibility/security are shown in the
  terminal as recognized-but-not-built audit types, not as suite skills.

Co-Authored-By: Claude Opus 4.8 <noreply@anthropic.com>
Claude-Session: https://claude.ai/code/session_01L22pJWjoypJEHfB9cqhWZF
</commit_message>
<xml_diff>
--- a/websdk-property/docs/adobe-data-collection-skills-suite.pptx
+++ b/websdk-property/docs/adobe-data-collection-skills-suite.pptx
@@ -16,6 +16,7 @@
     <p:sldId id="287" r:id="rId27"/>
     <p:sldId id="294" r:id="rId33"/>
     <p:sldId id="302" r:id="rId16"/>
+    <p:sldId id="303" r:id="rId17"/>
     <p:sldId id="296" r:id="rId35"/>
   </p:sldIdLst>
   <p:sldSz cx="12192000" cy="6858000"/>
@@ -1804,6 +1805,992 @@
 </p:sld>
 </file>
 
+<file path=ppt/slides/slide10.xml><?xml version="1.0" encoding="utf-8"?>
+<p:sld xmlns:a="http://schemas.openxmlformats.org/drawingml/2006/main" xmlns:p="http://schemas.openxmlformats.org/presentationml/2006/main" xmlns:r="http://schemas.openxmlformats.org/officeDocument/2006/relationships">
+  <p:cSld>
+    <p:spTree>
+      <p:nvGrpSpPr>
+        <p:cNvPr id="1" name=""/>
+        <p:cNvGrpSpPr/>
+        <p:nvPr/>
+      </p:nvGrpSpPr>
+      <p:grpSpPr/>
+      <p:sp>
+        <p:nvSpPr>
+          <p:cNvPr id="4" name="Text 1"/>
+          <p:cNvSpPr/>
+          <p:nvPr/>
+        </p:nvSpPr>
+        <p:spPr>
+          <a:xfrm>
+            <a:off x="548640" y="411480"/>
+            <a:ext cx="9144000" cy="292608"/>
+          </a:xfrm>
+          <a:prstGeom prst="rect">
+            <a:avLst/>
+          </a:prstGeom>
+          <a:noFill/>
+          <a:ln/>
+        </p:spPr>
+        <p:txBody>
+          <a:bodyPr wrap="square" lIns="0" tIns="0" rIns="0" bIns="0" rtlCol="0" anchor="ctr"/>
+          <a:lstStyle/>
+          <a:p>
+            <a:pPr marL="0" indent="0">
+              <a:buNone/>
+            </a:pPr>
+            <a:r>
+              <a:rPr lang="en-US" sz="1200" b="1" kern="0" spc="200" dirty="0">
+                <a:solidFill>
+                  <a:srgbClr val="0C62FB"/>
+                </a:solidFill>
+                <a:latin typeface="Avenir Next LT Pro" pitchFamily="34" charset="0"/>
+                <a:ea typeface="Avenir Next LT Pro" pitchFamily="34" charset="-122"/>
+                <a:cs typeface="Avenir Next LT Pro" pitchFamily="34" charset="-120"/>
+              </a:rPr>
+              <a:t>SEE IT IN ACTION</a:t>
+            </a:r>
+            <a:endParaRPr lang="en-US" sz="1200" dirty="0"/>
+          </a:p>
+        </p:txBody>
+      </p:sp>
+      <p:sp>
+        <p:nvSpPr>
+          <p:cNvPr id="5" name="Text 2"/>
+          <p:cNvSpPr/>
+          <p:nvPr/>
+        </p:nvSpPr>
+        <p:spPr>
+          <a:xfrm>
+            <a:off x="548640" y="667512"/>
+            <a:ext cx="11064240" cy="566928"/>
+          </a:xfrm>
+          <a:prstGeom prst="rect">
+            <a:avLst/>
+          </a:prstGeom>
+          <a:noFill/>
+          <a:ln/>
+        </p:spPr>
+        <p:txBody>
+          <a:bodyPr wrap="square" lIns="0" tIns="0" rIns="0" bIns="0" rtlCol="0" anchor="ctr"/>
+          <a:lstStyle/>
+          <a:p>
+            <a:pPr marL="0" indent="0">
+              <a:buNone/>
+            </a:pPr>
+            <a:r>
+              <a:rPr lang="en-US" sz="2800" b="1" dirty="0">
+                <a:solidFill>
+                  <a:srgbClr val="000000"/>
+                </a:solidFill>
+                <a:latin typeface="Avenir Next LT Pro" pitchFamily="34" charset="0"/>
+                <a:ea typeface="Avenir Next LT Pro" pitchFamily="34" charset="-122"/>
+                <a:cs typeface="Avenir Next LT Pro" pitchFamily="34" charset="-120"/>
+              </a:rPr>
+              <a:t>One Prompt, and the Skill Takes Over</a:t>
+            </a:r>
+            <a:endParaRPr lang="en-US" sz="2800" dirty="0"/>
+          </a:p>
+        </p:txBody>
+      </p:sp>
+      <p:sp>
+        <p:nvSpPr>
+          <p:cNvPr id="24" name="Shape 21"/>
+          <p:cNvSpPr/>
+          <p:nvPr/>
+        </p:nvSpPr>
+        <p:spPr>
+          <a:xfrm>
+            <a:off x="0" y="0"/>
+            <a:ext cx="2432304" cy="137160"/>
+          </a:xfrm>
+          <a:prstGeom prst="rect">
+            <a:avLst/>
+          </a:prstGeom>
+          <a:solidFill>
+            <a:srgbClr val="002FAF"/>
+          </a:solidFill>
+          <a:ln/>
+        </p:spPr>
+        <p:txBody>
+          <a:bodyPr/>
+          <a:lstStyle/>
+          <a:p>
+            <a:endParaRPr lang="en-US"/>
+          </a:p>
+        </p:txBody>
+      </p:sp>
+      <p:sp>
+        <p:nvSpPr>
+          <p:cNvPr id="25" name="Shape 22"/>
+          <p:cNvSpPr/>
+          <p:nvPr/>
+        </p:nvSpPr>
+        <p:spPr>
+          <a:xfrm>
+            <a:off x="2432304" y="0"/>
+            <a:ext cx="2432304" cy="137160"/>
+          </a:xfrm>
+          <a:prstGeom prst="rect">
+            <a:avLst/>
+          </a:prstGeom>
+          <a:solidFill>
+            <a:srgbClr val="0C62FB"/>
+          </a:solidFill>
+          <a:ln/>
+        </p:spPr>
+        <p:txBody>
+          <a:bodyPr/>
+          <a:lstStyle/>
+          <a:p>
+            <a:endParaRPr lang="en-US"/>
+          </a:p>
+        </p:txBody>
+      </p:sp>
+      <p:sp>
+        <p:nvSpPr>
+          <p:cNvPr id="26" name="Shape 23"/>
+          <p:cNvSpPr/>
+          <p:nvPr/>
+        </p:nvSpPr>
+        <p:spPr>
+          <a:xfrm>
+            <a:off x="4864608" y="0"/>
+            <a:ext cx="2432304" cy="137160"/>
+          </a:xfrm>
+          <a:prstGeom prst="rect">
+            <a:avLst/>
+          </a:prstGeom>
+          <a:solidFill>
+            <a:srgbClr val="1BE1F2"/>
+          </a:solidFill>
+          <a:ln/>
+        </p:spPr>
+        <p:txBody>
+          <a:bodyPr/>
+          <a:lstStyle/>
+          <a:p>
+            <a:endParaRPr lang="en-US"/>
+          </a:p>
+        </p:txBody>
+      </p:sp>
+      <p:sp>
+        <p:nvSpPr>
+          <p:cNvPr id="27" name="Shape 24"/>
+          <p:cNvSpPr/>
+          <p:nvPr/>
+        </p:nvSpPr>
+        <p:spPr>
+          <a:xfrm>
+            <a:off x="7296912" y="0"/>
+            <a:ext cx="2432304" cy="137160"/>
+          </a:xfrm>
+          <a:prstGeom prst="rect">
+            <a:avLst/>
+          </a:prstGeom>
+          <a:solidFill>
+            <a:srgbClr val="FF4D5F"/>
+          </a:solidFill>
+          <a:ln/>
+        </p:spPr>
+        <p:txBody>
+          <a:bodyPr/>
+          <a:lstStyle/>
+          <a:p>
+            <a:endParaRPr lang="en-US"/>
+          </a:p>
+        </p:txBody>
+      </p:sp>
+      <p:sp>
+        <p:nvSpPr>
+          <p:cNvPr id="28" name="Shape 25"/>
+          <p:cNvSpPr/>
+          <p:nvPr/>
+        </p:nvSpPr>
+        <p:spPr>
+          <a:xfrm>
+            <a:off x="9729216" y="0"/>
+            <a:ext cx="2432304" cy="137160"/>
+          </a:xfrm>
+          <a:prstGeom prst="rect">
+            <a:avLst/>
+          </a:prstGeom>
+          <a:solidFill>
+            <a:srgbClr val="C7B9FF"/>
+          </a:solidFill>
+          <a:ln/>
+        </p:spPr>
+        <p:txBody>
+          <a:bodyPr/>
+          <a:lstStyle/>
+          <a:p>
+            <a:endParaRPr lang="en-US"/>
+          </a:p>
+        </p:txBody>
+      </p:sp>
+      <p:sp>
+        <p:nvSpPr>
+          <p:cNvPr id="29" name="Text 26"/>
+          <p:cNvSpPr/>
+          <p:nvPr/>
+        </p:nvSpPr>
+        <p:spPr>
+          <a:xfrm>
+            <a:off x="548640" y="6446520"/>
+            <a:ext cx="7315200" cy="274320"/>
+          </a:xfrm>
+          <a:prstGeom prst="rect">
+            <a:avLst/>
+          </a:prstGeom>
+          <a:noFill/>
+          <a:ln/>
+        </p:spPr>
+        <p:txBody>
+          <a:bodyPr wrap="square" lIns="0" tIns="0" rIns="0" bIns="0" rtlCol="0" anchor="ctr"/>
+          <a:lstStyle/>
+          <a:p>
+            <a:pPr marL="0" indent="0" algn="l">
+              <a:buNone/>
+            </a:pPr>
+            <a:r>
+              <a:rPr lang="en-US" sz="750" dirty="0">
+                <a:solidFill>
+                  <a:srgbClr val="666666"/>
+                </a:solidFill>
+              </a:rPr>
+              <a:t>© Slalom. All Rights Reserved. Proprietary and Confidential.</a:t>
+            </a:r>
+            <a:endParaRPr lang="en-US" sz="750" dirty="0"/>
+          </a:p>
+        </p:txBody>
+      </p:sp>
+      <p:sp>
+        <p:nvSpPr>
+          <p:cNvPr id="30" name="Text 27"/>
+          <p:cNvSpPr/>
+          <p:nvPr/>
+        </p:nvSpPr>
+        <p:spPr>
+          <a:xfrm>
+            <a:off x="11521440" y="6446520"/>
+            <a:ext cx="365760" cy="274320"/>
+          </a:xfrm>
+          <a:prstGeom prst="rect">
+            <a:avLst/>
+          </a:prstGeom>
+          <a:noFill/>
+          <a:ln/>
+        </p:spPr>
+        <p:txBody>
+          <a:bodyPr wrap="square" lIns="0" tIns="0" rIns="0" bIns="0" rtlCol="0" anchor="ctr"/>
+          <a:lstStyle/>
+          <a:p>
+            <a:pPr marL="0" indent="0" algn="r">
+              <a:buNone/>
+            </a:pPr>
+            <a:r>
+              <a:rPr lang="en-US" sz="1000" dirty="0">
+                <a:solidFill>
+                  <a:srgbClr val="666666"/>
+                </a:solidFill>
+              </a:rPr>
+              <a:t>9</a:t>
+            </a:r>
+            <a:endParaRPr lang="en-US" sz="1000" dirty="0"/>
+          </a:p>
+        </p:txBody>
+      </p:sp>
+      <p:sp>
+        <p:nvSpPr>
+          <p:cNvPr id="31" name="TextBox 30"/>
+          <p:cNvSpPr txBox="1"/>
+          <p:nvPr/>
+        </p:nvSpPr>
+        <p:spPr>
+          <a:xfrm>
+            <a:off x="548640" y="1188720"/>
+            <a:ext cx="11064240" cy="365760"/>
+          </a:xfrm>
+          <a:prstGeom prst="rect">
+            <a:avLst/>
+          </a:prstGeom>
+          <a:noFill/>
+        </p:spPr>
+        <p:txBody>
+          <a:bodyPr wrap="square" lIns="27432" rIns="27432" tIns="0" bIns="0" anchor="ctr">
+            <a:spAutoFit/>
+          </a:bodyPr>
+          <a:lstStyle/>
+          <a:p>
+            <a:pPr algn="l"/>
+            <a:r>
+              <a:rPr sz="1400" b="0">
+                <a:solidFill>
+                  <a:srgbClr val="5A6478"/>
+                </a:solidFill>
+                <a:latin typeface="Avenir Next LT Pro"/>
+              </a:rPr>
+              <a:t>Name your site in plain English — the skill confirms scope, works from live data, and hands back a client-ready deck.</a:t>
+            </a:r>
+          </a:p>
+        </p:txBody>
+      </p:sp>
+      <p:pic>
+        <p:nvPicPr>
+          <p:cNvPr id="32" name="Picture 31" descr="terminal.png"/>
+          <p:cNvPicPr>
+            <a:picLocks noChangeAspect="1"/>
+          </p:cNvPicPr>
+          <p:nvPr/>
+        </p:nvPicPr>
+        <p:blipFill>
+          <a:blip r:embed="rId2"/>
+          <a:stretch>
+            <a:fillRect/>
+          </a:stretch>
+        </p:blipFill>
+        <p:spPr>
+          <a:xfrm>
+            <a:off x="512064" y="1691640"/>
+            <a:ext cx="7845552" cy="3584448"/>
+          </a:xfrm>
+          <a:prstGeom prst="rect">
+            <a:avLst/>
+          </a:prstGeom>
+        </p:spPr>
+      </p:pic>
+      <p:sp>
+        <p:nvSpPr>
+          <p:cNvPr id="33" name="TextBox 32"/>
+          <p:cNvSpPr txBox="1"/>
+          <p:nvPr/>
+        </p:nvSpPr>
+        <p:spPr>
+          <a:xfrm>
+            <a:off x="8650224" y="1755648"/>
+            <a:ext cx="3017520" cy="256032"/>
+          </a:xfrm>
+          <a:prstGeom prst="rect">
+            <a:avLst/>
+          </a:prstGeom>
+          <a:noFill/>
+        </p:spPr>
+        <p:txBody>
+          <a:bodyPr wrap="square" lIns="27432" rIns="27432" tIns="0" bIns="0" anchor="t">
+            <a:spAutoFit/>
+          </a:bodyPr>
+          <a:lstStyle/>
+          <a:p>
+            <a:pPr algn="l"/>
+            <a:r>
+              <a:rPr sz="1200" b="1">
+                <a:solidFill>
+                  <a:srgbClr val="9AA6BF"/>
+                </a:solidFill>
+                <a:latin typeface="Avenir Next LT Pro"/>
+              </a:rPr>
+              <a:t>WHAT JUST HAPPENED</a:t>
+            </a:r>
+          </a:p>
+        </p:txBody>
+      </p:sp>
+      <p:sp>
+        <p:nvSpPr>
+          <p:cNvPr id="34" name="Oval 33"/>
+          <p:cNvSpPr/>
+          <p:nvPr/>
+        </p:nvSpPr>
+        <p:spPr>
+          <a:xfrm>
+            <a:off x="8650224" y="2084831"/>
+            <a:ext cx="292608" cy="292608"/>
+          </a:xfrm>
+          <a:prstGeom prst="ellipse">
+            <a:avLst/>
+          </a:prstGeom>
+          <a:solidFill>
+            <a:srgbClr val="002FAF"/>
+          </a:solidFill>
+          <a:ln>
+            <a:noFill/>
+          </a:ln>
+          <a:effectLst/>
+        </p:spPr>
+        <p:style>
+          <a:lnRef idx="1">
+            <a:schemeClr val="accent1"/>
+          </a:lnRef>
+          <a:fillRef idx="3">
+            <a:schemeClr val="accent1"/>
+          </a:fillRef>
+          <a:effectRef idx="2">
+            <a:schemeClr val="accent1"/>
+          </a:effectRef>
+          <a:fontRef idx="minor">
+            <a:schemeClr val="lt1"/>
+          </a:fontRef>
+        </p:style>
+        <p:txBody>
+          <a:bodyPr rtlCol="0" anchor="ctr" wrap="square" lIns="27432" rIns="27432" tIns="0" bIns="0"/>
+          <a:lstStyle/>
+          <a:p>
+            <a:pPr algn="ctr"/>
+            <a:r>
+              <a:rPr sz="1300" b="1">
+                <a:solidFill>
+                  <a:srgbClr val="FFFFFF"/>
+                </a:solidFill>
+                <a:latin typeface="Calibri"/>
+              </a:rPr>
+              <a:t>1</a:t>
+            </a:r>
+          </a:p>
+        </p:txBody>
+      </p:sp>
+      <p:sp>
+        <p:nvSpPr>
+          <p:cNvPr id="35" name="TextBox 34"/>
+          <p:cNvSpPr txBox="1"/>
+          <p:nvPr/>
+        </p:nvSpPr>
+        <p:spPr>
+          <a:xfrm>
+            <a:off x="9070848" y="2066543"/>
+            <a:ext cx="2606040" cy="274320"/>
+          </a:xfrm>
+          <a:prstGeom prst="rect">
+            <a:avLst/>
+          </a:prstGeom>
+          <a:noFill/>
+        </p:spPr>
+        <p:txBody>
+          <a:bodyPr wrap="square" lIns="27432" rIns="27432" tIns="0" bIns="0" anchor="ctr">
+            <a:spAutoFit/>
+          </a:bodyPr>
+          <a:lstStyle/>
+          <a:p>
+            <a:pPr algn="l"/>
+            <a:r>
+              <a:rPr sz="1500" b="1">
+                <a:solidFill>
+                  <a:srgbClr val="002FAF"/>
+                </a:solidFill>
+                <a:latin typeface="Avenir Next LT Pro"/>
+              </a:rPr>
+              <a:t>You named the site.</a:t>
+            </a:r>
+          </a:p>
+        </p:txBody>
+      </p:sp>
+      <p:sp>
+        <p:nvSpPr>
+          <p:cNvPr id="36" name="TextBox 35"/>
+          <p:cNvSpPr txBox="1"/>
+          <p:nvPr/>
+        </p:nvSpPr>
+        <p:spPr>
+          <a:xfrm>
+            <a:off x="9070848" y="2359151"/>
+            <a:ext cx="2606040" cy="640080"/>
+          </a:xfrm>
+          <a:prstGeom prst="rect">
+            <a:avLst/>
+          </a:prstGeom>
+          <a:noFill/>
+        </p:spPr>
+        <p:txBody>
+          <a:bodyPr wrap="square" lIns="27432" rIns="27432" tIns="0" bIns="0" anchor="t">
+            <a:spAutoFit/>
+          </a:bodyPr>
+          <a:lstStyle/>
+          <a:p>
+            <a:pPr algn="l"/>
+            <a:r>
+              <a:rPr sz="1300" b="0">
+                <a:solidFill>
+                  <a:srgbClr val="3E4759"/>
+                </a:solidFill>
+                <a:latin typeface="Avenir Next LT Pro"/>
+              </a:rPr>
+              <a:t>That’s the entire prompt — </a:t>
+            </a:r>
+            <a:r>
+              <a:rPr sz="1200" b="1">
+                <a:solidFill>
+                  <a:srgbClr val="17203A"/>
+                </a:solidFill>
+                <a:latin typeface="Consolas"/>
+              </a:rPr>
+              <a:t>Audit the site slalom.com</a:t>
+            </a:r>
+          </a:p>
+        </p:txBody>
+      </p:sp>
+      <p:sp>
+        <p:nvSpPr>
+          <p:cNvPr id="37" name="Oval 36"/>
+          <p:cNvSpPr/>
+          <p:nvPr/>
+        </p:nvSpPr>
+        <p:spPr>
+          <a:xfrm>
+            <a:off x="8650224" y="3044952"/>
+            <a:ext cx="292608" cy="292608"/>
+          </a:xfrm>
+          <a:prstGeom prst="ellipse">
+            <a:avLst/>
+          </a:prstGeom>
+          <a:solidFill>
+            <a:srgbClr val="0C62FB"/>
+          </a:solidFill>
+          <a:ln>
+            <a:noFill/>
+          </a:ln>
+          <a:effectLst/>
+        </p:spPr>
+        <p:style>
+          <a:lnRef idx="1">
+            <a:schemeClr val="accent1"/>
+          </a:lnRef>
+          <a:fillRef idx="3">
+            <a:schemeClr val="accent1"/>
+          </a:fillRef>
+          <a:effectRef idx="2">
+            <a:schemeClr val="accent1"/>
+          </a:effectRef>
+          <a:fontRef idx="minor">
+            <a:schemeClr val="lt1"/>
+          </a:fontRef>
+        </p:style>
+        <p:txBody>
+          <a:bodyPr rtlCol="0" anchor="ctr" wrap="square" lIns="27432" rIns="27432" tIns="0" bIns="0"/>
+          <a:lstStyle/>
+          <a:p>
+            <a:pPr algn="ctr"/>
+            <a:r>
+              <a:rPr sz="1300" b="1">
+                <a:solidFill>
+                  <a:srgbClr val="FFFFFF"/>
+                </a:solidFill>
+                <a:latin typeface="Calibri"/>
+              </a:rPr>
+              <a:t>2</a:t>
+            </a:r>
+          </a:p>
+        </p:txBody>
+      </p:sp>
+      <p:sp>
+        <p:nvSpPr>
+          <p:cNvPr id="38" name="TextBox 37"/>
+          <p:cNvSpPr txBox="1"/>
+          <p:nvPr/>
+        </p:nvSpPr>
+        <p:spPr>
+          <a:xfrm>
+            <a:off x="9070848" y="3026664"/>
+            <a:ext cx="2606040" cy="274320"/>
+          </a:xfrm>
+          <a:prstGeom prst="rect">
+            <a:avLst/>
+          </a:prstGeom>
+          <a:noFill/>
+        </p:spPr>
+        <p:txBody>
+          <a:bodyPr wrap="square" lIns="27432" rIns="27432" tIns="0" bIns="0" anchor="ctr">
+            <a:spAutoFit/>
+          </a:bodyPr>
+          <a:lstStyle/>
+          <a:p>
+            <a:pPr algn="l"/>
+            <a:r>
+              <a:rPr sz="1500" b="1">
+                <a:solidFill>
+                  <a:srgbClr val="0C62FB"/>
+                </a:solidFill>
+                <a:latin typeface="Avenir Next LT Pro"/>
+              </a:rPr>
+              <a:t>It routed &amp; confirmed.</a:t>
+            </a:r>
+          </a:p>
+        </p:txBody>
+      </p:sp>
+      <p:sp>
+        <p:nvSpPr>
+          <p:cNvPr id="39" name="TextBox 38"/>
+          <p:cNvSpPr txBox="1"/>
+          <p:nvPr/>
+        </p:nvSpPr>
+        <p:spPr>
+          <a:xfrm>
+            <a:off x="9070848" y="3319272"/>
+            <a:ext cx="2606040" cy="640080"/>
+          </a:xfrm>
+          <a:prstGeom prst="rect">
+            <a:avLst/>
+          </a:prstGeom>
+          <a:noFill/>
+        </p:spPr>
+        <p:txBody>
+          <a:bodyPr wrap="square" lIns="27432" rIns="27432" tIns="0" bIns="0" anchor="t">
+            <a:spAutoFit/>
+          </a:bodyPr>
+          <a:lstStyle/>
+          <a:p>
+            <a:pPr algn="l"/>
+            <a:r>
+              <a:rPr sz="1300" b="0">
+                <a:solidFill>
+                  <a:srgbClr val="3E4759"/>
+                </a:solidFill>
+                <a:latin typeface="Avenir Next LT Pro"/>
+              </a:rPr>
+              <a:t>Picked the Adobe Tags audit and confirmed scope — no re-asking what you already said.</a:t>
+            </a:r>
+          </a:p>
+        </p:txBody>
+      </p:sp>
+      <p:sp>
+        <p:nvSpPr>
+          <p:cNvPr id="40" name="Oval 39"/>
+          <p:cNvSpPr/>
+          <p:nvPr/>
+        </p:nvSpPr>
+        <p:spPr>
+          <a:xfrm>
+            <a:off x="8650224" y="4005072"/>
+            <a:ext cx="292608" cy="292608"/>
+          </a:xfrm>
+          <a:prstGeom prst="ellipse">
+            <a:avLst/>
+          </a:prstGeom>
+          <a:solidFill>
+            <a:srgbClr val="0E8FA0"/>
+          </a:solidFill>
+          <a:ln>
+            <a:noFill/>
+          </a:ln>
+          <a:effectLst/>
+        </p:spPr>
+        <p:style>
+          <a:lnRef idx="1">
+            <a:schemeClr val="accent1"/>
+          </a:lnRef>
+          <a:fillRef idx="3">
+            <a:schemeClr val="accent1"/>
+          </a:fillRef>
+          <a:effectRef idx="2">
+            <a:schemeClr val="accent1"/>
+          </a:effectRef>
+          <a:fontRef idx="minor">
+            <a:schemeClr val="lt1"/>
+          </a:fontRef>
+        </p:style>
+        <p:txBody>
+          <a:bodyPr rtlCol="0" anchor="ctr" wrap="square" lIns="27432" rIns="27432" tIns="0" bIns="0"/>
+          <a:lstStyle/>
+          <a:p>
+            <a:pPr algn="ctr"/>
+            <a:r>
+              <a:rPr sz="1300" b="1">
+                <a:solidFill>
+                  <a:srgbClr val="FFFFFF"/>
+                </a:solidFill>
+                <a:latin typeface="Calibri"/>
+              </a:rPr>
+              <a:t>3</a:t>
+            </a:r>
+          </a:p>
+        </p:txBody>
+      </p:sp>
+      <p:sp>
+        <p:nvSpPr>
+          <p:cNvPr id="41" name="TextBox 40"/>
+          <p:cNvSpPr txBox="1"/>
+          <p:nvPr/>
+        </p:nvSpPr>
+        <p:spPr>
+          <a:xfrm>
+            <a:off x="9070848" y="3986784"/>
+            <a:ext cx="2606040" cy="274320"/>
+          </a:xfrm>
+          <a:prstGeom prst="rect">
+            <a:avLst/>
+          </a:prstGeom>
+          <a:noFill/>
+        </p:spPr>
+        <p:txBody>
+          <a:bodyPr wrap="square" lIns="27432" rIns="27432" tIns="0" bIns="0" anchor="ctr">
+            <a:spAutoFit/>
+          </a:bodyPr>
+          <a:lstStyle/>
+          <a:p>
+            <a:pPr algn="l"/>
+            <a:r>
+              <a:rPr sz="1500" b="1">
+                <a:solidFill>
+                  <a:srgbClr val="0E8FA0"/>
+                </a:solidFill>
+                <a:latin typeface="Avenir Next LT Pro"/>
+              </a:rPr>
+              <a:t>It works from live data.</a:t>
+            </a:r>
+          </a:p>
+        </p:txBody>
+      </p:sp>
+      <p:sp>
+        <p:nvSpPr>
+          <p:cNvPr id="42" name="TextBox 41"/>
+          <p:cNvSpPr txBox="1"/>
+          <p:nvPr/>
+        </p:nvSpPr>
+        <p:spPr>
+          <a:xfrm>
+            <a:off x="9070848" y="4279392"/>
+            <a:ext cx="2606040" cy="640080"/>
+          </a:xfrm>
+          <a:prstGeom prst="rect">
+            <a:avLst/>
+          </a:prstGeom>
+          <a:noFill/>
+        </p:spPr>
+        <p:txBody>
+          <a:bodyPr wrap="square" lIns="27432" rIns="27432" tIns="0" bIns="0" anchor="t">
+            <a:spAutoFit/>
+          </a:bodyPr>
+          <a:lstStyle/>
+          <a:p>
+            <a:pPr algn="l"/>
+            <a:r>
+              <a:rPr sz="1300" b="0">
+                <a:solidFill>
+                  <a:srgbClr val="3E4759"/>
+                </a:solidFill>
+                <a:latin typeface="Avenir Next LT Pro"/>
+              </a:rPr>
+              <a:t>A real headless browser detects the stack and pulls the published Launch library directly.</a:t>
+            </a:r>
+          </a:p>
+        </p:txBody>
+      </p:sp>
+      <p:sp>
+        <p:nvSpPr>
+          <p:cNvPr id="43" name="Rounded Rectangle 42"/>
+          <p:cNvSpPr/>
+          <p:nvPr/>
+        </p:nvSpPr>
+        <p:spPr>
+          <a:xfrm>
+            <a:off x="8650224" y="5029200"/>
+            <a:ext cx="3017520" cy="566928"/>
+          </a:xfrm>
+          <a:prstGeom prst="roundRect">
+            <a:avLst>
+              <a:gd name="adj" fmla="val 16000"/>
+            </a:avLst>
+          </a:prstGeom>
+          <a:solidFill>
+            <a:srgbClr val="EAF7EE"/>
+          </a:solidFill>
+          <a:ln w="12700">
+            <a:solidFill>
+              <a:srgbClr val="CDEBD6"/>
+            </a:solidFill>
+          </a:ln>
+          <a:effectLst/>
+        </p:spPr>
+        <p:style>
+          <a:lnRef idx="1">
+            <a:schemeClr val="accent1"/>
+          </a:lnRef>
+          <a:fillRef idx="3">
+            <a:schemeClr val="accent1"/>
+          </a:fillRef>
+          <a:effectRef idx="2">
+            <a:schemeClr val="accent1"/>
+          </a:effectRef>
+          <a:fontRef idx="minor">
+            <a:schemeClr val="lt1"/>
+          </a:fontRef>
+        </p:style>
+        <p:txBody>
+          <a:bodyPr rtlCol="0" anchor="ctr" wrap="square" lIns="27432" rIns="27432" tIns="0" bIns="0"/>
+          <a:lstStyle/>
+          <a:p>
+            <a:pPr algn="l"/>
+            <a:r>
+              <a:rPr sz="1250" b="1">
+                <a:solidFill>
+                  <a:srgbClr val="17203A"/>
+                </a:solidFill>
+                <a:latin typeface="Avenir Next LT Pro"/>
+              </a:rPr>
+              <a:t>Produces </a:t>
+            </a:r>
+            <a:r>
+              <a:rPr sz="1250" b="1">
+                <a:solidFill>
+                  <a:srgbClr val="2E9E5B"/>
+                </a:solidFill>
+                <a:latin typeface="Avenir Next LT Pro"/>
+              </a:rPr>
+              <a:t>a findings deck (PPTX)</a:t>
+            </a:r>
+            <a:r>
+              <a:rPr sz="1250" b="1">
+                <a:solidFill>
+                  <a:srgbClr val="17203A"/>
+                </a:solidFill>
+                <a:latin typeface="Avenir Next LT Pro"/>
+              </a:rPr>
+              <a:t> in the Slalom style.</a:t>
+            </a:r>
+          </a:p>
+        </p:txBody>
+      </p:sp>
+      <p:sp>
+        <p:nvSpPr>
+          <p:cNvPr id="44" name="Rounded Rectangle 43"/>
+          <p:cNvSpPr/>
+          <p:nvPr/>
+        </p:nvSpPr>
+        <p:spPr>
+          <a:xfrm>
+            <a:off x="512064" y="5486400"/>
+            <a:ext cx="7845552" cy="566928"/>
+          </a:xfrm>
+          <a:prstGeom prst="roundRect">
+            <a:avLst>
+              <a:gd name="adj" fmla="val 12000"/>
+            </a:avLst>
+          </a:prstGeom>
+          <a:solidFill>
+            <a:srgbClr val="F5F8FF"/>
+          </a:solidFill>
+          <a:ln>
+            <a:noFill/>
+          </a:ln>
+          <a:effectLst/>
+        </p:spPr>
+        <p:style>
+          <a:lnRef idx="1">
+            <a:schemeClr val="accent1"/>
+          </a:lnRef>
+          <a:fillRef idx="3">
+            <a:schemeClr val="accent1"/>
+          </a:fillRef>
+          <a:effectRef idx="2">
+            <a:schemeClr val="accent1"/>
+          </a:effectRef>
+          <a:fontRef idx="minor">
+            <a:schemeClr val="lt1"/>
+          </a:fontRef>
+        </p:style>
+        <p:txBody>
+          <a:bodyPr rtlCol="0" anchor="ctr"/>
+          <a:lstStyle/>
+          <a:p>
+            <a:pPr algn="ctr"/>
+          </a:p>
+        </p:txBody>
+      </p:sp>
+      <p:sp>
+        <p:nvSpPr>
+          <p:cNvPr id="45" name="Rounded Rectangle 44"/>
+          <p:cNvSpPr/>
+          <p:nvPr/>
+        </p:nvSpPr>
+        <p:spPr>
+          <a:xfrm>
+            <a:off x="512064" y="5486400"/>
+            <a:ext cx="73152" cy="566928"/>
+          </a:xfrm>
+          <a:prstGeom prst="roundRect">
+            <a:avLst>
+              <a:gd name="adj" fmla="val 50000"/>
+            </a:avLst>
+          </a:prstGeom>
+          <a:solidFill>
+            <a:srgbClr val="0C62FB"/>
+          </a:solidFill>
+          <a:ln>
+            <a:noFill/>
+          </a:ln>
+          <a:effectLst/>
+        </p:spPr>
+        <p:style>
+          <a:lnRef idx="1">
+            <a:schemeClr val="accent1"/>
+          </a:lnRef>
+          <a:fillRef idx="3">
+            <a:schemeClr val="accent1"/>
+          </a:fillRef>
+          <a:effectRef idx="2">
+            <a:schemeClr val="accent1"/>
+          </a:effectRef>
+          <a:fontRef idx="minor">
+            <a:schemeClr val="lt1"/>
+          </a:fontRef>
+        </p:style>
+        <p:txBody>
+          <a:bodyPr rtlCol="0" anchor="ctr"/>
+          <a:lstStyle/>
+          <a:p>
+            <a:pPr algn="ctr"/>
+          </a:p>
+        </p:txBody>
+      </p:sp>
+      <p:sp>
+        <p:nvSpPr>
+          <p:cNvPr id="46" name="TextBox 45"/>
+          <p:cNvSpPr txBox="1"/>
+          <p:nvPr/>
+        </p:nvSpPr>
+        <p:spPr>
+          <a:xfrm>
+            <a:off x="786384" y="5486400"/>
+            <a:ext cx="7406640" cy="566928"/>
+          </a:xfrm>
+          <a:prstGeom prst="rect">
+            <a:avLst/>
+          </a:prstGeom>
+          <a:noFill/>
+        </p:spPr>
+        <p:txBody>
+          <a:bodyPr wrap="square" lIns="27432" rIns="27432" tIns="0" bIns="0" anchor="ctr">
+            <a:spAutoFit/>
+          </a:bodyPr>
+          <a:lstStyle/>
+          <a:p>
+            <a:pPr algn="l"/>
+            <a:r>
+              <a:rPr sz="1400" b="1">
+                <a:solidFill>
+                  <a:srgbClr val="002FAF"/>
+                </a:solidFill>
+                <a:latin typeface="Avenir Next LT Pro"/>
+              </a:rPr>
+              <a:t>Same pattern for every skill: </a:t>
+            </a:r>
+            <a:r>
+              <a:rPr sz="1400" b="0">
+                <a:solidFill>
+                  <a:srgbClr val="3E4759"/>
+                </a:solidFill>
+                <a:latin typeface="Avenir Next LT Pro"/>
+              </a:rPr>
+              <a:t>name the target in one line — Detect, Build, Audit, Reconcile — and the matching skill routes, confirms, and runs.</a:t>
+            </a:r>
+          </a:p>
+        </p:txBody>
+      </p:sp>
+    </p:spTree>
+  </p:cSld>
+  <p:clrMapOvr>
+    <a:masterClrMapping/>
+  </p:clrMapOvr>
+</p:sld>
+</file>
+
 <file path=ppt/slides/slide2.xml><?xml version="1.0" encoding="utf-8"?>
 <p:sld xmlns:a="http://schemas.openxmlformats.org/drawingml/2006/main" xmlns:r="http://schemas.openxmlformats.org/officeDocument/2006/relationships" xmlns:p="http://schemas.openxmlformats.org/presentationml/2006/main">
   <p:cSld name="Slide 4">
@@ -13875,7 +14862,7 @@
                 </a:solidFill>
                 <a:latin typeface="Consolas"/>
               </a:rPr>
-              <a:t>What Adobe tools does aboutamazon.com run — Web SDK or AppMeasurement?</a:t>
+              <a:t>What's running on slalom.com — Web SDK or AppMeasurement?</a:t>
             </a:r>
           </a:p>
         </p:txBody>
@@ -14155,7 +15142,7 @@
                 </a:solidFill>
                 <a:latin typeface="Consolas"/>
               </a:rPr>
-              <a:t>Plan our DTM-to-Launch migration with consent gating and approval gates.</a:t>
+              <a:t>Plan the Adobe Launch migration for slalom.com.</a:t>
             </a:r>
           </a:p>
         </p:txBody>
@@ -14435,7 +15422,7 @@
                 </a:solidFill>
                 <a:latin typeface="Consolas"/>
               </a:rPr>
-              <a:t>Build the SDR and Web SDK XDM schema, with universal data elements &amp; rules.</a:t>
+              <a:t>Build the SDR + Web SDK XDM schema for slalom.com.</a:t>
             </a:r>
           </a:p>
         </p:txBody>
@@ -14715,7 +15702,7 @@
                 </a:solidFill>
                 <a:latin typeface="Consolas"/>
               </a:rPr>
-              <a:t>Create the Launch property via the Reactor API and publish dev → prod.</a:t>
+              <a:t>Create slalom.com's Launch property and publish dev → prod.</a:t>
             </a:r>
           </a:p>
         </p:txBody>
@@ -14995,7 +15982,7 @@
                 </a:solidFill>
                 <a:latin typeface="Consolas"/>
               </a:rPr>
-              <a:t>Audit this site's Adobe setup and turn the findings into a deck.</a:t>
+              <a:t>Audit the site slalom.com</a:t>
             </a:r>
           </a:p>
         </p:txBody>
@@ -15275,7 +16262,7 @@
                 </a:solidFill>
                 <a:latin typeface="Consolas"/>
               </a:rPr>
-              <a:t>Reconcile the report suite against the property — which eVars actually collect?</a:t>
+              <a:t>Reconcile slalom.com's report suite against the property.</a:t>
             </a:r>
           </a:p>
         </p:txBody>

</xml_diff>

<commit_message>
Slide 2: tag the SDR deliverable as CSV
Add a (CSV) file-type tag to the Build skill's SDR so every client-facing
deliverable (PPTX / XLSX / CSV) is labeled consistently; the Markdown
reports, JSON specs, and the live property stay untagged.

Co-Authored-By: Claude Opus 4.8 <noreply@anthropic.com>
Claude-Session: https://claude.ai/code/session_01L22pJWjoypJEHfB9cqhWZF
</commit_message>
<xml_diff>
--- a/websdk-property/docs/adobe-data-collection-skills-suite.pptx
+++ b/websdk-property/docs/adobe-data-collection-skills-suite.pptx
@@ -1806,15 +1806,59 @@
 </file>
 
 <file path=ppt/slides/slide10.xml><?xml version="1.0" encoding="utf-8"?>
-<p:sld xmlns:a="http://schemas.openxmlformats.org/drawingml/2006/main" xmlns:p="http://schemas.openxmlformats.org/presentationml/2006/main" xmlns:r="http://schemas.openxmlformats.org/officeDocument/2006/relationships">
-  <p:cSld>
+<p:sld xmlns:a="http://schemas.openxmlformats.org/drawingml/2006/main" xmlns:r="http://schemas.openxmlformats.org/officeDocument/2006/relationships" xmlns:p="http://schemas.openxmlformats.org/presentationml/2006/main">
+  <p:cSld name="Slide 41">
+    <p:bg>
+      <p:bgPr>
+        <a:solidFill>
+          <a:srgbClr val="002FAF"/>
+        </a:solidFill>
+        <a:effectLst/>
+      </p:bgPr>
+    </p:bg>
     <p:spTree>
       <p:nvGrpSpPr>
         <p:cNvPr id="1" name=""/>
         <p:cNvGrpSpPr/>
         <p:nvPr/>
       </p:nvGrpSpPr>
-      <p:grpSpPr/>
+      <p:grpSpPr>
+        <a:xfrm>
+          <a:off x="0" y="0"/>
+          <a:ext cx="0" cy="0"/>
+          <a:chOff x="0" y="0"/>
+          <a:chExt cx="0" cy="0"/>
+        </a:xfrm>
+      </p:grpSpPr>
+      <p:sp>
+        <p:nvSpPr>
+          <p:cNvPr id="3" name="Shape 0"/>
+          <p:cNvSpPr/>
+          <p:nvPr/>
+        </p:nvSpPr>
+        <p:spPr>
+          <a:xfrm>
+            <a:off x="7315200" y="-1828800"/>
+            <a:ext cx="5486400" cy="5486400"/>
+          </a:xfrm>
+          <a:prstGeom prst="ellipse">
+            <a:avLst/>
+          </a:prstGeom>
+          <a:solidFill>
+            <a:srgbClr val="0C62FB">
+              <a:alpha val="18000"/>
+            </a:srgbClr>
+          </a:solidFill>
+          <a:ln/>
+        </p:spPr>
+        <p:txBody>
+          <a:bodyPr/>
+          <a:lstStyle/>
+          <a:p>
+            <a:endParaRPr lang="en-US"/>
+          </a:p>
+        </p:txBody>
+      </p:sp>
       <p:sp>
         <p:nvSpPr>
           <p:cNvPr id="4" name="Text 1"/>
@@ -1823,8 +1867,8 @@
         </p:nvSpPr>
         <p:spPr>
           <a:xfrm>
-            <a:off x="548640" y="411480"/>
-            <a:ext cx="9144000" cy="292608"/>
+            <a:off x="914400" y="2286000"/>
+            <a:ext cx="10363200" cy="914400"/>
           </a:xfrm>
           <a:prstGeom prst="rect">
             <a:avLst/>
@@ -1840,17 +1884,17 @@
               <a:buNone/>
             </a:pPr>
             <a:r>
-              <a:rPr lang="en-US" sz="1200" b="1" kern="0" spc="200" dirty="0">
-                <a:solidFill>
-                  <a:srgbClr val="0C62FB"/>
+              <a:rPr lang="en-US" sz="5400" b="1" dirty="0">
+                <a:solidFill>
+                  <a:srgbClr val="FFFFFF"/>
                 </a:solidFill>
                 <a:latin typeface="Avenir Next LT Pro" pitchFamily="34" charset="0"/>
                 <a:ea typeface="Avenir Next LT Pro" pitchFamily="34" charset="-122"/>
                 <a:cs typeface="Avenir Next LT Pro" pitchFamily="34" charset="-120"/>
               </a:rPr>
-              <a:t>SEE IT IN ACTION</a:t>
-            </a:r>
-            <a:endParaRPr lang="en-US" sz="1200" dirty="0"/>
+              <a:t>Thank You</a:t>
+            </a:r>
+            <a:endParaRPr lang="en-US" sz="5400" dirty="0"/>
           </a:p>
         </p:txBody>
       </p:sp>
@@ -1862,8 +1906,8 @@
         </p:nvSpPr>
         <p:spPr>
           <a:xfrm>
-            <a:off x="548640" y="667512"/>
-            <a:ext cx="11064240" cy="566928"/>
+            <a:off x="914400" y="3200400"/>
+            <a:ext cx="10363200" cy="365760"/>
           </a:xfrm>
           <a:prstGeom prst="rect">
             <a:avLst/>
@@ -1879,36 +1923,36 @@
               <a:buNone/>
             </a:pPr>
             <a:r>
-              <a:rPr lang="en-US" sz="2800" b="1" dirty="0">
-                <a:solidFill>
-                  <a:srgbClr val="000000"/>
+              <a:rPr lang="en-US" sz="1600" dirty="0">
+                <a:solidFill>
+                  <a:srgbClr val="BFE0F5"/>
                 </a:solidFill>
                 <a:latin typeface="Avenir Next LT Pro" pitchFamily="34" charset="0"/>
                 <a:ea typeface="Avenir Next LT Pro" pitchFamily="34" charset="-122"/>
                 <a:cs typeface="Avenir Next LT Pro" pitchFamily="34" charset="-120"/>
               </a:rPr>
-              <a:t>One Prompt, and the Skill Takes Over</a:t>
-            </a:r>
-            <a:endParaRPr lang="en-US" sz="2800" dirty="0"/>
-          </a:p>
-        </p:txBody>
-      </p:sp>
-      <p:sp>
-        <p:nvSpPr>
-          <p:cNvPr id="24" name="Shape 21"/>
-          <p:cNvSpPr/>
-          <p:nvPr/>
-        </p:nvSpPr>
-        <p:spPr>
-          <a:xfrm>
-            <a:off x="0" y="0"/>
-            <a:ext cx="2432304" cy="137160"/>
-          </a:xfrm>
-          <a:prstGeom prst="rect">
-            <a:avLst/>
-          </a:prstGeom>
-          <a:solidFill>
-            <a:srgbClr val="002FAF"/>
+              <a:t>Detection to decisions, the same way every time. Let's talk.</a:t>
+            </a:r>
+            <a:endParaRPr lang="en-US" sz="1600" dirty="0"/>
+          </a:p>
+        </p:txBody>
+      </p:sp>
+      <p:sp>
+        <p:nvSpPr>
+          <p:cNvPr id="6" name="Shape Divider"/>
+          <p:cNvSpPr/>
+          <p:nvPr/>
+        </p:nvSpPr>
+        <p:spPr>
+          <a:xfrm>
+            <a:off x="914400" y="3840480"/>
+            <a:ext cx="1828800" cy="18288"/>
+          </a:xfrm>
+          <a:prstGeom prst="rect">
+            <a:avLst/>
+          </a:prstGeom>
+          <a:solidFill>
+            <a:srgbClr val="0C62FB"/>
           </a:solidFill>
           <a:ln/>
         </p:spPr>
@@ -1922,122 +1966,14 @@
       </p:sp>
       <p:sp>
         <p:nvSpPr>
-          <p:cNvPr id="25" name="Shape 22"/>
-          <p:cNvSpPr/>
-          <p:nvPr/>
-        </p:nvSpPr>
-        <p:spPr>
-          <a:xfrm>
-            <a:off x="2432304" y="0"/>
-            <a:ext cx="2432304" cy="137160"/>
-          </a:xfrm>
-          <a:prstGeom prst="rect">
-            <a:avLst/>
-          </a:prstGeom>
-          <a:solidFill>
-            <a:srgbClr val="0C62FB"/>
-          </a:solidFill>
-          <a:ln/>
-        </p:spPr>
-        <p:txBody>
-          <a:bodyPr/>
-          <a:lstStyle/>
-          <a:p>
-            <a:endParaRPr lang="en-US"/>
-          </a:p>
-        </p:txBody>
-      </p:sp>
-      <p:sp>
-        <p:nvSpPr>
-          <p:cNvPr id="26" name="Shape 23"/>
-          <p:cNvSpPr/>
-          <p:nvPr/>
-        </p:nvSpPr>
-        <p:spPr>
-          <a:xfrm>
-            <a:off x="4864608" y="0"/>
-            <a:ext cx="2432304" cy="137160"/>
-          </a:xfrm>
-          <a:prstGeom prst="rect">
-            <a:avLst/>
-          </a:prstGeom>
-          <a:solidFill>
-            <a:srgbClr val="1BE1F2"/>
-          </a:solidFill>
-          <a:ln/>
-        </p:spPr>
-        <p:txBody>
-          <a:bodyPr/>
-          <a:lstStyle/>
-          <a:p>
-            <a:endParaRPr lang="en-US"/>
-          </a:p>
-        </p:txBody>
-      </p:sp>
-      <p:sp>
-        <p:nvSpPr>
-          <p:cNvPr id="27" name="Shape 24"/>
-          <p:cNvSpPr/>
-          <p:nvPr/>
-        </p:nvSpPr>
-        <p:spPr>
-          <a:xfrm>
-            <a:off x="7296912" y="0"/>
-            <a:ext cx="2432304" cy="137160"/>
-          </a:xfrm>
-          <a:prstGeom prst="rect">
-            <a:avLst/>
-          </a:prstGeom>
-          <a:solidFill>
-            <a:srgbClr val="FF4D5F"/>
-          </a:solidFill>
-          <a:ln/>
-        </p:spPr>
-        <p:txBody>
-          <a:bodyPr/>
-          <a:lstStyle/>
-          <a:p>
-            <a:endParaRPr lang="en-US"/>
-          </a:p>
-        </p:txBody>
-      </p:sp>
-      <p:sp>
-        <p:nvSpPr>
-          <p:cNvPr id="28" name="Shape 25"/>
-          <p:cNvSpPr/>
-          <p:nvPr/>
-        </p:nvSpPr>
-        <p:spPr>
-          <a:xfrm>
-            <a:off x="9729216" y="0"/>
-            <a:ext cx="2432304" cy="137160"/>
-          </a:xfrm>
-          <a:prstGeom prst="rect">
-            <a:avLst/>
-          </a:prstGeom>
-          <a:solidFill>
-            <a:srgbClr val="C7B9FF"/>
-          </a:solidFill>
-          <a:ln/>
-        </p:spPr>
-        <p:txBody>
-          <a:bodyPr/>
-          <a:lstStyle/>
-          <a:p>
-            <a:endParaRPr lang="en-US"/>
-          </a:p>
-        </p:txBody>
-      </p:sp>
-      <p:sp>
-        <p:nvSpPr>
-          <p:cNvPr id="29" name="Text 26"/>
-          <p:cNvSpPr/>
-          <p:nvPr/>
-        </p:nvSpPr>
-        <p:spPr>
-          <a:xfrm>
-            <a:off x="548640" y="6446520"/>
-            <a:ext cx="7315200" cy="274320"/>
+          <p:cNvPr id="7" name="Text Name"/>
+          <p:cNvSpPr/>
+          <p:nvPr/>
+        </p:nvSpPr>
+        <p:spPr>
+          <a:xfrm>
+            <a:off x="914400" y="4114800"/>
+            <a:ext cx="10363200" cy="365760"/>
           </a:xfrm>
           <a:prstGeom prst="rect">
             <a:avLst/>
@@ -2049,31 +1985,34 @@
           <a:bodyPr wrap="square" lIns="0" tIns="0" rIns="0" bIns="0" rtlCol="0" anchor="ctr"/>
           <a:lstStyle/>
           <a:p>
-            <a:pPr marL="0" indent="0" algn="l">
+            <a:pPr marL="0" indent="0">
               <a:buNone/>
             </a:pPr>
             <a:r>
-              <a:rPr lang="en-US" sz="750" dirty="0">
-                <a:solidFill>
-                  <a:srgbClr val="666666"/>
-                </a:solidFill>
-              </a:rPr>
-              <a:t>© Slalom. All Rights Reserved. Proprietary and Confidential.</a:t>
-            </a:r>
-            <a:endParaRPr lang="en-US" sz="750" dirty="0"/>
-          </a:p>
-        </p:txBody>
-      </p:sp>
-      <p:sp>
-        <p:nvSpPr>
-          <p:cNvPr id="30" name="Text 27"/>
-          <p:cNvSpPr/>
-          <p:nvPr/>
-        </p:nvSpPr>
-        <p:spPr>
-          <a:xfrm>
-            <a:off x="11521440" y="6446520"/>
-            <a:ext cx="365760" cy="274320"/>
+              <a:rPr lang="en-US" sz="2000" b="1" dirty="0">
+                <a:solidFill>
+                  <a:srgbClr val="FFFFFF"/>
+                </a:solidFill>
+                <a:latin typeface="Avenir Next LT Pro" pitchFamily="34" charset="0"/>
+                <a:ea typeface="Avenir Next LT Pro" pitchFamily="34" charset="-122"/>
+                <a:cs typeface="Avenir Next LT Pro" pitchFamily="34" charset="-120"/>
+              </a:rPr>
+              <a:t>Scott Tavares</a:t>
+            </a:r>
+            <a:endParaRPr lang="en-US" sz="2000" dirty="0"/>
+          </a:p>
+        </p:txBody>
+      </p:sp>
+      <p:sp>
+        <p:nvSpPr>
+          <p:cNvPr id="8" name="Text Title"/>
+          <p:cNvSpPr/>
+          <p:nvPr/>
+        </p:nvSpPr>
+        <p:spPr>
+          <a:xfrm>
+            <a:off x="914400" y="4480560"/>
+            <a:ext cx="10363200" cy="292608"/>
           </a:xfrm>
           <a:prstGeom prst="rect">
             <a:avLst/>
@@ -2085,700 +2024,133 @@
           <a:bodyPr wrap="square" lIns="0" tIns="0" rIns="0" bIns="0" rtlCol="0" anchor="ctr"/>
           <a:lstStyle/>
           <a:p>
-            <a:pPr marL="0" indent="0" algn="r">
+            <a:pPr marL="0" indent="0">
               <a:buNone/>
             </a:pPr>
             <a:r>
-              <a:rPr lang="en-US" sz="1000" dirty="0">
-                <a:solidFill>
-                  <a:srgbClr val="666666"/>
-                </a:solidFill>
-              </a:rPr>
-              <a:t>9</a:t>
-            </a:r>
-            <a:endParaRPr lang="en-US" sz="1000" dirty="0"/>
-          </a:p>
-        </p:txBody>
-      </p:sp>
-      <p:sp>
-        <p:nvSpPr>
-          <p:cNvPr id="31" name="TextBox 30"/>
-          <p:cNvSpPr txBox="1"/>
-          <p:nvPr/>
-        </p:nvSpPr>
-        <p:spPr>
-          <a:xfrm>
-            <a:off x="548640" y="1188720"/>
-            <a:ext cx="11064240" cy="365760"/>
+              <a:rPr lang="en-US" sz="1300" dirty="0">
+                <a:solidFill>
+                  <a:srgbClr val="9FC6E8"/>
+                </a:solidFill>
+                <a:latin typeface="Avenir Next LT Pro" pitchFamily="34" charset="0"/>
+                <a:ea typeface="Avenir Next LT Pro" pitchFamily="34" charset="-122"/>
+                <a:cs typeface="Avenir Next LT Pro" pitchFamily="34" charset="-120"/>
+              </a:rPr>
+              <a:t>Senior Principal, Adobe Multi-Solution Architect</a:t>
+            </a:r>
+            <a:endParaRPr lang="en-US" sz="1300" dirty="0"/>
+          </a:p>
+        </p:txBody>
+      </p:sp>
+      <p:sp>
+        <p:nvSpPr>
+          <p:cNvPr id="9" name="Text Company"/>
+          <p:cNvSpPr/>
+          <p:nvPr/>
+        </p:nvSpPr>
+        <p:spPr>
+          <a:xfrm>
+            <a:off x="914400" y="4791075"/>
+            <a:ext cx="10363200" cy="292608"/>
           </a:xfrm>
           <a:prstGeom prst="rect">
             <a:avLst/>
           </a:prstGeom>
           <a:noFill/>
-        </p:spPr>
-        <p:txBody>
-          <a:bodyPr wrap="square" lIns="27432" rIns="27432" tIns="0" bIns="0" anchor="ctr">
-            <a:spAutoFit/>
-          </a:bodyPr>
-          <a:lstStyle/>
-          <a:p>
-            <a:pPr algn="l"/>
-            <a:r>
-              <a:rPr sz="1400" b="0">
-                <a:solidFill>
-                  <a:srgbClr val="5A6478"/>
-                </a:solidFill>
-                <a:latin typeface="Avenir Next LT Pro"/>
-              </a:rPr>
-              <a:t>Name your site in plain English — the skill confirms scope, works from live data, and hands back a client-ready deck.</a:t>
-            </a:r>
-          </a:p>
-        </p:txBody>
-      </p:sp>
-      <p:pic>
-        <p:nvPicPr>
-          <p:cNvPr id="32" name="Picture 31" descr="terminal.png"/>
-          <p:cNvPicPr>
-            <a:picLocks noChangeAspect="1"/>
-          </p:cNvPicPr>
-          <p:nvPr/>
-        </p:nvPicPr>
-        <p:blipFill>
-          <a:blip r:embed="rId2"/>
-          <a:stretch>
-            <a:fillRect/>
-          </a:stretch>
-        </p:blipFill>
-        <p:spPr>
-          <a:xfrm>
-            <a:off x="512064" y="1691640"/>
-            <a:ext cx="7845552" cy="3584448"/>
-          </a:xfrm>
-          <a:prstGeom prst="rect">
-            <a:avLst/>
-          </a:prstGeom>
-        </p:spPr>
-      </p:pic>
-      <p:sp>
-        <p:nvSpPr>
-          <p:cNvPr id="33" name="TextBox 32"/>
-          <p:cNvSpPr txBox="1"/>
-          <p:nvPr/>
-        </p:nvSpPr>
-        <p:spPr>
-          <a:xfrm>
-            <a:off x="8650224" y="1755648"/>
-            <a:ext cx="3017520" cy="256032"/>
+          <a:ln/>
+        </p:spPr>
+        <p:txBody>
+          <a:bodyPr wrap="square" lIns="0" tIns="0" rIns="0" bIns="0" rtlCol="0" anchor="ctr"/>
+          <a:lstStyle/>
+          <a:p>
+            <a:pPr marL="0" indent="0">
+              <a:buNone/>
+            </a:pPr>
+            <a:r>
+              <a:rPr lang="en-US" sz="1300" dirty="0">
+                <a:solidFill>
+                  <a:srgbClr val="9FC6E8"/>
+                </a:solidFill>
+                <a:latin typeface="Avenir Next LT Pro" pitchFamily="34" charset="0"/>
+                <a:ea typeface="Avenir Next LT Pro" pitchFamily="34" charset="-122"/>
+                <a:cs typeface="Avenir Next LT Pro" pitchFamily="34" charset="-120"/>
+              </a:rPr>
+              <a:t>Slalom</a:t>
+            </a:r>
+            <a:endParaRPr lang="en-US" sz="1300" dirty="0"/>
+          </a:p>
+        </p:txBody>
+      </p:sp>
+      <p:sp>
+        <p:nvSpPr>
+          <p:cNvPr id="10" name="Text Email"/>
+          <p:cNvSpPr/>
+          <p:nvPr/>
+        </p:nvSpPr>
+        <p:spPr>
+          <a:xfrm>
+            <a:off x="914400" y="5257800"/>
+            <a:ext cx="10363200" cy="292608"/>
           </a:xfrm>
           <a:prstGeom prst="rect">
             <a:avLst/>
           </a:prstGeom>
           <a:noFill/>
-        </p:spPr>
-        <p:txBody>
-          <a:bodyPr wrap="square" lIns="27432" rIns="27432" tIns="0" bIns="0" anchor="t">
-            <a:spAutoFit/>
-          </a:bodyPr>
-          <a:lstStyle/>
-          <a:p>
-            <a:pPr algn="l"/>
-            <a:r>
-              <a:rPr sz="1200" b="1">
-                <a:solidFill>
-                  <a:srgbClr val="9AA6BF"/>
-                </a:solidFill>
-                <a:latin typeface="Avenir Next LT Pro"/>
-              </a:rPr>
-              <a:t>WHAT JUST HAPPENED</a:t>
-            </a:r>
-          </a:p>
-        </p:txBody>
-      </p:sp>
-      <p:sp>
-        <p:nvSpPr>
-          <p:cNvPr id="34" name="Oval 33"/>
-          <p:cNvSpPr/>
-          <p:nvPr/>
-        </p:nvSpPr>
-        <p:spPr>
-          <a:xfrm>
-            <a:off x="8650224" y="2084831"/>
-            <a:ext cx="292608" cy="292608"/>
-          </a:xfrm>
-          <a:prstGeom prst="ellipse">
-            <a:avLst/>
-          </a:prstGeom>
-          <a:solidFill>
-            <a:srgbClr val="002FAF"/>
-          </a:solidFill>
-          <a:ln>
-            <a:noFill/>
-          </a:ln>
-          <a:effectLst/>
-        </p:spPr>
-        <p:style>
-          <a:lnRef idx="1">
-            <a:schemeClr val="accent1"/>
-          </a:lnRef>
-          <a:fillRef idx="3">
-            <a:schemeClr val="accent1"/>
-          </a:fillRef>
-          <a:effectRef idx="2">
-            <a:schemeClr val="accent1"/>
-          </a:effectRef>
-          <a:fontRef idx="minor">
-            <a:schemeClr val="lt1"/>
-          </a:fontRef>
-        </p:style>
-        <p:txBody>
-          <a:bodyPr rtlCol="0" anchor="ctr" wrap="square" lIns="27432" rIns="27432" tIns="0" bIns="0"/>
-          <a:lstStyle/>
-          <a:p>
-            <a:pPr algn="ctr"/>
-            <a:r>
-              <a:rPr sz="1300" b="1">
+          <a:ln/>
+        </p:spPr>
+        <p:txBody>
+          <a:bodyPr wrap="square" lIns="0" tIns="0" rIns="0" bIns="0" rtlCol="0" anchor="ctr"/>
+          <a:lstStyle/>
+          <a:p>
+            <a:pPr marL="0" indent="0">
+              <a:buNone/>
+            </a:pPr>
+            <a:r>
+              <a:rPr lang="en-US" sz="1300" b="1" dirty="0">
                 <a:solidFill>
                   <a:srgbClr val="FFFFFF"/>
                 </a:solidFill>
-                <a:latin typeface="Calibri"/>
-              </a:rPr>
-              <a:t>1</a:t>
-            </a:r>
-          </a:p>
-        </p:txBody>
-      </p:sp>
-      <p:sp>
-        <p:nvSpPr>
-          <p:cNvPr id="35" name="TextBox 34"/>
-          <p:cNvSpPr txBox="1"/>
-          <p:nvPr/>
-        </p:nvSpPr>
-        <p:spPr>
-          <a:xfrm>
-            <a:off x="9070848" y="2066543"/>
-            <a:ext cx="2606040" cy="274320"/>
+                <a:latin typeface="Avenir Next LT Pro" pitchFamily="34" charset="0"/>
+                <a:ea typeface="Avenir Next LT Pro" pitchFamily="34" charset="-122"/>
+                <a:cs typeface="Avenir Next LT Pro" pitchFamily="34" charset="-120"/>
+              </a:rPr>
+              <a:t>scott.tavares@slalom.com</a:t>
+            </a:r>
+            <a:endParaRPr lang="en-US" sz="1300" dirty="0"/>
+          </a:p>
+        </p:txBody>
+      </p:sp>
+      <p:sp>
+        <p:nvSpPr>
+          <p:cNvPr id="21" name="Text Copyright"/>
+          <p:cNvSpPr/>
+          <p:nvPr/>
+        </p:nvSpPr>
+        <p:spPr>
+          <a:xfrm>
+            <a:off x="914400" y="6446520"/>
+            <a:ext cx="7315200" cy="274320"/>
           </a:xfrm>
           <a:prstGeom prst="rect">
             <a:avLst/>
           </a:prstGeom>
           <a:noFill/>
-        </p:spPr>
-        <p:txBody>
-          <a:bodyPr wrap="square" lIns="27432" rIns="27432" tIns="0" bIns="0" anchor="ctr">
-            <a:spAutoFit/>
-          </a:bodyPr>
-          <a:lstStyle/>
-          <a:p>
-            <a:pPr algn="l"/>
-            <a:r>
-              <a:rPr sz="1500" b="1">
-                <a:solidFill>
-                  <a:srgbClr val="002FAF"/>
-                </a:solidFill>
-                <a:latin typeface="Avenir Next LT Pro"/>
-              </a:rPr>
-              <a:t>You named the site.</a:t>
-            </a:r>
-          </a:p>
-        </p:txBody>
-      </p:sp>
-      <p:sp>
-        <p:nvSpPr>
-          <p:cNvPr id="36" name="TextBox 35"/>
-          <p:cNvSpPr txBox="1"/>
-          <p:nvPr/>
-        </p:nvSpPr>
-        <p:spPr>
-          <a:xfrm>
-            <a:off x="9070848" y="2359151"/>
-            <a:ext cx="2606040" cy="640080"/>
-          </a:xfrm>
-          <a:prstGeom prst="rect">
-            <a:avLst/>
-          </a:prstGeom>
-          <a:noFill/>
-        </p:spPr>
-        <p:txBody>
-          <a:bodyPr wrap="square" lIns="27432" rIns="27432" tIns="0" bIns="0" anchor="t">
-            <a:spAutoFit/>
-          </a:bodyPr>
-          <a:lstStyle/>
-          <a:p>
-            <a:pPr algn="l"/>
-            <a:r>
-              <a:rPr sz="1300" b="0">
-                <a:solidFill>
-                  <a:srgbClr val="3E4759"/>
-                </a:solidFill>
-                <a:latin typeface="Avenir Next LT Pro"/>
-              </a:rPr>
-              <a:t>That’s the entire prompt — </a:t>
-            </a:r>
-            <a:r>
-              <a:rPr sz="1200" b="1">
-                <a:solidFill>
-                  <a:srgbClr val="17203A"/>
-                </a:solidFill>
-                <a:latin typeface="Consolas"/>
-              </a:rPr>
-              <a:t>Audit the site slalom.com</a:t>
-            </a:r>
-          </a:p>
-        </p:txBody>
-      </p:sp>
-      <p:sp>
-        <p:nvSpPr>
-          <p:cNvPr id="37" name="Oval 36"/>
-          <p:cNvSpPr/>
-          <p:nvPr/>
-        </p:nvSpPr>
-        <p:spPr>
-          <a:xfrm>
-            <a:off x="8650224" y="3044952"/>
-            <a:ext cx="292608" cy="292608"/>
-          </a:xfrm>
-          <a:prstGeom prst="ellipse">
-            <a:avLst/>
-          </a:prstGeom>
-          <a:solidFill>
-            <a:srgbClr val="0C62FB"/>
-          </a:solidFill>
-          <a:ln>
-            <a:noFill/>
-          </a:ln>
-          <a:effectLst/>
-        </p:spPr>
-        <p:style>
-          <a:lnRef idx="1">
-            <a:schemeClr val="accent1"/>
-          </a:lnRef>
-          <a:fillRef idx="3">
-            <a:schemeClr val="accent1"/>
-          </a:fillRef>
-          <a:effectRef idx="2">
-            <a:schemeClr val="accent1"/>
-          </a:effectRef>
-          <a:fontRef idx="minor">
-            <a:schemeClr val="lt1"/>
-          </a:fontRef>
-        </p:style>
-        <p:txBody>
-          <a:bodyPr rtlCol="0" anchor="ctr" wrap="square" lIns="27432" rIns="27432" tIns="0" bIns="0"/>
-          <a:lstStyle/>
-          <a:p>
-            <a:pPr algn="ctr"/>
-            <a:r>
-              <a:rPr sz="1300" b="1">
-                <a:solidFill>
-                  <a:srgbClr val="FFFFFF"/>
-                </a:solidFill>
-                <a:latin typeface="Calibri"/>
-              </a:rPr>
-              <a:t>2</a:t>
-            </a:r>
-          </a:p>
-        </p:txBody>
-      </p:sp>
-      <p:sp>
-        <p:nvSpPr>
-          <p:cNvPr id="38" name="TextBox 37"/>
-          <p:cNvSpPr txBox="1"/>
-          <p:nvPr/>
-        </p:nvSpPr>
-        <p:spPr>
-          <a:xfrm>
-            <a:off x="9070848" y="3026664"/>
-            <a:ext cx="2606040" cy="274320"/>
-          </a:xfrm>
-          <a:prstGeom prst="rect">
-            <a:avLst/>
-          </a:prstGeom>
-          <a:noFill/>
-        </p:spPr>
-        <p:txBody>
-          <a:bodyPr wrap="square" lIns="27432" rIns="27432" tIns="0" bIns="0" anchor="ctr">
-            <a:spAutoFit/>
-          </a:bodyPr>
-          <a:lstStyle/>
-          <a:p>
-            <a:pPr algn="l"/>
-            <a:r>
-              <a:rPr sz="1500" b="1">
-                <a:solidFill>
-                  <a:srgbClr val="0C62FB"/>
-                </a:solidFill>
-                <a:latin typeface="Avenir Next LT Pro"/>
-              </a:rPr>
-              <a:t>It routed &amp; confirmed.</a:t>
-            </a:r>
-          </a:p>
-        </p:txBody>
-      </p:sp>
-      <p:sp>
-        <p:nvSpPr>
-          <p:cNvPr id="39" name="TextBox 38"/>
-          <p:cNvSpPr txBox="1"/>
-          <p:nvPr/>
-        </p:nvSpPr>
-        <p:spPr>
-          <a:xfrm>
-            <a:off x="9070848" y="3319272"/>
-            <a:ext cx="2606040" cy="640080"/>
-          </a:xfrm>
-          <a:prstGeom prst="rect">
-            <a:avLst/>
-          </a:prstGeom>
-          <a:noFill/>
-        </p:spPr>
-        <p:txBody>
-          <a:bodyPr wrap="square" lIns="27432" rIns="27432" tIns="0" bIns="0" anchor="t">
-            <a:spAutoFit/>
-          </a:bodyPr>
-          <a:lstStyle/>
-          <a:p>
-            <a:pPr algn="l"/>
-            <a:r>
-              <a:rPr sz="1300" b="0">
-                <a:solidFill>
-                  <a:srgbClr val="3E4759"/>
-                </a:solidFill>
-                <a:latin typeface="Avenir Next LT Pro"/>
-              </a:rPr>
-              <a:t>Picked the Adobe Tags audit and confirmed scope — no re-asking what you already said.</a:t>
-            </a:r>
-          </a:p>
-        </p:txBody>
-      </p:sp>
-      <p:sp>
-        <p:nvSpPr>
-          <p:cNvPr id="40" name="Oval 39"/>
-          <p:cNvSpPr/>
-          <p:nvPr/>
-        </p:nvSpPr>
-        <p:spPr>
-          <a:xfrm>
-            <a:off x="8650224" y="4005072"/>
-            <a:ext cx="292608" cy="292608"/>
-          </a:xfrm>
-          <a:prstGeom prst="ellipse">
-            <a:avLst/>
-          </a:prstGeom>
-          <a:solidFill>
-            <a:srgbClr val="0E8FA0"/>
-          </a:solidFill>
-          <a:ln>
-            <a:noFill/>
-          </a:ln>
-          <a:effectLst/>
-        </p:spPr>
-        <p:style>
-          <a:lnRef idx="1">
-            <a:schemeClr val="accent1"/>
-          </a:lnRef>
-          <a:fillRef idx="3">
-            <a:schemeClr val="accent1"/>
-          </a:fillRef>
-          <a:effectRef idx="2">
-            <a:schemeClr val="accent1"/>
-          </a:effectRef>
-          <a:fontRef idx="minor">
-            <a:schemeClr val="lt1"/>
-          </a:fontRef>
-        </p:style>
-        <p:txBody>
-          <a:bodyPr rtlCol="0" anchor="ctr" wrap="square" lIns="27432" rIns="27432" tIns="0" bIns="0"/>
-          <a:lstStyle/>
-          <a:p>
-            <a:pPr algn="ctr"/>
-            <a:r>
-              <a:rPr sz="1300" b="1">
-                <a:solidFill>
-                  <a:srgbClr val="FFFFFF"/>
-                </a:solidFill>
-                <a:latin typeface="Calibri"/>
-              </a:rPr>
-              <a:t>3</a:t>
-            </a:r>
-          </a:p>
-        </p:txBody>
-      </p:sp>
-      <p:sp>
-        <p:nvSpPr>
-          <p:cNvPr id="41" name="TextBox 40"/>
-          <p:cNvSpPr txBox="1"/>
-          <p:nvPr/>
-        </p:nvSpPr>
-        <p:spPr>
-          <a:xfrm>
-            <a:off x="9070848" y="3986784"/>
-            <a:ext cx="2606040" cy="274320"/>
-          </a:xfrm>
-          <a:prstGeom prst="rect">
-            <a:avLst/>
-          </a:prstGeom>
-          <a:noFill/>
-        </p:spPr>
-        <p:txBody>
-          <a:bodyPr wrap="square" lIns="27432" rIns="27432" tIns="0" bIns="0" anchor="ctr">
-            <a:spAutoFit/>
-          </a:bodyPr>
-          <a:lstStyle/>
-          <a:p>
-            <a:pPr algn="l"/>
-            <a:r>
-              <a:rPr sz="1500" b="1">
-                <a:solidFill>
-                  <a:srgbClr val="0E8FA0"/>
-                </a:solidFill>
-                <a:latin typeface="Avenir Next LT Pro"/>
-              </a:rPr>
-              <a:t>It works from live data.</a:t>
-            </a:r>
-          </a:p>
-        </p:txBody>
-      </p:sp>
-      <p:sp>
-        <p:nvSpPr>
-          <p:cNvPr id="42" name="TextBox 41"/>
-          <p:cNvSpPr txBox="1"/>
-          <p:nvPr/>
-        </p:nvSpPr>
-        <p:spPr>
-          <a:xfrm>
-            <a:off x="9070848" y="4279392"/>
-            <a:ext cx="2606040" cy="640080"/>
-          </a:xfrm>
-          <a:prstGeom prst="rect">
-            <a:avLst/>
-          </a:prstGeom>
-          <a:noFill/>
-        </p:spPr>
-        <p:txBody>
-          <a:bodyPr wrap="square" lIns="27432" rIns="27432" tIns="0" bIns="0" anchor="t">
-            <a:spAutoFit/>
-          </a:bodyPr>
-          <a:lstStyle/>
-          <a:p>
-            <a:pPr algn="l"/>
-            <a:r>
-              <a:rPr sz="1300" b="0">
-                <a:solidFill>
-                  <a:srgbClr val="3E4759"/>
-                </a:solidFill>
-                <a:latin typeface="Avenir Next LT Pro"/>
-              </a:rPr>
-              <a:t>A real headless browser detects the stack and pulls the published Launch library directly.</a:t>
-            </a:r>
-          </a:p>
-        </p:txBody>
-      </p:sp>
-      <p:sp>
-        <p:nvSpPr>
-          <p:cNvPr id="43" name="Rounded Rectangle 42"/>
-          <p:cNvSpPr/>
-          <p:nvPr/>
-        </p:nvSpPr>
-        <p:spPr>
-          <a:xfrm>
-            <a:off x="8650224" y="5029200"/>
-            <a:ext cx="3017520" cy="566928"/>
-          </a:xfrm>
-          <a:prstGeom prst="roundRect">
-            <a:avLst>
-              <a:gd name="adj" fmla="val 16000"/>
-            </a:avLst>
-          </a:prstGeom>
-          <a:solidFill>
-            <a:srgbClr val="EAF7EE"/>
-          </a:solidFill>
-          <a:ln w="12700">
-            <a:solidFill>
-              <a:srgbClr val="CDEBD6"/>
-            </a:solidFill>
-          </a:ln>
-          <a:effectLst/>
-        </p:spPr>
-        <p:style>
-          <a:lnRef idx="1">
-            <a:schemeClr val="accent1"/>
-          </a:lnRef>
-          <a:fillRef idx="3">
-            <a:schemeClr val="accent1"/>
-          </a:fillRef>
-          <a:effectRef idx="2">
-            <a:schemeClr val="accent1"/>
-          </a:effectRef>
-          <a:fontRef idx="minor">
-            <a:schemeClr val="lt1"/>
-          </a:fontRef>
-        </p:style>
-        <p:txBody>
-          <a:bodyPr rtlCol="0" anchor="ctr" wrap="square" lIns="27432" rIns="27432" tIns="0" bIns="0"/>
-          <a:lstStyle/>
-          <a:p>
-            <a:pPr algn="l"/>
-            <a:r>
-              <a:rPr sz="1250" b="1">
-                <a:solidFill>
-                  <a:srgbClr val="17203A"/>
-                </a:solidFill>
-                <a:latin typeface="Avenir Next LT Pro"/>
-              </a:rPr>
-              <a:t>Produces </a:t>
-            </a:r>
-            <a:r>
-              <a:rPr sz="1250" b="1">
-                <a:solidFill>
-                  <a:srgbClr val="2E9E5B"/>
-                </a:solidFill>
-                <a:latin typeface="Avenir Next LT Pro"/>
-              </a:rPr>
-              <a:t>a findings deck (PPTX)</a:t>
-            </a:r>
-            <a:r>
-              <a:rPr sz="1250" b="1">
-                <a:solidFill>
-                  <a:srgbClr val="17203A"/>
-                </a:solidFill>
-                <a:latin typeface="Avenir Next LT Pro"/>
-              </a:rPr>
-              <a:t> in the Slalom style.</a:t>
-            </a:r>
-          </a:p>
-        </p:txBody>
-      </p:sp>
-      <p:sp>
-        <p:nvSpPr>
-          <p:cNvPr id="44" name="Rounded Rectangle 43"/>
-          <p:cNvSpPr/>
-          <p:nvPr/>
-        </p:nvSpPr>
-        <p:spPr>
-          <a:xfrm>
-            <a:off x="512064" y="5486400"/>
-            <a:ext cx="7845552" cy="566928"/>
-          </a:xfrm>
-          <a:prstGeom prst="roundRect">
-            <a:avLst>
-              <a:gd name="adj" fmla="val 12000"/>
-            </a:avLst>
-          </a:prstGeom>
-          <a:solidFill>
-            <a:srgbClr val="F5F8FF"/>
-          </a:solidFill>
-          <a:ln>
-            <a:noFill/>
-          </a:ln>
-          <a:effectLst/>
-        </p:spPr>
-        <p:style>
-          <a:lnRef idx="1">
-            <a:schemeClr val="accent1"/>
-          </a:lnRef>
-          <a:fillRef idx="3">
-            <a:schemeClr val="accent1"/>
-          </a:fillRef>
-          <a:effectRef idx="2">
-            <a:schemeClr val="accent1"/>
-          </a:effectRef>
-          <a:fontRef idx="minor">
-            <a:schemeClr val="lt1"/>
-          </a:fontRef>
-        </p:style>
-        <p:txBody>
-          <a:bodyPr rtlCol="0" anchor="ctr"/>
-          <a:lstStyle/>
-          <a:p>
-            <a:pPr algn="ctr"/>
-          </a:p>
-        </p:txBody>
-      </p:sp>
-      <p:sp>
-        <p:nvSpPr>
-          <p:cNvPr id="45" name="Rounded Rectangle 44"/>
-          <p:cNvSpPr/>
-          <p:nvPr/>
-        </p:nvSpPr>
-        <p:spPr>
-          <a:xfrm>
-            <a:off x="512064" y="5486400"/>
-            <a:ext cx="73152" cy="566928"/>
-          </a:xfrm>
-          <a:prstGeom prst="roundRect">
-            <a:avLst>
-              <a:gd name="adj" fmla="val 50000"/>
-            </a:avLst>
-          </a:prstGeom>
-          <a:solidFill>
-            <a:srgbClr val="0C62FB"/>
-          </a:solidFill>
-          <a:ln>
-            <a:noFill/>
-          </a:ln>
-          <a:effectLst/>
-        </p:spPr>
-        <p:style>
-          <a:lnRef idx="1">
-            <a:schemeClr val="accent1"/>
-          </a:lnRef>
-          <a:fillRef idx="3">
-            <a:schemeClr val="accent1"/>
-          </a:fillRef>
-          <a:effectRef idx="2">
-            <a:schemeClr val="accent1"/>
-          </a:effectRef>
-          <a:fontRef idx="minor">
-            <a:schemeClr val="lt1"/>
-          </a:fontRef>
-        </p:style>
-        <p:txBody>
-          <a:bodyPr rtlCol="0" anchor="ctr"/>
-          <a:lstStyle/>
-          <a:p>
-            <a:pPr algn="ctr"/>
-          </a:p>
-        </p:txBody>
-      </p:sp>
-      <p:sp>
-        <p:nvSpPr>
-          <p:cNvPr id="46" name="TextBox 45"/>
-          <p:cNvSpPr txBox="1"/>
-          <p:nvPr/>
-        </p:nvSpPr>
-        <p:spPr>
-          <a:xfrm>
-            <a:off x="786384" y="5486400"/>
-            <a:ext cx="7406640" cy="566928"/>
-          </a:xfrm>
-          <a:prstGeom prst="rect">
-            <a:avLst/>
-          </a:prstGeom>
-          <a:noFill/>
-        </p:spPr>
-        <p:txBody>
-          <a:bodyPr wrap="square" lIns="27432" rIns="27432" tIns="0" bIns="0" anchor="ctr">
-            <a:spAutoFit/>
-          </a:bodyPr>
-          <a:lstStyle/>
-          <a:p>
-            <a:pPr algn="l"/>
-            <a:r>
-              <a:rPr sz="1400" b="1">
-                <a:solidFill>
-                  <a:srgbClr val="002FAF"/>
-                </a:solidFill>
-                <a:latin typeface="Avenir Next LT Pro"/>
-              </a:rPr>
-              <a:t>Same pattern for every skill: </a:t>
-            </a:r>
-            <a:r>
-              <a:rPr sz="1400" b="0">
-                <a:solidFill>
-                  <a:srgbClr val="3E4759"/>
-                </a:solidFill>
-                <a:latin typeface="Avenir Next LT Pro"/>
-              </a:rPr>
-              <a:t>name the target in one line — Detect, Build, Audit, Reconcile — and the matching skill routes, confirms, and runs.</a:t>
+          <a:ln/>
+        </p:spPr>
+        <p:txBody>
+          <a:bodyPr wrap="square" lIns="0" tIns="0" rIns="0" bIns="0" rtlCol="0" anchor="ctr"/>
+          <a:lstStyle/>
+          <a:p>
+            <a:pPr marL="0" indent="0">
+              <a:buNone/>
+            </a:pPr>
+            <a:r>
+              <a:rPr lang="en-US" sz="900" dirty="0">
+                <a:solidFill>
+                  <a:srgbClr val="6E93B8"/>
+                </a:solidFill>
+              </a:rPr>
+              <a:t>© Slalom. All Rights Reserved. Proprietary and Confidential.</a:t>
             </a:r>
           </a:p>
         </p:txBody>
@@ -3987,7 +3359,7 @@
                 </a:solidFill>
                 <a:latin typeface="Avenir Next LT Pro"/>
               </a:rPr>
-              <a:t>SDR + XDM schema + data elements &amp; rules</a:t>
+              <a:t>SDR (CSV) + XDM schema + data elements &amp; rules</a:t>
             </a:r>
           </a:p>
         </p:txBody>
@@ -16276,59 +15648,15 @@
 </file>
 
 <file path=ppt/slides/slide9.xml><?xml version="1.0" encoding="utf-8"?>
-<p:sld xmlns:a="http://schemas.openxmlformats.org/drawingml/2006/main" xmlns:r="http://schemas.openxmlformats.org/officeDocument/2006/relationships" xmlns:p="http://schemas.openxmlformats.org/presentationml/2006/main">
-  <p:cSld name="Slide 41">
-    <p:bg>
-      <p:bgPr>
-        <a:solidFill>
-          <a:srgbClr val="002FAF"/>
-        </a:solidFill>
-        <a:effectLst/>
-      </p:bgPr>
-    </p:bg>
+<p:sld xmlns:a="http://schemas.openxmlformats.org/drawingml/2006/main" xmlns:p="http://schemas.openxmlformats.org/presentationml/2006/main" xmlns:r="http://schemas.openxmlformats.org/officeDocument/2006/relationships">
+  <p:cSld>
     <p:spTree>
       <p:nvGrpSpPr>
         <p:cNvPr id="1" name=""/>
         <p:cNvGrpSpPr/>
         <p:nvPr/>
       </p:nvGrpSpPr>
-      <p:grpSpPr>
-        <a:xfrm>
-          <a:off x="0" y="0"/>
-          <a:ext cx="0" cy="0"/>
-          <a:chOff x="0" y="0"/>
-          <a:chExt cx="0" cy="0"/>
-        </a:xfrm>
-      </p:grpSpPr>
-      <p:sp>
-        <p:nvSpPr>
-          <p:cNvPr id="3" name="Shape 0"/>
-          <p:cNvSpPr/>
-          <p:nvPr/>
-        </p:nvSpPr>
-        <p:spPr>
-          <a:xfrm>
-            <a:off x="7315200" y="-1828800"/>
-            <a:ext cx="5486400" cy="5486400"/>
-          </a:xfrm>
-          <a:prstGeom prst="ellipse">
-            <a:avLst/>
-          </a:prstGeom>
-          <a:solidFill>
-            <a:srgbClr val="0C62FB">
-              <a:alpha val="18000"/>
-            </a:srgbClr>
-          </a:solidFill>
-          <a:ln/>
-        </p:spPr>
-        <p:txBody>
-          <a:bodyPr/>
-          <a:lstStyle/>
-          <a:p>
-            <a:endParaRPr lang="en-US"/>
-          </a:p>
-        </p:txBody>
-      </p:sp>
+      <p:grpSpPr/>
       <p:sp>
         <p:nvSpPr>
           <p:cNvPr id="4" name="Text 1"/>
@@ -16337,8 +15665,8 @@
         </p:nvSpPr>
         <p:spPr>
           <a:xfrm>
-            <a:off x="914400" y="2286000"/>
-            <a:ext cx="10363200" cy="914400"/>
+            <a:off x="548640" y="411480"/>
+            <a:ext cx="9144000" cy="292608"/>
           </a:xfrm>
           <a:prstGeom prst="rect">
             <a:avLst/>
@@ -16354,17 +15682,17 @@
               <a:buNone/>
             </a:pPr>
             <a:r>
-              <a:rPr lang="en-US" sz="5400" b="1" dirty="0">
-                <a:solidFill>
-                  <a:srgbClr val="FFFFFF"/>
+              <a:rPr lang="en-US" sz="1200" b="1" kern="0" spc="200" dirty="0">
+                <a:solidFill>
+                  <a:srgbClr val="0C62FB"/>
                 </a:solidFill>
                 <a:latin typeface="Avenir Next LT Pro" pitchFamily="34" charset="0"/>
                 <a:ea typeface="Avenir Next LT Pro" pitchFamily="34" charset="-122"/>
                 <a:cs typeface="Avenir Next LT Pro" pitchFamily="34" charset="-120"/>
               </a:rPr>
-              <a:t>Thank You</a:t>
-            </a:r>
-            <a:endParaRPr lang="en-US" sz="5400" dirty="0"/>
+              <a:t>SEE IT IN ACTION</a:t>
+            </a:r>
+            <a:endParaRPr lang="en-US" sz="1200" dirty="0"/>
           </a:p>
         </p:txBody>
       </p:sp>
@@ -16376,8 +15704,8 @@
         </p:nvSpPr>
         <p:spPr>
           <a:xfrm>
-            <a:off x="914400" y="3200400"/>
-            <a:ext cx="10363200" cy="365760"/>
+            <a:off x="548640" y="667512"/>
+            <a:ext cx="11064240" cy="566928"/>
           </a:xfrm>
           <a:prstGeom prst="rect">
             <a:avLst/>
@@ -16393,30 +15721,57 @@
               <a:buNone/>
             </a:pPr>
             <a:r>
-              <a:rPr lang="en-US" sz="1600" dirty="0">
-                <a:solidFill>
-                  <a:srgbClr val="BFE0F5"/>
+              <a:rPr lang="en-US" sz="2800" b="1" dirty="0">
+                <a:solidFill>
+                  <a:srgbClr val="000000"/>
                 </a:solidFill>
                 <a:latin typeface="Avenir Next LT Pro" pitchFamily="34" charset="0"/>
                 <a:ea typeface="Avenir Next LT Pro" pitchFamily="34" charset="-122"/>
                 <a:cs typeface="Avenir Next LT Pro" pitchFamily="34" charset="-120"/>
               </a:rPr>
-              <a:t>Detection to decisions, the same way every time. Let's talk.</a:t>
-            </a:r>
-            <a:endParaRPr lang="en-US" sz="1600" dirty="0"/>
-          </a:p>
-        </p:txBody>
-      </p:sp>
-      <p:sp>
-        <p:nvSpPr>
-          <p:cNvPr id="6" name="Shape Divider"/>
-          <p:cNvSpPr/>
-          <p:nvPr/>
-        </p:nvSpPr>
-        <p:spPr>
-          <a:xfrm>
-            <a:off x="914400" y="3840480"/>
-            <a:ext cx="1828800" cy="18288"/>
+              <a:t>One Prompt, and the Skill Takes Over</a:t>
+            </a:r>
+            <a:endParaRPr lang="en-US" sz="2800" dirty="0"/>
+          </a:p>
+        </p:txBody>
+      </p:sp>
+      <p:sp>
+        <p:nvSpPr>
+          <p:cNvPr id="24" name="Shape 21"/>
+          <p:cNvSpPr/>
+          <p:nvPr/>
+        </p:nvSpPr>
+        <p:spPr>
+          <a:xfrm>
+            <a:off x="0" y="0"/>
+            <a:ext cx="2432304" cy="137160"/>
+          </a:xfrm>
+          <a:prstGeom prst="rect">
+            <a:avLst/>
+          </a:prstGeom>
+          <a:solidFill>
+            <a:srgbClr val="002FAF"/>
+          </a:solidFill>
+          <a:ln/>
+        </p:spPr>
+        <p:txBody>
+          <a:bodyPr/>
+          <a:lstStyle/>
+          <a:p>
+            <a:endParaRPr lang="en-US"/>
+          </a:p>
+        </p:txBody>
+      </p:sp>
+      <p:sp>
+        <p:nvSpPr>
+          <p:cNvPr id="25" name="Shape 22"/>
+          <p:cNvSpPr/>
+          <p:nvPr/>
+        </p:nvSpPr>
+        <p:spPr>
+          <a:xfrm>
+            <a:off x="2432304" y="0"/>
+            <a:ext cx="2432304" cy="137160"/>
           </a:xfrm>
           <a:prstGeom prst="rect">
             <a:avLst/>
@@ -16436,14 +15791,95 @@
       </p:sp>
       <p:sp>
         <p:nvSpPr>
-          <p:cNvPr id="7" name="Text Name"/>
-          <p:cNvSpPr/>
-          <p:nvPr/>
-        </p:nvSpPr>
-        <p:spPr>
-          <a:xfrm>
-            <a:off x="914400" y="4114800"/>
-            <a:ext cx="10363200" cy="365760"/>
+          <p:cNvPr id="26" name="Shape 23"/>
+          <p:cNvSpPr/>
+          <p:nvPr/>
+        </p:nvSpPr>
+        <p:spPr>
+          <a:xfrm>
+            <a:off x="4864608" y="0"/>
+            <a:ext cx="2432304" cy="137160"/>
+          </a:xfrm>
+          <a:prstGeom prst="rect">
+            <a:avLst/>
+          </a:prstGeom>
+          <a:solidFill>
+            <a:srgbClr val="1BE1F2"/>
+          </a:solidFill>
+          <a:ln/>
+        </p:spPr>
+        <p:txBody>
+          <a:bodyPr/>
+          <a:lstStyle/>
+          <a:p>
+            <a:endParaRPr lang="en-US"/>
+          </a:p>
+        </p:txBody>
+      </p:sp>
+      <p:sp>
+        <p:nvSpPr>
+          <p:cNvPr id="27" name="Shape 24"/>
+          <p:cNvSpPr/>
+          <p:nvPr/>
+        </p:nvSpPr>
+        <p:spPr>
+          <a:xfrm>
+            <a:off x="7296912" y="0"/>
+            <a:ext cx="2432304" cy="137160"/>
+          </a:xfrm>
+          <a:prstGeom prst="rect">
+            <a:avLst/>
+          </a:prstGeom>
+          <a:solidFill>
+            <a:srgbClr val="FF4D5F"/>
+          </a:solidFill>
+          <a:ln/>
+        </p:spPr>
+        <p:txBody>
+          <a:bodyPr/>
+          <a:lstStyle/>
+          <a:p>
+            <a:endParaRPr lang="en-US"/>
+          </a:p>
+        </p:txBody>
+      </p:sp>
+      <p:sp>
+        <p:nvSpPr>
+          <p:cNvPr id="28" name="Shape 25"/>
+          <p:cNvSpPr/>
+          <p:nvPr/>
+        </p:nvSpPr>
+        <p:spPr>
+          <a:xfrm>
+            <a:off x="9729216" y="0"/>
+            <a:ext cx="2432304" cy="137160"/>
+          </a:xfrm>
+          <a:prstGeom prst="rect">
+            <a:avLst/>
+          </a:prstGeom>
+          <a:solidFill>
+            <a:srgbClr val="C7B9FF"/>
+          </a:solidFill>
+          <a:ln/>
+        </p:spPr>
+        <p:txBody>
+          <a:bodyPr/>
+          <a:lstStyle/>
+          <a:p>
+            <a:endParaRPr lang="en-US"/>
+          </a:p>
+        </p:txBody>
+      </p:sp>
+      <p:sp>
+        <p:nvSpPr>
+          <p:cNvPr id="29" name="Text 26"/>
+          <p:cNvSpPr/>
+          <p:nvPr/>
+        </p:nvSpPr>
+        <p:spPr>
+          <a:xfrm>
+            <a:off x="548640" y="6446520"/>
+            <a:ext cx="7315200" cy="274320"/>
           </a:xfrm>
           <a:prstGeom prst="rect">
             <a:avLst/>
@@ -16455,34 +15891,31 @@
           <a:bodyPr wrap="square" lIns="0" tIns="0" rIns="0" bIns="0" rtlCol="0" anchor="ctr"/>
           <a:lstStyle/>
           <a:p>
-            <a:pPr marL="0" indent="0">
+            <a:pPr marL="0" indent="0" algn="l">
               <a:buNone/>
             </a:pPr>
             <a:r>
-              <a:rPr lang="en-US" sz="2000" b="1" dirty="0">
-                <a:solidFill>
-                  <a:srgbClr val="FFFFFF"/>
-                </a:solidFill>
-                <a:latin typeface="Avenir Next LT Pro" pitchFamily="34" charset="0"/>
-                <a:ea typeface="Avenir Next LT Pro" pitchFamily="34" charset="-122"/>
-                <a:cs typeface="Avenir Next LT Pro" pitchFamily="34" charset="-120"/>
-              </a:rPr>
-              <a:t>Scott Tavares</a:t>
-            </a:r>
-            <a:endParaRPr lang="en-US" sz="2000" dirty="0"/>
-          </a:p>
-        </p:txBody>
-      </p:sp>
-      <p:sp>
-        <p:nvSpPr>
-          <p:cNvPr id="8" name="Text Title"/>
-          <p:cNvSpPr/>
-          <p:nvPr/>
-        </p:nvSpPr>
-        <p:spPr>
-          <a:xfrm>
-            <a:off x="914400" y="4480560"/>
-            <a:ext cx="10363200" cy="292608"/>
+              <a:rPr lang="en-US" sz="750" dirty="0">
+                <a:solidFill>
+                  <a:srgbClr val="666666"/>
+                </a:solidFill>
+              </a:rPr>
+              <a:t>© Slalom. All Rights Reserved. Proprietary and Confidential.</a:t>
+            </a:r>
+            <a:endParaRPr lang="en-US" sz="750" dirty="0"/>
+          </a:p>
+        </p:txBody>
+      </p:sp>
+      <p:sp>
+        <p:nvSpPr>
+          <p:cNvPr id="30" name="Text 27"/>
+          <p:cNvSpPr/>
+          <p:nvPr/>
+        </p:nvSpPr>
+        <p:spPr>
+          <a:xfrm>
+            <a:off x="11521440" y="6446520"/>
+            <a:ext cx="365760" cy="274320"/>
           </a:xfrm>
           <a:prstGeom prst="rect">
             <a:avLst/>
@@ -16494,133 +15927,700 @@
           <a:bodyPr wrap="square" lIns="0" tIns="0" rIns="0" bIns="0" rtlCol="0" anchor="ctr"/>
           <a:lstStyle/>
           <a:p>
-            <a:pPr marL="0" indent="0">
+            <a:pPr marL="0" indent="0" algn="r">
               <a:buNone/>
             </a:pPr>
             <a:r>
-              <a:rPr lang="en-US" sz="1300" dirty="0">
-                <a:solidFill>
-                  <a:srgbClr val="9FC6E8"/>
-                </a:solidFill>
-                <a:latin typeface="Avenir Next LT Pro" pitchFamily="34" charset="0"/>
-                <a:ea typeface="Avenir Next LT Pro" pitchFamily="34" charset="-122"/>
-                <a:cs typeface="Avenir Next LT Pro" pitchFamily="34" charset="-120"/>
-              </a:rPr>
-              <a:t>Senior Principal, Adobe Multi-Solution Architect</a:t>
-            </a:r>
-            <a:endParaRPr lang="en-US" sz="1300" dirty="0"/>
-          </a:p>
-        </p:txBody>
-      </p:sp>
-      <p:sp>
-        <p:nvSpPr>
-          <p:cNvPr id="9" name="Text Company"/>
-          <p:cNvSpPr/>
-          <p:nvPr/>
-        </p:nvSpPr>
-        <p:spPr>
-          <a:xfrm>
-            <a:off x="914400" y="4791075"/>
-            <a:ext cx="10363200" cy="292608"/>
+              <a:rPr lang="en-US" sz="1000" dirty="0">
+                <a:solidFill>
+                  <a:srgbClr val="666666"/>
+                </a:solidFill>
+              </a:rPr>
+              <a:t>9</a:t>
+            </a:r>
+            <a:endParaRPr lang="en-US" sz="1000" dirty="0"/>
+          </a:p>
+        </p:txBody>
+      </p:sp>
+      <p:sp>
+        <p:nvSpPr>
+          <p:cNvPr id="31" name="TextBox 30"/>
+          <p:cNvSpPr txBox="1"/>
+          <p:nvPr/>
+        </p:nvSpPr>
+        <p:spPr>
+          <a:xfrm>
+            <a:off x="548640" y="1188720"/>
+            <a:ext cx="11064240" cy="365760"/>
           </a:xfrm>
           <a:prstGeom prst="rect">
             <a:avLst/>
           </a:prstGeom>
           <a:noFill/>
-          <a:ln/>
-        </p:spPr>
-        <p:txBody>
-          <a:bodyPr wrap="square" lIns="0" tIns="0" rIns="0" bIns="0" rtlCol="0" anchor="ctr"/>
-          <a:lstStyle/>
-          <a:p>
-            <a:pPr marL="0" indent="0">
-              <a:buNone/>
-            </a:pPr>
-            <a:r>
-              <a:rPr lang="en-US" sz="1300" dirty="0">
-                <a:solidFill>
-                  <a:srgbClr val="9FC6E8"/>
-                </a:solidFill>
-                <a:latin typeface="Avenir Next LT Pro" pitchFamily="34" charset="0"/>
-                <a:ea typeface="Avenir Next LT Pro" pitchFamily="34" charset="-122"/>
-                <a:cs typeface="Avenir Next LT Pro" pitchFamily="34" charset="-120"/>
-              </a:rPr>
-              <a:t>Slalom</a:t>
-            </a:r>
-            <a:endParaRPr lang="en-US" sz="1300" dirty="0"/>
-          </a:p>
-        </p:txBody>
-      </p:sp>
-      <p:sp>
-        <p:nvSpPr>
-          <p:cNvPr id="10" name="Text Email"/>
-          <p:cNvSpPr/>
-          <p:nvPr/>
-        </p:nvSpPr>
-        <p:spPr>
-          <a:xfrm>
-            <a:off x="914400" y="5257800"/>
-            <a:ext cx="10363200" cy="292608"/>
+        </p:spPr>
+        <p:txBody>
+          <a:bodyPr wrap="square" lIns="27432" rIns="27432" tIns="0" bIns="0" anchor="ctr">
+            <a:spAutoFit/>
+          </a:bodyPr>
+          <a:lstStyle/>
+          <a:p>
+            <a:pPr algn="l"/>
+            <a:r>
+              <a:rPr sz="1400" b="0">
+                <a:solidFill>
+                  <a:srgbClr val="5A6478"/>
+                </a:solidFill>
+                <a:latin typeface="Avenir Next LT Pro"/>
+              </a:rPr>
+              <a:t>Name your site in plain English — the skill confirms scope, works from live data, and hands back a client-ready deck.</a:t>
+            </a:r>
+          </a:p>
+        </p:txBody>
+      </p:sp>
+      <p:pic>
+        <p:nvPicPr>
+          <p:cNvPr id="32" name="Picture 31" descr="terminal.png"/>
+          <p:cNvPicPr>
+            <a:picLocks noChangeAspect="1"/>
+          </p:cNvPicPr>
+          <p:nvPr/>
+        </p:nvPicPr>
+        <p:blipFill>
+          <a:blip r:embed="rId2"/>
+          <a:stretch>
+            <a:fillRect/>
+          </a:stretch>
+        </p:blipFill>
+        <p:spPr>
+          <a:xfrm>
+            <a:off x="512064" y="1691640"/>
+            <a:ext cx="7845552" cy="3584448"/>
+          </a:xfrm>
+          <a:prstGeom prst="rect">
+            <a:avLst/>
+          </a:prstGeom>
+        </p:spPr>
+      </p:pic>
+      <p:sp>
+        <p:nvSpPr>
+          <p:cNvPr id="33" name="TextBox 32"/>
+          <p:cNvSpPr txBox="1"/>
+          <p:nvPr/>
+        </p:nvSpPr>
+        <p:spPr>
+          <a:xfrm>
+            <a:off x="8650224" y="1755648"/>
+            <a:ext cx="3017520" cy="256032"/>
           </a:xfrm>
           <a:prstGeom prst="rect">
             <a:avLst/>
           </a:prstGeom>
           <a:noFill/>
-          <a:ln/>
-        </p:spPr>
-        <p:txBody>
-          <a:bodyPr wrap="square" lIns="0" tIns="0" rIns="0" bIns="0" rtlCol="0" anchor="ctr"/>
-          <a:lstStyle/>
-          <a:p>
-            <a:pPr marL="0" indent="0">
-              <a:buNone/>
-            </a:pPr>
-            <a:r>
-              <a:rPr lang="en-US" sz="1300" b="1" dirty="0">
+        </p:spPr>
+        <p:txBody>
+          <a:bodyPr wrap="square" lIns="27432" rIns="27432" tIns="0" bIns="0" anchor="t">
+            <a:spAutoFit/>
+          </a:bodyPr>
+          <a:lstStyle/>
+          <a:p>
+            <a:pPr algn="l"/>
+            <a:r>
+              <a:rPr sz="1200" b="1">
+                <a:solidFill>
+                  <a:srgbClr val="9AA6BF"/>
+                </a:solidFill>
+                <a:latin typeface="Avenir Next LT Pro"/>
+              </a:rPr>
+              <a:t>WHAT JUST HAPPENED</a:t>
+            </a:r>
+          </a:p>
+        </p:txBody>
+      </p:sp>
+      <p:sp>
+        <p:nvSpPr>
+          <p:cNvPr id="34" name="Oval 33"/>
+          <p:cNvSpPr/>
+          <p:nvPr/>
+        </p:nvSpPr>
+        <p:spPr>
+          <a:xfrm>
+            <a:off x="8650224" y="2084831"/>
+            <a:ext cx="292608" cy="292608"/>
+          </a:xfrm>
+          <a:prstGeom prst="ellipse">
+            <a:avLst/>
+          </a:prstGeom>
+          <a:solidFill>
+            <a:srgbClr val="002FAF"/>
+          </a:solidFill>
+          <a:ln>
+            <a:noFill/>
+          </a:ln>
+          <a:effectLst/>
+        </p:spPr>
+        <p:style>
+          <a:lnRef idx="1">
+            <a:schemeClr val="accent1"/>
+          </a:lnRef>
+          <a:fillRef idx="3">
+            <a:schemeClr val="accent1"/>
+          </a:fillRef>
+          <a:effectRef idx="2">
+            <a:schemeClr val="accent1"/>
+          </a:effectRef>
+          <a:fontRef idx="minor">
+            <a:schemeClr val="lt1"/>
+          </a:fontRef>
+        </p:style>
+        <p:txBody>
+          <a:bodyPr rtlCol="0" anchor="ctr" wrap="square" lIns="27432" rIns="27432" tIns="0" bIns="0"/>
+          <a:lstStyle/>
+          <a:p>
+            <a:pPr algn="ctr"/>
+            <a:r>
+              <a:rPr sz="1300" b="1">
                 <a:solidFill>
                   <a:srgbClr val="FFFFFF"/>
                 </a:solidFill>
-                <a:latin typeface="Avenir Next LT Pro" pitchFamily="34" charset="0"/>
-                <a:ea typeface="Avenir Next LT Pro" pitchFamily="34" charset="-122"/>
-                <a:cs typeface="Avenir Next LT Pro" pitchFamily="34" charset="-120"/>
-              </a:rPr>
-              <a:t>scott.tavares@slalom.com</a:t>
-            </a:r>
-            <a:endParaRPr lang="en-US" sz="1300" dirty="0"/>
-          </a:p>
-        </p:txBody>
-      </p:sp>
-      <p:sp>
-        <p:nvSpPr>
-          <p:cNvPr id="21" name="Text Copyright"/>
-          <p:cNvSpPr/>
-          <p:nvPr/>
-        </p:nvSpPr>
-        <p:spPr>
-          <a:xfrm>
-            <a:off x="914400" y="6446520"/>
-            <a:ext cx="7315200" cy="274320"/>
+                <a:latin typeface="Calibri"/>
+              </a:rPr>
+              <a:t>1</a:t>
+            </a:r>
+          </a:p>
+        </p:txBody>
+      </p:sp>
+      <p:sp>
+        <p:nvSpPr>
+          <p:cNvPr id="35" name="TextBox 34"/>
+          <p:cNvSpPr txBox="1"/>
+          <p:nvPr/>
+        </p:nvSpPr>
+        <p:spPr>
+          <a:xfrm>
+            <a:off x="9070848" y="2066543"/>
+            <a:ext cx="2606040" cy="274320"/>
           </a:xfrm>
           <a:prstGeom prst="rect">
             <a:avLst/>
           </a:prstGeom>
           <a:noFill/>
-          <a:ln/>
-        </p:spPr>
-        <p:txBody>
-          <a:bodyPr wrap="square" lIns="0" tIns="0" rIns="0" bIns="0" rtlCol="0" anchor="ctr"/>
-          <a:lstStyle/>
-          <a:p>
-            <a:pPr marL="0" indent="0">
-              <a:buNone/>
-            </a:pPr>
-            <a:r>
-              <a:rPr lang="en-US" sz="900" dirty="0">
-                <a:solidFill>
-                  <a:srgbClr val="6E93B8"/>
-                </a:solidFill>
-              </a:rPr>
-              <a:t>© Slalom. All Rights Reserved. Proprietary and Confidential.</a:t>
+        </p:spPr>
+        <p:txBody>
+          <a:bodyPr wrap="square" lIns="27432" rIns="27432" tIns="0" bIns="0" anchor="ctr">
+            <a:spAutoFit/>
+          </a:bodyPr>
+          <a:lstStyle/>
+          <a:p>
+            <a:pPr algn="l"/>
+            <a:r>
+              <a:rPr sz="1500" b="1">
+                <a:solidFill>
+                  <a:srgbClr val="002FAF"/>
+                </a:solidFill>
+                <a:latin typeface="Avenir Next LT Pro"/>
+              </a:rPr>
+              <a:t>You named the site.</a:t>
+            </a:r>
+          </a:p>
+        </p:txBody>
+      </p:sp>
+      <p:sp>
+        <p:nvSpPr>
+          <p:cNvPr id="36" name="TextBox 35"/>
+          <p:cNvSpPr txBox="1"/>
+          <p:nvPr/>
+        </p:nvSpPr>
+        <p:spPr>
+          <a:xfrm>
+            <a:off x="9070848" y="2359151"/>
+            <a:ext cx="2606040" cy="640080"/>
+          </a:xfrm>
+          <a:prstGeom prst="rect">
+            <a:avLst/>
+          </a:prstGeom>
+          <a:noFill/>
+        </p:spPr>
+        <p:txBody>
+          <a:bodyPr wrap="square" lIns="27432" rIns="27432" tIns="0" bIns="0" anchor="t">
+            <a:spAutoFit/>
+          </a:bodyPr>
+          <a:lstStyle/>
+          <a:p>
+            <a:pPr algn="l"/>
+            <a:r>
+              <a:rPr sz="1300" b="0">
+                <a:solidFill>
+                  <a:srgbClr val="3E4759"/>
+                </a:solidFill>
+                <a:latin typeface="Avenir Next LT Pro"/>
+              </a:rPr>
+              <a:t>That’s the entire prompt — </a:t>
+            </a:r>
+            <a:r>
+              <a:rPr sz="1200" b="1">
+                <a:solidFill>
+                  <a:srgbClr val="17203A"/>
+                </a:solidFill>
+                <a:latin typeface="Consolas"/>
+              </a:rPr>
+              <a:t>Audit the site slalom.com</a:t>
+            </a:r>
+          </a:p>
+        </p:txBody>
+      </p:sp>
+      <p:sp>
+        <p:nvSpPr>
+          <p:cNvPr id="37" name="Oval 36"/>
+          <p:cNvSpPr/>
+          <p:nvPr/>
+        </p:nvSpPr>
+        <p:spPr>
+          <a:xfrm>
+            <a:off x="8650224" y="3044952"/>
+            <a:ext cx="292608" cy="292608"/>
+          </a:xfrm>
+          <a:prstGeom prst="ellipse">
+            <a:avLst/>
+          </a:prstGeom>
+          <a:solidFill>
+            <a:srgbClr val="0C62FB"/>
+          </a:solidFill>
+          <a:ln>
+            <a:noFill/>
+          </a:ln>
+          <a:effectLst/>
+        </p:spPr>
+        <p:style>
+          <a:lnRef idx="1">
+            <a:schemeClr val="accent1"/>
+          </a:lnRef>
+          <a:fillRef idx="3">
+            <a:schemeClr val="accent1"/>
+          </a:fillRef>
+          <a:effectRef idx="2">
+            <a:schemeClr val="accent1"/>
+          </a:effectRef>
+          <a:fontRef idx="minor">
+            <a:schemeClr val="lt1"/>
+          </a:fontRef>
+        </p:style>
+        <p:txBody>
+          <a:bodyPr rtlCol="0" anchor="ctr" wrap="square" lIns="27432" rIns="27432" tIns="0" bIns="0"/>
+          <a:lstStyle/>
+          <a:p>
+            <a:pPr algn="ctr"/>
+            <a:r>
+              <a:rPr sz="1300" b="1">
+                <a:solidFill>
+                  <a:srgbClr val="FFFFFF"/>
+                </a:solidFill>
+                <a:latin typeface="Calibri"/>
+              </a:rPr>
+              <a:t>2</a:t>
+            </a:r>
+          </a:p>
+        </p:txBody>
+      </p:sp>
+      <p:sp>
+        <p:nvSpPr>
+          <p:cNvPr id="38" name="TextBox 37"/>
+          <p:cNvSpPr txBox="1"/>
+          <p:nvPr/>
+        </p:nvSpPr>
+        <p:spPr>
+          <a:xfrm>
+            <a:off x="9070848" y="3026664"/>
+            <a:ext cx="2606040" cy="274320"/>
+          </a:xfrm>
+          <a:prstGeom prst="rect">
+            <a:avLst/>
+          </a:prstGeom>
+          <a:noFill/>
+        </p:spPr>
+        <p:txBody>
+          <a:bodyPr wrap="square" lIns="27432" rIns="27432" tIns="0" bIns="0" anchor="ctr">
+            <a:spAutoFit/>
+          </a:bodyPr>
+          <a:lstStyle/>
+          <a:p>
+            <a:pPr algn="l"/>
+            <a:r>
+              <a:rPr sz="1500" b="1">
+                <a:solidFill>
+                  <a:srgbClr val="0C62FB"/>
+                </a:solidFill>
+                <a:latin typeface="Avenir Next LT Pro"/>
+              </a:rPr>
+              <a:t>It routed &amp; confirmed.</a:t>
+            </a:r>
+          </a:p>
+        </p:txBody>
+      </p:sp>
+      <p:sp>
+        <p:nvSpPr>
+          <p:cNvPr id="39" name="TextBox 38"/>
+          <p:cNvSpPr txBox="1"/>
+          <p:nvPr/>
+        </p:nvSpPr>
+        <p:spPr>
+          <a:xfrm>
+            <a:off x="9070848" y="3319272"/>
+            <a:ext cx="2606040" cy="640080"/>
+          </a:xfrm>
+          <a:prstGeom prst="rect">
+            <a:avLst/>
+          </a:prstGeom>
+          <a:noFill/>
+        </p:spPr>
+        <p:txBody>
+          <a:bodyPr wrap="square" lIns="27432" rIns="27432" tIns="0" bIns="0" anchor="t">
+            <a:spAutoFit/>
+          </a:bodyPr>
+          <a:lstStyle/>
+          <a:p>
+            <a:pPr algn="l"/>
+            <a:r>
+              <a:rPr sz="1300" b="0">
+                <a:solidFill>
+                  <a:srgbClr val="3E4759"/>
+                </a:solidFill>
+                <a:latin typeface="Avenir Next LT Pro"/>
+              </a:rPr>
+              <a:t>Picked the Adobe Tags audit and confirmed scope — no re-asking what you already said.</a:t>
+            </a:r>
+          </a:p>
+        </p:txBody>
+      </p:sp>
+      <p:sp>
+        <p:nvSpPr>
+          <p:cNvPr id="40" name="Oval 39"/>
+          <p:cNvSpPr/>
+          <p:nvPr/>
+        </p:nvSpPr>
+        <p:spPr>
+          <a:xfrm>
+            <a:off x="8650224" y="4005072"/>
+            <a:ext cx="292608" cy="292608"/>
+          </a:xfrm>
+          <a:prstGeom prst="ellipse">
+            <a:avLst/>
+          </a:prstGeom>
+          <a:solidFill>
+            <a:srgbClr val="0E8FA0"/>
+          </a:solidFill>
+          <a:ln>
+            <a:noFill/>
+          </a:ln>
+          <a:effectLst/>
+        </p:spPr>
+        <p:style>
+          <a:lnRef idx="1">
+            <a:schemeClr val="accent1"/>
+          </a:lnRef>
+          <a:fillRef idx="3">
+            <a:schemeClr val="accent1"/>
+          </a:fillRef>
+          <a:effectRef idx="2">
+            <a:schemeClr val="accent1"/>
+          </a:effectRef>
+          <a:fontRef idx="minor">
+            <a:schemeClr val="lt1"/>
+          </a:fontRef>
+        </p:style>
+        <p:txBody>
+          <a:bodyPr rtlCol="0" anchor="ctr" wrap="square" lIns="27432" rIns="27432" tIns="0" bIns="0"/>
+          <a:lstStyle/>
+          <a:p>
+            <a:pPr algn="ctr"/>
+            <a:r>
+              <a:rPr sz="1300" b="1">
+                <a:solidFill>
+                  <a:srgbClr val="FFFFFF"/>
+                </a:solidFill>
+                <a:latin typeface="Calibri"/>
+              </a:rPr>
+              <a:t>3</a:t>
+            </a:r>
+          </a:p>
+        </p:txBody>
+      </p:sp>
+      <p:sp>
+        <p:nvSpPr>
+          <p:cNvPr id="41" name="TextBox 40"/>
+          <p:cNvSpPr txBox="1"/>
+          <p:nvPr/>
+        </p:nvSpPr>
+        <p:spPr>
+          <a:xfrm>
+            <a:off x="9070848" y="3986784"/>
+            <a:ext cx="2606040" cy="274320"/>
+          </a:xfrm>
+          <a:prstGeom prst="rect">
+            <a:avLst/>
+          </a:prstGeom>
+          <a:noFill/>
+        </p:spPr>
+        <p:txBody>
+          <a:bodyPr wrap="square" lIns="27432" rIns="27432" tIns="0" bIns="0" anchor="ctr">
+            <a:spAutoFit/>
+          </a:bodyPr>
+          <a:lstStyle/>
+          <a:p>
+            <a:pPr algn="l"/>
+            <a:r>
+              <a:rPr sz="1500" b="1">
+                <a:solidFill>
+                  <a:srgbClr val="0E8FA0"/>
+                </a:solidFill>
+                <a:latin typeface="Avenir Next LT Pro"/>
+              </a:rPr>
+              <a:t>It works from live data.</a:t>
+            </a:r>
+          </a:p>
+        </p:txBody>
+      </p:sp>
+      <p:sp>
+        <p:nvSpPr>
+          <p:cNvPr id="42" name="TextBox 41"/>
+          <p:cNvSpPr txBox="1"/>
+          <p:nvPr/>
+        </p:nvSpPr>
+        <p:spPr>
+          <a:xfrm>
+            <a:off x="9070848" y="4279392"/>
+            <a:ext cx="2606040" cy="640080"/>
+          </a:xfrm>
+          <a:prstGeom prst="rect">
+            <a:avLst/>
+          </a:prstGeom>
+          <a:noFill/>
+        </p:spPr>
+        <p:txBody>
+          <a:bodyPr wrap="square" lIns="27432" rIns="27432" tIns="0" bIns="0" anchor="t">
+            <a:spAutoFit/>
+          </a:bodyPr>
+          <a:lstStyle/>
+          <a:p>
+            <a:pPr algn="l"/>
+            <a:r>
+              <a:rPr sz="1300" b="0">
+                <a:solidFill>
+                  <a:srgbClr val="3E4759"/>
+                </a:solidFill>
+                <a:latin typeface="Avenir Next LT Pro"/>
+              </a:rPr>
+              <a:t>A real headless browser detects the stack and pulls the published Launch library directly.</a:t>
+            </a:r>
+          </a:p>
+        </p:txBody>
+      </p:sp>
+      <p:sp>
+        <p:nvSpPr>
+          <p:cNvPr id="43" name="Rounded Rectangle 42"/>
+          <p:cNvSpPr/>
+          <p:nvPr/>
+        </p:nvSpPr>
+        <p:spPr>
+          <a:xfrm>
+            <a:off x="8650224" y="5029200"/>
+            <a:ext cx="3017520" cy="566928"/>
+          </a:xfrm>
+          <a:prstGeom prst="roundRect">
+            <a:avLst>
+              <a:gd name="adj" fmla="val 16000"/>
+            </a:avLst>
+          </a:prstGeom>
+          <a:solidFill>
+            <a:srgbClr val="EAF7EE"/>
+          </a:solidFill>
+          <a:ln w="12700">
+            <a:solidFill>
+              <a:srgbClr val="CDEBD6"/>
+            </a:solidFill>
+          </a:ln>
+          <a:effectLst/>
+        </p:spPr>
+        <p:style>
+          <a:lnRef idx="1">
+            <a:schemeClr val="accent1"/>
+          </a:lnRef>
+          <a:fillRef idx="3">
+            <a:schemeClr val="accent1"/>
+          </a:fillRef>
+          <a:effectRef idx="2">
+            <a:schemeClr val="accent1"/>
+          </a:effectRef>
+          <a:fontRef idx="minor">
+            <a:schemeClr val="lt1"/>
+          </a:fontRef>
+        </p:style>
+        <p:txBody>
+          <a:bodyPr rtlCol="0" anchor="ctr" wrap="square" lIns="27432" rIns="27432" tIns="0" bIns="0"/>
+          <a:lstStyle/>
+          <a:p>
+            <a:pPr algn="l"/>
+            <a:r>
+              <a:rPr sz="1250" b="1">
+                <a:solidFill>
+                  <a:srgbClr val="17203A"/>
+                </a:solidFill>
+                <a:latin typeface="Avenir Next LT Pro"/>
+              </a:rPr>
+              <a:t>Produces </a:t>
+            </a:r>
+            <a:r>
+              <a:rPr sz="1250" b="1">
+                <a:solidFill>
+                  <a:srgbClr val="2E9E5B"/>
+                </a:solidFill>
+                <a:latin typeface="Avenir Next LT Pro"/>
+              </a:rPr>
+              <a:t>a findings deck (PPTX)</a:t>
+            </a:r>
+            <a:r>
+              <a:rPr sz="1250" b="1">
+                <a:solidFill>
+                  <a:srgbClr val="17203A"/>
+                </a:solidFill>
+                <a:latin typeface="Avenir Next LT Pro"/>
+              </a:rPr>
+              <a:t> in the Slalom style.</a:t>
+            </a:r>
+          </a:p>
+        </p:txBody>
+      </p:sp>
+      <p:sp>
+        <p:nvSpPr>
+          <p:cNvPr id="44" name="Rounded Rectangle 43"/>
+          <p:cNvSpPr/>
+          <p:nvPr/>
+        </p:nvSpPr>
+        <p:spPr>
+          <a:xfrm>
+            <a:off x="512064" y="5486400"/>
+            <a:ext cx="7845552" cy="566928"/>
+          </a:xfrm>
+          <a:prstGeom prst="roundRect">
+            <a:avLst>
+              <a:gd name="adj" fmla="val 12000"/>
+            </a:avLst>
+          </a:prstGeom>
+          <a:solidFill>
+            <a:srgbClr val="F5F8FF"/>
+          </a:solidFill>
+          <a:ln>
+            <a:noFill/>
+          </a:ln>
+          <a:effectLst/>
+        </p:spPr>
+        <p:style>
+          <a:lnRef idx="1">
+            <a:schemeClr val="accent1"/>
+          </a:lnRef>
+          <a:fillRef idx="3">
+            <a:schemeClr val="accent1"/>
+          </a:fillRef>
+          <a:effectRef idx="2">
+            <a:schemeClr val="accent1"/>
+          </a:effectRef>
+          <a:fontRef idx="minor">
+            <a:schemeClr val="lt1"/>
+          </a:fontRef>
+        </p:style>
+        <p:txBody>
+          <a:bodyPr rtlCol="0" anchor="ctr"/>
+          <a:lstStyle/>
+          <a:p>
+            <a:pPr algn="ctr"/>
+          </a:p>
+        </p:txBody>
+      </p:sp>
+      <p:sp>
+        <p:nvSpPr>
+          <p:cNvPr id="45" name="Rounded Rectangle 44"/>
+          <p:cNvSpPr/>
+          <p:nvPr/>
+        </p:nvSpPr>
+        <p:spPr>
+          <a:xfrm>
+            <a:off x="512064" y="5486400"/>
+            <a:ext cx="73152" cy="566928"/>
+          </a:xfrm>
+          <a:prstGeom prst="roundRect">
+            <a:avLst>
+              <a:gd name="adj" fmla="val 50000"/>
+            </a:avLst>
+          </a:prstGeom>
+          <a:solidFill>
+            <a:srgbClr val="0C62FB"/>
+          </a:solidFill>
+          <a:ln>
+            <a:noFill/>
+          </a:ln>
+          <a:effectLst/>
+        </p:spPr>
+        <p:style>
+          <a:lnRef idx="1">
+            <a:schemeClr val="accent1"/>
+          </a:lnRef>
+          <a:fillRef idx="3">
+            <a:schemeClr val="accent1"/>
+          </a:fillRef>
+          <a:effectRef idx="2">
+            <a:schemeClr val="accent1"/>
+          </a:effectRef>
+          <a:fontRef idx="minor">
+            <a:schemeClr val="lt1"/>
+          </a:fontRef>
+        </p:style>
+        <p:txBody>
+          <a:bodyPr rtlCol="0" anchor="ctr"/>
+          <a:lstStyle/>
+          <a:p>
+            <a:pPr algn="ctr"/>
+          </a:p>
+        </p:txBody>
+      </p:sp>
+      <p:sp>
+        <p:nvSpPr>
+          <p:cNvPr id="46" name="TextBox 45"/>
+          <p:cNvSpPr txBox="1"/>
+          <p:nvPr/>
+        </p:nvSpPr>
+        <p:spPr>
+          <a:xfrm>
+            <a:off x="786384" y="5486400"/>
+            <a:ext cx="7406640" cy="566928"/>
+          </a:xfrm>
+          <a:prstGeom prst="rect">
+            <a:avLst/>
+          </a:prstGeom>
+          <a:noFill/>
+        </p:spPr>
+        <p:txBody>
+          <a:bodyPr wrap="square" lIns="27432" rIns="27432" tIns="0" bIns="0" anchor="ctr">
+            <a:spAutoFit/>
+          </a:bodyPr>
+          <a:lstStyle/>
+          <a:p>
+            <a:pPr algn="l"/>
+            <a:r>
+              <a:rPr sz="1400" b="1">
+                <a:solidFill>
+                  <a:srgbClr val="002FAF"/>
+                </a:solidFill>
+                <a:latin typeface="Avenir Next LT Pro"/>
+              </a:rPr>
+              <a:t>Same pattern for every skill: </a:t>
+            </a:r>
+            <a:r>
+              <a:rPr sz="1400" b="0">
+                <a:solidFill>
+                  <a:srgbClr val="3E4759"/>
+                </a:solidFill>
+                <a:latin typeface="Avenir Next LT Pro"/>
+              </a:rPr>
+              <a:t>name the target in one line — Detect, Build, Audit, Reconcile — and the matching skill routes, confirms, and runs.</a:t>
             </a:r>
           </a:p>
         </p:txBody>

</xml_diff>

<commit_message>
Slide 7: remove stray text-box borders; slide 9: real ASCII banner
- Deliverables slide: explicitly set no-line on every shape so the
  inherited default outline stops drawing a thin border around each text
  box.
- See-it-in-action terminal: replace the plain "SLALOM" box with the
  actual slant ASCII wordmark the skill prints, above FIERCELY HUMAN
  CONSULTING.

Co-Authored-By: Claude Opus 4.8 <noreply@anthropic.com>
Claude-Session: https://claude.ai/code/session_01L22pJWjoypJEHfB9cqhWZF
</commit_message>
<xml_diff>
--- a/websdk-property/docs/adobe-data-collection-skills-suite.pptx
+++ b/websdk-property/docs/adobe-data-collection-skills-suite.pptx
@@ -12371,7 +12371,7 @@
           </a:prstGeom>
           <a:noFill/>
           <a:ln>
-            <a:solidFill/>
+            <a:noFill/>
           </a:ln>
         </p:spPr>
         <p:txBody>
@@ -12412,7 +12412,7 @@
           </a:prstGeom>
           <a:noFill/>
           <a:ln>
-            <a:solidFill/>
+            <a:noFill/>
           </a:ln>
         </p:spPr>
         <p:txBody>
@@ -12457,7 +12457,7 @@
             <a:srgbClr val="F2F2F2"/>
           </a:solidFill>
           <a:ln>
-            <a:solidFill/>
+            <a:noFill/>
           </a:ln>
         </p:spPr>
         <p:txBody>
@@ -12484,7 +12484,7 @@
           </a:prstGeom>
           <a:noFill/>
           <a:ln>
-            <a:solidFill/>
+            <a:noFill/>
           </a:ln>
         </p:spPr>
         <p:txBody>
@@ -12525,7 +12525,7 @@
           </a:prstGeom>
           <a:noFill/>
           <a:ln>
-            <a:solidFill/>
+            <a:noFill/>
           </a:ln>
         </p:spPr>
         <p:txBody>
@@ -12570,7 +12570,7 @@
             <a:srgbClr val="F2F2F2"/>
           </a:solidFill>
           <a:ln>
-            <a:solidFill/>
+            <a:noFill/>
           </a:ln>
         </p:spPr>
         <p:txBody>
@@ -12597,7 +12597,7 @@
           </a:prstGeom>
           <a:noFill/>
           <a:ln>
-            <a:solidFill/>
+            <a:noFill/>
           </a:ln>
         </p:spPr>
         <p:txBody>
@@ -12638,7 +12638,7 @@
           </a:prstGeom>
           <a:noFill/>
           <a:ln>
-            <a:solidFill/>
+            <a:noFill/>
           </a:ln>
         </p:spPr>
         <p:txBody>
@@ -12683,7 +12683,7 @@
             <a:srgbClr val="0C62FB"/>
           </a:solidFill>
           <a:ln>
-            <a:solidFill/>
+            <a:noFill/>
           </a:ln>
         </p:spPr>
         <p:txBody>
@@ -12710,7 +12710,7 @@
           </a:prstGeom>
           <a:noFill/>
           <a:ln>
-            <a:solidFill/>
+            <a:noFill/>
           </a:ln>
         </p:spPr>
         <p:txBody>
@@ -12755,7 +12755,7 @@
             <a:srgbClr val="0E8FA0"/>
           </a:solidFill>
           <a:ln>
-            <a:solidFill/>
+            <a:noFill/>
           </a:ln>
         </p:spPr>
         <p:txBody>
@@ -12782,7 +12782,7 @@
           </a:prstGeom>
           <a:noFill/>
           <a:ln>
-            <a:solidFill/>
+            <a:noFill/>
           </a:ln>
         </p:spPr>
         <p:txBody>
@@ -12823,7 +12823,7 @@
           </a:prstGeom>
           <a:noFill/>
           <a:ln>
-            <a:solidFill/>
+            <a:noFill/>
           </a:ln>
         </p:spPr>
         <p:txBody>
@@ -12867,7 +12867,7 @@
           </a:prstGeom>
           <a:noFill/>
           <a:ln>
-            <a:solidFill/>
+            <a:noFill/>
           </a:ln>
         </p:spPr>
         <p:txBody>
@@ -12911,7 +12911,7 @@
           </a:prstGeom>
           <a:noFill/>
           <a:ln>
-            <a:solidFill/>
+            <a:noFill/>
           </a:ln>
         </p:spPr>
         <p:txBody>
@@ -12955,7 +12955,7 @@
           </a:prstGeom>
           <a:noFill/>
           <a:ln>
-            <a:solidFill/>
+            <a:noFill/>
           </a:ln>
         </p:spPr>
         <p:txBody>
@@ -12999,7 +12999,7 @@
           </a:prstGeom>
           <a:noFill/>
           <a:ln>
-            <a:solidFill/>
+            <a:noFill/>
           </a:ln>
         </p:spPr>
         <p:txBody>
@@ -13045,7 +13045,7 @@
             <a:srgbClr val="002FAF"/>
           </a:solidFill>
           <a:ln>
-            <a:solidFill/>
+            <a:noFill/>
           </a:ln>
         </p:spPr>
         <p:txBody>
@@ -13074,7 +13074,7 @@
             <a:srgbClr val="0C62FB"/>
           </a:solidFill>
           <a:ln>
-            <a:solidFill/>
+            <a:noFill/>
           </a:ln>
         </p:spPr>
         <p:txBody>
@@ -13103,7 +13103,7 @@
             <a:srgbClr val="1BE1F2"/>
           </a:solidFill>
           <a:ln>
-            <a:solidFill/>
+            <a:noFill/>
           </a:ln>
         </p:spPr>
         <p:txBody>
@@ -13132,7 +13132,7 @@
             <a:srgbClr val="FF4D5F"/>
           </a:solidFill>
           <a:ln>
-            <a:solidFill/>
+            <a:noFill/>
           </a:ln>
         </p:spPr>
         <p:txBody>
@@ -13161,7 +13161,7 @@
             <a:srgbClr val="C7B9FF"/>
           </a:solidFill>
           <a:ln>
-            <a:solidFill/>
+            <a:noFill/>
           </a:ln>
         </p:spPr>
         <p:txBody>
@@ -13188,7 +13188,7 @@
           </a:prstGeom>
           <a:noFill/>
           <a:ln>
-            <a:solidFill/>
+            <a:noFill/>
           </a:ln>
         </p:spPr>
         <p:txBody>
@@ -13226,7 +13226,7 @@
           </a:prstGeom>
           <a:noFill/>
           <a:ln>
-            <a:solidFill/>
+            <a:noFill/>
           </a:ln>
         </p:spPr>
         <p:txBody>
@@ -13266,7 +13266,7 @@
             <a:srgbClr val="0C62FB"/>
           </a:solidFill>
           <a:ln>
-            <a:solidFill/>
+            <a:noFill/>
           </a:ln>
           <a:effectLst/>
         </p:spPr>
@@ -13315,7 +13315,7 @@
             <a:avLst/>
           </a:prstGeom>
           <a:ln>
-            <a:solidFill/>
+            <a:noFill/>
           </a:ln>
         </p:spPr>
       </p:pic>
@@ -13337,7 +13337,7 @@
             <a:srgbClr val="0C62FB"/>
           </a:solidFill>
           <a:ln>
-            <a:solidFill/>
+            <a:noFill/>
           </a:ln>
           <a:effectLst/>
         </p:spPr>
@@ -13386,7 +13386,7 @@
             <a:avLst/>
           </a:prstGeom>
           <a:ln>
-            <a:solidFill/>
+            <a:noFill/>
           </a:ln>
         </p:spPr>
       </p:pic>
@@ -13408,7 +13408,7 @@
             <a:srgbClr val="0E8FA0"/>
           </a:solidFill>
           <a:ln>
-            <a:solidFill/>
+            <a:noFill/>
           </a:ln>
           <a:effectLst/>
         </p:spPr>
@@ -13457,7 +13457,7 @@
             <a:avLst/>
           </a:prstGeom>
           <a:ln>
-            <a:solidFill/>
+            <a:noFill/>
           </a:ln>
         </p:spPr>
       </p:pic>
@@ -13479,7 +13479,7 @@
             <a:srgbClr val="0E8FA0"/>
           </a:solidFill>
           <a:ln>
-            <a:solidFill/>
+            <a:noFill/>
           </a:ln>
           <a:effectLst/>
         </p:spPr>
@@ -13528,7 +13528,7 @@
             <a:avLst/>
           </a:prstGeom>
           <a:ln>
-            <a:solidFill/>
+            <a:noFill/>
           </a:ln>
         </p:spPr>
       </p:pic>
@@ -13550,7 +13550,7 @@
             <a:srgbClr val="0E8FA0"/>
           </a:solidFill>
           <a:ln>
-            <a:solidFill/>
+            <a:noFill/>
           </a:ln>
           <a:effectLst/>
         </p:spPr>
@@ -13599,7 +13599,7 @@
             <a:avLst/>
           </a:prstGeom>
           <a:ln>
-            <a:solidFill/>
+            <a:noFill/>
           </a:ln>
         </p:spPr>
       </p:pic>
@@ -15977,30 +15977,6 @@
           </a:p>
         </p:txBody>
       </p:sp>
-      <p:pic>
-        <p:nvPicPr>
-          <p:cNvPr id="32" name="Picture 31" descr="terminal.png"/>
-          <p:cNvPicPr>
-            <a:picLocks noChangeAspect="1"/>
-          </p:cNvPicPr>
-          <p:nvPr/>
-        </p:nvPicPr>
-        <p:blipFill>
-          <a:blip r:embed="rId2"/>
-          <a:stretch>
-            <a:fillRect/>
-          </a:stretch>
-        </p:blipFill>
-        <p:spPr>
-          <a:xfrm>
-            <a:off x="512064" y="1691640"/>
-            <a:ext cx="7845552" cy="3584448"/>
-          </a:xfrm>
-          <a:prstGeom prst="rect">
-            <a:avLst/>
-          </a:prstGeom>
-        </p:spPr>
-      </p:pic>
       <p:sp>
         <p:nvSpPr>
           <p:cNvPr id="33" name="TextBox 32"/>
@@ -16625,6 +16601,30 @@
           </a:p>
         </p:txBody>
       </p:sp>
+      <p:pic>
+        <p:nvPicPr>
+          <p:cNvPr id="47" name="Picture 46" descr="terminal.png"/>
+          <p:cNvPicPr>
+            <a:picLocks noChangeAspect="1"/>
+          </p:cNvPicPr>
+          <p:nvPr/>
+        </p:nvPicPr>
+        <p:blipFill>
+          <a:blip r:embed="rId3"/>
+          <a:stretch>
+            <a:fillRect/>
+          </a:stretch>
+        </p:blipFill>
+        <p:spPr>
+          <a:xfrm>
+            <a:off x="512064" y="1691640"/>
+            <a:ext cx="7845552" cy="3584448"/>
+          </a:xfrm>
+          <a:prstGeom prst="rect">
+            <a:avLst/>
+          </a:prstGeom>
+        </p:spPr>
+      </p:pic>
     </p:spTree>
   </p:cSld>
   <p:clrMapOvr>

</xml_diff>